<commit_message>
MAJ 28/01/26 projet 2 terminé; avancée projet 4 et début projet 5
</commit_message>
<xml_diff>
--- a/Data_Analyst/Projet_4/Template+de+présentation_Faim_monde-V2.pptx
+++ b/Data_Analyst/Projet_4/Template+de+présentation_Faim_monde-V2.pptx
@@ -266,6 +266,9 @@
     </a:lvl9pPr>
   </p:defaultTextStyle>
   <p:extLst>
+    <p:ext uri="{EFAFB233-063F-42B5-8137-9DF3F51BA10A}">
+      <p15:sldGuideLst xmlns:p15="http://schemas.microsoft.com/office/powerpoint/2012/main"/>
+    </p:ext>
     <p:ext uri="GoogleSlidesCustomDataVersion2">
       <go:slidesCustomData xmlns:go="http://customooxmlschemas.google.com/" xmlns:ahyp="http://schemas.microsoft.com/office/drawing/2018/hyperlinkcolor" xmlns:p15="http://schemas.microsoft.com/office/powerpoint/2012/main" xmlns:p14="http://schemas.microsoft.com/office/powerpoint/2010/main" xmlns:com="http://schemas.openxmlformats.org/drawingml/2006/compatibility" xmlns:pvml="urn:schemas-microsoft-com:office:powerpoint" xmlns:v="urn:schemas-microsoft-com:vml" xmlns:o="urn:schemas-microsoft-com:office:office" xmlns:dgm="http://schemas.openxmlformats.org/drawingml/2006/diagram" xmlns:c="http://schemas.openxmlformats.org/drawingml/2006/chart" xmlns:mv="urn:schemas-microsoft-com:mac:vml" xmlns:mc="http://schemas.openxmlformats.org/markup-compatibility/2006" xmlns="" r:id="rId25" roundtripDataSignature="AMtx7mirjfFyYNBG5sNntC35Cbhoqt17Cg=="/>
     </p:ext>
@@ -277,19 +280,19 @@
 <pc:chgInfo xmlns:a="http://schemas.openxmlformats.org/drawingml/2006/main" xmlns:r="http://schemas.openxmlformats.org/officeDocument/2006/relationships" xmlns:ac="http://schemas.microsoft.com/office/drawing/2013/main/command" xmlns:pc="http://schemas.microsoft.com/office/powerpoint/2013/main/command">
   <pc:docChgLst>
     <pc:chgData name="Zied Belhocine" userId="200cc0e2b299676e" providerId="LiveId" clId="{36CCCAD6-9B8B-4ECC-B7BF-7E36B9ADD69A}"/>
-    <pc:docChg chg="custSel modSld">
-      <pc:chgData name="Zied Belhocine" userId="200cc0e2b299676e" providerId="LiveId" clId="{36CCCAD6-9B8B-4ECC-B7BF-7E36B9ADD69A}" dt="2026-01-22T11:09:00.622" v="44" actId="1076"/>
+    <pc:docChg chg="undo custSel modSld">
+      <pc:chgData name="Zied Belhocine" userId="200cc0e2b299676e" providerId="LiveId" clId="{36CCCAD6-9B8B-4ECC-B7BF-7E36B9ADD69A}" dt="2026-01-28T14:31:50.018" v="1111" actId="2711"/>
       <pc:docMkLst>
         <pc:docMk/>
       </pc:docMkLst>
       <pc:sldChg chg="addSp delSp modSp mod">
-        <pc:chgData name="Zied Belhocine" userId="200cc0e2b299676e" providerId="LiveId" clId="{36CCCAD6-9B8B-4ECC-B7BF-7E36B9ADD69A}" dt="2026-01-22T11:05:22.348" v="25" actId="20577"/>
+        <pc:chgData name="Zied Belhocine" userId="200cc0e2b299676e" providerId="LiveId" clId="{36CCCAD6-9B8B-4ECC-B7BF-7E36B9ADD69A}" dt="2026-01-28T14:29:46.176" v="1087" actId="2711"/>
         <pc:sldMkLst>
           <pc:docMk/>
           <pc:sldMk cId="0" sldId="256"/>
         </pc:sldMkLst>
-        <pc:spChg chg="ord">
-          <ac:chgData name="Zied Belhocine" userId="200cc0e2b299676e" providerId="LiveId" clId="{36CCCAD6-9B8B-4ECC-B7BF-7E36B9ADD69A}" dt="2026-01-22T11:05:09.983" v="7" actId="167"/>
+        <pc:spChg chg="mod ord">
+          <ac:chgData name="Zied Belhocine" userId="200cc0e2b299676e" providerId="LiveId" clId="{36CCCAD6-9B8B-4ECC-B7BF-7E36B9ADD69A}" dt="2026-01-28T14:29:46.176" v="1087" actId="2711"/>
           <ac:spMkLst>
             <pc:docMk/>
             <pc:sldMk cId="0" sldId="256"/>
@@ -297,11 +300,27 @@
           </ac:spMkLst>
         </pc:spChg>
         <pc:spChg chg="mod">
-          <ac:chgData name="Zied Belhocine" userId="200cc0e2b299676e" providerId="LiveId" clId="{36CCCAD6-9B8B-4ECC-B7BF-7E36B9ADD69A}" dt="2026-01-22T11:05:22.348" v="25" actId="20577"/>
+          <ac:chgData name="Zied Belhocine" userId="200cc0e2b299676e" providerId="LiveId" clId="{36CCCAD6-9B8B-4ECC-B7BF-7E36B9ADD69A}" dt="2026-01-28T14:29:46.176" v="1087" actId="2711"/>
+          <ac:spMkLst>
+            <pc:docMk/>
+            <pc:sldMk cId="0" sldId="256"/>
+            <ac:spMk id="121" creationId="{00000000-0000-0000-0000-000000000000}"/>
+          </ac:spMkLst>
+        </pc:spChg>
+        <pc:spChg chg="mod">
+          <ac:chgData name="Zied Belhocine" userId="200cc0e2b299676e" providerId="LiveId" clId="{36CCCAD6-9B8B-4ECC-B7BF-7E36B9ADD69A}" dt="2026-01-28T14:29:46.176" v="1087" actId="2711"/>
           <ac:spMkLst>
             <pc:docMk/>
             <pc:sldMk cId="0" sldId="256"/>
             <ac:spMk id="122" creationId="{00000000-0000-0000-0000-000000000000}"/>
+          </ac:spMkLst>
+        </pc:spChg>
+        <pc:spChg chg="mod">
+          <ac:chgData name="Zied Belhocine" userId="200cc0e2b299676e" providerId="LiveId" clId="{36CCCAD6-9B8B-4ECC-B7BF-7E36B9ADD69A}" dt="2026-01-28T14:29:46.176" v="1087" actId="2711"/>
+          <ac:spMkLst>
+            <pc:docMk/>
+            <pc:sldMk cId="0" sldId="256"/>
+            <ac:spMk id="123" creationId="{00000000-0000-0000-0000-000000000000}"/>
           </ac:spMkLst>
         </pc:spChg>
         <pc:spChg chg="del">
@@ -321,7 +340,7 @@
           </ac:picMkLst>
         </pc:picChg>
         <pc:picChg chg="add mod">
-          <ac:chgData name="Zied Belhocine" userId="200cc0e2b299676e" providerId="LiveId" clId="{36CCCAD6-9B8B-4ECC-B7BF-7E36B9ADD69A}" dt="2026-01-22T11:05:03.251" v="4" actId="167"/>
+          <ac:chgData name="Zied Belhocine" userId="200cc0e2b299676e" providerId="LiveId" clId="{36CCCAD6-9B8B-4ECC-B7BF-7E36B9ADD69A}" dt="2026-01-28T14:29:46.176" v="1087" actId="2711"/>
           <ac:picMkLst>
             <pc:docMk/>
             <pc:sldMk cId="0" sldId="256"/>
@@ -330,33 +349,137 @@
         </pc:picChg>
       </pc:sldChg>
       <pc:sldChg chg="addSp delSp modSp mod">
-        <pc:chgData name="Zied Belhocine" userId="200cc0e2b299676e" providerId="LiveId" clId="{36CCCAD6-9B8B-4ECC-B7BF-7E36B9ADD69A}" dt="2026-01-22T11:09:00.622" v="44" actId="1076"/>
+        <pc:chgData name="Zied Belhocine" userId="200cc0e2b299676e" providerId="LiveId" clId="{36CCCAD6-9B8B-4ECC-B7BF-7E36B9ADD69A}" dt="2026-01-28T14:06:01.989" v="802" actId="1076"/>
         <pc:sldMkLst>
           <pc:docMk/>
           <pc:sldMk cId="0" sldId="257"/>
         </pc:sldMkLst>
-        <pc:spChg chg="mod">
-          <ac:chgData name="Zied Belhocine" userId="200cc0e2b299676e" providerId="LiveId" clId="{36CCCAD6-9B8B-4ECC-B7BF-7E36B9ADD69A}" dt="2026-01-22T11:07:05.260" v="37" actId="27636"/>
+        <pc:spChg chg="add del mod">
+          <ac:chgData name="Zied Belhocine" userId="200cc0e2b299676e" providerId="LiveId" clId="{36CCCAD6-9B8B-4ECC-B7BF-7E36B9ADD69A}" dt="2026-01-28T14:03:31.604" v="698"/>
+          <ac:spMkLst>
+            <pc:docMk/>
+            <pc:sldMk cId="0" sldId="257"/>
+            <ac:spMk id="13" creationId="{A1D4AEB0-0B7A-608E-927D-A1E8BC2B9D3F}"/>
+          </ac:spMkLst>
+        </pc:spChg>
+        <pc:spChg chg="add mod">
+          <ac:chgData name="Zied Belhocine" userId="200cc0e2b299676e" providerId="LiveId" clId="{36CCCAD6-9B8B-4ECC-B7BF-7E36B9ADD69A}" dt="2026-01-28T14:04:34.663" v="731" actId="1076"/>
+          <ac:spMkLst>
+            <pc:docMk/>
+            <pc:sldMk cId="0" sldId="257"/>
+            <ac:spMk id="15" creationId="{DC22E4E6-ED57-8B00-7961-177B59E2654B}"/>
+          </ac:spMkLst>
+        </pc:spChg>
+        <pc:spChg chg="add del mod">
+          <ac:chgData name="Zied Belhocine" userId="200cc0e2b299676e" providerId="LiveId" clId="{36CCCAD6-9B8B-4ECC-B7BF-7E36B9ADD69A}" dt="2026-01-28T14:04:22.850" v="727" actId="478"/>
+          <ac:spMkLst>
+            <pc:docMk/>
+            <pc:sldMk cId="0" sldId="257"/>
+            <ac:spMk id="17" creationId="{32B95310-0C24-2803-1B2A-0D5C6F252912}"/>
+          </ac:spMkLst>
+        </pc:spChg>
+        <pc:spChg chg="add mod">
+          <ac:chgData name="Zied Belhocine" userId="200cc0e2b299676e" providerId="LiveId" clId="{36CCCAD6-9B8B-4ECC-B7BF-7E36B9ADD69A}" dt="2026-01-28T14:05:02.836" v="744" actId="1076"/>
+          <ac:spMkLst>
+            <pc:docMk/>
+            <pc:sldMk cId="0" sldId="257"/>
+            <ac:spMk id="18" creationId="{B8AD7F91-224E-4E58-1E9B-8CF6F2BC5A10}"/>
+          </ac:spMkLst>
+        </pc:spChg>
+        <pc:spChg chg="add mod">
+          <ac:chgData name="Zied Belhocine" userId="200cc0e2b299676e" providerId="LiveId" clId="{36CCCAD6-9B8B-4ECC-B7BF-7E36B9ADD69A}" dt="2026-01-28T14:05:24.037" v="763" actId="1076"/>
+          <ac:spMkLst>
+            <pc:docMk/>
+            <pc:sldMk cId="0" sldId="257"/>
+            <ac:spMk id="19" creationId="{FE5646BF-38AB-8B4E-AE81-B47E38FFB4CD}"/>
+          </ac:spMkLst>
+        </pc:spChg>
+        <pc:spChg chg="add mod">
+          <ac:chgData name="Zied Belhocine" userId="200cc0e2b299676e" providerId="LiveId" clId="{36CCCAD6-9B8B-4ECC-B7BF-7E36B9ADD69A}" dt="2026-01-28T14:05:37.814" v="780" actId="1076"/>
+          <ac:spMkLst>
+            <pc:docMk/>
+            <pc:sldMk cId="0" sldId="257"/>
+            <ac:spMk id="20" creationId="{34CD730F-DE43-F7D8-55FB-06E87979880C}"/>
+          </ac:spMkLst>
+        </pc:spChg>
+        <pc:spChg chg="add mod">
+          <ac:chgData name="Zied Belhocine" userId="200cc0e2b299676e" providerId="LiveId" clId="{36CCCAD6-9B8B-4ECC-B7BF-7E36B9ADD69A}" dt="2026-01-28T14:06:01.989" v="802" actId="1076"/>
+          <ac:spMkLst>
+            <pc:docMk/>
+            <pc:sldMk cId="0" sldId="257"/>
+            <ac:spMk id="21" creationId="{CA73EB3A-A00B-827C-12E6-9E9C62C1B0EA}"/>
+          </ac:spMkLst>
+        </pc:spChg>
+        <pc:spChg chg="del mod">
+          <ac:chgData name="Zied Belhocine" userId="200cc0e2b299676e" providerId="LiveId" clId="{36CCCAD6-9B8B-4ECC-B7BF-7E36B9ADD69A}" dt="2026-01-28T14:04:17.757" v="725" actId="478"/>
           <ac:spMkLst>
             <pc:docMk/>
             <pc:sldMk cId="0" sldId="257"/>
             <ac:spMk id="131" creationId="{00000000-0000-0000-0000-000000000000}"/>
           </ac:spMkLst>
         </pc:spChg>
-        <pc:spChg chg="mod">
-          <ac:chgData name="Zied Belhocine" userId="200cc0e2b299676e" providerId="LiveId" clId="{36CCCAD6-9B8B-4ECC-B7BF-7E36B9ADD69A}" dt="2026-01-22T11:07:59.343" v="42" actId="1076"/>
+        <pc:spChg chg="del mod">
+          <ac:chgData name="Zied Belhocine" userId="200cc0e2b299676e" providerId="LiveId" clId="{36CCCAD6-9B8B-4ECC-B7BF-7E36B9ADD69A}" dt="2026-01-28T13:39:11.310" v="455" actId="478"/>
           <ac:spMkLst>
             <pc:docMk/>
             <pc:sldMk cId="0" sldId="257"/>
             <ac:spMk id="132" creationId="{00000000-0000-0000-0000-000000000000}"/>
           </ac:spMkLst>
         </pc:spChg>
-        <pc:picChg chg="add mod">
-          <ac:chgData name="Zied Belhocine" userId="200cc0e2b299676e" providerId="LiveId" clId="{36CCCAD6-9B8B-4ECC-B7BF-7E36B9ADD69A}" dt="2026-01-22T11:09:00.622" v="44" actId="1076"/>
+        <pc:picChg chg="add del mod">
+          <ac:chgData name="Zied Belhocine" userId="200cc0e2b299676e" providerId="LiveId" clId="{36CCCAD6-9B8B-4ECC-B7BF-7E36B9ADD69A}" dt="2026-01-28T13:55:01.567" v="651" actId="478"/>
+          <ac:picMkLst>
+            <pc:docMk/>
+            <pc:sldMk cId="0" sldId="257"/>
+            <ac:picMk id="2" creationId="{D28E7D32-8AEC-5DCC-8123-0662C73CF435}"/>
+          </ac:picMkLst>
+        </pc:picChg>
+        <pc:picChg chg="add del mod">
+          <ac:chgData name="Zied Belhocine" userId="200cc0e2b299676e" providerId="LiveId" clId="{36CCCAD6-9B8B-4ECC-B7BF-7E36B9ADD69A}" dt="2026-01-28T13:46:30.979" v="629" actId="478"/>
           <ac:picMkLst>
             <pc:docMk/>
             <pc:sldMk cId="0" sldId="257"/>
             <ac:picMk id="3" creationId="{CE2D3E78-94E0-33A2-B003-41AFC89F1630}"/>
+          </ac:picMkLst>
+        </pc:picChg>
+        <pc:picChg chg="add del">
+          <ac:chgData name="Zied Belhocine" userId="200cc0e2b299676e" providerId="LiveId" clId="{36CCCAD6-9B8B-4ECC-B7BF-7E36B9ADD69A}" dt="2026-01-28T14:00:49.741" v="654" actId="478"/>
+          <ac:picMkLst>
+            <pc:docMk/>
+            <pc:sldMk cId="0" sldId="257"/>
+            <ac:picMk id="4" creationId="{7FCF4687-E68B-A097-149A-56A858B2D858}"/>
+          </ac:picMkLst>
+        </pc:picChg>
+        <pc:picChg chg="add mod">
+          <ac:chgData name="Zied Belhocine" userId="200cc0e2b299676e" providerId="LiveId" clId="{36CCCAD6-9B8B-4ECC-B7BF-7E36B9ADD69A}" dt="2026-01-28T14:02:56.529" v="691" actId="1076"/>
+          <ac:picMkLst>
+            <pc:docMk/>
+            <pc:sldMk cId="0" sldId="257"/>
+            <ac:picMk id="6" creationId="{E96593C4-5F17-1784-5D86-B25CEC5A0CFA}"/>
+          </ac:picMkLst>
+        </pc:picChg>
+        <pc:picChg chg="add mod">
+          <ac:chgData name="Zied Belhocine" userId="200cc0e2b299676e" providerId="LiveId" clId="{36CCCAD6-9B8B-4ECC-B7BF-7E36B9ADD69A}" dt="2026-01-28T14:02:53.193" v="689" actId="14100"/>
+          <ac:picMkLst>
+            <pc:docMk/>
+            <pc:sldMk cId="0" sldId="257"/>
+            <ac:picMk id="8" creationId="{E9E961B2-5A76-FBC0-4674-27E6CC2013E9}"/>
+          </ac:picMkLst>
+        </pc:picChg>
+        <pc:picChg chg="add mod">
+          <ac:chgData name="Zied Belhocine" userId="200cc0e2b299676e" providerId="LiveId" clId="{36CCCAD6-9B8B-4ECC-B7BF-7E36B9ADD69A}" dt="2026-01-28T14:02:48.848" v="687" actId="14100"/>
+          <ac:picMkLst>
+            <pc:docMk/>
+            <pc:sldMk cId="0" sldId="257"/>
+            <ac:picMk id="10" creationId="{D1AFCA19-923C-B2E1-4542-9FD9C8FB66C8}"/>
+          </ac:picMkLst>
+        </pc:picChg>
+        <pc:picChg chg="add mod">
+          <ac:chgData name="Zied Belhocine" userId="200cc0e2b299676e" providerId="LiveId" clId="{36CCCAD6-9B8B-4ECC-B7BF-7E36B9ADD69A}" dt="2026-01-28T14:02:50.931" v="688" actId="14100"/>
+          <ac:picMkLst>
+            <pc:docMk/>
+            <pc:sldMk cId="0" sldId="257"/>
+            <ac:picMk id="12" creationId="{8CE40920-D2F2-4DCD-E0DB-060718A0E545}"/>
           </ac:picMkLst>
         </pc:picChg>
         <pc:picChg chg="add del mod">
@@ -367,6 +490,568 @@
             <ac:picMk id="2050" creationId="{214EB35B-3934-99D3-0A18-A0B907F54F31}"/>
           </ac:picMkLst>
         </pc:picChg>
+        <pc:picChg chg="add del mod">
+          <ac:chgData name="Zied Belhocine" userId="200cc0e2b299676e" providerId="LiveId" clId="{36CCCAD6-9B8B-4ECC-B7BF-7E36B9ADD69A}" dt="2026-01-28T14:02:08.017" v="681" actId="478"/>
+          <ac:picMkLst>
+            <pc:docMk/>
+            <pc:sldMk cId="0" sldId="257"/>
+            <ac:picMk id="2050" creationId="{6C279282-AC02-04C4-F8C7-83DFA344BAFB}"/>
+          </ac:picMkLst>
+        </pc:picChg>
+        <pc:picChg chg="add del mod">
+          <ac:chgData name="Zied Belhocine" userId="200cc0e2b299676e" providerId="LiveId" clId="{36CCCAD6-9B8B-4ECC-B7BF-7E36B9ADD69A}" dt="2026-01-28T14:02:00.643" v="677" actId="478"/>
+          <ac:picMkLst>
+            <pc:docMk/>
+            <pc:sldMk cId="0" sldId="257"/>
+            <ac:picMk id="2052" creationId="{ADCC6600-870F-5D7C-DF83-ECCCF2E4873F}"/>
+          </ac:picMkLst>
+        </pc:picChg>
+        <pc:picChg chg="add del mod">
+          <ac:chgData name="Zied Belhocine" userId="200cc0e2b299676e" providerId="LiveId" clId="{36CCCAD6-9B8B-4ECC-B7BF-7E36B9ADD69A}" dt="2026-01-28T14:01:15.138" v="662" actId="478"/>
+          <ac:picMkLst>
+            <pc:docMk/>
+            <pc:sldMk cId="0" sldId="257"/>
+            <ac:picMk id="2054" creationId="{C43AEC59-FACF-7421-5D0E-673416DFEC31}"/>
+          </ac:picMkLst>
+        </pc:picChg>
+      </pc:sldChg>
+      <pc:sldChg chg="addSp delSp modSp mod">
+        <pc:chgData name="Zied Belhocine" userId="200cc0e2b299676e" providerId="LiveId" clId="{36CCCAD6-9B8B-4ECC-B7BF-7E36B9ADD69A}" dt="2026-01-28T14:14:47.297" v="1086" actId="14100"/>
+        <pc:sldMkLst>
+          <pc:docMk/>
+          <pc:sldMk cId="0" sldId="258"/>
+        </pc:sldMkLst>
+        <pc:spChg chg="add del mod">
+          <ac:chgData name="Zied Belhocine" userId="200cc0e2b299676e" providerId="LiveId" clId="{36CCCAD6-9B8B-4ECC-B7BF-7E36B9ADD69A}" dt="2026-01-28T14:09:54.591" v="943" actId="478"/>
+          <ac:spMkLst>
+            <pc:docMk/>
+            <pc:sldMk cId="0" sldId="258"/>
+            <ac:spMk id="4" creationId="{F7B36883-404B-4CE4-050C-5044F70B4A1E}"/>
+          </ac:spMkLst>
+        </pc:spChg>
+        <pc:spChg chg="add mod">
+          <ac:chgData name="Zied Belhocine" userId="200cc0e2b299676e" providerId="LiveId" clId="{36CCCAD6-9B8B-4ECC-B7BF-7E36B9ADD69A}" dt="2026-01-28T14:09:50.835" v="942" actId="20577"/>
+          <ac:spMkLst>
+            <pc:docMk/>
+            <pc:sldMk cId="0" sldId="258"/>
+            <ac:spMk id="6" creationId="{083BBDBB-4C1A-0131-5FF2-0FC124AAF63E}"/>
+          </ac:spMkLst>
+        </pc:spChg>
+        <pc:spChg chg="add del">
+          <ac:chgData name="Zied Belhocine" userId="200cc0e2b299676e" providerId="LiveId" clId="{36CCCAD6-9B8B-4ECC-B7BF-7E36B9ADD69A}" dt="2026-01-28T14:12:27.898" v="966" actId="478"/>
+          <ac:spMkLst>
+            <pc:docMk/>
+            <pc:sldMk cId="0" sldId="258"/>
+            <ac:spMk id="10" creationId="{481B25D7-E35C-FD08-E08B-B7CFB5D0C2E0}"/>
+          </ac:spMkLst>
+        </pc:spChg>
+        <pc:spChg chg="add mod">
+          <ac:chgData name="Zied Belhocine" userId="200cc0e2b299676e" providerId="LiveId" clId="{36CCCAD6-9B8B-4ECC-B7BF-7E36B9ADD69A}" dt="2026-01-28T14:14:33.287" v="1073" actId="14100"/>
+          <ac:spMkLst>
+            <pc:docMk/>
+            <pc:sldMk cId="0" sldId="258"/>
+            <ac:spMk id="12" creationId="{17D4718E-3242-053A-E02A-1051C4EDB346}"/>
+          </ac:spMkLst>
+        </pc:spChg>
+        <pc:spChg chg="add mod">
+          <ac:chgData name="Zied Belhocine" userId="200cc0e2b299676e" providerId="LiveId" clId="{36CCCAD6-9B8B-4ECC-B7BF-7E36B9ADD69A}" dt="2026-01-28T14:13:56.874" v="1045" actId="14100"/>
+          <ac:spMkLst>
+            <pc:docMk/>
+            <pc:sldMk cId="0" sldId="258"/>
+            <ac:spMk id="13" creationId="{061CF1BD-A45D-224F-ACCA-1E870EB53166}"/>
+          </ac:spMkLst>
+        </pc:spChg>
+        <pc:spChg chg="add mod">
+          <ac:chgData name="Zied Belhocine" userId="200cc0e2b299676e" providerId="LiveId" clId="{36CCCAD6-9B8B-4ECC-B7BF-7E36B9ADD69A}" dt="2026-01-28T14:14:47.297" v="1086" actId="14100"/>
+          <ac:spMkLst>
+            <pc:docMk/>
+            <pc:sldMk cId="0" sldId="258"/>
+            <ac:spMk id="14" creationId="{CD6A90EC-6099-7E3B-C134-5FA9C0719DC6}"/>
+          </ac:spMkLst>
+        </pc:spChg>
+        <pc:spChg chg="del mod">
+          <ac:chgData name="Zied Belhocine" userId="200cc0e2b299676e" providerId="LiveId" clId="{36CCCAD6-9B8B-4ECC-B7BF-7E36B9ADD69A}" dt="2026-01-28T14:07:20.192" v="813" actId="478"/>
+          <ac:spMkLst>
+            <pc:docMk/>
+            <pc:sldMk cId="0" sldId="258"/>
+            <ac:spMk id="138" creationId="{00000000-0000-0000-0000-000000000000}"/>
+          </ac:spMkLst>
+        </pc:spChg>
+        <pc:spChg chg="del mod">
+          <ac:chgData name="Zied Belhocine" userId="200cc0e2b299676e" providerId="LiveId" clId="{36CCCAD6-9B8B-4ECC-B7BF-7E36B9ADD69A}" dt="2026-01-28T14:10:05.233" v="946" actId="478"/>
+          <ac:spMkLst>
+            <pc:docMk/>
+            <pc:sldMk cId="0" sldId="258"/>
+            <ac:spMk id="139" creationId="{00000000-0000-0000-0000-000000000000}"/>
+          </ac:spMkLst>
+        </pc:spChg>
+        <pc:spChg chg="del mod">
+          <ac:chgData name="Zied Belhocine" userId="200cc0e2b299676e" providerId="LiveId" clId="{36CCCAD6-9B8B-4ECC-B7BF-7E36B9ADD69A}" dt="2026-01-28T14:09:01.050" v="823" actId="478"/>
+          <ac:spMkLst>
+            <pc:docMk/>
+            <pc:sldMk cId="0" sldId="258"/>
+            <ac:spMk id="140" creationId="{00000000-0000-0000-0000-000000000000}"/>
+          </ac:spMkLst>
+        </pc:spChg>
+        <pc:picChg chg="add mod">
+          <ac:chgData name="Zied Belhocine" userId="200cc0e2b299676e" providerId="LiveId" clId="{36CCCAD6-9B8B-4ECC-B7BF-7E36B9ADD69A}" dt="2026-01-28T14:12:56.573" v="977" actId="1076"/>
+          <ac:picMkLst>
+            <pc:docMk/>
+            <pc:sldMk cId="0" sldId="258"/>
+            <ac:picMk id="2" creationId="{3B15BA9A-FE9C-13C9-8D6D-B0203B27CDA7}"/>
+          </ac:picMkLst>
+        </pc:picChg>
+        <pc:picChg chg="add del mod">
+          <ac:chgData name="Zied Belhocine" userId="200cc0e2b299676e" providerId="LiveId" clId="{36CCCAD6-9B8B-4ECC-B7BF-7E36B9ADD69A}" dt="2026-01-28T14:11:20.594" v="958" actId="478"/>
+          <ac:picMkLst>
+            <pc:docMk/>
+            <pc:sldMk cId="0" sldId="258"/>
+            <ac:picMk id="5" creationId="{4A8E4176-E6F9-1602-FE27-A69B18B73E4F}"/>
+          </ac:picMkLst>
+        </pc:picChg>
+        <pc:picChg chg="add mod">
+          <ac:chgData name="Zied Belhocine" userId="200cc0e2b299676e" providerId="LiveId" clId="{36CCCAD6-9B8B-4ECC-B7BF-7E36B9ADD69A}" dt="2026-01-28T14:12:56.573" v="977" actId="1076"/>
+          <ac:picMkLst>
+            <pc:docMk/>
+            <pc:sldMk cId="0" sldId="258"/>
+            <ac:picMk id="7" creationId="{B990FCBC-1B23-B5D7-6316-6C6F69C6756D}"/>
+          </ac:picMkLst>
+        </pc:picChg>
+        <pc:picChg chg="add mod">
+          <ac:chgData name="Zied Belhocine" userId="200cc0e2b299676e" providerId="LiveId" clId="{36CCCAD6-9B8B-4ECC-B7BF-7E36B9ADD69A}" dt="2026-01-28T14:12:56.573" v="977" actId="1076"/>
+          <ac:picMkLst>
+            <pc:docMk/>
+            <pc:sldMk cId="0" sldId="258"/>
+            <ac:picMk id="8" creationId="{04931248-A79D-0AF4-F81B-E47B6EF5BB30}"/>
+          </ac:picMkLst>
+        </pc:picChg>
+        <pc:picChg chg="add mod">
+          <ac:chgData name="Zied Belhocine" userId="200cc0e2b299676e" providerId="LiveId" clId="{36CCCAD6-9B8B-4ECC-B7BF-7E36B9ADD69A}" dt="2026-01-28T14:12:56.573" v="977" actId="1076"/>
+          <ac:picMkLst>
+            <pc:docMk/>
+            <pc:sldMk cId="0" sldId="258"/>
+            <ac:picMk id="11" creationId="{2D223084-931D-FFB2-E638-36887CF766F6}"/>
+          </ac:picMkLst>
+        </pc:picChg>
+        <pc:picChg chg="add del mod">
+          <ac:chgData name="Zied Belhocine" userId="200cc0e2b299676e" providerId="LiveId" clId="{36CCCAD6-9B8B-4ECC-B7BF-7E36B9ADD69A}" dt="2026-01-28T13:41:44.611" v="537" actId="478"/>
+          <ac:picMkLst>
+            <pc:docMk/>
+            <pc:sldMk cId="0" sldId="258"/>
+            <ac:picMk id="1026" creationId="{AFB696D4-79A7-79E1-B0D4-02C508BD5AF5}"/>
+          </ac:picMkLst>
+        </pc:picChg>
+        <pc:picChg chg="add del mod">
+          <ac:chgData name="Zied Belhocine" userId="200cc0e2b299676e" providerId="LiveId" clId="{36CCCAD6-9B8B-4ECC-B7BF-7E36B9ADD69A}" dt="2026-01-28T14:07:17.615" v="811" actId="478"/>
+          <ac:picMkLst>
+            <pc:docMk/>
+            <pc:sldMk cId="0" sldId="258"/>
+            <ac:picMk id="1028" creationId="{C2755AE2-D2BE-E4A2-2E1A-DB018DD7A3D5}"/>
+          </ac:picMkLst>
+        </pc:picChg>
+      </pc:sldChg>
+      <pc:sldChg chg="modSp mod">
+        <pc:chgData name="Zied Belhocine" userId="200cc0e2b299676e" providerId="LiveId" clId="{36CCCAD6-9B8B-4ECC-B7BF-7E36B9ADD69A}" dt="2026-01-28T14:29:59.048" v="1088" actId="2711"/>
+        <pc:sldMkLst>
+          <pc:docMk/>
+          <pc:sldMk cId="0" sldId="259"/>
+        </pc:sldMkLst>
+        <pc:spChg chg="mod">
+          <ac:chgData name="Zied Belhocine" userId="200cc0e2b299676e" providerId="LiveId" clId="{36CCCAD6-9B8B-4ECC-B7BF-7E36B9ADD69A}" dt="2026-01-28T14:29:59.048" v="1088" actId="2711"/>
+          <ac:spMkLst>
+            <pc:docMk/>
+            <pc:sldMk cId="0" sldId="259"/>
+            <ac:spMk id="145" creationId="{00000000-0000-0000-0000-000000000000}"/>
+          </ac:spMkLst>
+        </pc:spChg>
+        <pc:spChg chg="mod">
+          <ac:chgData name="Zied Belhocine" userId="200cc0e2b299676e" providerId="LiveId" clId="{36CCCAD6-9B8B-4ECC-B7BF-7E36B9ADD69A}" dt="2026-01-28T14:29:59.048" v="1088" actId="2711"/>
+          <ac:spMkLst>
+            <pc:docMk/>
+            <pc:sldMk cId="0" sldId="259"/>
+            <ac:spMk id="146" creationId="{00000000-0000-0000-0000-000000000000}"/>
+          </ac:spMkLst>
+        </pc:spChg>
+        <pc:spChg chg="mod">
+          <ac:chgData name="Zied Belhocine" userId="200cc0e2b299676e" providerId="LiveId" clId="{36CCCAD6-9B8B-4ECC-B7BF-7E36B9ADD69A}" dt="2026-01-28T14:29:59.048" v="1088" actId="2711"/>
+          <ac:spMkLst>
+            <pc:docMk/>
+            <pc:sldMk cId="0" sldId="259"/>
+            <ac:spMk id="147" creationId="{00000000-0000-0000-0000-000000000000}"/>
+          </ac:spMkLst>
+        </pc:spChg>
+      </pc:sldChg>
+      <pc:sldChg chg="modSp mod">
+        <pc:chgData name="Zied Belhocine" userId="200cc0e2b299676e" providerId="LiveId" clId="{36CCCAD6-9B8B-4ECC-B7BF-7E36B9ADD69A}" dt="2026-01-28T14:30:03.517" v="1089" actId="2711"/>
+        <pc:sldMkLst>
+          <pc:docMk/>
+          <pc:sldMk cId="0" sldId="260"/>
+        </pc:sldMkLst>
+        <pc:spChg chg="mod">
+          <ac:chgData name="Zied Belhocine" userId="200cc0e2b299676e" providerId="LiveId" clId="{36CCCAD6-9B8B-4ECC-B7BF-7E36B9ADD69A}" dt="2026-01-28T14:30:03.517" v="1089" actId="2711"/>
+          <ac:spMkLst>
+            <pc:docMk/>
+            <pc:sldMk cId="0" sldId="260"/>
+            <ac:spMk id="152" creationId="{00000000-0000-0000-0000-000000000000}"/>
+          </ac:spMkLst>
+        </pc:spChg>
+        <pc:spChg chg="mod">
+          <ac:chgData name="Zied Belhocine" userId="200cc0e2b299676e" providerId="LiveId" clId="{36CCCAD6-9B8B-4ECC-B7BF-7E36B9ADD69A}" dt="2026-01-28T14:30:03.517" v="1089" actId="2711"/>
+          <ac:spMkLst>
+            <pc:docMk/>
+            <pc:sldMk cId="0" sldId="260"/>
+            <ac:spMk id="153" creationId="{00000000-0000-0000-0000-000000000000}"/>
+          </ac:spMkLst>
+        </pc:spChg>
+        <pc:spChg chg="mod">
+          <ac:chgData name="Zied Belhocine" userId="200cc0e2b299676e" providerId="LiveId" clId="{36CCCAD6-9B8B-4ECC-B7BF-7E36B9ADD69A}" dt="2026-01-28T14:30:03.517" v="1089" actId="2711"/>
+          <ac:spMkLst>
+            <pc:docMk/>
+            <pc:sldMk cId="0" sldId="260"/>
+            <ac:spMk id="154" creationId="{00000000-0000-0000-0000-000000000000}"/>
+          </ac:spMkLst>
+        </pc:spChg>
+      </pc:sldChg>
+      <pc:sldChg chg="modSp mod">
+        <pc:chgData name="Zied Belhocine" userId="200cc0e2b299676e" providerId="LiveId" clId="{36CCCAD6-9B8B-4ECC-B7BF-7E36B9ADD69A}" dt="2026-01-28T14:30:15.889" v="1091" actId="2711"/>
+        <pc:sldMkLst>
+          <pc:docMk/>
+          <pc:sldMk cId="0" sldId="261"/>
+        </pc:sldMkLst>
+        <pc:spChg chg="mod">
+          <ac:chgData name="Zied Belhocine" userId="200cc0e2b299676e" providerId="LiveId" clId="{36CCCAD6-9B8B-4ECC-B7BF-7E36B9ADD69A}" dt="2026-01-28T14:30:15.889" v="1091" actId="2711"/>
+          <ac:spMkLst>
+            <pc:docMk/>
+            <pc:sldMk cId="0" sldId="261"/>
+            <ac:spMk id="159" creationId="{00000000-0000-0000-0000-000000000000}"/>
+          </ac:spMkLst>
+        </pc:spChg>
+        <pc:spChg chg="mod">
+          <ac:chgData name="Zied Belhocine" userId="200cc0e2b299676e" providerId="LiveId" clId="{36CCCAD6-9B8B-4ECC-B7BF-7E36B9ADD69A}" dt="2026-01-28T14:30:15.889" v="1091" actId="2711"/>
+          <ac:spMkLst>
+            <pc:docMk/>
+            <pc:sldMk cId="0" sldId="261"/>
+            <ac:spMk id="160" creationId="{00000000-0000-0000-0000-000000000000}"/>
+          </ac:spMkLst>
+        </pc:spChg>
+        <pc:spChg chg="mod">
+          <ac:chgData name="Zied Belhocine" userId="200cc0e2b299676e" providerId="LiveId" clId="{36CCCAD6-9B8B-4ECC-B7BF-7E36B9ADD69A}" dt="2026-01-28T14:30:15.889" v="1091" actId="2711"/>
+          <ac:spMkLst>
+            <pc:docMk/>
+            <pc:sldMk cId="0" sldId="261"/>
+            <ac:spMk id="161" creationId="{00000000-0000-0000-0000-000000000000}"/>
+          </ac:spMkLst>
+        </pc:spChg>
+      </pc:sldChg>
+      <pc:sldChg chg="modSp mod setBg">
+        <pc:chgData name="Zied Belhocine" userId="200cc0e2b299676e" providerId="LiveId" clId="{36CCCAD6-9B8B-4ECC-B7BF-7E36B9ADD69A}" dt="2026-01-28T14:30:27.238" v="1093"/>
+        <pc:sldMkLst>
+          <pc:docMk/>
+          <pc:sldMk cId="0" sldId="262"/>
+        </pc:sldMkLst>
+        <pc:spChg chg="mod">
+          <ac:chgData name="Zied Belhocine" userId="200cc0e2b299676e" providerId="LiveId" clId="{36CCCAD6-9B8B-4ECC-B7BF-7E36B9ADD69A}" dt="2026-01-28T14:30:27.238" v="1093"/>
+          <ac:spMkLst>
+            <pc:docMk/>
+            <pc:sldMk cId="0" sldId="262"/>
+            <ac:spMk id="166" creationId="{00000000-0000-0000-0000-000000000000}"/>
+          </ac:spMkLst>
+        </pc:spChg>
+        <pc:spChg chg="mod">
+          <ac:chgData name="Zied Belhocine" userId="200cc0e2b299676e" providerId="LiveId" clId="{36CCCAD6-9B8B-4ECC-B7BF-7E36B9ADD69A}" dt="2026-01-28T14:30:27.238" v="1093"/>
+          <ac:spMkLst>
+            <pc:docMk/>
+            <pc:sldMk cId="0" sldId="262"/>
+            <ac:spMk id="167" creationId="{00000000-0000-0000-0000-000000000000}"/>
+          </ac:spMkLst>
+        </pc:spChg>
+        <pc:spChg chg="mod">
+          <ac:chgData name="Zied Belhocine" userId="200cc0e2b299676e" providerId="LiveId" clId="{36CCCAD6-9B8B-4ECC-B7BF-7E36B9ADD69A}" dt="2026-01-28T14:30:24.145" v="1092" actId="2711"/>
+          <ac:spMkLst>
+            <pc:docMk/>
+            <pc:sldMk cId="0" sldId="262"/>
+            <ac:spMk id="168" creationId="{00000000-0000-0000-0000-000000000000}"/>
+          </ac:spMkLst>
+        </pc:spChg>
+        <pc:spChg chg="mod">
+          <ac:chgData name="Zied Belhocine" userId="200cc0e2b299676e" providerId="LiveId" clId="{36CCCAD6-9B8B-4ECC-B7BF-7E36B9ADD69A}" dt="2026-01-28T14:30:24.145" v="1092" actId="2711"/>
+          <ac:spMkLst>
+            <pc:docMk/>
+            <pc:sldMk cId="0" sldId="262"/>
+            <ac:spMk id="169" creationId="{00000000-0000-0000-0000-000000000000}"/>
+          </ac:spMkLst>
+        </pc:spChg>
+      </pc:sldChg>
+      <pc:sldChg chg="modSp mod setBg">
+        <pc:chgData name="Zied Belhocine" userId="200cc0e2b299676e" providerId="LiveId" clId="{36CCCAD6-9B8B-4ECC-B7BF-7E36B9ADD69A}" dt="2026-01-28T14:30:33.694" v="1095" actId="2711"/>
+        <pc:sldMkLst>
+          <pc:docMk/>
+          <pc:sldMk cId="0" sldId="263"/>
+        </pc:sldMkLst>
+        <pc:spChg chg="mod">
+          <ac:chgData name="Zied Belhocine" userId="200cc0e2b299676e" providerId="LiveId" clId="{36CCCAD6-9B8B-4ECC-B7BF-7E36B9ADD69A}" dt="2026-01-28T14:30:33.694" v="1095" actId="2711"/>
+          <ac:spMkLst>
+            <pc:docMk/>
+            <pc:sldMk cId="0" sldId="263"/>
+            <ac:spMk id="174" creationId="{00000000-0000-0000-0000-000000000000}"/>
+          </ac:spMkLst>
+        </pc:spChg>
+        <pc:spChg chg="mod">
+          <ac:chgData name="Zied Belhocine" userId="200cc0e2b299676e" providerId="LiveId" clId="{36CCCAD6-9B8B-4ECC-B7BF-7E36B9ADD69A}" dt="2026-01-28T14:30:33.694" v="1095" actId="2711"/>
+          <ac:spMkLst>
+            <pc:docMk/>
+            <pc:sldMk cId="0" sldId="263"/>
+            <ac:spMk id="175" creationId="{00000000-0000-0000-0000-000000000000}"/>
+          </ac:spMkLst>
+        </pc:spChg>
+        <pc:spChg chg="mod">
+          <ac:chgData name="Zied Belhocine" userId="200cc0e2b299676e" providerId="LiveId" clId="{36CCCAD6-9B8B-4ECC-B7BF-7E36B9ADD69A}" dt="2026-01-28T14:30:33.694" v="1095" actId="2711"/>
+          <ac:spMkLst>
+            <pc:docMk/>
+            <pc:sldMk cId="0" sldId="263"/>
+            <ac:spMk id="176" creationId="{00000000-0000-0000-0000-000000000000}"/>
+          </ac:spMkLst>
+        </pc:spChg>
+      </pc:sldChg>
+      <pc:sldChg chg="modSp mod">
+        <pc:chgData name="Zied Belhocine" userId="200cc0e2b299676e" providerId="LiveId" clId="{36CCCAD6-9B8B-4ECC-B7BF-7E36B9ADD69A}" dt="2026-01-28T14:30:43.739" v="1096" actId="2711"/>
+        <pc:sldMkLst>
+          <pc:docMk/>
+          <pc:sldMk cId="0" sldId="264"/>
+        </pc:sldMkLst>
+        <pc:spChg chg="mod">
+          <ac:chgData name="Zied Belhocine" userId="200cc0e2b299676e" providerId="LiveId" clId="{36CCCAD6-9B8B-4ECC-B7BF-7E36B9ADD69A}" dt="2026-01-28T14:30:43.739" v="1096" actId="2711"/>
+          <ac:spMkLst>
+            <pc:docMk/>
+            <pc:sldMk cId="0" sldId="264"/>
+            <ac:spMk id="181" creationId="{00000000-0000-0000-0000-000000000000}"/>
+          </ac:spMkLst>
+        </pc:spChg>
+        <pc:spChg chg="mod">
+          <ac:chgData name="Zied Belhocine" userId="200cc0e2b299676e" providerId="LiveId" clId="{36CCCAD6-9B8B-4ECC-B7BF-7E36B9ADD69A}" dt="2026-01-28T14:30:43.739" v="1096" actId="2711"/>
+          <ac:spMkLst>
+            <pc:docMk/>
+            <pc:sldMk cId="0" sldId="264"/>
+            <ac:spMk id="182" creationId="{00000000-0000-0000-0000-000000000000}"/>
+          </ac:spMkLst>
+        </pc:spChg>
+        <pc:spChg chg="mod">
+          <ac:chgData name="Zied Belhocine" userId="200cc0e2b299676e" providerId="LiveId" clId="{36CCCAD6-9B8B-4ECC-B7BF-7E36B9ADD69A}" dt="2026-01-28T14:30:43.739" v="1096" actId="2711"/>
+          <ac:spMkLst>
+            <pc:docMk/>
+            <pc:sldMk cId="0" sldId="264"/>
+            <ac:spMk id="183" creationId="{00000000-0000-0000-0000-000000000000}"/>
+          </ac:spMkLst>
+        </pc:spChg>
+      </pc:sldChg>
+      <pc:sldChg chg="modSp mod">
+        <pc:chgData name="Zied Belhocine" userId="200cc0e2b299676e" providerId="LiveId" clId="{36CCCAD6-9B8B-4ECC-B7BF-7E36B9ADD69A}" dt="2026-01-28T14:31:00.316" v="1101" actId="2711"/>
+        <pc:sldMkLst>
+          <pc:docMk/>
+          <pc:sldMk cId="0" sldId="265"/>
+        </pc:sldMkLst>
+        <pc:spChg chg="mod">
+          <ac:chgData name="Zied Belhocine" userId="200cc0e2b299676e" providerId="LiveId" clId="{36CCCAD6-9B8B-4ECC-B7BF-7E36B9ADD69A}" dt="2026-01-28T14:31:00.316" v="1101" actId="2711"/>
+          <ac:spMkLst>
+            <pc:docMk/>
+            <pc:sldMk cId="0" sldId="265"/>
+            <ac:spMk id="188" creationId="{00000000-0000-0000-0000-000000000000}"/>
+          </ac:spMkLst>
+        </pc:spChg>
+        <pc:spChg chg="mod">
+          <ac:chgData name="Zied Belhocine" userId="200cc0e2b299676e" providerId="LiveId" clId="{36CCCAD6-9B8B-4ECC-B7BF-7E36B9ADD69A}" dt="2026-01-28T14:31:00.316" v="1101" actId="2711"/>
+          <ac:spMkLst>
+            <pc:docMk/>
+            <pc:sldMk cId="0" sldId="265"/>
+            <ac:spMk id="189" creationId="{00000000-0000-0000-0000-000000000000}"/>
+          </ac:spMkLst>
+        </pc:spChg>
+        <pc:spChg chg="mod">
+          <ac:chgData name="Zied Belhocine" userId="200cc0e2b299676e" providerId="LiveId" clId="{36CCCAD6-9B8B-4ECC-B7BF-7E36B9ADD69A}" dt="2026-01-28T14:31:00.316" v="1101" actId="2711"/>
+          <ac:spMkLst>
+            <pc:docMk/>
+            <pc:sldMk cId="0" sldId="265"/>
+            <ac:spMk id="190" creationId="{00000000-0000-0000-0000-000000000000}"/>
+          </ac:spMkLst>
+        </pc:spChg>
+      </pc:sldChg>
+      <pc:sldChg chg="modSp mod">
+        <pc:chgData name="Zied Belhocine" userId="200cc0e2b299676e" providerId="LiveId" clId="{36CCCAD6-9B8B-4ECC-B7BF-7E36B9ADD69A}" dt="2026-01-28T14:31:12.402" v="1104" actId="2711"/>
+        <pc:sldMkLst>
+          <pc:docMk/>
+          <pc:sldMk cId="0" sldId="266"/>
+        </pc:sldMkLst>
+        <pc:spChg chg="mod">
+          <ac:chgData name="Zied Belhocine" userId="200cc0e2b299676e" providerId="LiveId" clId="{36CCCAD6-9B8B-4ECC-B7BF-7E36B9ADD69A}" dt="2026-01-28T14:31:12.402" v="1104" actId="2711"/>
+          <ac:spMkLst>
+            <pc:docMk/>
+            <pc:sldMk cId="0" sldId="266"/>
+            <ac:spMk id="195" creationId="{00000000-0000-0000-0000-000000000000}"/>
+          </ac:spMkLst>
+        </pc:spChg>
+        <pc:spChg chg="mod">
+          <ac:chgData name="Zied Belhocine" userId="200cc0e2b299676e" providerId="LiveId" clId="{36CCCAD6-9B8B-4ECC-B7BF-7E36B9ADD69A}" dt="2026-01-28T14:31:12.402" v="1104" actId="2711"/>
+          <ac:spMkLst>
+            <pc:docMk/>
+            <pc:sldMk cId="0" sldId="266"/>
+            <ac:spMk id="196" creationId="{00000000-0000-0000-0000-000000000000}"/>
+          </ac:spMkLst>
+        </pc:spChg>
+        <pc:spChg chg="mod">
+          <ac:chgData name="Zied Belhocine" userId="200cc0e2b299676e" providerId="LiveId" clId="{36CCCAD6-9B8B-4ECC-B7BF-7E36B9ADD69A}" dt="2026-01-28T14:31:12.402" v="1104" actId="2711"/>
+          <ac:spMkLst>
+            <pc:docMk/>
+            <pc:sldMk cId="0" sldId="266"/>
+            <ac:spMk id="197" creationId="{00000000-0000-0000-0000-000000000000}"/>
+          </ac:spMkLst>
+        </pc:spChg>
+      </pc:sldChg>
+      <pc:sldChg chg="modSp mod">
+        <pc:chgData name="Zied Belhocine" userId="200cc0e2b299676e" providerId="LiveId" clId="{36CCCAD6-9B8B-4ECC-B7BF-7E36B9ADD69A}" dt="2026-01-28T14:31:25.076" v="1105" actId="2711"/>
+        <pc:sldMkLst>
+          <pc:docMk/>
+          <pc:sldMk cId="0" sldId="267"/>
+        </pc:sldMkLst>
+        <pc:spChg chg="mod">
+          <ac:chgData name="Zied Belhocine" userId="200cc0e2b299676e" providerId="LiveId" clId="{36CCCAD6-9B8B-4ECC-B7BF-7E36B9ADD69A}" dt="2026-01-28T14:31:25.076" v="1105" actId="2711"/>
+          <ac:spMkLst>
+            <pc:docMk/>
+            <pc:sldMk cId="0" sldId="267"/>
+            <ac:spMk id="202" creationId="{00000000-0000-0000-0000-000000000000}"/>
+          </ac:spMkLst>
+        </pc:spChg>
+        <pc:spChg chg="mod">
+          <ac:chgData name="Zied Belhocine" userId="200cc0e2b299676e" providerId="LiveId" clId="{36CCCAD6-9B8B-4ECC-B7BF-7E36B9ADD69A}" dt="2026-01-28T14:31:25.076" v="1105" actId="2711"/>
+          <ac:spMkLst>
+            <pc:docMk/>
+            <pc:sldMk cId="0" sldId="267"/>
+            <ac:spMk id="203" creationId="{00000000-0000-0000-0000-000000000000}"/>
+          </ac:spMkLst>
+        </pc:spChg>
+        <pc:spChg chg="mod">
+          <ac:chgData name="Zied Belhocine" userId="200cc0e2b299676e" providerId="LiveId" clId="{36CCCAD6-9B8B-4ECC-B7BF-7E36B9ADD69A}" dt="2026-01-28T14:31:25.076" v="1105" actId="2711"/>
+          <ac:spMkLst>
+            <pc:docMk/>
+            <pc:sldMk cId="0" sldId="267"/>
+            <ac:spMk id="204" creationId="{00000000-0000-0000-0000-000000000000}"/>
+          </ac:spMkLst>
+        </pc:spChg>
+      </pc:sldChg>
+      <pc:sldChg chg="modSp mod">
+        <pc:chgData name="Zied Belhocine" userId="200cc0e2b299676e" providerId="LiveId" clId="{36CCCAD6-9B8B-4ECC-B7BF-7E36B9ADD69A}" dt="2026-01-28T14:31:29.988" v="1106" actId="2711"/>
+        <pc:sldMkLst>
+          <pc:docMk/>
+          <pc:sldMk cId="0" sldId="268"/>
+        </pc:sldMkLst>
+        <pc:spChg chg="mod">
+          <ac:chgData name="Zied Belhocine" userId="200cc0e2b299676e" providerId="LiveId" clId="{36CCCAD6-9B8B-4ECC-B7BF-7E36B9ADD69A}" dt="2026-01-28T14:31:29.988" v="1106" actId="2711"/>
+          <ac:spMkLst>
+            <pc:docMk/>
+            <pc:sldMk cId="0" sldId="268"/>
+            <ac:spMk id="209" creationId="{00000000-0000-0000-0000-000000000000}"/>
+          </ac:spMkLst>
+        </pc:spChg>
+        <pc:spChg chg="mod">
+          <ac:chgData name="Zied Belhocine" userId="200cc0e2b299676e" providerId="LiveId" clId="{36CCCAD6-9B8B-4ECC-B7BF-7E36B9ADD69A}" dt="2026-01-28T14:31:29.988" v="1106" actId="2711"/>
+          <ac:spMkLst>
+            <pc:docMk/>
+            <pc:sldMk cId="0" sldId="268"/>
+            <ac:spMk id="210" creationId="{00000000-0000-0000-0000-000000000000}"/>
+          </ac:spMkLst>
+        </pc:spChg>
+        <pc:spChg chg="mod">
+          <ac:chgData name="Zied Belhocine" userId="200cc0e2b299676e" providerId="LiveId" clId="{36CCCAD6-9B8B-4ECC-B7BF-7E36B9ADD69A}" dt="2026-01-28T14:31:29.988" v="1106" actId="2711"/>
+          <ac:spMkLst>
+            <pc:docMk/>
+            <pc:sldMk cId="0" sldId="268"/>
+            <ac:spMk id="211" creationId="{00000000-0000-0000-0000-000000000000}"/>
+          </ac:spMkLst>
+        </pc:spChg>
+      </pc:sldChg>
+      <pc:sldChg chg="modSp mod">
+        <pc:chgData name="Zied Belhocine" userId="200cc0e2b299676e" providerId="LiveId" clId="{36CCCAD6-9B8B-4ECC-B7BF-7E36B9ADD69A}" dt="2026-01-28T14:31:37.731" v="1109" actId="2711"/>
+        <pc:sldMkLst>
+          <pc:docMk/>
+          <pc:sldMk cId="0" sldId="269"/>
+        </pc:sldMkLst>
+        <pc:spChg chg="mod">
+          <ac:chgData name="Zied Belhocine" userId="200cc0e2b299676e" providerId="LiveId" clId="{36CCCAD6-9B8B-4ECC-B7BF-7E36B9ADD69A}" dt="2026-01-28T14:31:37.731" v="1109" actId="2711"/>
+          <ac:spMkLst>
+            <pc:docMk/>
+            <pc:sldMk cId="0" sldId="269"/>
+            <ac:spMk id="216" creationId="{00000000-0000-0000-0000-000000000000}"/>
+          </ac:spMkLst>
+        </pc:spChg>
+        <pc:spChg chg="mod">
+          <ac:chgData name="Zied Belhocine" userId="200cc0e2b299676e" providerId="LiveId" clId="{36CCCAD6-9B8B-4ECC-B7BF-7E36B9ADD69A}" dt="2026-01-28T14:31:37.731" v="1109" actId="2711"/>
+          <ac:spMkLst>
+            <pc:docMk/>
+            <pc:sldMk cId="0" sldId="269"/>
+            <ac:spMk id="217" creationId="{00000000-0000-0000-0000-000000000000}"/>
+          </ac:spMkLst>
+        </pc:spChg>
+        <pc:spChg chg="mod">
+          <ac:chgData name="Zied Belhocine" userId="200cc0e2b299676e" providerId="LiveId" clId="{36CCCAD6-9B8B-4ECC-B7BF-7E36B9ADD69A}" dt="2026-01-28T14:31:37.731" v="1109" actId="2711"/>
+          <ac:spMkLst>
+            <pc:docMk/>
+            <pc:sldMk cId="0" sldId="269"/>
+            <ac:spMk id="218" creationId="{00000000-0000-0000-0000-000000000000}"/>
+          </ac:spMkLst>
+        </pc:spChg>
+      </pc:sldChg>
+      <pc:sldChg chg="modSp mod">
+        <pc:chgData name="Zied Belhocine" userId="200cc0e2b299676e" providerId="LiveId" clId="{36CCCAD6-9B8B-4ECC-B7BF-7E36B9ADD69A}" dt="2026-01-28T14:31:43.852" v="1110" actId="2711"/>
+        <pc:sldMkLst>
+          <pc:docMk/>
+          <pc:sldMk cId="0" sldId="270"/>
+        </pc:sldMkLst>
+        <pc:spChg chg="mod">
+          <ac:chgData name="Zied Belhocine" userId="200cc0e2b299676e" providerId="LiveId" clId="{36CCCAD6-9B8B-4ECC-B7BF-7E36B9ADD69A}" dt="2026-01-28T14:31:43.852" v="1110" actId="2711"/>
+          <ac:spMkLst>
+            <pc:docMk/>
+            <pc:sldMk cId="0" sldId="270"/>
+            <ac:spMk id="223" creationId="{00000000-0000-0000-0000-000000000000}"/>
+          </ac:spMkLst>
+        </pc:spChg>
+        <pc:spChg chg="mod">
+          <ac:chgData name="Zied Belhocine" userId="200cc0e2b299676e" providerId="LiveId" clId="{36CCCAD6-9B8B-4ECC-B7BF-7E36B9ADD69A}" dt="2026-01-28T14:31:43.852" v="1110" actId="2711"/>
+          <ac:spMkLst>
+            <pc:docMk/>
+            <pc:sldMk cId="0" sldId="270"/>
+            <ac:spMk id="224" creationId="{00000000-0000-0000-0000-000000000000}"/>
+          </ac:spMkLst>
+        </pc:spChg>
+        <pc:spChg chg="mod">
+          <ac:chgData name="Zied Belhocine" userId="200cc0e2b299676e" providerId="LiveId" clId="{36CCCAD6-9B8B-4ECC-B7BF-7E36B9ADD69A}" dt="2026-01-28T14:31:43.852" v="1110" actId="2711"/>
+          <ac:spMkLst>
+            <pc:docMk/>
+            <pc:sldMk cId="0" sldId="270"/>
+            <ac:spMk id="225" creationId="{00000000-0000-0000-0000-000000000000}"/>
+          </ac:spMkLst>
+        </pc:spChg>
+      </pc:sldChg>
+      <pc:sldChg chg="modSp mod">
+        <pc:chgData name="Zied Belhocine" userId="200cc0e2b299676e" providerId="LiveId" clId="{36CCCAD6-9B8B-4ECC-B7BF-7E36B9ADD69A}" dt="2026-01-28T14:31:50.018" v="1111" actId="2711"/>
+        <pc:sldMkLst>
+          <pc:docMk/>
+          <pc:sldMk cId="0" sldId="271"/>
+        </pc:sldMkLst>
+        <pc:spChg chg="mod">
+          <ac:chgData name="Zied Belhocine" userId="200cc0e2b299676e" providerId="LiveId" clId="{36CCCAD6-9B8B-4ECC-B7BF-7E36B9ADD69A}" dt="2026-01-28T14:31:50.018" v="1111" actId="2711"/>
+          <ac:spMkLst>
+            <pc:docMk/>
+            <pc:sldMk cId="0" sldId="271"/>
+            <ac:spMk id="230" creationId="{00000000-0000-0000-0000-000000000000}"/>
+          </ac:spMkLst>
+        </pc:spChg>
+        <pc:spChg chg="mod">
+          <ac:chgData name="Zied Belhocine" userId="200cc0e2b299676e" providerId="LiveId" clId="{36CCCAD6-9B8B-4ECC-B7BF-7E36B9ADD69A}" dt="2026-01-28T14:31:50.018" v="1111" actId="2711"/>
+          <ac:spMkLst>
+            <pc:docMk/>
+            <pc:sldMk cId="0" sldId="271"/>
+            <ac:spMk id="231" creationId="{00000000-0000-0000-0000-000000000000}"/>
+          </ac:spMkLst>
+        </pc:spChg>
       </pc:sldChg>
     </pc:docChg>
   </pc:docChgLst>
@@ -21514,7 +22199,7 @@
               <a:solidFill>
                 <a:schemeClr val="lt1"/>
               </a:solidFill>
-              <a:latin typeface="Century Gothic"/>
+              <a:latin typeface="Century Gothic" panose="020B0502020202020204" pitchFamily="34" charset="0"/>
               <a:ea typeface="Century Gothic"/>
               <a:cs typeface="Century Gothic"/>
               <a:sym typeface="Century Gothic"/>
@@ -21691,9 +22376,7 @@
               <a:solidFill>
                 <a:srgbClr val="000000"/>
               </a:solidFill>
-              <a:latin typeface="Arial"/>
-              <a:ea typeface="Arial"/>
-              <a:cs typeface="Arial"/>
+              <a:latin typeface="Century Gothic" panose="020B0502020202020204" pitchFamily="34" charset="0"/>
               <a:sym typeface="Arial"/>
             </a:endParaRPr>
           </a:p>
@@ -21749,10 +22432,14 @@
               <a:buNone/>
             </a:pPr>
             <a:r>
-              <a:rPr lang="fr-FR" sz="2800" dirty="0"/>
+              <a:rPr lang="fr-FR" sz="2800" dirty="0">
+                <a:latin typeface="Century Gothic" panose="020B0502020202020204" pitchFamily="34" charset="0"/>
+              </a:rPr>
               <a:t>Zied Belhocine</a:t>
             </a:r>
-            <a:endParaRPr sz="2800" dirty="0"/>
+            <a:endParaRPr sz="2800" dirty="0">
+              <a:latin typeface="Century Gothic" panose="020B0502020202020204" pitchFamily="34" charset="0"/>
+            </a:endParaRPr>
           </a:p>
           <a:p>
             <a:pPr marL="0" lvl="0" indent="0" algn="ctr" rtl="0">
@@ -21769,10 +22456,14 @@
               <a:buNone/>
             </a:pPr>
             <a:r>
-              <a:rPr lang="fr-FR" sz="2800" dirty="0"/>
+              <a:rPr lang="fr-FR" sz="2800" dirty="0">
+                <a:latin typeface="Century Gothic" panose="020B0502020202020204" pitchFamily="34" charset="0"/>
+              </a:rPr>
               <a:t>FAO</a:t>
             </a:r>
-            <a:endParaRPr dirty="0"/>
+            <a:endParaRPr dirty="0">
+              <a:latin typeface="Century Gothic" panose="020B0502020202020204" pitchFamily="34" charset="0"/>
+            </a:endParaRPr>
           </a:p>
         </p:txBody>
       </p:sp>
@@ -21830,10 +22521,25 @@
               <a:buNone/>
             </a:pPr>
             <a:r>
-              <a:rPr lang="fr-FR" sz="4400"/>
-              <a:t>Étude sur l’alimentation dans le monde</a:t>
+              <a:rPr lang="fr-FR" sz="4400" dirty="0">
+                <a:latin typeface="Century Gothic" panose="020B0502020202020204" pitchFamily="34" charset="0"/>
+              </a:rPr>
+              <a:t>Étude sur l’alimentation dans le monde </a:t>
             </a:r>
-            <a:endParaRPr/>
+            <a:br>
+              <a:rPr lang="fr-FR" sz="4400" dirty="0">
+                <a:latin typeface="Century Gothic" panose="020B0502020202020204" pitchFamily="34" charset="0"/>
+              </a:rPr>
+            </a:br>
+            <a:r>
+              <a:rPr lang="fr-FR" sz="4400" dirty="0">
+                <a:latin typeface="Century Gothic" panose="020B0502020202020204" pitchFamily="34" charset="0"/>
+              </a:rPr>
+              <a:t>2013 - 2017</a:t>
+            </a:r>
+            <a:endParaRPr dirty="0">
+              <a:latin typeface="Century Gothic" panose="020B0502020202020204" pitchFamily="34" charset="0"/>
+            </a:endParaRPr>
           </a:p>
         </p:txBody>
       </p:sp>
@@ -21916,10 +22622,14 @@
               <a:buNone/>
             </a:pPr>
             <a:r>
-              <a:rPr lang="fr-FR" sz="3200"/>
+              <a:rPr lang="fr-FR" sz="3200" dirty="0">
+                <a:latin typeface="Century Gothic" panose="020B0502020202020204" pitchFamily="34" charset="0"/>
+              </a:rPr>
               <a:t>7) Liste des 10 pays qui ont le plus bénéficié de l’aide alimentaire entre 2013 et 2016</a:t>
             </a:r>
-            <a:endParaRPr/>
+            <a:endParaRPr dirty="0">
+              <a:latin typeface="Century Gothic" panose="020B0502020202020204" pitchFamily="34" charset="0"/>
+            </a:endParaRPr>
           </a:p>
         </p:txBody>
       </p:sp>
@@ -21972,7 +22682,9 @@
               <a:buSzPts val="1800"/>
               <a:buNone/>
             </a:pPr>
-            <a:endParaRPr/>
+            <a:endParaRPr dirty="0">
+              <a:latin typeface="Century Gothic" panose="020B0502020202020204" pitchFamily="34" charset="0"/>
+            </a:endParaRPr>
           </a:p>
         </p:txBody>
       </p:sp>
@@ -22031,7 +22743,7 @@
                 <a:solidFill>
                   <a:srgbClr val="000000"/>
                 </a:solidFill>
-                <a:latin typeface="Century Gothic"/>
+                <a:latin typeface="Century Gothic" panose="020B0502020202020204" pitchFamily="34" charset="0"/>
                 <a:ea typeface="Century Gothic"/>
                 <a:cs typeface="Century Gothic"/>
                 <a:sym typeface="Century Gothic"/>
@@ -22042,9 +22754,7 @@
               <a:solidFill>
                 <a:srgbClr val="000000"/>
               </a:solidFill>
-              <a:latin typeface="Arial"/>
-              <a:ea typeface="Arial"/>
-              <a:cs typeface="Arial"/>
+              <a:latin typeface="Century Gothic" panose="020B0502020202020204" pitchFamily="34" charset="0"/>
               <a:sym typeface="Arial"/>
             </a:endParaRPr>
           </a:p>
@@ -22070,7 +22780,7 @@
               <a:solidFill>
                 <a:srgbClr val="000000"/>
               </a:solidFill>
-              <a:latin typeface="Century Gothic"/>
+              <a:latin typeface="Century Gothic" panose="020B0502020202020204" pitchFamily="34" charset="0"/>
               <a:ea typeface="Century Gothic"/>
               <a:cs typeface="Century Gothic"/>
               <a:sym typeface="Century Gothic"/>
@@ -22099,7 +22809,7 @@
                 <a:solidFill>
                   <a:srgbClr val="000000"/>
                 </a:solidFill>
-                <a:latin typeface="Century Gothic"/>
+                <a:latin typeface="Century Gothic" panose="020B0502020202020204" pitchFamily="34" charset="0"/>
                 <a:ea typeface="Century Gothic"/>
                 <a:cs typeface="Century Gothic"/>
                 <a:sym typeface="Century Gothic"/>
@@ -22110,7 +22820,7 @@
               <a:solidFill>
                 <a:srgbClr val="000000"/>
               </a:solidFill>
-              <a:latin typeface="Century Gothic"/>
+              <a:latin typeface="Century Gothic" panose="020B0502020202020204" pitchFamily="34" charset="0"/>
               <a:ea typeface="Century Gothic"/>
               <a:cs typeface="Century Gothic"/>
               <a:sym typeface="Century Gothic"/>
@@ -22139,7 +22849,7 @@
                 <a:solidFill>
                   <a:schemeClr val="dk1"/>
                 </a:solidFill>
-                <a:latin typeface="Century Gothic"/>
+                <a:latin typeface="Century Gothic" panose="020B0502020202020204" pitchFamily="34" charset="0"/>
                 <a:ea typeface="Century Gothic"/>
                 <a:cs typeface="Century Gothic"/>
                 <a:sym typeface="Century Gothic"/>
@@ -22151,7 +22861,7 @@
                 <a:solidFill>
                   <a:srgbClr val="000000"/>
                 </a:solidFill>
-                <a:latin typeface="Century Gothic"/>
+                <a:latin typeface="Century Gothic" panose="020B0502020202020204" pitchFamily="34" charset="0"/>
                 <a:ea typeface="Century Gothic"/>
                 <a:cs typeface="Century Gothic"/>
                 <a:sym typeface="Century Gothic"/>
@@ -22162,9 +22872,7 @@
               <a:solidFill>
                 <a:srgbClr val="000000"/>
               </a:solidFill>
-              <a:latin typeface="Arial"/>
-              <a:ea typeface="Arial"/>
-              <a:cs typeface="Arial"/>
+              <a:latin typeface="Century Gothic" panose="020B0502020202020204" pitchFamily="34" charset="0"/>
               <a:sym typeface="Arial"/>
             </a:endParaRPr>
           </a:p>
@@ -22190,7 +22898,7 @@
               <a:solidFill>
                 <a:srgbClr val="000000"/>
               </a:solidFill>
-              <a:latin typeface="Century Gothic"/>
+              <a:latin typeface="Century Gothic" panose="020B0502020202020204" pitchFamily="34" charset="0"/>
               <a:ea typeface="Century Gothic"/>
               <a:cs typeface="Century Gothic"/>
               <a:sym typeface="Century Gothic"/>
@@ -22219,7 +22927,7 @@
                 <a:solidFill>
                   <a:srgbClr val="000000"/>
                 </a:solidFill>
-                <a:latin typeface="Century Gothic"/>
+                <a:latin typeface="Century Gothic" panose="020B0502020202020204" pitchFamily="34" charset="0"/>
                 <a:ea typeface="Century Gothic"/>
                 <a:cs typeface="Century Gothic"/>
                 <a:sym typeface="Century Gothic"/>
@@ -22230,9 +22938,7 @@
               <a:solidFill>
                 <a:srgbClr val="000000"/>
               </a:solidFill>
-              <a:latin typeface="Arial"/>
-              <a:ea typeface="Arial"/>
-              <a:cs typeface="Arial"/>
+              <a:latin typeface="Century Gothic" panose="020B0502020202020204" pitchFamily="34" charset="0"/>
               <a:sym typeface="Arial"/>
             </a:endParaRPr>
           </a:p>
@@ -22317,10 +23023,14 @@
               <a:buNone/>
             </a:pPr>
             <a:r>
-              <a:rPr lang="fr-FR" sz="3200"/>
+              <a:rPr lang="fr-FR" sz="3200">
+                <a:latin typeface="Century Gothic" panose="020B0502020202020204" pitchFamily="34" charset="0"/>
+              </a:rPr>
               <a:t>8) Évolution de l’aide alimentaire pour les 5 pays qui en ont le plus bénéficié entre 2013 et 2016</a:t>
             </a:r>
-            <a:endParaRPr/>
+            <a:endParaRPr>
+              <a:latin typeface="Century Gothic" panose="020B0502020202020204" pitchFamily="34" charset="0"/>
+            </a:endParaRPr>
           </a:p>
         </p:txBody>
       </p:sp>
@@ -22373,7 +23083,9 @@
               <a:buSzPts val="1800"/>
               <a:buNone/>
             </a:pPr>
-            <a:endParaRPr/>
+            <a:endParaRPr dirty="0">
+              <a:latin typeface="Century Gothic" panose="020B0502020202020204" pitchFamily="34" charset="0"/>
+            </a:endParaRPr>
           </a:p>
         </p:txBody>
       </p:sp>
@@ -22432,7 +23144,7 @@
                 <a:solidFill>
                   <a:srgbClr val="000000"/>
                 </a:solidFill>
-                <a:latin typeface="Century Gothic"/>
+                <a:latin typeface="Century Gothic" panose="020B0502020202020204" pitchFamily="34" charset="0"/>
                 <a:ea typeface="Century Gothic"/>
                 <a:cs typeface="Century Gothic"/>
                 <a:sym typeface="Century Gothic"/>
@@ -22443,9 +23155,7 @@
               <a:solidFill>
                 <a:srgbClr val="000000"/>
               </a:solidFill>
-              <a:latin typeface="Arial"/>
-              <a:ea typeface="Arial"/>
-              <a:cs typeface="Arial"/>
+              <a:latin typeface="Century Gothic" panose="020B0502020202020204" pitchFamily="34" charset="0"/>
               <a:sym typeface="Arial"/>
             </a:endParaRPr>
           </a:p>
@@ -22471,7 +23181,7 @@
               <a:solidFill>
                 <a:srgbClr val="000000"/>
               </a:solidFill>
-              <a:latin typeface="Century Gothic"/>
+              <a:latin typeface="Century Gothic" panose="020B0502020202020204" pitchFamily="34" charset="0"/>
               <a:ea typeface="Century Gothic"/>
               <a:cs typeface="Century Gothic"/>
               <a:sym typeface="Century Gothic"/>
@@ -22500,7 +23210,7 @@
                 <a:solidFill>
                   <a:srgbClr val="000000"/>
                 </a:solidFill>
-                <a:latin typeface="Century Gothic"/>
+                <a:latin typeface="Century Gothic" panose="020B0502020202020204" pitchFamily="34" charset="0"/>
                 <a:ea typeface="Century Gothic"/>
                 <a:cs typeface="Century Gothic"/>
                 <a:sym typeface="Century Gothic"/>
@@ -22511,9 +23221,7 @@
               <a:solidFill>
                 <a:srgbClr val="000000"/>
               </a:solidFill>
-              <a:latin typeface="Arial"/>
-              <a:ea typeface="Arial"/>
-              <a:cs typeface="Arial"/>
+              <a:latin typeface="Century Gothic" panose="020B0502020202020204" pitchFamily="34" charset="0"/>
               <a:sym typeface="Arial"/>
             </a:endParaRPr>
           </a:p>
@@ -22540,7 +23248,7 @@
                 <a:solidFill>
                   <a:srgbClr val="000000"/>
                 </a:solidFill>
-                <a:latin typeface="Century Gothic"/>
+                <a:latin typeface="Century Gothic" panose="020B0502020202020204" pitchFamily="34" charset="0"/>
                 <a:ea typeface="Century Gothic"/>
                 <a:cs typeface="Century Gothic"/>
                 <a:sym typeface="Century Gothic"/>
@@ -22551,9 +23259,7 @@
               <a:solidFill>
                 <a:srgbClr val="000000"/>
               </a:solidFill>
-              <a:latin typeface="Arial"/>
-              <a:ea typeface="Arial"/>
-              <a:cs typeface="Arial"/>
+              <a:latin typeface="Century Gothic" panose="020B0502020202020204" pitchFamily="34" charset="0"/>
               <a:sym typeface="Arial"/>
             </a:endParaRPr>
           </a:p>
@@ -22579,7 +23285,7 @@
               <a:solidFill>
                 <a:srgbClr val="000000"/>
               </a:solidFill>
-              <a:latin typeface="Century Gothic"/>
+              <a:latin typeface="Century Gothic" panose="020B0502020202020204" pitchFamily="34" charset="0"/>
               <a:ea typeface="Century Gothic"/>
               <a:cs typeface="Century Gothic"/>
               <a:sym typeface="Century Gothic"/>
@@ -22608,7 +23314,7 @@
                 <a:solidFill>
                   <a:srgbClr val="000000"/>
                 </a:solidFill>
-                <a:latin typeface="Century Gothic"/>
+                <a:latin typeface="Century Gothic" panose="020B0502020202020204" pitchFamily="34" charset="0"/>
                 <a:ea typeface="Century Gothic"/>
                 <a:cs typeface="Century Gothic"/>
                 <a:sym typeface="Century Gothic"/>
@@ -22619,9 +23325,7 @@
               <a:solidFill>
                 <a:srgbClr val="000000"/>
               </a:solidFill>
-              <a:latin typeface="Arial"/>
-              <a:ea typeface="Arial"/>
-              <a:cs typeface="Arial"/>
+              <a:latin typeface="Century Gothic" panose="020B0502020202020204" pitchFamily="34" charset="0"/>
               <a:sym typeface="Arial"/>
             </a:endParaRPr>
           </a:p>
@@ -22706,10 +23410,14 @@
               <a:buNone/>
             </a:pPr>
             <a:r>
-              <a:rPr lang="fr-FR" sz="3200"/>
+              <a:rPr lang="fr-FR" sz="3200">
+                <a:latin typeface="Century Gothic" panose="020B0502020202020204" pitchFamily="34" charset="0"/>
+              </a:rPr>
               <a:t>9) Liste des 10 pays qui ont la plus forte disponibilité alimentaire par habitant</a:t>
             </a:r>
-            <a:endParaRPr sz="3200"/>
+            <a:endParaRPr sz="3200">
+              <a:latin typeface="Century Gothic" panose="020B0502020202020204" pitchFamily="34" charset="0"/>
+            </a:endParaRPr>
           </a:p>
         </p:txBody>
       </p:sp>
@@ -22762,7 +23470,9 @@
               <a:buSzPts val="1800"/>
               <a:buNone/>
             </a:pPr>
-            <a:endParaRPr/>
+            <a:endParaRPr>
+              <a:latin typeface="Century Gothic" panose="020B0502020202020204" pitchFamily="34" charset="0"/>
+            </a:endParaRPr>
           </a:p>
         </p:txBody>
       </p:sp>
@@ -22821,7 +23531,7 @@
                 <a:solidFill>
                   <a:srgbClr val="000000"/>
                 </a:solidFill>
-                <a:latin typeface="Century Gothic"/>
+                <a:latin typeface="Century Gothic" panose="020B0502020202020204" pitchFamily="34" charset="0"/>
                 <a:ea typeface="Century Gothic"/>
                 <a:cs typeface="Century Gothic"/>
                 <a:sym typeface="Century Gothic"/>
@@ -22832,9 +23542,7 @@
               <a:solidFill>
                 <a:srgbClr val="000000"/>
               </a:solidFill>
-              <a:latin typeface="Arial"/>
-              <a:ea typeface="Arial"/>
-              <a:cs typeface="Arial"/>
+              <a:latin typeface="Century Gothic" panose="020B0502020202020204" pitchFamily="34" charset="0"/>
               <a:sym typeface="Arial"/>
             </a:endParaRPr>
           </a:p>
@@ -22860,7 +23568,7 @@
               <a:solidFill>
                 <a:srgbClr val="000000"/>
               </a:solidFill>
-              <a:latin typeface="Century Gothic"/>
+              <a:latin typeface="Century Gothic" panose="020B0502020202020204" pitchFamily="34" charset="0"/>
               <a:ea typeface="Century Gothic"/>
               <a:cs typeface="Century Gothic"/>
               <a:sym typeface="Century Gothic"/>
@@ -22889,7 +23597,7 @@
                 <a:solidFill>
                   <a:srgbClr val="000000"/>
                 </a:solidFill>
-                <a:latin typeface="Century Gothic"/>
+                <a:latin typeface="Century Gothic" panose="020B0502020202020204" pitchFamily="34" charset="0"/>
                 <a:ea typeface="Century Gothic"/>
                 <a:cs typeface="Century Gothic"/>
                 <a:sym typeface="Century Gothic"/>
@@ -22900,9 +23608,7 @@
               <a:solidFill>
                 <a:srgbClr val="000000"/>
               </a:solidFill>
-              <a:latin typeface="Arial"/>
-              <a:ea typeface="Arial"/>
-              <a:cs typeface="Arial"/>
+              <a:latin typeface="Century Gothic" panose="020B0502020202020204" pitchFamily="34" charset="0"/>
               <a:sym typeface="Arial"/>
             </a:endParaRPr>
           </a:p>
@@ -22929,7 +23635,7 @@
                 <a:solidFill>
                   <a:srgbClr val="000000"/>
                 </a:solidFill>
-                <a:latin typeface="Century Gothic"/>
+                <a:latin typeface="Century Gothic" panose="020B0502020202020204" pitchFamily="34" charset="0"/>
                 <a:ea typeface="Century Gothic"/>
                 <a:cs typeface="Century Gothic"/>
                 <a:sym typeface="Century Gothic"/>
@@ -22940,9 +23646,7 @@
               <a:solidFill>
                 <a:srgbClr val="000000"/>
               </a:solidFill>
-              <a:latin typeface="Arial"/>
-              <a:ea typeface="Arial"/>
-              <a:cs typeface="Arial"/>
+              <a:latin typeface="Century Gothic" panose="020B0502020202020204" pitchFamily="34" charset="0"/>
               <a:sym typeface="Arial"/>
             </a:endParaRPr>
           </a:p>
@@ -22969,7 +23673,7 @@
                 <a:solidFill>
                   <a:srgbClr val="000000"/>
                 </a:solidFill>
-                <a:latin typeface="Century Gothic"/>
+                <a:latin typeface="Century Gothic" panose="020B0502020202020204" pitchFamily="34" charset="0"/>
                 <a:ea typeface="Century Gothic"/>
                 <a:cs typeface="Century Gothic"/>
                 <a:sym typeface="Century Gothic"/>
@@ -22980,9 +23684,7 @@
               <a:solidFill>
                 <a:srgbClr val="000000"/>
               </a:solidFill>
-              <a:latin typeface="Arial"/>
-              <a:ea typeface="Arial"/>
-              <a:cs typeface="Arial"/>
+              <a:latin typeface="Century Gothic" panose="020B0502020202020204" pitchFamily="34" charset="0"/>
               <a:sym typeface="Arial"/>
             </a:endParaRPr>
           </a:p>
@@ -23008,7 +23710,7 @@
               <a:solidFill>
                 <a:srgbClr val="000000"/>
               </a:solidFill>
-              <a:latin typeface="Century Gothic"/>
+              <a:latin typeface="Century Gothic" panose="020B0502020202020204" pitchFamily="34" charset="0"/>
               <a:ea typeface="Century Gothic"/>
               <a:cs typeface="Century Gothic"/>
               <a:sym typeface="Century Gothic"/>
@@ -23037,7 +23739,7 @@
                 <a:solidFill>
                   <a:srgbClr val="000000"/>
                 </a:solidFill>
-                <a:latin typeface="Century Gothic"/>
+                <a:latin typeface="Century Gothic" panose="020B0502020202020204" pitchFamily="34" charset="0"/>
                 <a:ea typeface="Century Gothic"/>
                 <a:cs typeface="Century Gothic"/>
                 <a:sym typeface="Century Gothic"/>
@@ -23048,9 +23750,7 @@
               <a:solidFill>
                 <a:srgbClr val="000000"/>
               </a:solidFill>
-              <a:latin typeface="Arial"/>
-              <a:ea typeface="Arial"/>
-              <a:cs typeface="Arial"/>
+              <a:latin typeface="Century Gothic" panose="020B0502020202020204" pitchFamily="34" charset="0"/>
               <a:sym typeface="Arial"/>
             </a:endParaRPr>
           </a:p>
@@ -23135,10 +23835,14 @@
               <a:buNone/>
             </a:pPr>
             <a:r>
-              <a:rPr lang="fr-FR" sz="3200"/>
+              <a:rPr lang="fr-FR" sz="3200">
+                <a:latin typeface="Century Gothic" panose="020B0502020202020204" pitchFamily="34" charset="0"/>
+              </a:rPr>
               <a:t>9) Liste des 10 pays qui ont la plus faible disponibilité alimentaire par habitant</a:t>
             </a:r>
-            <a:endParaRPr/>
+            <a:endParaRPr>
+              <a:latin typeface="Century Gothic" panose="020B0502020202020204" pitchFamily="34" charset="0"/>
+            </a:endParaRPr>
           </a:p>
         </p:txBody>
       </p:sp>
@@ -23191,7 +23895,9 @@
               <a:buSzPts val="1800"/>
               <a:buNone/>
             </a:pPr>
-            <a:endParaRPr/>
+            <a:endParaRPr>
+              <a:latin typeface="Century Gothic" panose="020B0502020202020204" pitchFamily="34" charset="0"/>
+            </a:endParaRPr>
           </a:p>
         </p:txBody>
       </p:sp>
@@ -23250,7 +23956,7 @@
                 <a:solidFill>
                   <a:srgbClr val="000000"/>
                 </a:solidFill>
-                <a:latin typeface="Century Gothic"/>
+                <a:latin typeface="Century Gothic" panose="020B0502020202020204" pitchFamily="34" charset="0"/>
                 <a:ea typeface="Century Gothic"/>
                 <a:cs typeface="Century Gothic"/>
                 <a:sym typeface="Century Gothic"/>
@@ -23261,9 +23967,7 @@
               <a:solidFill>
                 <a:srgbClr val="000000"/>
               </a:solidFill>
-              <a:latin typeface="Arial"/>
-              <a:ea typeface="Arial"/>
-              <a:cs typeface="Arial"/>
+              <a:latin typeface="Century Gothic" panose="020B0502020202020204" pitchFamily="34" charset="0"/>
               <a:sym typeface="Arial"/>
             </a:endParaRPr>
           </a:p>
@@ -23289,7 +23993,7 @@
               <a:solidFill>
                 <a:srgbClr val="000000"/>
               </a:solidFill>
-              <a:latin typeface="Century Gothic"/>
+              <a:latin typeface="Century Gothic" panose="020B0502020202020204" pitchFamily="34" charset="0"/>
               <a:ea typeface="Century Gothic"/>
               <a:cs typeface="Century Gothic"/>
               <a:sym typeface="Century Gothic"/>
@@ -23318,7 +24022,7 @@
                 <a:solidFill>
                   <a:srgbClr val="000000"/>
                 </a:solidFill>
-                <a:latin typeface="Century Gothic"/>
+                <a:latin typeface="Century Gothic" panose="020B0502020202020204" pitchFamily="34" charset="0"/>
                 <a:ea typeface="Century Gothic"/>
                 <a:cs typeface="Century Gothic"/>
                 <a:sym typeface="Century Gothic"/>
@@ -23329,9 +24033,7 @@
               <a:solidFill>
                 <a:srgbClr val="000000"/>
               </a:solidFill>
-              <a:latin typeface="Arial"/>
-              <a:ea typeface="Arial"/>
-              <a:cs typeface="Arial"/>
+              <a:latin typeface="Century Gothic" panose="020B0502020202020204" pitchFamily="34" charset="0"/>
               <a:sym typeface="Arial"/>
             </a:endParaRPr>
           </a:p>
@@ -23358,7 +24060,7 @@
                 <a:solidFill>
                   <a:srgbClr val="000000"/>
                 </a:solidFill>
-                <a:latin typeface="Century Gothic"/>
+                <a:latin typeface="Century Gothic" panose="020B0502020202020204" pitchFamily="34" charset="0"/>
                 <a:ea typeface="Century Gothic"/>
                 <a:cs typeface="Century Gothic"/>
                 <a:sym typeface="Century Gothic"/>
@@ -23369,9 +24071,7 @@
               <a:solidFill>
                 <a:srgbClr val="000000"/>
               </a:solidFill>
-              <a:latin typeface="Arial"/>
-              <a:ea typeface="Arial"/>
-              <a:cs typeface="Arial"/>
+              <a:latin typeface="Century Gothic" panose="020B0502020202020204" pitchFamily="34" charset="0"/>
               <a:sym typeface="Arial"/>
             </a:endParaRPr>
           </a:p>
@@ -23398,7 +24098,7 @@
                 <a:solidFill>
                   <a:srgbClr val="000000"/>
                 </a:solidFill>
-                <a:latin typeface="Century Gothic"/>
+                <a:latin typeface="Century Gothic" panose="020B0502020202020204" pitchFamily="34" charset="0"/>
                 <a:ea typeface="Century Gothic"/>
                 <a:cs typeface="Century Gothic"/>
                 <a:sym typeface="Century Gothic"/>
@@ -23409,9 +24109,7 @@
               <a:solidFill>
                 <a:srgbClr val="000000"/>
               </a:solidFill>
-              <a:latin typeface="Arial"/>
-              <a:ea typeface="Arial"/>
-              <a:cs typeface="Arial"/>
+              <a:latin typeface="Century Gothic" panose="020B0502020202020204" pitchFamily="34" charset="0"/>
               <a:sym typeface="Arial"/>
             </a:endParaRPr>
           </a:p>
@@ -23437,7 +24135,7 @@
               <a:solidFill>
                 <a:srgbClr val="000000"/>
               </a:solidFill>
-              <a:latin typeface="Century Gothic"/>
+              <a:latin typeface="Century Gothic" panose="020B0502020202020204" pitchFamily="34" charset="0"/>
               <a:ea typeface="Century Gothic"/>
               <a:cs typeface="Century Gothic"/>
               <a:sym typeface="Century Gothic"/>
@@ -23466,7 +24164,7 @@
                 <a:solidFill>
                   <a:srgbClr val="000000"/>
                 </a:solidFill>
-                <a:latin typeface="Century Gothic"/>
+                <a:latin typeface="Century Gothic" panose="020B0502020202020204" pitchFamily="34" charset="0"/>
                 <a:ea typeface="Century Gothic"/>
                 <a:cs typeface="Century Gothic"/>
                 <a:sym typeface="Century Gothic"/>
@@ -23477,9 +24175,7 @@
               <a:solidFill>
                 <a:srgbClr val="000000"/>
               </a:solidFill>
-              <a:latin typeface="Arial"/>
-              <a:ea typeface="Arial"/>
-              <a:cs typeface="Arial"/>
+              <a:latin typeface="Century Gothic" panose="020B0502020202020204" pitchFamily="34" charset="0"/>
               <a:sym typeface="Arial"/>
             </a:endParaRPr>
           </a:p>
@@ -23564,10 +24260,14 @@
               <a:buNone/>
             </a:pPr>
             <a:r>
-              <a:rPr lang="fr-FR" sz="3200"/>
+              <a:rPr lang="fr-FR" sz="3200">
+                <a:latin typeface="Century Gothic" panose="020B0502020202020204" pitchFamily="34" charset="0"/>
+              </a:rPr>
               <a:t>10) Étude sur le manioc en Thaïlande</a:t>
             </a:r>
-            <a:endParaRPr/>
+            <a:endParaRPr>
+              <a:latin typeface="Century Gothic" panose="020B0502020202020204" pitchFamily="34" charset="0"/>
+            </a:endParaRPr>
           </a:p>
         </p:txBody>
       </p:sp>
@@ -23620,7 +24320,9 @@
               <a:buSzPts val="1800"/>
               <a:buNone/>
             </a:pPr>
-            <a:endParaRPr/>
+            <a:endParaRPr dirty="0">
+              <a:latin typeface="Century Gothic" panose="020B0502020202020204" pitchFamily="34" charset="0"/>
+            </a:endParaRPr>
           </a:p>
         </p:txBody>
       </p:sp>
@@ -23632,7 +24334,7 @@
         </p:nvSpPr>
         <p:spPr>
           <a:xfrm>
-            <a:off x="7835901" y="2840469"/>
+            <a:off x="7941262" y="1898637"/>
             <a:ext cx="3432024" cy="3742364"/>
           </a:xfrm>
           <a:prstGeom prst="rect">
@@ -23675,24 +24377,22 @@
               <a:buNone/>
             </a:pPr>
             <a:r>
-              <a:rPr lang="fr-FR" sz="1800" b="0" i="0" u="none" strike="noStrike" cap="none">
+              <a:rPr lang="fr-FR" sz="1800" b="0" i="0" u="none" strike="noStrike" cap="none" dirty="0">
                 <a:solidFill>
                   <a:srgbClr val="000000"/>
                 </a:solidFill>
-                <a:latin typeface="Century Gothic"/>
+                <a:latin typeface="Century Gothic" panose="020B0502020202020204" pitchFamily="34" charset="0"/>
                 <a:ea typeface="Century Gothic"/>
                 <a:cs typeface="Century Gothic"/>
                 <a:sym typeface="Century Gothic"/>
               </a:rPr>
               <a:t>MEMO : </a:t>
             </a:r>
-            <a:endParaRPr sz="1400" b="0" i="0" u="none" strike="noStrike" cap="none">
+            <a:endParaRPr sz="1400" b="0" i="0" u="none" strike="noStrike" cap="none" dirty="0">
               <a:solidFill>
                 <a:srgbClr val="000000"/>
               </a:solidFill>
-              <a:latin typeface="Arial"/>
-              <a:ea typeface="Arial"/>
-              <a:cs typeface="Arial"/>
+              <a:latin typeface="Century Gothic" panose="020B0502020202020204" pitchFamily="34" charset="0"/>
               <a:sym typeface="Arial"/>
             </a:endParaRPr>
           </a:p>
@@ -23714,11 +24414,11 @@
               <a:buFont typeface="Arial"/>
               <a:buNone/>
             </a:pPr>
-            <a:endParaRPr sz="1800" b="0" i="0" u="none" strike="noStrike" cap="none">
+            <a:endParaRPr sz="1800" b="0" i="0" u="none" strike="noStrike" cap="none" dirty="0">
               <a:solidFill>
                 <a:srgbClr val="000000"/>
               </a:solidFill>
-              <a:latin typeface="Century Gothic"/>
+              <a:latin typeface="Century Gothic" panose="020B0502020202020204" pitchFamily="34" charset="0"/>
               <a:ea typeface="Century Gothic"/>
               <a:cs typeface="Century Gothic"/>
               <a:sym typeface="Century Gothic"/>
@@ -23743,24 +24443,22 @@
               <a:buChar char="⇒"/>
             </a:pPr>
             <a:r>
-              <a:rPr lang="fr-FR" sz="1800" b="0" i="0" u="none" strike="noStrike" cap="none">
+              <a:rPr lang="fr-FR" sz="1800" b="0" i="0" u="none" strike="noStrike" cap="none" dirty="0">
                 <a:solidFill>
                   <a:srgbClr val="000000"/>
                 </a:solidFill>
-                <a:latin typeface="Century Gothic"/>
+                <a:latin typeface="Century Gothic" panose="020B0502020202020204" pitchFamily="34" charset="0"/>
                 <a:ea typeface="Century Gothic"/>
                 <a:cs typeface="Century Gothic"/>
                 <a:sym typeface="Century Gothic"/>
               </a:rPr>
               <a:t>Donner la part de personnes en état de sous- nutrition pour ce pays</a:t>
             </a:r>
-            <a:endParaRPr sz="1400" b="0" i="0" u="none" strike="noStrike" cap="none">
+            <a:endParaRPr sz="1400" b="0" i="0" u="none" strike="noStrike" cap="none" dirty="0">
               <a:solidFill>
                 <a:srgbClr val="000000"/>
               </a:solidFill>
-              <a:latin typeface="Arial"/>
-              <a:ea typeface="Arial"/>
-              <a:cs typeface="Arial"/>
+              <a:latin typeface="Century Gothic" panose="020B0502020202020204" pitchFamily="34" charset="0"/>
               <a:sym typeface="Arial"/>
             </a:endParaRPr>
           </a:p>
@@ -23783,24 +24481,22 @@
               <a:buChar char="⇒"/>
             </a:pPr>
             <a:r>
-              <a:rPr lang="fr-FR" sz="1800" b="0" i="0" u="none" strike="noStrike" cap="none">
+              <a:rPr lang="fr-FR" sz="1800" b="0" i="0" u="none" strike="noStrike" cap="none" dirty="0">
                 <a:solidFill>
                   <a:srgbClr val="000000"/>
                 </a:solidFill>
-                <a:latin typeface="Century Gothic"/>
+                <a:latin typeface="Century Gothic" panose="020B0502020202020204" pitchFamily="34" charset="0"/>
                 <a:ea typeface="Century Gothic"/>
                 <a:cs typeface="Century Gothic"/>
                 <a:sym typeface="Century Gothic"/>
               </a:rPr>
               <a:t>Regarder les exportations et la production de Manioc</a:t>
             </a:r>
-            <a:endParaRPr sz="1400" b="0" i="0" u="none" strike="noStrike" cap="none">
+            <a:endParaRPr sz="1400" b="0" i="0" u="none" strike="noStrike" cap="none" dirty="0">
               <a:solidFill>
                 <a:srgbClr val="000000"/>
               </a:solidFill>
-              <a:latin typeface="Arial"/>
-              <a:ea typeface="Arial"/>
-              <a:cs typeface="Arial"/>
+              <a:latin typeface="Century Gothic" panose="020B0502020202020204" pitchFamily="34" charset="0"/>
               <a:sym typeface="Arial"/>
             </a:endParaRPr>
           </a:p>
@@ -23823,24 +24519,22 @@
               <a:buChar char="⇒"/>
             </a:pPr>
             <a:r>
-              <a:rPr lang="fr-FR" sz="1800" b="0" i="0" u="none" strike="noStrike" cap="none">
+              <a:rPr lang="fr-FR" sz="1800" b="0" i="0" u="none" strike="noStrike" cap="none" dirty="0">
                 <a:solidFill>
                   <a:srgbClr val="000000"/>
                 </a:solidFill>
-                <a:latin typeface="Century Gothic"/>
+                <a:latin typeface="Century Gothic" panose="020B0502020202020204" pitchFamily="34" charset="0"/>
                 <a:ea typeface="Century Gothic"/>
                 <a:cs typeface="Century Gothic"/>
                 <a:sym typeface="Century Gothic"/>
               </a:rPr>
               <a:t>Est-ce que c’est logique ? </a:t>
             </a:r>
-            <a:endParaRPr sz="1400" b="0" i="0" u="none" strike="noStrike" cap="none">
+            <a:endParaRPr sz="1400" b="0" i="0" u="none" strike="noStrike" cap="none" dirty="0">
               <a:solidFill>
                 <a:srgbClr val="000000"/>
               </a:solidFill>
-              <a:latin typeface="Arial"/>
-              <a:ea typeface="Arial"/>
-              <a:cs typeface="Arial"/>
+              <a:latin typeface="Century Gothic" panose="020B0502020202020204" pitchFamily="34" charset="0"/>
               <a:sym typeface="Arial"/>
             </a:endParaRPr>
           </a:p>
@@ -23863,24 +24557,22 @@
               <a:buChar char="⇒"/>
             </a:pPr>
             <a:r>
-              <a:rPr lang="fr-FR" sz="1800" b="0" i="0" u="none" strike="noStrike" cap="none">
+              <a:rPr lang="fr-FR" sz="1800" b="0" i="0" u="none" strike="noStrike" cap="none" dirty="0">
                 <a:solidFill>
                   <a:srgbClr val="000000"/>
                 </a:solidFill>
-                <a:latin typeface="Century Gothic"/>
+                <a:latin typeface="Century Gothic" panose="020B0502020202020204" pitchFamily="34" charset="0"/>
                 <a:ea typeface="Century Gothic"/>
                 <a:cs typeface="Century Gothic"/>
                 <a:sym typeface="Century Gothic"/>
               </a:rPr>
               <a:t>Quelle est la disponibilité par habitant pour la Thaïlande ? </a:t>
             </a:r>
-            <a:endParaRPr sz="1400" b="0" i="0" u="none" strike="noStrike" cap="none">
+            <a:endParaRPr sz="1400" b="0" i="0" u="none" strike="noStrike" cap="none" dirty="0">
               <a:solidFill>
                 <a:srgbClr val="000000"/>
               </a:solidFill>
-              <a:latin typeface="Arial"/>
-              <a:ea typeface="Arial"/>
-              <a:cs typeface="Arial"/>
+              <a:latin typeface="Century Gothic" panose="020B0502020202020204" pitchFamily="34" charset="0"/>
               <a:sym typeface="Arial"/>
             </a:endParaRPr>
           </a:p>
@@ -23965,10 +24657,14 @@
               <a:buNone/>
             </a:pPr>
             <a:r>
-              <a:rPr lang="fr-FR" sz="3200"/>
+              <a:rPr lang="fr-FR" sz="3200" dirty="0">
+                <a:latin typeface="Century Gothic" panose="020B0502020202020204" pitchFamily="34" charset="0"/>
+              </a:rPr>
               <a:t>11) Analyses complémentaires</a:t>
             </a:r>
-            <a:endParaRPr sz="3200"/>
+            <a:endParaRPr sz="3200" dirty="0">
+              <a:latin typeface="Century Gothic" panose="020B0502020202020204" pitchFamily="34" charset="0"/>
+            </a:endParaRPr>
           </a:p>
         </p:txBody>
       </p:sp>
@@ -24021,7 +24717,9 @@
               <a:buSzPts val="1800"/>
               <a:buNone/>
             </a:pPr>
-            <a:endParaRPr/>
+            <a:endParaRPr dirty="0">
+              <a:latin typeface="Century Gothic" panose="020B0502020202020204" pitchFamily="34" charset="0"/>
+            </a:endParaRPr>
           </a:p>
         </p:txBody>
       </p:sp>
@@ -24033,7 +24731,7 @@
         </p:nvSpPr>
         <p:spPr>
           <a:xfrm>
-            <a:off x="7835901" y="2840469"/>
+            <a:off x="7781037" y="2169360"/>
             <a:ext cx="3432024" cy="3742364"/>
           </a:xfrm>
           <a:prstGeom prst="rect">
@@ -24076,24 +24774,22 @@
               <a:buNone/>
             </a:pPr>
             <a:r>
-              <a:rPr lang="fr-FR" sz="1800" b="0" i="0" u="none" strike="noStrike" cap="none">
+              <a:rPr lang="fr-FR" sz="1800" b="0" i="0" u="none" strike="noStrike" cap="none" dirty="0">
                 <a:solidFill>
                   <a:srgbClr val="000000"/>
                 </a:solidFill>
-                <a:latin typeface="Century Gothic"/>
+                <a:latin typeface="Century Gothic" panose="020B0502020202020204" pitchFamily="34" charset="0"/>
                 <a:ea typeface="Century Gothic"/>
                 <a:cs typeface="Century Gothic"/>
                 <a:sym typeface="Century Gothic"/>
               </a:rPr>
               <a:t>MEMO : </a:t>
             </a:r>
-            <a:endParaRPr sz="1400" b="0" i="0" u="none" strike="noStrike" cap="none">
+            <a:endParaRPr sz="1400" b="0" i="0" u="none" strike="noStrike" cap="none" dirty="0">
               <a:solidFill>
                 <a:srgbClr val="000000"/>
               </a:solidFill>
-              <a:latin typeface="Arial"/>
-              <a:ea typeface="Arial"/>
-              <a:cs typeface="Arial"/>
+              <a:latin typeface="Century Gothic" panose="020B0502020202020204" pitchFamily="34" charset="0"/>
               <a:sym typeface="Arial"/>
             </a:endParaRPr>
           </a:p>
@@ -24115,11 +24811,11 @@
               <a:buFont typeface="Arial"/>
               <a:buNone/>
             </a:pPr>
-            <a:endParaRPr sz="1800" b="0" i="0" u="none" strike="noStrike" cap="none">
+            <a:endParaRPr sz="1800" b="0" i="0" u="none" strike="noStrike" cap="none" dirty="0">
               <a:solidFill>
                 <a:srgbClr val="000000"/>
               </a:solidFill>
-              <a:latin typeface="Century Gothic"/>
+              <a:latin typeface="Century Gothic" panose="020B0502020202020204" pitchFamily="34" charset="0"/>
               <a:ea typeface="Century Gothic"/>
               <a:cs typeface="Century Gothic"/>
               <a:sym typeface="Century Gothic"/>
@@ -24144,24 +24840,22 @@
               <a:buChar char="⇒"/>
             </a:pPr>
             <a:r>
-              <a:rPr lang="fr-FR" sz="1800" b="0" i="0" u="none" strike="noStrike" cap="none">
+              <a:rPr lang="fr-FR" sz="1800" b="0" i="0" u="none" strike="noStrike" cap="none" dirty="0">
                 <a:solidFill>
                   <a:srgbClr val="000000"/>
                 </a:solidFill>
-                <a:latin typeface="Century Gothic"/>
+                <a:latin typeface="Century Gothic" panose="020B0502020202020204" pitchFamily="34" charset="0"/>
                 <a:ea typeface="Century Gothic"/>
                 <a:cs typeface="Century Gothic"/>
                 <a:sym typeface="Century Gothic"/>
               </a:rPr>
               <a:t>Je vais peut-être trouver des choses supplémentaires pendant l’analyse.</a:t>
             </a:r>
-            <a:endParaRPr sz="1400" b="0" i="0" u="none" strike="noStrike" cap="none">
+            <a:endParaRPr sz="1400" b="0" i="0" u="none" strike="noStrike" cap="none" dirty="0">
               <a:solidFill>
                 <a:srgbClr val="000000"/>
               </a:solidFill>
-              <a:latin typeface="Arial"/>
-              <a:ea typeface="Arial"/>
-              <a:cs typeface="Arial"/>
+              <a:latin typeface="Century Gothic" panose="020B0502020202020204" pitchFamily="34" charset="0"/>
               <a:sym typeface="Arial"/>
             </a:endParaRPr>
           </a:p>
@@ -24246,10 +24940,14 @@
               <a:buNone/>
             </a:pPr>
             <a:r>
-              <a:rPr lang="fr-FR"/>
+              <a:rPr lang="fr-FR" dirty="0">
+                <a:latin typeface="Century Gothic" panose="020B0502020202020204" pitchFamily="34" charset="0"/>
+              </a:rPr>
               <a:t>Conclusion</a:t>
             </a:r>
-            <a:endParaRPr/>
+            <a:endParaRPr dirty="0">
+              <a:latin typeface="Century Gothic" panose="020B0502020202020204" pitchFamily="34" charset="0"/>
+            </a:endParaRPr>
           </a:p>
         </p:txBody>
       </p:sp>
@@ -24302,7 +25000,9 @@
               <a:buSzPts val="1800"/>
               <a:buNone/>
             </a:pPr>
-            <a:endParaRPr/>
+            <a:endParaRPr dirty="0">
+              <a:latin typeface="Century Gothic" panose="020B0502020202020204" pitchFamily="34" charset="0"/>
+            </a:endParaRPr>
           </a:p>
         </p:txBody>
       </p:sp>
@@ -24385,249 +25085,19 @@
               <a:buNone/>
             </a:pPr>
             <a:r>
-              <a:rPr lang="fr-FR" sz="3200"/>
+              <a:rPr lang="fr-FR" sz="3200" dirty="0"/>
               <a:t>Contexte et spécification des données</a:t>
             </a:r>
-            <a:endParaRPr sz="3200"/>
-          </a:p>
-        </p:txBody>
-      </p:sp>
-      <p:sp>
-        <p:nvSpPr>
-          <p:cNvPr id="131" name="Google Shape;131;p2"/>
-          <p:cNvSpPr txBox="1">
-            <a:spLocks noGrp="1"/>
-          </p:cNvSpPr>
-          <p:nvPr>
-            <p:ph type="body" idx="1"/>
-          </p:nvPr>
-        </p:nvSpPr>
-        <p:spPr>
-          <a:xfrm>
-            <a:off x="818712" y="2222287"/>
-            <a:ext cx="3626288" cy="4188525"/>
-          </a:xfrm>
-          <a:prstGeom prst="rect">
-            <a:avLst/>
-          </a:prstGeom>
-          <a:noFill/>
-          <a:ln>
-            <a:noFill/>
-          </a:ln>
-          <a:effectLst>
-            <a:outerShdw blurRad="50800">
-              <a:srgbClr val="000000">
-                <a:alpha val="40000"/>
-              </a:srgbClr>
-            </a:outerShdw>
-          </a:effectLst>
-        </p:spPr>
-        <p:txBody>
-          <a:bodyPr spcFirstLastPara="1" wrap="square" lIns="91425" tIns="45700" rIns="91425" bIns="45700" anchor="ctr" anchorCtr="0">
-            <a:normAutofit fontScale="92500" lnSpcReduction="10000"/>
-          </a:bodyPr>
-          <a:lstStyle/>
-          <a:p>
-            <a:pPr marL="342900" lvl="0" indent="-228600" algn="l" rtl="0">
-              <a:lnSpc>
-                <a:spcPct val="100000"/>
-              </a:lnSpc>
-              <a:spcBef>
-                <a:spcPts val="0"/>
-              </a:spcBef>
-              <a:spcAft>
-                <a:spcPts val="0"/>
-              </a:spcAft>
-              <a:buSzPts val="1800"/>
-              <a:buNone/>
-            </a:pPr>
-            <a:r>
-              <a:rPr lang="fr-FR" dirty="0"/>
-              <a:t>Nous sommes en train de réaliser une grosse étude sur l’alimentation dans le monde. Je souhaite t’intégrer à ce projet afin que tu puisses nous aider à produire les différentes analyses. Nous avons découpé l'analyse en deux parties. Julien a déjà traité la partie de 2018 à maintenant avant de partir. De ton côté, tu vas donc t’occuper de la partie “historique” avec les données allant de 2013 à 2017.</a:t>
-            </a:r>
-            <a:endParaRPr dirty="0"/>
-          </a:p>
-        </p:txBody>
-      </p:sp>
-      <p:sp>
-        <p:nvSpPr>
-          <p:cNvPr id="132" name="Google Shape;132;p2"/>
-          <p:cNvSpPr/>
-          <p:nvPr/>
-        </p:nvSpPr>
-        <p:spPr>
-          <a:xfrm>
-            <a:off x="6893078" y="0"/>
-            <a:ext cx="3432024" cy="2582431"/>
-          </a:xfrm>
-          <a:prstGeom prst="rect">
-            <a:avLst/>
-          </a:prstGeom>
-          <a:solidFill>
-            <a:srgbClr val="FFFF00"/>
-          </a:solidFill>
-          <a:ln w="15875" cap="rnd" cmpd="sng">
-            <a:solidFill>
-              <a:srgbClr val="AE813B"/>
-            </a:solidFill>
-            <a:prstDash val="solid"/>
-            <a:round/>
-            <a:headEnd type="none" w="sm" len="sm"/>
-            <a:tailEnd type="none" w="sm" len="sm"/>
-          </a:ln>
-        </p:spPr>
-        <p:txBody>
-          <a:bodyPr spcFirstLastPara="1" wrap="square" lIns="91425" tIns="45700" rIns="91425" bIns="45700" anchor="ctr" anchorCtr="0">
-            <a:noAutofit/>
-          </a:bodyPr>
-          <a:lstStyle/>
-          <a:p>
-            <a:pPr marL="0" marR="0" lvl="0" indent="0" algn="ctr" rtl="0">
-              <a:lnSpc>
-                <a:spcPct val="100000"/>
-              </a:lnSpc>
-              <a:spcBef>
-                <a:spcPts val="0"/>
-              </a:spcBef>
-              <a:spcAft>
-                <a:spcPts val="0"/>
-              </a:spcAft>
-              <a:buClr>
-                <a:srgbClr val="000000"/>
-              </a:buClr>
-              <a:buSzPts val="1800"/>
-              <a:buFont typeface="Arial"/>
-              <a:buNone/>
-            </a:pPr>
-            <a:r>
-              <a:rPr lang="fr-FR" sz="1800" b="0" i="0" u="none" strike="noStrike" cap="none" dirty="0">
-                <a:solidFill>
-                  <a:srgbClr val="000000"/>
-                </a:solidFill>
-                <a:latin typeface="Century Gothic"/>
-                <a:ea typeface="Century Gothic"/>
-                <a:cs typeface="Century Gothic"/>
-                <a:sym typeface="Century Gothic"/>
-              </a:rPr>
-              <a:t>MEMO : </a:t>
-            </a:r>
-            <a:endParaRPr sz="1400" b="0" i="0" u="none" strike="noStrike" cap="none" dirty="0">
-              <a:solidFill>
-                <a:srgbClr val="000000"/>
-              </a:solidFill>
-              <a:latin typeface="Arial"/>
-              <a:ea typeface="Arial"/>
-              <a:cs typeface="Arial"/>
-              <a:sym typeface="Arial"/>
-            </a:endParaRPr>
-          </a:p>
-          <a:p>
-            <a:pPr marL="0" marR="0" lvl="0" indent="0" algn="ctr" rtl="0">
-              <a:lnSpc>
-                <a:spcPct val="100000"/>
-              </a:lnSpc>
-              <a:spcBef>
-                <a:spcPts val="0"/>
-              </a:spcBef>
-              <a:spcAft>
-                <a:spcPts val="0"/>
-              </a:spcAft>
-              <a:buClr>
-                <a:srgbClr val="000000"/>
-              </a:buClr>
-              <a:buSzPts val="1800"/>
-              <a:buFont typeface="Arial"/>
-              <a:buNone/>
-            </a:pPr>
-            <a:r>
-              <a:rPr lang="fr-FR" sz="1800" b="0" i="0" u="none" strike="noStrike" cap="none" dirty="0">
-                <a:solidFill>
-                  <a:srgbClr val="000000"/>
-                </a:solidFill>
-                <a:latin typeface="Century Gothic"/>
-                <a:ea typeface="Century Gothic"/>
-                <a:cs typeface="Century Gothic"/>
-                <a:sym typeface="Century Gothic"/>
-              </a:rPr>
-              <a:t>Rappel de ce que nous devons faire</a:t>
-            </a:r>
-            <a:endParaRPr sz="1800" b="0" i="0" u="none" strike="noStrike" cap="none" dirty="0">
-              <a:solidFill>
-                <a:srgbClr val="000000"/>
-              </a:solidFill>
-              <a:latin typeface="Century Gothic"/>
-              <a:ea typeface="Century Gothic"/>
-              <a:cs typeface="Century Gothic"/>
-              <a:sym typeface="Century Gothic"/>
-            </a:endParaRPr>
-          </a:p>
-          <a:p>
-            <a:pPr marL="0" marR="0" lvl="0" indent="0" algn="ctr" rtl="0">
-              <a:lnSpc>
-                <a:spcPct val="100000"/>
-              </a:lnSpc>
-              <a:spcBef>
-                <a:spcPts val="0"/>
-              </a:spcBef>
-              <a:spcAft>
-                <a:spcPts val="0"/>
-              </a:spcAft>
-              <a:buClr>
-                <a:srgbClr val="000000"/>
-              </a:buClr>
-              <a:buSzPts val="1800"/>
-              <a:buFont typeface="Arial"/>
-              <a:buNone/>
-            </a:pPr>
-            <a:endParaRPr sz="1800" dirty="0">
-              <a:latin typeface="Century Gothic"/>
-              <a:ea typeface="Century Gothic"/>
-              <a:cs typeface="Century Gothic"/>
-              <a:sym typeface="Century Gothic"/>
-            </a:endParaRPr>
-          </a:p>
-          <a:p>
-            <a:pPr marL="0" marR="0" lvl="0" indent="0" algn="ctr" rtl="0">
-              <a:lnSpc>
-                <a:spcPct val="100000"/>
-              </a:lnSpc>
-              <a:spcBef>
-                <a:spcPts val="0"/>
-              </a:spcBef>
-              <a:spcAft>
-                <a:spcPts val="0"/>
-              </a:spcAft>
-              <a:buClr>
-                <a:srgbClr val="000000"/>
-              </a:buClr>
-              <a:buSzPts val="1800"/>
-              <a:buFont typeface="Arial"/>
-              <a:buNone/>
-            </a:pPr>
-            <a:r>
-              <a:rPr lang="fr-FR" sz="1800" dirty="0">
-                <a:latin typeface="Century Gothic"/>
-                <a:ea typeface="Century Gothic"/>
-                <a:cs typeface="Century Gothic"/>
-                <a:sym typeface="Century Gothic"/>
-              </a:rPr>
-              <a:t>Présentation des types de données à analyser</a:t>
-            </a:r>
-            <a:endParaRPr sz="1800" dirty="0">
-              <a:latin typeface="Century Gothic"/>
-              <a:ea typeface="Century Gothic"/>
-              <a:cs typeface="Century Gothic"/>
-              <a:sym typeface="Century Gothic"/>
-            </a:endParaRPr>
+            <a:endParaRPr sz="3200" dirty="0"/>
           </a:p>
         </p:txBody>
       </p:sp>
       <p:pic>
         <p:nvPicPr>
-          <p:cNvPr id="3" name="Image 2">
+          <p:cNvPr id="6" name="Image 5">
             <a:extLst>
               <a:ext uri="{FF2B5EF4-FFF2-40B4-BE49-F238E27FC236}">
-                <a16:creationId xmlns:a16="http://schemas.microsoft.com/office/drawing/2014/main" id="{CE2D3E78-94E0-33A2-B003-41AFC89F1630}"/>
+                <a16:creationId xmlns:a16="http://schemas.microsoft.com/office/drawing/2014/main" id="{E96593C4-5F17-1784-5D86-B25CEC5A0CFA}"/>
               </a:ext>
             </a:extLst>
           </p:cNvPr>
@@ -24644,14 +25114,305 @@
         </p:blipFill>
         <p:spPr>
           <a:xfrm>
-            <a:off x="6403789" y="3029619"/>
-            <a:ext cx="2686425" cy="1467055"/>
+            <a:off x="8879023" y="3813560"/>
+            <a:ext cx="2721291" cy="1581894"/>
           </a:xfrm>
           <a:prstGeom prst="rect">
             <a:avLst/>
           </a:prstGeom>
         </p:spPr>
       </p:pic>
+      <p:pic>
+        <p:nvPicPr>
+          <p:cNvPr id="8" name="Image 7">
+            <a:extLst>
+              <a:ext uri="{FF2B5EF4-FFF2-40B4-BE49-F238E27FC236}">
+                <a16:creationId xmlns:a16="http://schemas.microsoft.com/office/drawing/2014/main" id="{E9E961B2-5A76-FBC0-4674-27E6CC2013E9}"/>
+              </a:ext>
+            </a:extLst>
+          </p:cNvPr>
+          <p:cNvPicPr>
+            <a:picLocks noChangeAspect="1"/>
+          </p:cNvPicPr>
+          <p:nvPr/>
+        </p:nvPicPr>
+        <p:blipFill>
+          <a:blip r:embed="rId4"/>
+          <a:stretch>
+            <a:fillRect/>
+          </a:stretch>
+        </p:blipFill>
+        <p:spPr>
+          <a:xfrm>
+            <a:off x="6379822" y="3813560"/>
+            <a:ext cx="2419596" cy="1581894"/>
+          </a:xfrm>
+          <a:prstGeom prst="rect">
+            <a:avLst/>
+          </a:prstGeom>
+        </p:spPr>
+      </p:pic>
+      <p:pic>
+        <p:nvPicPr>
+          <p:cNvPr id="10" name="Image 9">
+            <a:extLst>
+              <a:ext uri="{FF2B5EF4-FFF2-40B4-BE49-F238E27FC236}">
+                <a16:creationId xmlns:a16="http://schemas.microsoft.com/office/drawing/2014/main" id="{D1AFCA19-923C-B2E1-4542-9FD9C8FB66C8}"/>
+              </a:ext>
+            </a:extLst>
+          </p:cNvPr>
+          <p:cNvPicPr>
+            <a:picLocks noChangeAspect="1"/>
+          </p:cNvPicPr>
+          <p:nvPr/>
+        </p:nvPicPr>
+        <p:blipFill>
+          <a:blip r:embed="rId5"/>
+          <a:stretch>
+            <a:fillRect/>
+          </a:stretch>
+        </p:blipFill>
+        <p:spPr>
+          <a:xfrm>
+            <a:off x="914773" y="3803581"/>
+            <a:ext cx="2721291" cy="1591873"/>
+          </a:xfrm>
+          <a:prstGeom prst="rect">
+            <a:avLst/>
+          </a:prstGeom>
+        </p:spPr>
+      </p:pic>
+      <p:pic>
+        <p:nvPicPr>
+          <p:cNvPr id="12" name="Image 11">
+            <a:extLst>
+              <a:ext uri="{FF2B5EF4-FFF2-40B4-BE49-F238E27FC236}">
+                <a16:creationId xmlns:a16="http://schemas.microsoft.com/office/drawing/2014/main" id="{8CE40920-D2F2-4DCD-E0DB-060718A0E545}"/>
+              </a:ext>
+            </a:extLst>
+          </p:cNvPr>
+          <p:cNvPicPr>
+            <a:picLocks noChangeAspect="1"/>
+          </p:cNvPicPr>
+          <p:nvPr/>
+        </p:nvPicPr>
+        <p:blipFill>
+          <a:blip r:embed="rId6"/>
+          <a:stretch>
+            <a:fillRect/>
+          </a:stretch>
+        </p:blipFill>
+        <p:spPr>
+          <a:xfrm>
+            <a:off x="3723319" y="3813560"/>
+            <a:ext cx="2576898" cy="1581894"/>
+          </a:xfrm>
+          <a:prstGeom prst="rect">
+            <a:avLst/>
+          </a:prstGeom>
+        </p:spPr>
+      </p:pic>
+      <p:sp>
+        <p:nvSpPr>
+          <p:cNvPr id="15" name="ZoneTexte 14">
+            <a:extLst>
+              <a:ext uri="{FF2B5EF4-FFF2-40B4-BE49-F238E27FC236}">
+                <a16:creationId xmlns:a16="http://schemas.microsoft.com/office/drawing/2014/main" id="{DC22E4E6-ED57-8B00-7961-177B59E2654B}"/>
+              </a:ext>
+            </a:extLst>
+          </p:cNvPr>
+          <p:cNvSpPr txBox="1"/>
+          <p:nvPr/>
+        </p:nvSpPr>
+        <p:spPr>
+          <a:xfrm>
+            <a:off x="1309079" y="2374975"/>
+            <a:ext cx="9573839" cy="923330"/>
+          </a:xfrm>
+          <a:prstGeom prst="rect">
+            <a:avLst/>
+          </a:prstGeom>
+          <a:noFill/>
+        </p:spPr>
+        <p:txBody>
+          <a:bodyPr wrap="square">
+            <a:spAutoFit/>
+          </a:bodyPr>
+          <a:lstStyle/>
+          <a:p>
+            <a:pPr algn="just"/>
+            <a:r>
+              <a:rPr lang="fr-FR" sz="1800" dirty="0">
+                <a:solidFill>
+                  <a:schemeClr val="bg1"/>
+                </a:solidFill>
+                <a:latin typeface="Century Gothic" panose="020B0502020202020204" pitchFamily="34" charset="0"/>
+              </a:rPr>
+              <a:t>Nous sommes en train de réaliser une étude de grande ampleur sur le thème de l’alimentation et plus particulièrement sur la sous-nutrition dans le monde. Nous allons utiliser 4 fichiers de la FAO (Food and Agriculture Organisation).</a:t>
+            </a:r>
+          </a:p>
+        </p:txBody>
+      </p:sp>
+      <p:sp>
+        <p:nvSpPr>
+          <p:cNvPr id="18" name="ZoneTexte 17">
+            <a:extLst>
+              <a:ext uri="{FF2B5EF4-FFF2-40B4-BE49-F238E27FC236}">
+                <a16:creationId xmlns:a16="http://schemas.microsoft.com/office/drawing/2014/main" id="{B8AD7F91-224E-4E58-1E9B-8CF6F2BC5A10}"/>
+              </a:ext>
+            </a:extLst>
+          </p:cNvPr>
+          <p:cNvSpPr txBox="1"/>
+          <p:nvPr/>
+        </p:nvSpPr>
+        <p:spPr>
+          <a:xfrm>
+            <a:off x="1580356" y="5531398"/>
+            <a:ext cx="1390124" cy="369332"/>
+          </a:xfrm>
+          <a:prstGeom prst="rect">
+            <a:avLst/>
+          </a:prstGeom>
+          <a:noFill/>
+        </p:spPr>
+        <p:txBody>
+          <a:bodyPr wrap="none" rtlCol="0">
+            <a:spAutoFit/>
+          </a:bodyPr>
+          <a:lstStyle/>
+          <a:p>
+            <a:r>
+              <a:rPr lang="fr-FR" sz="1800" dirty="0">
+                <a:solidFill>
+                  <a:schemeClr val="bg1"/>
+                </a:solidFill>
+                <a:latin typeface="Century Gothic" panose="020B0502020202020204" pitchFamily="34" charset="0"/>
+              </a:rPr>
+              <a:t>Population</a:t>
+            </a:r>
+          </a:p>
+        </p:txBody>
+      </p:sp>
+      <p:sp>
+        <p:nvSpPr>
+          <p:cNvPr id="19" name="ZoneTexte 18">
+            <a:extLst>
+              <a:ext uri="{FF2B5EF4-FFF2-40B4-BE49-F238E27FC236}">
+                <a16:creationId xmlns:a16="http://schemas.microsoft.com/office/drawing/2014/main" id="{FE5646BF-38AB-8B4E-AE81-B47E38FFB4CD}"/>
+              </a:ext>
+            </a:extLst>
+          </p:cNvPr>
+          <p:cNvSpPr txBox="1"/>
+          <p:nvPr/>
+        </p:nvSpPr>
+        <p:spPr>
+          <a:xfrm>
+            <a:off x="3993700" y="5531398"/>
+            <a:ext cx="2036135" cy="369332"/>
+          </a:xfrm>
+          <a:prstGeom prst="rect">
+            <a:avLst/>
+          </a:prstGeom>
+          <a:noFill/>
+        </p:spPr>
+        <p:txBody>
+          <a:bodyPr wrap="none" rtlCol="0">
+            <a:spAutoFit/>
+          </a:bodyPr>
+          <a:lstStyle/>
+          <a:p>
+            <a:r>
+              <a:rPr lang="fr-FR" sz="1800" dirty="0">
+                <a:solidFill>
+                  <a:schemeClr val="bg1"/>
+                </a:solidFill>
+                <a:latin typeface="Century Gothic" panose="020B0502020202020204" pitchFamily="34" charset="0"/>
+              </a:rPr>
+              <a:t>Aide alimentaire</a:t>
+            </a:r>
+          </a:p>
+        </p:txBody>
+      </p:sp>
+      <p:sp>
+        <p:nvSpPr>
+          <p:cNvPr id="20" name="ZoneTexte 19">
+            <a:extLst>
+              <a:ext uri="{FF2B5EF4-FFF2-40B4-BE49-F238E27FC236}">
+                <a16:creationId xmlns:a16="http://schemas.microsoft.com/office/drawing/2014/main" id="{34CD730F-DE43-F7D8-55FB-06E87979880C}"/>
+              </a:ext>
+            </a:extLst>
+          </p:cNvPr>
+          <p:cNvSpPr txBox="1"/>
+          <p:nvPr/>
+        </p:nvSpPr>
+        <p:spPr>
+          <a:xfrm>
+            <a:off x="6770325" y="5531398"/>
+            <a:ext cx="1638590" cy="369332"/>
+          </a:xfrm>
+          <a:prstGeom prst="rect">
+            <a:avLst/>
+          </a:prstGeom>
+          <a:noFill/>
+        </p:spPr>
+        <p:txBody>
+          <a:bodyPr wrap="none" rtlCol="0">
+            <a:spAutoFit/>
+          </a:bodyPr>
+          <a:lstStyle/>
+          <a:p>
+            <a:r>
+              <a:rPr lang="fr-FR" sz="1800" dirty="0">
+                <a:solidFill>
+                  <a:schemeClr val="bg1"/>
+                </a:solidFill>
+                <a:latin typeface="Century Gothic" panose="020B0502020202020204" pitchFamily="34" charset="0"/>
+              </a:rPr>
+              <a:t>Sous nutrition</a:t>
+            </a:r>
+          </a:p>
+        </p:txBody>
+      </p:sp>
+      <p:sp>
+        <p:nvSpPr>
+          <p:cNvPr id="21" name="ZoneTexte 20">
+            <a:extLst>
+              <a:ext uri="{FF2B5EF4-FFF2-40B4-BE49-F238E27FC236}">
+                <a16:creationId xmlns:a16="http://schemas.microsoft.com/office/drawing/2014/main" id="{CA73EB3A-A00B-827C-12E6-9E9C62C1B0EA}"/>
+              </a:ext>
+            </a:extLst>
+          </p:cNvPr>
+          <p:cNvSpPr txBox="1"/>
+          <p:nvPr/>
+        </p:nvSpPr>
+        <p:spPr>
+          <a:xfrm>
+            <a:off x="9257699" y="5531398"/>
+            <a:ext cx="2124299" cy="369332"/>
+          </a:xfrm>
+          <a:prstGeom prst="rect">
+            <a:avLst/>
+          </a:prstGeom>
+          <a:noFill/>
+        </p:spPr>
+        <p:txBody>
+          <a:bodyPr wrap="none" rtlCol="0">
+            <a:spAutoFit/>
+          </a:bodyPr>
+          <a:lstStyle/>
+          <a:p>
+            <a:r>
+              <a:rPr lang="fr-FR" sz="1800" dirty="0">
+                <a:solidFill>
+                  <a:schemeClr val="bg1"/>
+                </a:solidFill>
+                <a:latin typeface="Century Gothic" panose="020B0502020202020204" pitchFamily="34" charset="0"/>
+              </a:rPr>
+              <a:t>Dispo alimentaire</a:t>
+            </a:r>
+          </a:p>
+        </p:txBody>
+      </p:sp>
     </p:spTree>
   </p:cSld>
   <p:clrMapOvr>
@@ -24738,448 +25499,286 @@
           </a:p>
         </p:txBody>
       </p:sp>
+      <p:pic>
+        <p:nvPicPr>
+          <p:cNvPr id="2" name="Image 1">
+            <a:extLst>
+              <a:ext uri="{FF2B5EF4-FFF2-40B4-BE49-F238E27FC236}">
+                <a16:creationId xmlns:a16="http://schemas.microsoft.com/office/drawing/2014/main" id="{3B15BA9A-FE9C-13C9-8D6D-B0203B27CDA7}"/>
+              </a:ext>
+            </a:extLst>
+          </p:cNvPr>
+          <p:cNvPicPr>
+            <a:picLocks noChangeAspect="1"/>
+          </p:cNvPicPr>
+          <p:nvPr/>
+        </p:nvPicPr>
+        <p:blipFill>
+          <a:blip r:embed="rId3"/>
+          <a:stretch>
+            <a:fillRect/>
+          </a:stretch>
+        </p:blipFill>
+        <p:spPr>
+          <a:xfrm>
+            <a:off x="3954668" y="2219681"/>
+            <a:ext cx="3782968" cy="2127920"/>
+          </a:xfrm>
+          <a:prstGeom prst="rect">
+            <a:avLst/>
+          </a:prstGeom>
+        </p:spPr>
+      </p:pic>
       <p:sp>
         <p:nvSpPr>
-          <p:cNvPr id="138" name="Google Shape;138;p3"/>
-          <p:cNvSpPr txBox="1">
-            <a:spLocks noGrp="1"/>
-          </p:cNvSpPr>
-          <p:nvPr>
-            <p:ph type="body" idx="1"/>
-          </p:nvPr>
+          <p:cNvPr id="6" name="ZoneTexte 5">
+            <a:extLst>
+              <a:ext uri="{FF2B5EF4-FFF2-40B4-BE49-F238E27FC236}">
+                <a16:creationId xmlns:a16="http://schemas.microsoft.com/office/drawing/2014/main" id="{083BBDBB-4C1A-0131-5FF2-0FC124AAF63E}"/>
+              </a:ext>
+            </a:extLst>
+          </p:cNvPr>
+          <p:cNvSpPr txBox="1"/>
+          <p:nvPr/>
         </p:nvSpPr>
         <p:spPr>
           <a:xfrm>
-            <a:off x="818712" y="2222287"/>
-            <a:ext cx="10554574" cy="3636511"/>
+            <a:off x="861669" y="6210757"/>
+            <a:ext cx="9030036" cy="400110"/>
           </a:xfrm>
           <a:prstGeom prst="rect">
             <a:avLst/>
           </a:prstGeom>
           <a:noFill/>
-          <a:ln>
-            <a:noFill/>
-          </a:ln>
-          <a:effectLst>
-            <a:outerShdw blurRad="50800">
-              <a:srgbClr val="000000">
-                <a:alpha val="40000"/>
-              </a:srgbClr>
-            </a:outerShdw>
-          </a:effectLst>
         </p:spPr>
         <p:txBody>
-          <a:bodyPr spcFirstLastPara="1" wrap="square" lIns="91425" tIns="45700" rIns="91425" bIns="45700" anchor="ctr" anchorCtr="0">
-            <a:normAutofit/>
+          <a:bodyPr wrap="none" rtlCol="0">
+            <a:spAutoFit/>
           </a:bodyPr>
           <a:lstStyle/>
           <a:p>
-            <a:pPr marL="342900" lvl="0" indent="-228600" algn="l" rtl="0">
-              <a:lnSpc>
-                <a:spcPct val="100000"/>
-              </a:lnSpc>
-              <a:spcBef>
-                <a:spcPts val="0"/>
-              </a:spcBef>
-              <a:spcAft>
-                <a:spcPts val="0"/>
-              </a:spcAft>
-              <a:buSzPts val="1800"/>
-              <a:buNone/>
-            </a:pPr>
-            <a:endParaRPr/>
+            <a:r>
+              <a:rPr lang="fr-FR" sz="2000" dirty="0">
+                <a:solidFill>
+                  <a:schemeClr val="bg1"/>
+                </a:solidFill>
+                <a:latin typeface="Century Gothic" panose="020B0502020202020204" pitchFamily="34" charset="0"/>
+              </a:rPr>
+              <a:t>Ici on ne traite aucune donnée personnelle, le RGPD ne s’applique pas.</a:t>
+            </a:r>
+          </a:p>
+        </p:txBody>
+      </p:sp>
+      <p:pic>
+        <p:nvPicPr>
+          <p:cNvPr id="7" name="Image 6">
+            <a:extLst>
+              <a:ext uri="{FF2B5EF4-FFF2-40B4-BE49-F238E27FC236}">
+                <a16:creationId xmlns:a16="http://schemas.microsoft.com/office/drawing/2014/main" id="{B990FCBC-1B23-B5D7-6316-6C6F69C6756D}"/>
+              </a:ext>
+            </a:extLst>
+          </p:cNvPr>
+          <p:cNvPicPr>
+            <a:picLocks noChangeAspect="1"/>
+          </p:cNvPicPr>
+          <p:nvPr/>
+        </p:nvPicPr>
+        <p:blipFill>
+          <a:blip r:embed="rId4"/>
+          <a:stretch>
+            <a:fillRect/>
+          </a:stretch>
+        </p:blipFill>
+        <p:spPr>
+          <a:xfrm>
+            <a:off x="8037854" y="2219681"/>
+            <a:ext cx="2987053" cy="1274476"/>
+          </a:xfrm>
+          <a:prstGeom prst="rect">
+            <a:avLst/>
+          </a:prstGeom>
+        </p:spPr>
+      </p:pic>
+      <p:pic>
+        <p:nvPicPr>
+          <p:cNvPr id="8" name="Image 7">
+            <a:extLst>
+              <a:ext uri="{FF2B5EF4-FFF2-40B4-BE49-F238E27FC236}">
+                <a16:creationId xmlns:a16="http://schemas.microsoft.com/office/drawing/2014/main" id="{04931248-A79D-0AF4-F81B-E47B6EF5BB30}"/>
+              </a:ext>
+            </a:extLst>
+          </p:cNvPr>
+          <p:cNvPicPr>
+            <a:picLocks noChangeAspect="1"/>
+          </p:cNvPicPr>
+          <p:nvPr/>
+        </p:nvPicPr>
+        <p:blipFill>
+          <a:blip r:embed="rId5"/>
+          <a:stretch>
+            <a:fillRect/>
+          </a:stretch>
+        </p:blipFill>
+        <p:spPr>
+          <a:xfrm>
+            <a:off x="8037853" y="3494157"/>
+            <a:ext cx="2987053" cy="853444"/>
+          </a:xfrm>
+          <a:prstGeom prst="rect">
+            <a:avLst/>
+          </a:prstGeom>
+        </p:spPr>
+      </p:pic>
+      <p:pic>
+        <p:nvPicPr>
+          <p:cNvPr id="11" name="Image 10">
+            <a:extLst>
+              <a:ext uri="{FF2B5EF4-FFF2-40B4-BE49-F238E27FC236}">
+                <a16:creationId xmlns:a16="http://schemas.microsoft.com/office/drawing/2014/main" id="{2D223084-931D-FFB2-E638-36887CF766F6}"/>
+              </a:ext>
+            </a:extLst>
+          </p:cNvPr>
+          <p:cNvPicPr>
+            <a:picLocks noChangeAspect="1"/>
+          </p:cNvPicPr>
+          <p:nvPr/>
+        </p:nvPicPr>
+        <p:blipFill>
+          <a:blip r:embed="rId6"/>
+          <a:stretch>
+            <a:fillRect/>
+          </a:stretch>
+        </p:blipFill>
+        <p:spPr>
+          <a:xfrm>
+            <a:off x="810000" y="2209616"/>
+            <a:ext cx="2844450" cy="2137985"/>
+          </a:xfrm>
+          <a:prstGeom prst="rect">
+            <a:avLst/>
+          </a:prstGeom>
+        </p:spPr>
+      </p:pic>
+      <p:sp>
+        <p:nvSpPr>
+          <p:cNvPr id="12" name="ZoneTexte 11">
+            <a:extLst>
+              <a:ext uri="{FF2B5EF4-FFF2-40B4-BE49-F238E27FC236}">
+                <a16:creationId xmlns:a16="http://schemas.microsoft.com/office/drawing/2014/main" id="{17D4718E-3242-053A-E02A-1051C4EDB346}"/>
+              </a:ext>
+            </a:extLst>
+          </p:cNvPr>
+          <p:cNvSpPr txBox="1"/>
+          <p:nvPr/>
+        </p:nvSpPr>
+        <p:spPr>
+          <a:xfrm>
+            <a:off x="810000" y="4626272"/>
+            <a:ext cx="2844450" cy="369332"/>
+          </a:xfrm>
+          <a:prstGeom prst="rect">
+            <a:avLst/>
+          </a:prstGeom>
+          <a:noFill/>
+        </p:spPr>
+        <p:txBody>
+          <a:bodyPr wrap="square" rtlCol="0">
+            <a:spAutoFit/>
+          </a:bodyPr>
+          <a:lstStyle/>
+          <a:p>
+            <a:pPr algn="just"/>
+            <a:r>
+              <a:rPr lang="fr-FR" sz="1800" dirty="0">
+                <a:solidFill>
+                  <a:schemeClr val="bg1"/>
+                </a:solidFill>
+                <a:latin typeface="Century Gothic" panose="020B0502020202020204" pitchFamily="34" charset="0"/>
+              </a:rPr>
+              <a:t>Donnée brutes (4 csv)</a:t>
+            </a:r>
           </a:p>
         </p:txBody>
       </p:sp>
       <p:sp>
         <p:nvSpPr>
-          <p:cNvPr id="139" name="Google Shape;139;p3"/>
-          <p:cNvSpPr/>
+          <p:cNvPr id="13" name="ZoneTexte 12">
+            <a:extLst>
+              <a:ext uri="{FF2B5EF4-FFF2-40B4-BE49-F238E27FC236}">
+                <a16:creationId xmlns:a16="http://schemas.microsoft.com/office/drawing/2014/main" id="{061CF1BD-A45D-224F-ACCA-1E870EB53166}"/>
+              </a:ext>
+            </a:extLst>
+          </p:cNvPr>
+          <p:cNvSpPr txBox="1"/>
           <p:nvPr/>
         </p:nvSpPr>
         <p:spPr>
           <a:xfrm>
-            <a:off x="7823925" y="2222275"/>
-            <a:ext cx="3691200" cy="3783000"/>
+            <a:off x="3954668" y="4626272"/>
+            <a:ext cx="3782968" cy="369332"/>
           </a:xfrm>
           <a:prstGeom prst="rect">
             <a:avLst/>
           </a:prstGeom>
-          <a:solidFill>
-            <a:srgbClr val="FFFF00"/>
-          </a:solidFill>
-          <a:ln w="15875" cap="rnd" cmpd="sng">
-            <a:solidFill>
-              <a:srgbClr val="AE813B"/>
-            </a:solidFill>
-            <a:prstDash val="solid"/>
-            <a:round/>
-            <a:headEnd type="none" w="sm" len="sm"/>
-            <a:tailEnd type="none" w="sm" len="sm"/>
-          </a:ln>
+          <a:noFill/>
         </p:spPr>
         <p:txBody>
-          <a:bodyPr spcFirstLastPara="1" wrap="square" lIns="91425" tIns="45700" rIns="91425" bIns="45700" anchor="ctr" anchorCtr="0">
-            <a:noAutofit/>
+          <a:bodyPr wrap="square" rtlCol="0">
+            <a:spAutoFit/>
           </a:bodyPr>
           <a:lstStyle/>
           <a:p>
-            <a:pPr marL="0" marR="0" lvl="0" indent="0" algn="ctr" rtl="0">
-              <a:lnSpc>
-                <a:spcPct val="100000"/>
-              </a:lnSpc>
-              <a:spcBef>
-                <a:spcPts val="0"/>
-              </a:spcBef>
-              <a:spcAft>
-                <a:spcPts val="0"/>
-              </a:spcAft>
-              <a:buClr>
-                <a:srgbClr val="000000"/>
-              </a:buClr>
-              <a:buSzPts val="1800"/>
-              <a:buFont typeface="Arial"/>
-              <a:buNone/>
-            </a:pPr>
+            <a:pPr algn="just"/>
             <a:r>
-              <a:rPr lang="fr-FR" sz="1800" b="0" i="0" u="none" strike="noStrike" cap="none">
-                <a:solidFill>
-                  <a:srgbClr val="000000"/>
-                </a:solidFill>
-                <a:latin typeface="Century Gothic"/>
-                <a:ea typeface="Century Gothic"/>
-                <a:cs typeface="Century Gothic"/>
-                <a:sym typeface="Century Gothic"/>
+              <a:rPr lang="fr-FR" sz="1800" dirty="0">
+                <a:solidFill>
+                  <a:schemeClr val="bg1"/>
+                </a:solidFill>
+                <a:latin typeface="Century Gothic" panose="020B0502020202020204" pitchFamily="34" charset="0"/>
               </a:rPr>
-              <a:t>MEMO : </a:t>
+              <a:t>Traitement statistique</a:t>
             </a:r>
-            <a:endParaRPr sz="1400" b="0" i="0" u="none" strike="noStrike" cap="none">
-              <a:solidFill>
-                <a:srgbClr val="000000"/>
-              </a:solidFill>
-              <a:latin typeface="Arial"/>
-              <a:ea typeface="Arial"/>
-              <a:cs typeface="Arial"/>
-              <a:sym typeface="Arial"/>
-            </a:endParaRPr>
-          </a:p>
-          <a:p>
-            <a:pPr marL="0" marR="0" lvl="0" indent="0" algn="ctr" rtl="0">
-              <a:lnSpc>
-                <a:spcPct val="100000"/>
-              </a:lnSpc>
-              <a:spcBef>
-                <a:spcPts val="0"/>
-              </a:spcBef>
-              <a:spcAft>
-                <a:spcPts val="0"/>
-              </a:spcAft>
-              <a:buClr>
-                <a:srgbClr val="000000"/>
-              </a:buClr>
-              <a:buSzPts val="1800"/>
-              <a:buFont typeface="Arial"/>
-              <a:buNone/>
-            </a:pPr>
-            <a:r>
-              <a:rPr lang="fr-FR" sz="1800" b="0" i="0" u="none" strike="noStrike" cap="none">
-                <a:solidFill>
-                  <a:srgbClr val="000000"/>
-                </a:solidFill>
-                <a:latin typeface="Century Gothic"/>
-                <a:ea typeface="Century Gothic"/>
-                <a:cs typeface="Century Gothic"/>
-                <a:sym typeface="Century Gothic"/>
-              </a:rPr>
-              <a:t>Comment j’ai fait mon analyse ? </a:t>
-            </a:r>
-            <a:endParaRPr sz="1400" b="0" i="0" u="none" strike="noStrike" cap="none">
-              <a:solidFill>
-                <a:srgbClr val="000000"/>
-              </a:solidFill>
-              <a:latin typeface="Arial"/>
-              <a:ea typeface="Arial"/>
-              <a:cs typeface="Arial"/>
-              <a:sym typeface="Arial"/>
-            </a:endParaRPr>
-          </a:p>
-          <a:p>
-            <a:pPr marL="0" marR="0" lvl="0" indent="0" algn="ctr" rtl="0">
-              <a:lnSpc>
-                <a:spcPct val="100000"/>
-              </a:lnSpc>
-              <a:spcBef>
-                <a:spcPts val="0"/>
-              </a:spcBef>
-              <a:spcAft>
-                <a:spcPts val="0"/>
-              </a:spcAft>
-              <a:buClr>
-                <a:srgbClr val="000000"/>
-              </a:buClr>
-              <a:buSzPts val="1800"/>
-              <a:buFont typeface="Arial"/>
-              <a:buNone/>
-            </a:pPr>
-            <a:endParaRPr sz="1800" b="0" i="0" u="none" strike="noStrike" cap="none">
-              <a:solidFill>
-                <a:srgbClr val="000000"/>
-              </a:solidFill>
-              <a:latin typeface="Century Gothic"/>
-              <a:ea typeface="Century Gothic"/>
-              <a:cs typeface="Century Gothic"/>
-              <a:sym typeface="Century Gothic"/>
-            </a:endParaRPr>
-          </a:p>
-          <a:p>
-            <a:pPr marL="0" marR="0" lvl="0" indent="0" algn="ctr" rtl="0">
-              <a:lnSpc>
-                <a:spcPct val="100000"/>
-              </a:lnSpc>
-              <a:spcBef>
-                <a:spcPts val="0"/>
-              </a:spcBef>
-              <a:spcAft>
-                <a:spcPts val="0"/>
-              </a:spcAft>
-              <a:buClr>
-                <a:srgbClr val="000000"/>
-              </a:buClr>
-              <a:buSzPts val="1800"/>
-              <a:buFont typeface="Arial"/>
-              <a:buNone/>
-            </a:pPr>
-            <a:r>
-              <a:rPr lang="fr-FR" sz="1800" b="0" i="0" u="none" strike="noStrike" cap="none">
-                <a:solidFill>
-                  <a:srgbClr val="000000"/>
-                </a:solidFill>
-                <a:latin typeface="Century Gothic"/>
-                <a:ea typeface="Century Gothic"/>
-                <a:cs typeface="Century Gothic"/>
-                <a:sym typeface="Century Gothic"/>
-              </a:rPr>
-              <a:t>Attention, il faut s’adapter à l’interlocuteur (pas trop de technique)</a:t>
-            </a:r>
-            <a:endParaRPr sz="1400" b="0" i="0" u="none" strike="noStrike" cap="none">
-              <a:solidFill>
-                <a:srgbClr val="000000"/>
-              </a:solidFill>
-              <a:latin typeface="Arial"/>
-              <a:ea typeface="Arial"/>
-              <a:cs typeface="Arial"/>
-              <a:sym typeface="Arial"/>
-            </a:endParaRPr>
-          </a:p>
-          <a:p>
-            <a:pPr marL="0" marR="0" lvl="0" indent="0" algn="ctr" rtl="0">
-              <a:lnSpc>
-                <a:spcPct val="100000"/>
-              </a:lnSpc>
-              <a:spcBef>
-                <a:spcPts val="0"/>
-              </a:spcBef>
-              <a:spcAft>
-                <a:spcPts val="0"/>
-              </a:spcAft>
-              <a:buClr>
-                <a:srgbClr val="000000"/>
-              </a:buClr>
-              <a:buSzPts val="1800"/>
-              <a:buFont typeface="Arial"/>
-              <a:buNone/>
-            </a:pPr>
-            <a:r>
-              <a:rPr lang="fr-FR" sz="1800" b="0" i="0" u="none" strike="noStrike" cap="none">
-                <a:solidFill>
-                  <a:srgbClr val="000000"/>
-                </a:solidFill>
-                <a:latin typeface="Century Gothic"/>
-                <a:ea typeface="Century Gothic"/>
-                <a:cs typeface="Century Gothic"/>
-                <a:sym typeface="Century Gothic"/>
-              </a:rPr>
-              <a:t>Vérifier que l’interlocuteur comprend  bien les choses</a:t>
-            </a:r>
-            <a:endParaRPr sz="1800" b="0" i="0" u="none" strike="noStrike" cap="none">
-              <a:solidFill>
-                <a:srgbClr val="000000"/>
-              </a:solidFill>
-              <a:latin typeface="Century Gothic"/>
-              <a:ea typeface="Century Gothic"/>
-              <a:cs typeface="Century Gothic"/>
-              <a:sym typeface="Century Gothic"/>
-            </a:endParaRPr>
-          </a:p>
-          <a:p>
-            <a:pPr marL="0" marR="0" lvl="0" indent="0" algn="ctr" rtl="0">
-              <a:lnSpc>
-                <a:spcPct val="100000"/>
-              </a:lnSpc>
-              <a:spcBef>
-                <a:spcPts val="0"/>
-              </a:spcBef>
-              <a:spcAft>
-                <a:spcPts val="0"/>
-              </a:spcAft>
-              <a:buClr>
-                <a:srgbClr val="000000"/>
-              </a:buClr>
-              <a:buSzPts val="1800"/>
-              <a:buFont typeface="Arial"/>
-              <a:buNone/>
-            </a:pPr>
-            <a:endParaRPr sz="1800" b="0" i="0" u="none" strike="noStrike" cap="none">
-              <a:solidFill>
-                <a:srgbClr val="000000"/>
-              </a:solidFill>
-              <a:latin typeface="Century Gothic"/>
-              <a:ea typeface="Century Gothic"/>
-              <a:cs typeface="Century Gothic"/>
-              <a:sym typeface="Century Gothic"/>
-            </a:endParaRPr>
-          </a:p>
-          <a:p>
-            <a:pPr marL="0" marR="0" lvl="0" indent="0" algn="ctr" rtl="0">
-              <a:lnSpc>
-                <a:spcPct val="100000"/>
-              </a:lnSpc>
-              <a:spcBef>
-                <a:spcPts val="0"/>
-              </a:spcBef>
-              <a:spcAft>
-                <a:spcPts val="0"/>
-              </a:spcAft>
-              <a:buClr>
-                <a:srgbClr val="000000"/>
-              </a:buClr>
-              <a:buSzPts val="1800"/>
-              <a:buFont typeface="Arial"/>
-              <a:buNone/>
-            </a:pPr>
-            <a:r>
-              <a:rPr lang="fr-FR" sz="1800" b="0" i="0" u="none" strike="noStrike" cap="none">
-                <a:solidFill>
-                  <a:srgbClr val="000000"/>
-                </a:solidFill>
-                <a:latin typeface="Century Gothic"/>
-                <a:ea typeface="Century Gothic"/>
-                <a:cs typeface="Century Gothic"/>
-                <a:sym typeface="Century Gothic"/>
-              </a:rPr>
-              <a:t>Penser à commenter les slides pendant la présentation mais à ne pas les lire</a:t>
-            </a:r>
-            <a:endParaRPr sz="1800" b="0" i="0" u="none" strike="noStrike" cap="none">
-              <a:solidFill>
-                <a:srgbClr val="000000"/>
-              </a:solidFill>
-              <a:latin typeface="Century Gothic"/>
-              <a:ea typeface="Century Gothic"/>
-              <a:cs typeface="Century Gothic"/>
-              <a:sym typeface="Century Gothic"/>
-            </a:endParaRPr>
-          </a:p>
-          <a:p>
-            <a:pPr marL="0" marR="0" lvl="0" indent="0" algn="ctr" rtl="0">
-              <a:lnSpc>
-                <a:spcPct val="100000"/>
-              </a:lnSpc>
-              <a:spcBef>
-                <a:spcPts val="0"/>
-              </a:spcBef>
-              <a:spcAft>
-                <a:spcPts val="0"/>
-              </a:spcAft>
-              <a:buClr>
-                <a:srgbClr val="000000"/>
-              </a:buClr>
-              <a:buSzPts val="1800"/>
-              <a:buFont typeface="Arial"/>
-              <a:buNone/>
-            </a:pPr>
-            <a:endParaRPr sz="1800" b="0" i="0" u="none" strike="noStrike" cap="none">
-              <a:solidFill>
-                <a:srgbClr val="000000"/>
-              </a:solidFill>
-              <a:latin typeface="Century Gothic"/>
-              <a:ea typeface="Century Gothic"/>
-              <a:cs typeface="Century Gothic"/>
-              <a:sym typeface="Century Gothic"/>
-            </a:endParaRPr>
           </a:p>
         </p:txBody>
       </p:sp>
       <p:sp>
         <p:nvSpPr>
-          <p:cNvPr id="140" name="Google Shape;140;p3"/>
-          <p:cNvSpPr/>
+          <p:cNvPr id="14" name="ZoneTexte 13">
+            <a:extLst>
+              <a:ext uri="{FF2B5EF4-FFF2-40B4-BE49-F238E27FC236}">
+                <a16:creationId xmlns:a16="http://schemas.microsoft.com/office/drawing/2014/main" id="{CD6A90EC-6099-7E3B-C134-5FA9C0719DC6}"/>
+              </a:ext>
+            </a:extLst>
+          </p:cNvPr>
+          <p:cNvSpPr txBox="1"/>
           <p:nvPr/>
         </p:nvSpPr>
         <p:spPr>
           <a:xfrm>
-            <a:off x="4878750" y="3605500"/>
-            <a:ext cx="2653800" cy="2716200"/>
+            <a:off x="8037852" y="4626272"/>
+            <a:ext cx="2987053" cy="369332"/>
           </a:xfrm>
           <a:prstGeom prst="rect">
             <a:avLst/>
           </a:prstGeom>
-          <a:solidFill>
-            <a:srgbClr val="FFFF00"/>
-          </a:solidFill>
-          <a:ln w="15875" cap="rnd" cmpd="sng">
-            <a:solidFill>
-              <a:srgbClr val="AE813B"/>
-            </a:solidFill>
-            <a:prstDash val="solid"/>
-            <a:round/>
-            <a:headEnd type="none" w="sm" len="sm"/>
-            <a:tailEnd type="none" w="sm" len="sm"/>
-          </a:ln>
+          <a:noFill/>
         </p:spPr>
         <p:txBody>
-          <a:bodyPr spcFirstLastPara="1" wrap="square" lIns="91425" tIns="45700" rIns="91425" bIns="45700" anchor="ctr" anchorCtr="0">
-            <a:noAutofit/>
+          <a:bodyPr wrap="square" rtlCol="0">
+            <a:spAutoFit/>
           </a:bodyPr>
           <a:lstStyle/>
           <a:p>
-            <a:pPr marL="0" marR="0" lvl="0" indent="0" algn="l" rtl="0">
-              <a:lnSpc>
-                <a:spcPct val="100000"/>
-              </a:lnSpc>
-              <a:spcBef>
-                <a:spcPts val="0"/>
-              </a:spcBef>
-              <a:spcAft>
-                <a:spcPts val="0"/>
-              </a:spcAft>
-              <a:buClr>
-                <a:srgbClr val="000000"/>
-              </a:buClr>
-              <a:buSzPts val="1800"/>
-              <a:buFont typeface="Arial"/>
-              <a:buNone/>
-            </a:pPr>
+            <a:pPr algn="just"/>
             <a:r>
-              <a:rPr lang="fr-FR" sz="1800" b="0" i="0" u="none" strike="noStrike" cap="none">
-                <a:solidFill>
-                  <a:srgbClr val="000000"/>
-                </a:solidFill>
-                <a:latin typeface="Century Gothic"/>
-                <a:ea typeface="Century Gothic"/>
-                <a:cs typeface="Century Gothic"/>
-                <a:sym typeface="Century Gothic"/>
+              <a:rPr lang="fr-FR" sz="1800" dirty="0">
+                <a:solidFill>
+                  <a:schemeClr val="bg1"/>
+                </a:solidFill>
+                <a:latin typeface="Century Gothic" panose="020B0502020202020204" pitchFamily="34" charset="0"/>
               </a:rPr>
-              <a:t>Est-ce que le RGPD s’applique dans notre projet ?</a:t>
+              <a:t>Visualisation graphique</a:t>
             </a:r>
-            <a:endParaRPr sz="1800" b="0" i="0" u="none" strike="noStrike" cap="none">
-              <a:solidFill>
-                <a:srgbClr val="000000"/>
-              </a:solidFill>
-              <a:latin typeface="Century Gothic"/>
-              <a:ea typeface="Century Gothic"/>
-              <a:cs typeface="Century Gothic"/>
-              <a:sym typeface="Century Gothic"/>
-            </a:endParaRPr>
           </a:p>
         </p:txBody>
       </p:sp>
@@ -25262,10 +25861,14 @@
               <a:buNone/>
             </a:pPr>
             <a:r>
-              <a:rPr lang="fr-FR" sz="3200"/>
+              <a:rPr lang="fr-FR" sz="3200">
+                <a:latin typeface="Century Gothic" panose="020B0502020202020204" pitchFamily="34" charset="0"/>
+              </a:rPr>
               <a:t>1) Proportion de personnes en état de sous-nutrition en 2017</a:t>
             </a:r>
-            <a:endParaRPr sz="3200"/>
+            <a:endParaRPr sz="3200">
+              <a:latin typeface="Century Gothic" panose="020B0502020202020204" pitchFamily="34" charset="0"/>
+            </a:endParaRPr>
           </a:p>
         </p:txBody>
       </p:sp>
@@ -25318,7 +25921,15 @@
               <a:buSzPts val="1800"/>
               <a:buNone/>
             </a:pPr>
-            <a:endParaRPr/>
+            <a:r>
+              <a:rPr lang="fr-FR" dirty="0">
+                <a:latin typeface="Century Gothic" panose="020B0502020202020204" pitchFamily="34" charset="0"/>
+              </a:rPr>
+              <a:t>Mettre une infographie et un camembert.</a:t>
+            </a:r>
+            <a:endParaRPr dirty="0">
+              <a:latin typeface="Century Gothic" panose="020B0502020202020204" pitchFamily="34" charset="0"/>
+            </a:endParaRPr>
           </a:p>
         </p:txBody>
       </p:sp>
@@ -25377,7 +25988,7 @@
                 <a:solidFill>
                   <a:srgbClr val="000000"/>
                 </a:solidFill>
-                <a:latin typeface="Century Gothic"/>
+                <a:latin typeface="Century Gothic" panose="020B0502020202020204" pitchFamily="34" charset="0"/>
                 <a:ea typeface="Century Gothic"/>
                 <a:cs typeface="Century Gothic"/>
                 <a:sym typeface="Century Gothic"/>
@@ -25388,9 +25999,7 @@
               <a:solidFill>
                 <a:srgbClr val="000000"/>
               </a:solidFill>
-              <a:latin typeface="Arial"/>
-              <a:ea typeface="Arial"/>
-              <a:cs typeface="Arial"/>
+              <a:latin typeface="Century Gothic" panose="020B0502020202020204" pitchFamily="34" charset="0"/>
               <a:sym typeface="Arial"/>
             </a:endParaRPr>
           </a:p>
@@ -25417,7 +26026,7 @@
                 <a:solidFill>
                   <a:srgbClr val="000000"/>
                 </a:solidFill>
-                <a:latin typeface="Century Gothic"/>
+                <a:latin typeface="Century Gothic" panose="020B0502020202020204" pitchFamily="34" charset="0"/>
                 <a:ea typeface="Century Gothic"/>
                 <a:cs typeface="Century Gothic"/>
                 <a:sym typeface="Century Gothic"/>
@@ -25428,9 +26037,7 @@
               <a:solidFill>
                 <a:srgbClr val="000000"/>
               </a:solidFill>
-              <a:latin typeface="Arial"/>
-              <a:ea typeface="Arial"/>
-              <a:cs typeface="Arial"/>
+              <a:latin typeface="Century Gothic" panose="020B0502020202020204" pitchFamily="34" charset="0"/>
               <a:sym typeface="Arial"/>
             </a:endParaRPr>
           </a:p>
@@ -25456,7 +26063,7 @@
               <a:solidFill>
                 <a:srgbClr val="000000"/>
               </a:solidFill>
-              <a:latin typeface="Century Gothic"/>
+              <a:latin typeface="Century Gothic" panose="020B0502020202020204" pitchFamily="34" charset="0"/>
               <a:ea typeface="Century Gothic"/>
               <a:cs typeface="Century Gothic"/>
               <a:sym typeface="Century Gothic"/>
@@ -25485,7 +26092,7 @@
                 <a:solidFill>
                   <a:srgbClr val="000000"/>
                 </a:solidFill>
-                <a:latin typeface="Century Gothic"/>
+                <a:latin typeface="Century Gothic" panose="020B0502020202020204" pitchFamily="34" charset="0"/>
                 <a:ea typeface="Century Gothic"/>
                 <a:cs typeface="Century Gothic"/>
                 <a:sym typeface="Century Gothic"/>
@@ -25496,9 +26103,7 @@
               <a:solidFill>
                 <a:srgbClr val="000000"/>
               </a:solidFill>
-              <a:latin typeface="Arial"/>
-              <a:ea typeface="Arial"/>
-              <a:cs typeface="Arial"/>
+              <a:latin typeface="Century Gothic" panose="020B0502020202020204" pitchFamily="34" charset="0"/>
               <a:sym typeface="Arial"/>
             </a:endParaRPr>
           </a:p>
@@ -25583,10 +26188,14 @@
               <a:buNone/>
             </a:pPr>
             <a:r>
-              <a:rPr lang="fr-FR" sz="3200"/>
+              <a:rPr lang="fr-FR" sz="3200">
+                <a:latin typeface="Century Gothic" panose="020B0502020202020204" pitchFamily="34" charset="0"/>
+              </a:rPr>
               <a:t>2) Nombre théorique de personnes qui pourraient être nourries en 2017</a:t>
             </a:r>
-            <a:endParaRPr sz="3200"/>
+            <a:endParaRPr sz="3200">
+              <a:latin typeface="Century Gothic" panose="020B0502020202020204" pitchFamily="34" charset="0"/>
+            </a:endParaRPr>
           </a:p>
         </p:txBody>
       </p:sp>
@@ -25639,7 +26248,15 @@
               <a:buSzPts val="1800"/>
               <a:buNone/>
             </a:pPr>
-            <a:endParaRPr/>
+            <a:r>
+              <a:rPr lang="fr-FR" dirty="0">
+                <a:latin typeface="Century Gothic" panose="020B0502020202020204" pitchFamily="34" charset="0"/>
+              </a:rPr>
+              <a:t>Mettre le lien vers l’info + graph</a:t>
+            </a:r>
+            <a:endParaRPr dirty="0">
+              <a:latin typeface="Century Gothic" panose="020B0502020202020204" pitchFamily="34" charset="0"/>
+            </a:endParaRPr>
           </a:p>
         </p:txBody>
       </p:sp>
@@ -25698,7 +26315,7 @@
                 <a:solidFill>
                   <a:srgbClr val="000000"/>
                 </a:solidFill>
-                <a:latin typeface="Century Gothic"/>
+                <a:latin typeface="Century Gothic" panose="020B0502020202020204" pitchFamily="34" charset="0"/>
                 <a:ea typeface="Century Gothic"/>
                 <a:cs typeface="Century Gothic"/>
                 <a:sym typeface="Century Gothic"/>
@@ -25709,9 +26326,7 @@
               <a:solidFill>
                 <a:srgbClr val="000000"/>
               </a:solidFill>
-              <a:latin typeface="Arial"/>
-              <a:ea typeface="Arial"/>
-              <a:cs typeface="Arial"/>
+              <a:latin typeface="Century Gothic" panose="020B0502020202020204" pitchFamily="34" charset="0"/>
               <a:sym typeface="Arial"/>
             </a:endParaRPr>
           </a:p>
@@ -25738,7 +26353,7 @@
                 <a:solidFill>
                   <a:srgbClr val="000000"/>
                 </a:solidFill>
-                <a:latin typeface="Century Gothic"/>
+                <a:latin typeface="Century Gothic" panose="020B0502020202020204" pitchFamily="34" charset="0"/>
                 <a:ea typeface="Century Gothic"/>
                 <a:cs typeface="Century Gothic"/>
                 <a:sym typeface="Century Gothic"/>
@@ -25749,9 +26364,7 @@
               <a:solidFill>
                 <a:srgbClr val="000000"/>
               </a:solidFill>
-              <a:latin typeface="Arial"/>
-              <a:ea typeface="Arial"/>
-              <a:cs typeface="Arial"/>
+              <a:latin typeface="Century Gothic" panose="020B0502020202020204" pitchFamily="34" charset="0"/>
               <a:sym typeface="Arial"/>
             </a:endParaRPr>
           </a:p>
@@ -25777,7 +26390,7 @@
               <a:solidFill>
                 <a:srgbClr val="000000"/>
               </a:solidFill>
-              <a:latin typeface="Century Gothic"/>
+              <a:latin typeface="Century Gothic" panose="020B0502020202020204" pitchFamily="34" charset="0"/>
               <a:ea typeface="Century Gothic"/>
               <a:cs typeface="Century Gothic"/>
               <a:sym typeface="Century Gothic"/>
@@ -25806,7 +26419,7 @@
                 <a:solidFill>
                   <a:srgbClr val="000000"/>
                 </a:solidFill>
-                <a:latin typeface="Century Gothic"/>
+                <a:latin typeface="Century Gothic" panose="020B0502020202020204" pitchFamily="34" charset="0"/>
                 <a:ea typeface="Century Gothic"/>
                 <a:cs typeface="Century Gothic"/>
                 <a:sym typeface="Century Gothic"/>
@@ -25817,9 +26430,7 @@
               <a:solidFill>
                 <a:srgbClr val="000000"/>
               </a:solidFill>
-              <a:latin typeface="Arial"/>
-              <a:ea typeface="Arial"/>
-              <a:cs typeface="Arial"/>
+              <a:latin typeface="Century Gothic" panose="020B0502020202020204" pitchFamily="34" charset="0"/>
               <a:sym typeface="Arial"/>
             </a:endParaRPr>
           </a:p>
@@ -25846,7 +26457,7 @@
                 <a:solidFill>
                   <a:srgbClr val="000000"/>
                 </a:solidFill>
-                <a:latin typeface="Century Gothic"/>
+                <a:latin typeface="Century Gothic" panose="020B0502020202020204" pitchFamily="34" charset="0"/>
                 <a:ea typeface="Century Gothic"/>
                 <a:cs typeface="Century Gothic"/>
                 <a:sym typeface="Century Gothic"/>
@@ -25857,9 +26468,7 @@
               <a:solidFill>
                 <a:srgbClr val="000000"/>
               </a:solidFill>
-              <a:latin typeface="Arial"/>
-              <a:ea typeface="Arial"/>
-              <a:cs typeface="Arial"/>
+              <a:latin typeface="Century Gothic" panose="020B0502020202020204" pitchFamily="34" charset="0"/>
               <a:sym typeface="Arial"/>
             </a:endParaRPr>
           </a:p>
@@ -25944,10 +26553,14 @@
               <a:buNone/>
             </a:pPr>
             <a:r>
-              <a:rPr lang="fr-FR" sz="3200"/>
+              <a:rPr lang="fr-FR" sz="3200">
+                <a:latin typeface="Century Gothic" panose="020B0502020202020204" pitchFamily="34" charset="0"/>
+              </a:rPr>
               <a:t>3) Nombre théorique de personnes qui pourraient être nourries uniquement avec les végétaux en 2017</a:t>
             </a:r>
-            <a:endParaRPr/>
+            <a:endParaRPr>
+              <a:latin typeface="Century Gothic" panose="020B0502020202020204" pitchFamily="34" charset="0"/>
+            </a:endParaRPr>
           </a:p>
         </p:txBody>
       </p:sp>
@@ -26000,7 +26613,9 @@
               <a:buSzPts val="1800"/>
               <a:buNone/>
             </a:pPr>
-            <a:endParaRPr/>
+            <a:endParaRPr dirty="0">
+              <a:latin typeface="Century Gothic" panose="020B0502020202020204" pitchFamily="34" charset="0"/>
+            </a:endParaRPr>
           </a:p>
         </p:txBody>
       </p:sp>
@@ -26062,7 +26677,7 @@
                 <a:highlight>
                   <a:srgbClr val="FFFF00"/>
                 </a:highlight>
-                <a:latin typeface="Century Gothic"/>
+                <a:latin typeface="Century Gothic" panose="020B0502020202020204" pitchFamily="34" charset="0"/>
                 <a:ea typeface="Century Gothic"/>
                 <a:cs typeface="Century Gothic"/>
                 <a:sym typeface="Century Gothic"/>
@@ -26073,9 +26688,7 @@
               <a:solidFill>
                 <a:srgbClr val="000000"/>
               </a:solidFill>
-              <a:latin typeface="Arial"/>
-              <a:ea typeface="Arial"/>
-              <a:cs typeface="Arial"/>
+              <a:latin typeface="Century Gothic" panose="020B0502020202020204" pitchFamily="34" charset="0"/>
               <a:sym typeface="Arial"/>
             </a:endParaRPr>
           </a:p>
@@ -26105,7 +26718,7 @@
                 <a:highlight>
                   <a:srgbClr val="FFFF00"/>
                 </a:highlight>
-                <a:latin typeface="Century Gothic"/>
+                <a:latin typeface="Century Gothic" panose="020B0502020202020204" pitchFamily="34" charset="0"/>
                 <a:ea typeface="Century Gothic"/>
                 <a:cs typeface="Century Gothic"/>
                 <a:sym typeface="Century Gothic"/>
@@ -26116,9 +26729,7 @@
               <a:solidFill>
                 <a:srgbClr val="000000"/>
               </a:solidFill>
-              <a:latin typeface="Arial"/>
-              <a:ea typeface="Arial"/>
-              <a:cs typeface="Arial"/>
+              <a:latin typeface="Century Gothic" panose="020B0502020202020204" pitchFamily="34" charset="0"/>
               <a:sym typeface="Arial"/>
             </a:endParaRPr>
           </a:p>
@@ -26135,6 +26746,14 @@
 <file path=ppt/slides/slide7.xml><?xml version="1.0" encoding="utf-8"?>
 <p:sld xmlns:a="http://schemas.openxmlformats.org/drawingml/2006/main" xmlns:r="http://schemas.openxmlformats.org/officeDocument/2006/relationships" xmlns:p="http://schemas.openxmlformats.org/presentationml/2006/main">
   <p:cSld>
+    <p:bg>
+      <p:bgPr>
+        <a:solidFill>
+          <a:schemeClr val="dk2"/>
+        </a:solidFill>
+        <a:effectLst/>
+      </p:bgPr>
+    </p:bg>
     <p:spTree>
       <p:nvGrpSpPr>
         <p:cNvPr id="1" name="Shape 165"/>
@@ -26160,10 +26779,6 @@
           </p:nvPr>
         </p:nvSpPr>
         <p:spPr>
-          <a:xfrm>
-            <a:off x="810000" y="447188"/>
-            <a:ext cx="10571998" cy="970450"/>
-          </a:xfrm>
           <a:prstGeom prst="rect">
             <a:avLst/>
           </a:prstGeom>
@@ -26203,10 +26818,14 @@
               <a:buNone/>
             </a:pPr>
             <a:r>
-              <a:rPr lang="fr-FR" sz="3200"/>
+              <a:rPr lang="fr-FR" sz="3200">
+                <a:latin typeface="Century Gothic" panose="020B0502020202020204" pitchFamily="34" charset="0"/>
+              </a:rPr>
               <a:t>4) Répartition de la disponibilité intérieure</a:t>
             </a:r>
-            <a:endParaRPr/>
+            <a:endParaRPr>
+              <a:latin typeface="Century Gothic" panose="020B0502020202020204" pitchFamily="34" charset="0"/>
+            </a:endParaRPr>
           </a:p>
         </p:txBody>
       </p:sp>
@@ -26221,10 +26840,6 @@
           </p:nvPr>
         </p:nvSpPr>
         <p:spPr>
-          <a:xfrm>
-            <a:off x="818712" y="2222287"/>
-            <a:ext cx="10554574" cy="3636511"/>
-          </a:xfrm>
           <a:prstGeom prst="rect">
             <a:avLst/>
           </a:prstGeom>
@@ -26263,7 +26878,9 @@
               <a:buFont typeface="Arial"/>
               <a:buNone/>
             </a:pPr>
-            <a:endParaRPr/>
+            <a:endParaRPr>
+              <a:latin typeface="Century Gothic" panose="020B0502020202020204" pitchFamily="34" charset="0"/>
+            </a:endParaRPr>
           </a:p>
         </p:txBody>
       </p:sp>
@@ -26275,7 +26892,7 @@
         </p:nvSpPr>
         <p:spPr>
           <a:xfrm>
-            <a:off x="8760001" y="1510444"/>
+            <a:off x="7682715" y="2600341"/>
             <a:ext cx="3432000" cy="2582400"/>
           </a:xfrm>
           <a:prstGeom prst="rect">
@@ -26322,7 +26939,7 @@
                 <a:solidFill>
                   <a:srgbClr val="000000"/>
                 </a:solidFill>
-                <a:latin typeface="Century Gothic"/>
+                <a:latin typeface="Century Gothic" panose="020B0502020202020204" pitchFamily="34" charset="0"/>
                 <a:ea typeface="Century Gothic"/>
                 <a:cs typeface="Century Gothic"/>
                 <a:sym typeface="Century Gothic"/>
@@ -26333,9 +26950,7 @@
               <a:solidFill>
                 <a:srgbClr val="000000"/>
               </a:solidFill>
-              <a:latin typeface="Arial"/>
-              <a:ea typeface="Arial"/>
-              <a:cs typeface="Arial"/>
+              <a:latin typeface="Century Gothic" panose="020B0502020202020204" pitchFamily="34" charset="0"/>
               <a:sym typeface="Arial"/>
             </a:endParaRPr>
           </a:p>
@@ -26362,7 +26977,7 @@
                 <a:solidFill>
                   <a:srgbClr val="000000"/>
                 </a:solidFill>
-                <a:latin typeface="Century Gothic"/>
+                <a:latin typeface="Century Gothic" panose="020B0502020202020204" pitchFamily="34" charset="0"/>
                 <a:ea typeface="Century Gothic"/>
                 <a:cs typeface="Century Gothic"/>
                 <a:sym typeface="Century Gothic"/>
@@ -26373,9 +26988,7 @@
               <a:solidFill>
                 <a:srgbClr val="000000"/>
               </a:solidFill>
-              <a:latin typeface="Arial"/>
-              <a:ea typeface="Arial"/>
-              <a:cs typeface="Arial"/>
+              <a:latin typeface="Century Gothic" panose="020B0502020202020204" pitchFamily="34" charset="0"/>
               <a:sym typeface="Arial"/>
             </a:endParaRPr>
           </a:p>
@@ -26402,7 +27015,7 @@
                 <a:solidFill>
                   <a:srgbClr val="000000"/>
                 </a:solidFill>
-                <a:latin typeface="Century Gothic"/>
+                <a:latin typeface="Century Gothic" panose="020B0502020202020204" pitchFamily="34" charset="0"/>
                 <a:ea typeface="Century Gothic"/>
                 <a:cs typeface="Century Gothic"/>
                 <a:sym typeface="Century Gothic"/>
@@ -26413,9 +27026,7 @@
               <a:solidFill>
                 <a:srgbClr val="000000"/>
               </a:solidFill>
-              <a:latin typeface="Arial"/>
-              <a:ea typeface="Arial"/>
-              <a:cs typeface="Arial"/>
+              <a:latin typeface="Century Gothic" panose="020B0502020202020204" pitchFamily="34" charset="0"/>
               <a:sym typeface="Arial"/>
             </a:endParaRPr>
           </a:p>
@@ -26429,7 +27040,7 @@
         </p:nvSpPr>
         <p:spPr>
           <a:xfrm>
-            <a:off x="8372801" y="4310269"/>
+            <a:off x="4250715" y="2600341"/>
             <a:ext cx="3432000" cy="2582400"/>
           </a:xfrm>
           <a:prstGeom prst="rect">
@@ -26476,7 +27087,7 @@
                 <a:solidFill>
                   <a:srgbClr val="000000"/>
                 </a:solidFill>
-                <a:latin typeface="Century Gothic"/>
+                <a:latin typeface="Century Gothic" panose="020B0502020202020204" pitchFamily="34" charset="0"/>
                 <a:ea typeface="Century Gothic"/>
                 <a:cs typeface="Century Gothic"/>
                 <a:sym typeface="Century Gothic"/>
@@ -26487,7 +27098,7 @@
               <a:solidFill>
                 <a:srgbClr val="000000"/>
               </a:solidFill>
-              <a:latin typeface="Century Gothic"/>
+              <a:latin typeface="Century Gothic" panose="020B0502020202020204" pitchFamily="34" charset="0"/>
               <a:ea typeface="Century Gothic"/>
               <a:cs typeface="Century Gothic"/>
               <a:sym typeface="Century Gothic"/>
@@ -26516,7 +27127,7 @@
                 <a:solidFill>
                   <a:srgbClr val="000000"/>
                 </a:solidFill>
-                <a:latin typeface="Century Gothic"/>
+                <a:latin typeface="Century Gothic" panose="020B0502020202020204" pitchFamily="34" charset="0"/>
                 <a:ea typeface="Century Gothic"/>
                 <a:cs typeface="Century Gothic"/>
                 <a:sym typeface="Century Gothic"/>
@@ -26527,7 +27138,7 @@
               <a:solidFill>
                 <a:srgbClr val="000000"/>
               </a:solidFill>
-              <a:latin typeface="Century Gothic"/>
+              <a:latin typeface="Century Gothic" panose="020B0502020202020204" pitchFamily="34" charset="0"/>
               <a:ea typeface="Century Gothic"/>
               <a:cs typeface="Century Gothic"/>
               <a:sym typeface="Century Gothic"/>
@@ -26556,7 +27167,7 @@
                 <a:solidFill>
                   <a:srgbClr val="000000"/>
                 </a:solidFill>
-                <a:latin typeface="Century Gothic"/>
+                <a:latin typeface="Century Gothic" panose="020B0502020202020204" pitchFamily="34" charset="0"/>
                 <a:ea typeface="Century Gothic"/>
                 <a:cs typeface="Century Gothic"/>
                 <a:sym typeface="Century Gothic"/>
@@ -26567,7 +27178,7 @@
               <a:solidFill>
                 <a:srgbClr val="000000"/>
               </a:solidFill>
-              <a:latin typeface="Century Gothic"/>
+              <a:latin typeface="Century Gothic" panose="020B0502020202020204" pitchFamily="34" charset="0"/>
               <a:ea typeface="Century Gothic"/>
               <a:cs typeface="Century Gothic"/>
               <a:sym typeface="Century Gothic"/>
@@ -26596,7 +27207,7 @@
                 <a:solidFill>
                   <a:srgbClr val="000000"/>
                 </a:solidFill>
-                <a:latin typeface="Century Gothic"/>
+                <a:latin typeface="Century Gothic" panose="020B0502020202020204" pitchFamily="34" charset="0"/>
                 <a:ea typeface="Century Gothic"/>
                 <a:cs typeface="Century Gothic"/>
                 <a:sym typeface="Century Gothic"/>
@@ -26607,7 +27218,7 @@
               <a:solidFill>
                 <a:srgbClr val="000000"/>
               </a:solidFill>
-              <a:latin typeface="Century Gothic"/>
+              <a:latin typeface="Century Gothic" panose="020B0502020202020204" pitchFamily="34" charset="0"/>
               <a:ea typeface="Century Gothic"/>
               <a:cs typeface="Century Gothic"/>
               <a:sym typeface="Century Gothic"/>
@@ -26636,7 +27247,7 @@
                 <a:solidFill>
                   <a:srgbClr val="000000"/>
                 </a:solidFill>
-                <a:latin typeface="Century Gothic"/>
+                <a:latin typeface="Century Gothic" panose="020B0502020202020204" pitchFamily="34" charset="0"/>
                 <a:ea typeface="Century Gothic"/>
                 <a:cs typeface="Century Gothic"/>
                 <a:sym typeface="Century Gothic"/>
@@ -26647,7 +27258,7 @@
               <a:solidFill>
                 <a:srgbClr val="000000"/>
               </a:solidFill>
-              <a:latin typeface="Century Gothic"/>
+              <a:latin typeface="Century Gothic" panose="020B0502020202020204" pitchFamily="34" charset="0"/>
               <a:ea typeface="Century Gothic"/>
               <a:cs typeface="Century Gothic"/>
               <a:sym typeface="Century Gothic"/>
@@ -26676,7 +27287,7 @@
                 <a:solidFill>
                   <a:srgbClr val="000000"/>
                 </a:solidFill>
-                <a:latin typeface="Century Gothic"/>
+                <a:latin typeface="Century Gothic" panose="020B0502020202020204" pitchFamily="34" charset="0"/>
                 <a:ea typeface="Century Gothic"/>
                 <a:cs typeface="Century Gothic"/>
                 <a:sym typeface="Century Gothic"/>
@@ -26687,7 +27298,7 @@
               <a:solidFill>
                 <a:srgbClr val="000000"/>
               </a:solidFill>
-              <a:latin typeface="Century Gothic"/>
+              <a:latin typeface="Century Gothic" panose="020B0502020202020204" pitchFamily="34" charset="0"/>
               <a:ea typeface="Century Gothic"/>
               <a:cs typeface="Century Gothic"/>
               <a:sym typeface="Century Gothic"/>
@@ -26698,7 +27309,7 @@
     </p:spTree>
   </p:cSld>
   <p:clrMapOvr>
-    <a:masterClrMapping/>
+    <a:overrideClrMapping bg1="lt1" tx1="dk1" bg2="dk2" tx2="lt2" accent1="accent1" accent2="accent2" accent3="accent3" accent4="accent4" accent5="accent5" accent6="accent6" hlink="hlink" folHlink="folHlink"/>
   </p:clrMapOvr>
 </p:sld>
 </file>
@@ -26706,6 +27317,14 @@
 <file path=ppt/slides/slide8.xml><?xml version="1.0" encoding="utf-8"?>
 <p:sld xmlns:a="http://schemas.openxmlformats.org/drawingml/2006/main" xmlns:r="http://schemas.openxmlformats.org/officeDocument/2006/relationships" xmlns:p="http://schemas.openxmlformats.org/presentationml/2006/main">
   <p:cSld>
+    <p:bg>
+      <p:bgPr>
+        <a:solidFill>
+          <a:schemeClr val="dk2"/>
+        </a:solidFill>
+        <a:effectLst/>
+      </p:bgPr>
+    </p:bg>
     <p:spTree>
       <p:nvGrpSpPr>
         <p:cNvPr id="1" name="Shape 173"/>
@@ -26731,10 +27350,6 @@
           </p:nvPr>
         </p:nvSpPr>
         <p:spPr>
-          <a:xfrm>
-            <a:off x="810000" y="447188"/>
-            <a:ext cx="10571998" cy="970450"/>
-          </a:xfrm>
           <a:prstGeom prst="rect">
             <a:avLst/>
           </a:prstGeom>
@@ -26774,10 +27389,14 @@
               <a:buNone/>
             </a:pPr>
             <a:r>
-              <a:rPr lang="fr-FR" sz="3200"/>
+              <a:rPr lang="fr-FR" sz="3200">
+                <a:latin typeface="Century Gothic" panose="020B0502020202020204" pitchFamily="34" charset="0"/>
+              </a:rPr>
               <a:t>5) Part de l’utilisation des principales céréales entre l’alimentation humaine et animale</a:t>
             </a:r>
-            <a:endParaRPr/>
+            <a:endParaRPr>
+              <a:latin typeface="Century Gothic" panose="020B0502020202020204" pitchFamily="34" charset="0"/>
+            </a:endParaRPr>
           </a:p>
         </p:txBody>
       </p:sp>
@@ -26792,10 +27411,6 @@
           </p:nvPr>
         </p:nvSpPr>
         <p:spPr>
-          <a:xfrm>
-            <a:off x="818712" y="2222287"/>
-            <a:ext cx="10554574" cy="3636511"/>
-          </a:xfrm>
           <a:prstGeom prst="rect">
             <a:avLst/>
           </a:prstGeom>
@@ -26830,7 +27445,9 @@
               <a:buSzPts val="1800"/>
               <a:buNone/>
             </a:pPr>
-            <a:endParaRPr/>
+            <a:endParaRPr dirty="0">
+              <a:latin typeface="Century Gothic" panose="020B0502020202020204" pitchFamily="34" charset="0"/>
+            </a:endParaRPr>
           </a:p>
         </p:txBody>
       </p:sp>
@@ -26889,7 +27506,7 @@
                 <a:solidFill>
                   <a:srgbClr val="000000"/>
                 </a:solidFill>
-                <a:latin typeface="Century Gothic"/>
+                <a:latin typeface="Century Gothic" panose="020B0502020202020204" pitchFamily="34" charset="0"/>
                 <a:ea typeface="Century Gothic"/>
                 <a:cs typeface="Century Gothic"/>
                 <a:sym typeface="Century Gothic"/>
@@ -26900,9 +27517,7 @@
               <a:solidFill>
                 <a:srgbClr val="000000"/>
               </a:solidFill>
-              <a:latin typeface="Arial"/>
-              <a:ea typeface="Arial"/>
-              <a:cs typeface="Arial"/>
+              <a:latin typeface="Century Gothic" panose="020B0502020202020204" pitchFamily="34" charset="0"/>
               <a:sym typeface="Arial"/>
             </a:endParaRPr>
           </a:p>
@@ -26929,7 +27544,7 @@
                 <a:solidFill>
                   <a:srgbClr val="000000"/>
                 </a:solidFill>
-                <a:latin typeface="Century Gothic"/>
+                <a:latin typeface="Century Gothic" panose="020B0502020202020204" pitchFamily="34" charset="0"/>
                 <a:ea typeface="Century Gothic"/>
                 <a:cs typeface="Century Gothic"/>
                 <a:sym typeface="Century Gothic"/>
@@ -26940,9 +27555,7 @@
               <a:solidFill>
                 <a:srgbClr val="000000"/>
               </a:solidFill>
-              <a:latin typeface="Arial"/>
-              <a:ea typeface="Arial"/>
-              <a:cs typeface="Arial"/>
+              <a:latin typeface="Century Gothic" panose="020B0502020202020204" pitchFamily="34" charset="0"/>
               <a:sym typeface="Arial"/>
             </a:endParaRPr>
           </a:p>
@@ -26969,7 +27582,7 @@
                 <a:solidFill>
                   <a:srgbClr val="000000"/>
                 </a:solidFill>
-                <a:latin typeface="Century Gothic"/>
+                <a:latin typeface="Century Gothic" panose="020B0502020202020204" pitchFamily="34" charset="0"/>
                 <a:ea typeface="Century Gothic"/>
                 <a:cs typeface="Century Gothic"/>
                 <a:sym typeface="Century Gothic"/>
@@ -26980,9 +27593,7 @@
               <a:solidFill>
                 <a:srgbClr val="000000"/>
               </a:solidFill>
-              <a:latin typeface="Arial"/>
-              <a:ea typeface="Arial"/>
-              <a:cs typeface="Arial"/>
+              <a:latin typeface="Century Gothic" panose="020B0502020202020204" pitchFamily="34" charset="0"/>
               <a:sym typeface="Arial"/>
             </a:endParaRPr>
           </a:p>
@@ -27009,7 +27620,7 @@
                 <a:solidFill>
                   <a:srgbClr val="000000"/>
                 </a:solidFill>
-                <a:latin typeface="Century Gothic"/>
+                <a:latin typeface="Century Gothic" panose="020B0502020202020204" pitchFamily="34" charset="0"/>
                 <a:ea typeface="Century Gothic"/>
                 <a:cs typeface="Century Gothic"/>
                 <a:sym typeface="Century Gothic"/>
@@ -27020,9 +27631,7 @@
               <a:solidFill>
                 <a:srgbClr val="000000"/>
               </a:solidFill>
-              <a:latin typeface="Arial"/>
-              <a:ea typeface="Arial"/>
-              <a:cs typeface="Arial"/>
+              <a:latin typeface="Century Gothic" panose="020B0502020202020204" pitchFamily="34" charset="0"/>
               <a:sym typeface="Arial"/>
             </a:endParaRPr>
           </a:p>
@@ -27049,7 +27658,7 @@
                 <a:solidFill>
                   <a:srgbClr val="000000"/>
                 </a:solidFill>
-                <a:latin typeface="Century Gothic"/>
+                <a:latin typeface="Century Gothic" panose="020B0502020202020204" pitchFamily="34" charset="0"/>
                 <a:ea typeface="Century Gothic"/>
                 <a:cs typeface="Century Gothic"/>
                 <a:sym typeface="Century Gothic"/>
@@ -27060,9 +27669,7 @@
               <a:solidFill>
                 <a:srgbClr val="000000"/>
               </a:solidFill>
-              <a:latin typeface="Arial"/>
-              <a:ea typeface="Arial"/>
-              <a:cs typeface="Arial"/>
+              <a:latin typeface="Century Gothic" panose="020B0502020202020204" pitchFamily="34" charset="0"/>
               <a:sym typeface="Arial"/>
             </a:endParaRPr>
           </a:p>
@@ -27089,7 +27696,7 @@
                 <a:solidFill>
                   <a:srgbClr val="000000"/>
                 </a:solidFill>
-                <a:latin typeface="Century Gothic"/>
+                <a:latin typeface="Century Gothic" panose="020B0502020202020204" pitchFamily="34" charset="0"/>
                 <a:ea typeface="Century Gothic"/>
                 <a:cs typeface="Century Gothic"/>
                 <a:sym typeface="Century Gothic"/>
@@ -27100,9 +27707,7 @@
               <a:solidFill>
                 <a:srgbClr val="000000"/>
               </a:solidFill>
-              <a:latin typeface="Arial"/>
-              <a:ea typeface="Arial"/>
-              <a:cs typeface="Arial"/>
+              <a:latin typeface="Century Gothic" panose="020B0502020202020204" pitchFamily="34" charset="0"/>
               <a:sym typeface="Arial"/>
             </a:endParaRPr>
           </a:p>
@@ -27129,7 +27734,7 @@
                 <a:solidFill>
                   <a:srgbClr val="000000"/>
                 </a:solidFill>
-                <a:latin typeface="Century Gothic"/>
+                <a:latin typeface="Century Gothic" panose="020B0502020202020204" pitchFamily="34" charset="0"/>
                 <a:ea typeface="Century Gothic"/>
                 <a:cs typeface="Century Gothic"/>
                 <a:sym typeface="Century Gothic"/>
@@ -27140,9 +27745,7 @@
               <a:solidFill>
                 <a:srgbClr val="000000"/>
               </a:solidFill>
-              <a:latin typeface="Arial"/>
-              <a:ea typeface="Arial"/>
-              <a:cs typeface="Arial"/>
+              <a:latin typeface="Century Gothic" panose="020B0502020202020204" pitchFamily="34" charset="0"/>
               <a:sym typeface="Arial"/>
             </a:endParaRPr>
           </a:p>
@@ -27169,7 +27772,7 @@
                 <a:solidFill>
                   <a:srgbClr val="000000"/>
                 </a:solidFill>
-                <a:latin typeface="Century Gothic"/>
+                <a:latin typeface="Century Gothic" panose="020B0502020202020204" pitchFamily="34" charset="0"/>
                 <a:ea typeface="Century Gothic"/>
                 <a:cs typeface="Century Gothic"/>
                 <a:sym typeface="Century Gothic"/>
@@ -27180,9 +27783,7 @@
               <a:solidFill>
                 <a:srgbClr val="000000"/>
               </a:solidFill>
-              <a:latin typeface="Arial"/>
-              <a:ea typeface="Arial"/>
-              <a:cs typeface="Arial"/>
+              <a:latin typeface="Century Gothic" panose="020B0502020202020204" pitchFamily="34" charset="0"/>
               <a:sym typeface="Arial"/>
             </a:endParaRPr>
           </a:p>
@@ -27209,7 +27810,7 @@
                 <a:solidFill>
                   <a:srgbClr val="000000"/>
                 </a:solidFill>
-                <a:latin typeface="Century Gothic"/>
+                <a:latin typeface="Century Gothic" panose="020B0502020202020204" pitchFamily="34" charset="0"/>
                 <a:ea typeface="Century Gothic"/>
                 <a:cs typeface="Century Gothic"/>
                 <a:sym typeface="Century Gothic"/>
@@ -27220,9 +27821,7 @@
               <a:solidFill>
                 <a:srgbClr val="000000"/>
               </a:solidFill>
-              <a:latin typeface="Arial"/>
-              <a:ea typeface="Arial"/>
-              <a:cs typeface="Arial"/>
+              <a:latin typeface="Century Gothic" panose="020B0502020202020204" pitchFamily="34" charset="0"/>
               <a:sym typeface="Arial"/>
             </a:endParaRPr>
           </a:p>
@@ -27249,7 +27848,7 @@
                 <a:solidFill>
                   <a:srgbClr val="000000"/>
                 </a:solidFill>
-                <a:latin typeface="Century Gothic"/>
+                <a:latin typeface="Century Gothic" panose="020B0502020202020204" pitchFamily="34" charset="0"/>
                 <a:ea typeface="Century Gothic"/>
                 <a:cs typeface="Century Gothic"/>
                 <a:sym typeface="Century Gothic"/>
@@ -27260,9 +27859,7 @@
               <a:solidFill>
                 <a:srgbClr val="000000"/>
               </a:solidFill>
-              <a:latin typeface="Arial"/>
-              <a:ea typeface="Arial"/>
-              <a:cs typeface="Arial"/>
+              <a:latin typeface="Century Gothic" panose="020B0502020202020204" pitchFamily="34" charset="0"/>
               <a:sym typeface="Arial"/>
             </a:endParaRPr>
           </a:p>
@@ -27289,7 +27886,7 @@
                 <a:solidFill>
                   <a:srgbClr val="000000"/>
                 </a:solidFill>
-                <a:latin typeface="Century Gothic"/>
+                <a:latin typeface="Century Gothic" panose="020B0502020202020204" pitchFamily="34" charset="0"/>
                 <a:ea typeface="Century Gothic"/>
                 <a:cs typeface="Century Gothic"/>
                 <a:sym typeface="Century Gothic"/>
@@ -27300,7 +27897,7 @@
               <a:solidFill>
                 <a:srgbClr val="000000"/>
               </a:solidFill>
-              <a:latin typeface="Century Gothic"/>
+              <a:latin typeface="Century Gothic" panose="020B0502020202020204" pitchFamily="34" charset="0"/>
               <a:ea typeface="Century Gothic"/>
               <a:cs typeface="Century Gothic"/>
               <a:sym typeface="Century Gothic"/>
@@ -27329,7 +27926,7 @@
                 <a:solidFill>
                   <a:srgbClr val="000000"/>
                 </a:solidFill>
-                <a:latin typeface="Century Gothic"/>
+                <a:latin typeface="Century Gothic" panose="020B0502020202020204" pitchFamily="34" charset="0"/>
                 <a:ea typeface="Century Gothic"/>
                 <a:cs typeface="Century Gothic"/>
                 <a:sym typeface="Century Gothic"/>
@@ -27340,9 +27937,7 @@
               <a:solidFill>
                 <a:srgbClr val="000000"/>
               </a:solidFill>
-              <a:latin typeface="Arial"/>
-              <a:ea typeface="Arial"/>
-              <a:cs typeface="Arial"/>
+              <a:latin typeface="Century Gothic" panose="020B0502020202020204" pitchFamily="34" charset="0"/>
               <a:sym typeface="Arial"/>
             </a:endParaRPr>
           </a:p>
@@ -27369,7 +27964,7 @@
                 <a:solidFill>
                   <a:srgbClr val="000000"/>
                 </a:solidFill>
-                <a:latin typeface="Century Gothic"/>
+                <a:latin typeface="Century Gothic" panose="020B0502020202020204" pitchFamily="34" charset="0"/>
                 <a:ea typeface="Century Gothic"/>
                 <a:cs typeface="Century Gothic"/>
                 <a:sym typeface="Century Gothic"/>
@@ -27380,9 +27975,7 @@
               <a:solidFill>
                 <a:srgbClr val="000000"/>
               </a:solidFill>
-              <a:latin typeface="Arial"/>
-              <a:ea typeface="Arial"/>
-              <a:cs typeface="Arial"/>
+              <a:latin typeface="Century Gothic" panose="020B0502020202020204" pitchFamily="34" charset="0"/>
               <a:sym typeface="Arial"/>
             </a:endParaRPr>
           </a:p>
@@ -27409,7 +28002,7 @@
                 <a:solidFill>
                   <a:srgbClr val="000000"/>
                 </a:solidFill>
-                <a:latin typeface="Century Gothic"/>
+                <a:latin typeface="Century Gothic" panose="020B0502020202020204" pitchFamily="34" charset="0"/>
                 <a:ea typeface="Century Gothic"/>
                 <a:cs typeface="Century Gothic"/>
                 <a:sym typeface="Century Gothic"/>
@@ -27420,9 +28013,7 @@
               <a:solidFill>
                 <a:srgbClr val="000000"/>
               </a:solidFill>
-              <a:latin typeface="Arial"/>
-              <a:ea typeface="Arial"/>
-              <a:cs typeface="Arial"/>
+              <a:latin typeface="Century Gothic" panose="020B0502020202020204" pitchFamily="34" charset="0"/>
               <a:sym typeface="Arial"/>
             </a:endParaRPr>
           </a:p>
@@ -27431,7 +28022,7 @@
     </p:spTree>
   </p:cSld>
   <p:clrMapOvr>
-    <a:masterClrMapping/>
+    <a:overrideClrMapping bg1="lt1" tx1="dk1" bg2="dk2" tx2="lt2" accent1="accent1" accent2="accent2" accent3="accent3" accent4="accent4" accent5="accent5" accent6="accent6" hlink="hlink" folHlink="folHlink"/>
   </p:clrMapOvr>
 </p:sld>
 </file>
@@ -27507,7 +28098,9 @@
               <a:buNone/>
             </a:pPr>
             <a:r>
-              <a:rPr lang="fr-FR" sz="3200"/>
+              <a:rPr lang="fr-FR" sz="3200">
+                <a:latin typeface="Century Gothic" panose="020B0502020202020204" pitchFamily="34" charset="0"/>
+              </a:rPr>
               <a:t>6) Liste des 10 pays où la proportion de personnes en état de sous-nutrition est la plus forte en </a:t>
             </a:r>
             <a:r>
@@ -27515,10 +28108,13 @@
                 <a:solidFill>
                   <a:schemeClr val="lt1"/>
                 </a:solidFill>
+                <a:latin typeface="Century Gothic" panose="020B0502020202020204" pitchFamily="34" charset="0"/>
               </a:rPr>
               <a:t>2017</a:t>
             </a:r>
-            <a:endParaRPr/>
+            <a:endParaRPr>
+              <a:latin typeface="Century Gothic" panose="020B0502020202020204" pitchFamily="34" charset="0"/>
+            </a:endParaRPr>
           </a:p>
         </p:txBody>
       </p:sp>
@@ -27571,7 +28167,9 @@
               <a:buSzPts val="1800"/>
               <a:buNone/>
             </a:pPr>
-            <a:endParaRPr/>
+            <a:endParaRPr dirty="0">
+              <a:latin typeface="Century Gothic" panose="020B0502020202020204" pitchFamily="34" charset="0"/>
+            </a:endParaRPr>
           </a:p>
         </p:txBody>
       </p:sp>
@@ -27630,7 +28228,7 @@
                 <a:solidFill>
                   <a:srgbClr val="000000"/>
                 </a:solidFill>
-                <a:latin typeface="Century Gothic"/>
+                <a:latin typeface="Century Gothic" panose="020B0502020202020204" pitchFamily="34" charset="0"/>
                 <a:ea typeface="Century Gothic"/>
                 <a:cs typeface="Century Gothic"/>
                 <a:sym typeface="Century Gothic"/>
@@ -27641,9 +28239,7 @@
               <a:solidFill>
                 <a:srgbClr val="000000"/>
               </a:solidFill>
-              <a:latin typeface="Arial"/>
-              <a:ea typeface="Arial"/>
-              <a:cs typeface="Arial"/>
+              <a:latin typeface="Century Gothic" panose="020B0502020202020204" pitchFamily="34" charset="0"/>
               <a:sym typeface="Arial"/>
             </a:endParaRPr>
           </a:p>
@@ -27669,7 +28265,7 @@
               <a:solidFill>
                 <a:srgbClr val="000000"/>
               </a:solidFill>
-              <a:latin typeface="Century Gothic"/>
+              <a:latin typeface="Century Gothic" panose="020B0502020202020204" pitchFamily="34" charset="0"/>
               <a:ea typeface="Century Gothic"/>
               <a:cs typeface="Century Gothic"/>
               <a:sym typeface="Century Gothic"/>
@@ -27698,7 +28294,7 @@
                 <a:solidFill>
                   <a:srgbClr val="000000"/>
                 </a:solidFill>
-                <a:latin typeface="Century Gothic"/>
+                <a:latin typeface="Century Gothic" panose="020B0502020202020204" pitchFamily="34" charset="0"/>
                 <a:ea typeface="Century Gothic"/>
                 <a:cs typeface="Century Gothic"/>
                 <a:sym typeface="Century Gothic"/>
@@ -27709,9 +28305,7 @@
               <a:solidFill>
                 <a:srgbClr val="000000"/>
               </a:solidFill>
-              <a:latin typeface="Arial"/>
-              <a:ea typeface="Arial"/>
-              <a:cs typeface="Arial"/>
+              <a:latin typeface="Century Gothic" panose="020B0502020202020204" pitchFamily="34" charset="0"/>
               <a:sym typeface="Arial"/>
             </a:endParaRPr>
           </a:p>
@@ -27738,7 +28332,7 @@
                 <a:solidFill>
                   <a:srgbClr val="000000"/>
                 </a:solidFill>
-                <a:latin typeface="Century Gothic"/>
+                <a:latin typeface="Century Gothic" panose="020B0502020202020204" pitchFamily="34" charset="0"/>
                 <a:ea typeface="Century Gothic"/>
                 <a:cs typeface="Century Gothic"/>
                 <a:sym typeface="Century Gothic"/>
@@ -27749,9 +28343,7 @@
               <a:solidFill>
                 <a:srgbClr val="000000"/>
               </a:solidFill>
-              <a:latin typeface="Arial"/>
-              <a:ea typeface="Arial"/>
-              <a:cs typeface="Arial"/>
+              <a:latin typeface="Century Gothic" panose="020B0502020202020204" pitchFamily="34" charset="0"/>
               <a:sym typeface="Arial"/>
             </a:endParaRPr>
           </a:p>
@@ -27777,7 +28369,7 @@
               <a:solidFill>
                 <a:srgbClr val="000000"/>
               </a:solidFill>
-              <a:latin typeface="Century Gothic"/>
+              <a:latin typeface="Century Gothic" panose="020B0502020202020204" pitchFamily="34" charset="0"/>
               <a:ea typeface="Century Gothic"/>
               <a:cs typeface="Century Gothic"/>
               <a:sym typeface="Century Gothic"/>
@@ -27806,7 +28398,7 @@
                 <a:solidFill>
                   <a:srgbClr val="000000"/>
                 </a:solidFill>
-                <a:latin typeface="Century Gothic"/>
+                <a:latin typeface="Century Gothic" panose="020B0502020202020204" pitchFamily="34" charset="0"/>
                 <a:ea typeface="Century Gothic"/>
                 <a:cs typeface="Century Gothic"/>
                 <a:sym typeface="Century Gothic"/>
@@ -27817,9 +28409,7 @@
               <a:solidFill>
                 <a:srgbClr val="000000"/>
               </a:solidFill>
-              <a:latin typeface="Arial"/>
-              <a:ea typeface="Arial"/>
-              <a:cs typeface="Arial"/>
+              <a:latin typeface="Century Gothic" panose="020B0502020202020204" pitchFamily="34" charset="0"/>
               <a:sym typeface="Arial"/>
             </a:endParaRPr>
           </a:p>
@@ -28393,4 +28983,90 @@
   <a:objectDefaults/>
   <a:extraClrSchemeLst/>
 </a:theme>
+</file>
+
+<file path=ppt/theme/themeOverride1.xml><?xml version="1.0" encoding="utf-8"?>
+<a:themeOverride xmlns:a="http://schemas.openxmlformats.org/drawingml/2006/main">
+  <a:clrScheme name="Quotable">
+    <a:dk1>
+      <a:srgbClr val="000000"/>
+    </a:dk1>
+    <a:lt1>
+      <a:srgbClr val="FFFFFF"/>
+    </a:lt1>
+    <a:dk2>
+      <a:srgbClr val="212121"/>
+    </a:dk2>
+    <a:lt2>
+      <a:srgbClr val="636363"/>
+    </a:lt2>
+    <a:accent1>
+      <a:srgbClr val="00C6BB"/>
+    </a:accent1>
+    <a:accent2>
+      <a:srgbClr val="6FEBA0"/>
+    </a:accent2>
+    <a:accent3>
+      <a:srgbClr val="B6DF5E"/>
+    </a:accent3>
+    <a:accent4>
+      <a:srgbClr val="EFB251"/>
+    </a:accent4>
+    <a:accent5>
+      <a:srgbClr val="EF755F"/>
+    </a:accent5>
+    <a:accent6>
+      <a:srgbClr val="ED515C"/>
+    </a:accent6>
+    <a:hlink>
+      <a:srgbClr val="8F8F8F"/>
+    </a:hlink>
+    <a:folHlink>
+      <a:srgbClr val="A5A5A5"/>
+    </a:folHlink>
+  </a:clrScheme>
+</a:themeOverride>
+</file>
+
+<file path=ppt/theme/themeOverride2.xml><?xml version="1.0" encoding="utf-8"?>
+<a:themeOverride xmlns:a="http://schemas.openxmlformats.org/drawingml/2006/main">
+  <a:clrScheme name="Quotable">
+    <a:dk1>
+      <a:srgbClr val="000000"/>
+    </a:dk1>
+    <a:lt1>
+      <a:srgbClr val="FFFFFF"/>
+    </a:lt1>
+    <a:dk2>
+      <a:srgbClr val="212121"/>
+    </a:dk2>
+    <a:lt2>
+      <a:srgbClr val="636363"/>
+    </a:lt2>
+    <a:accent1>
+      <a:srgbClr val="00C6BB"/>
+    </a:accent1>
+    <a:accent2>
+      <a:srgbClr val="6FEBA0"/>
+    </a:accent2>
+    <a:accent3>
+      <a:srgbClr val="B6DF5E"/>
+    </a:accent3>
+    <a:accent4>
+      <a:srgbClr val="EFB251"/>
+    </a:accent4>
+    <a:accent5>
+      <a:srgbClr val="EF755F"/>
+    </a:accent5>
+    <a:accent6>
+      <a:srgbClr val="ED515C"/>
+    </a:accent6>
+    <a:hlink>
+      <a:srgbClr val="8F8F8F"/>
+    </a:hlink>
+    <a:folHlink>
+      <a:srgbClr val="A5A5A5"/>
+    </a:folHlink>
+  </a:clrScheme>
+</a:themeOverride>
 </file>
</xml_diff>

<commit_message>
MAJ 11/02/26 relecture projet 4 et avancée projet 5
</commit_message>
<xml_diff>
--- a/Data_Analyst/Projet_4/Template+de+présentation_Faim_monde-V2.pptx
+++ b/Data_Analyst/Projet_4/Template+de+présentation_Faim_monde-V2.pptx
@@ -281,7 +281,7 @@
   <pc:docChgLst>
     <pc:chgData name="Zied Belhocine" userId="200cc0e2b299676e" providerId="LiveId" clId="{36CCCAD6-9B8B-4ECC-B7BF-7E36B9ADD69A}"/>
     <pc:docChg chg="undo custSel modSld">
-      <pc:chgData name="Zied Belhocine" userId="200cc0e2b299676e" providerId="LiveId" clId="{36CCCAD6-9B8B-4ECC-B7BF-7E36B9ADD69A}" dt="2026-01-28T14:31:50.018" v="1111" actId="2711"/>
+      <pc:chgData name="Zied Belhocine" userId="200cc0e2b299676e" providerId="LiveId" clId="{36CCCAD6-9B8B-4ECC-B7BF-7E36B9ADD69A}" dt="2026-02-05T10:35:29.583" v="2583" actId="478"/>
       <pc:docMkLst>
         <pc:docMk/>
       </pc:docMkLst>
@@ -349,11 +349,19 @@
         </pc:picChg>
       </pc:sldChg>
       <pc:sldChg chg="addSp delSp modSp mod">
-        <pc:chgData name="Zied Belhocine" userId="200cc0e2b299676e" providerId="LiveId" clId="{36CCCAD6-9B8B-4ECC-B7BF-7E36B9ADD69A}" dt="2026-01-28T14:06:01.989" v="802" actId="1076"/>
+        <pc:chgData name="Zied Belhocine" userId="200cc0e2b299676e" providerId="LiveId" clId="{36CCCAD6-9B8B-4ECC-B7BF-7E36B9ADD69A}" dt="2026-02-05T08:47:15.528" v="2515" actId="1076"/>
         <pc:sldMkLst>
           <pc:docMk/>
           <pc:sldMk cId="0" sldId="257"/>
         </pc:sldMkLst>
+        <pc:spChg chg="add mod">
+          <ac:chgData name="Zied Belhocine" userId="200cc0e2b299676e" providerId="LiveId" clId="{36CCCAD6-9B8B-4ECC-B7BF-7E36B9ADD69A}" dt="2026-02-05T08:47:15.528" v="2515" actId="1076"/>
+          <ac:spMkLst>
+            <pc:docMk/>
+            <pc:sldMk cId="0" sldId="257"/>
+            <ac:spMk id="2" creationId="{502E3F99-3B74-F244-9CD3-C337EAE5FFF7}"/>
+          </ac:spMkLst>
+        </pc:spChg>
         <pc:spChg chg="add del mod">
           <ac:chgData name="Zied Belhocine" userId="200cc0e2b299676e" providerId="LiveId" clId="{36CCCAD6-9B8B-4ECC-B7BF-7E36B9ADD69A}" dt="2026-01-28T14:03:31.604" v="698"/>
           <ac:spMkLst>
@@ -432,6 +440,14 @@
             <pc:docMk/>
             <pc:sldMk cId="0" sldId="257"/>
             <ac:picMk id="2" creationId="{D28E7D32-8AEC-5DCC-8123-0662C73CF435}"/>
+          </ac:picMkLst>
+        </pc:picChg>
+        <pc:picChg chg="add del">
+          <ac:chgData name="Zied Belhocine" userId="200cc0e2b299676e" providerId="LiveId" clId="{36CCCAD6-9B8B-4ECC-B7BF-7E36B9ADD69A}" dt="2026-02-03T10:37:18.631" v="2084" actId="22"/>
+          <ac:picMkLst>
+            <pc:docMk/>
+            <pc:sldMk cId="0" sldId="257"/>
+            <ac:picMk id="3" creationId="{3E45E234-3144-1F7E-EFCC-848AAE2DE0D5}"/>
           </ac:picMkLst>
         </pc:picChg>
         <pc:picChg chg="add del mod">
@@ -516,11 +532,27 @@
         </pc:picChg>
       </pc:sldChg>
       <pc:sldChg chg="addSp delSp modSp mod">
-        <pc:chgData name="Zied Belhocine" userId="200cc0e2b299676e" providerId="LiveId" clId="{36CCCAD6-9B8B-4ECC-B7BF-7E36B9ADD69A}" dt="2026-01-28T14:14:47.297" v="1086" actId="14100"/>
+        <pc:chgData name="Zied Belhocine" userId="200cc0e2b299676e" providerId="LiveId" clId="{36CCCAD6-9B8B-4ECC-B7BF-7E36B9ADD69A}" dt="2026-02-05T08:47:58.630" v="2519" actId="1076"/>
         <pc:sldMkLst>
           <pc:docMk/>
           <pc:sldMk cId="0" sldId="258"/>
         </pc:sldMkLst>
+        <pc:spChg chg="add mod">
+          <ac:chgData name="Zied Belhocine" userId="200cc0e2b299676e" providerId="LiveId" clId="{36CCCAD6-9B8B-4ECC-B7BF-7E36B9ADD69A}" dt="2026-02-05T08:47:58.630" v="2519" actId="1076"/>
+          <ac:spMkLst>
+            <pc:docMk/>
+            <pc:sldMk cId="0" sldId="258"/>
+            <ac:spMk id="3" creationId="{EECD0240-8179-BCDF-47CF-EC5CF7CB5FB6}"/>
+          </ac:spMkLst>
+        </pc:spChg>
+        <pc:spChg chg="add mod">
+          <ac:chgData name="Zied Belhocine" userId="200cc0e2b299676e" providerId="LiveId" clId="{36CCCAD6-9B8B-4ECC-B7BF-7E36B9ADD69A}" dt="2026-02-05T08:47:55.226" v="2518" actId="1076"/>
+          <ac:spMkLst>
+            <pc:docMk/>
+            <pc:sldMk cId="0" sldId="258"/>
+            <ac:spMk id="4" creationId="{45559D09-3D65-7B25-A451-9C10E26A6A25}"/>
+          </ac:spMkLst>
+        </pc:spChg>
         <pc:spChg chg="add del mod">
           <ac:chgData name="Zied Belhocine" userId="200cc0e2b299676e" providerId="LiveId" clId="{36CCCAD6-9B8B-4ECC-B7BF-7E36B9ADD69A}" dt="2026-01-28T14:09:54.591" v="943" actId="478"/>
           <ac:spMkLst>
@@ -650,43 +682,307 @@
           </ac:picMkLst>
         </pc:picChg>
       </pc:sldChg>
-      <pc:sldChg chg="modSp mod">
-        <pc:chgData name="Zied Belhocine" userId="200cc0e2b299676e" providerId="LiveId" clId="{36CCCAD6-9B8B-4ECC-B7BF-7E36B9ADD69A}" dt="2026-01-28T14:29:59.048" v="1088" actId="2711"/>
+      <pc:sldChg chg="addSp delSp modSp mod">
+        <pc:chgData name="Zied Belhocine" userId="200cc0e2b299676e" providerId="LiveId" clId="{36CCCAD6-9B8B-4ECC-B7BF-7E36B9ADD69A}" dt="2026-02-05T08:53:00.758" v="2545" actId="1076"/>
         <pc:sldMkLst>
           <pc:docMk/>
           <pc:sldMk cId="0" sldId="259"/>
         </pc:sldMkLst>
+        <pc:spChg chg="add mod">
+          <ac:chgData name="Zied Belhocine" userId="200cc0e2b299676e" providerId="LiveId" clId="{36CCCAD6-9B8B-4ECC-B7BF-7E36B9ADD69A}" dt="2026-02-05T08:48:38.480" v="2521" actId="1076"/>
+          <ac:spMkLst>
+            <pc:docMk/>
+            <pc:sldMk cId="0" sldId="259"/>
+            <ac:spMk id="2" creationId="{877C2B17-23E2-4B8A-E055-0F562898E27C}"/>
+          </ac:spMkLst>
+        </pc:spChg>
+        <pc:spChg chg="add del">
+          <ac:chgData name="Zied Belhocine" userId="200cc0e2b299676e" providerId="LiveId" clId="{36CCCAD6-9B8B-4ECC-B7BF-7E36B9ADD69A}" dt="2026-01-30T16:34:32.519" v="1114" actId="22"/>
+          <ac:spMkLst>
+            <pc:docMk/>
+            <pc:sldMk cId="0" sldId="259"/>
+            <ac:spMk id="3" creationId="{9BCD1FB3-DE5B-74E7-04C9-EB87A3944002}"/>
+          </ac:spMkLst>
+        </pc:spChg>
+        <pc:spChg chg="add">
+          <ac:chgData name="Zied Belhocine" userId="200cc0e2b299676e" providerId="LiveId" clId="{36CCCAD6-9B8B-4ECC-B7BF-7E36B9ADD69A}" dt="2026-01-30T16:34:35.892" v="1115"/>
+          <ac:spMkLst>
+            <pc:docMk/>
+            <pc:sldMk cId="0" sldId="259"/>
+            <ac:spMk id="4" creationId="{4854AF66-421A-0037-E3B6-BC967ECB2910}"/>
+          </ac:spMkLst>
+        </pc:spChg>
+        <pc:spChg chg="add mod">
+          <ac:chgData name="Zied Belhocine" userId="200cc0e2b299676e" providerId="LiveId" clId="{36CCCAD6-9B8B-4ECC-B7BF-7E36B9ADD69A}" dt="2026-01-30T16:34:47.167" v="1117"/>
+          <ac:spMkLst>
+            <pc:docMk/>
+            <pc:sldMk cId="0" sldId="259"/>
+            <ac:spMk id="5" creationId="{5CD9ED61-414C-F28E-508F-EA844F92704B}"/>
+          </ac:spMkLst>
+        </pc:spChg>
+        <pc:spChg chg="add del mod">
+          <ac:chgData name="Zied Belhocine" userId="200cc0e2b299676e" providerId="LiveId" clId="{36CCCAD6-9B8B-4ECC-B7BF-7E36B9ADD69A}" dt="2026-02-05T08:51:47.688" v="2527" actId="478"/>
+          <ac:spMkLst>
+            <pc:docMk/>
+            <pc:sldMk cId="0" sldId="259"/>
+            <ac:spMk id="6" creationId="{3AFB7DEC-ECDC-F409-D668-E1C2FC232B02}"/>
+          </ac:spMkLst>
+        </pc:spChg>
+        <pc:spChg chg="add mod">
+          <ac:chgData name="Zied Belhocine" userId="200cc0e2b299676e" providerId="LiveId" clId="{36CCCAD6-9B8B-4ECC-B7BF-7E36B9ADD69A}" dt="2026-02-05T08:52:56.185" v="2544" actId="1076"/>
+          <ac:spMkLst>
+            <pc:docMk/>
+            <pc:sldMk cId="0" sldId="259"/>
+            <ac:spMk id="7" creationId="{DE350F41-FEEB-F480-B4A8-DF32C04F4EB7}"/>
+          </ac:spMkLst>
+        </pc:spChg>
+        <pc:spChg chg="add">
+          <ac:chgData name="Zied Belhocine" userId="200cc0e2b299676e" providerId="LiveId" clId="{36CCCAD6-9B8B-4ECC-B7BF-7E36B9ADD69A}" dt="2026-01-30T16:35:53.170" v="1120"/>
+          <ac:spMkLst>
+            <pc:docMk/>
+            <pc:sldMk cId="0" sldId="259"/>
+            <ac:spMk id="8" creationId="{F7E3456F-0090-A2F0-3F23-0D13283B82EB}"/>
+          </ac:spMkLst>
+        </pc:spChg>
+        <pc:spChg chg="add">
+          <ac:chgData name="Zied Belhocine" userId="200cc0e2b299676e" providerId="LiveId" clId="{36CCCAD6-9B8B-4ECC-B7BF-7E36B9ADD69A}" dt="2026-01-30T16:37:57.364" v="1342"/>
+          <ac:spMkLst>
+            <pc:docMk/>
+            <pc:sldMk cId="0" sldId="259"/>
+            <ac:spMk id="11" creationId="{C30DEE9C-6013-2FDE-4F7D-FB3910A59E94}"/>
+          </ac:spMkLst>
+        </pc:spChg>
+        <pc:spChg chg="add mod">
+          <ac:chgData name="Zied Belhocine" userId="200cc0e2b299676e" providerId="LiveId" clId="{36CCCAD6-9B8B-4ECC-B7BF-7E36B9ADD69A}" dt="2026-01-30T16:39:58.947" v="1359"/>
+          <ac:spMkLst>
+            <pc:docMk/>
+            <pc:sldMk cId="0" sldId="259"/>
+            <ac:spMk id="14" creationId="{E8C93C5F-BC8D-6571-C5C6-87440A2E91DD}"/>
+          </ac:spMkLst>
+        </pc:spChg>
+        <pc:spChg chg="add mod">
+          <ac:chgData name="Zied Belhocine" userId="200cc0e2b299676e" providerId="LiveId" clId="{36CCCAD6-9B8B-4ECC-B7BF-7E36B9ADD69A}" dt="2026-01-30T16:39:58.947" v="1359"/>
+          <ac:spMkLst>
+            <pc:docMk/>
+            <pc:sldMk cId="0" sldId="259"/>
+            <ac:spMk id="15" creationId="{B5C06CD8-CF23-37C0-FA53-8EC695412C81}"/>
+          </ac:spMkLst>
+        </pc:spChg>
+        <pc:spChg chg="add del">
+          <ac:chgData name="Zied Belhocine" userId="200cc0e2b299676e" providerId="LiveId" clId="{36CCCAD6-9B8B-4ECC-B7BF-7E36B9ADD69A}" dt="2026-01-30T16:40:03.381" v="1362" actId="478"/>
+          <ac:spMkLst>
+            <pc:docMk/>
+            <pc:sldMk cId="0" sldId="259"/>
+            <ac:spMk id="17" creationId="{5CF54A93-067D-429C-DB59-0ADE12E96A22}"/>
+          </ac:spMkLst>
+        </pc:spChg>
+        <pc:spChg chg="add del mod">
+          <ac:chgData name="Zied Belhocine" userId="200cc0e2b299676e" providerId="LiveId" clId="{36CCCAD6-9B8B-4ECC-B7BF-7E36B9ADD69A}" dt="2026-01-30T16:41:26.304" v="1415"/>
+          <ac:spMkLst>
+            <pc:docMk/>
+            <pc:sldMk cId="0" sldId="259"/>
+            <ac:spMk id="20" creationId="{1B5B1C95-53BC-AF42-2134-37CE7C9A3E05}"/>
+          </ac:spMkLst>
+        </pc:spChg>
+        <pc:spChg chg="add mod">
+          <ac:chgData name="Zied Belhocine" userId="200cc0e2b299676e" providerId="LiveId" clId="{36CCCAD6-9B8B-4ECC-B7BF-7E36B9ADD69A}" dt="2026-01-30T16:41:25.874" v="1413" actId="1076"/>
+          <ac:spMkLst>
+            <pc:docMk/>
+            <pc:sldMk cId="0" sldId="259"/>
+            <ac:spMk id="21" creationId="{972F5F94-D4F7-FB0F-86DE-1DBA70A4C8A7}"/>
+          </ac:spMkLst>
+        </pc:spChg>
         <pc:spChg chg="mod">
-          <ac:chgData name="Zied Belhocine" userId="200cc0e2b299676e" providerId="LiveId" clId="{36CCCAD6-9B8B-4ECC-B7BF-7E36B9ADD69A}" dt="2026-01-28T14:29:59.048" v="1088" actId="2711"/>
+          <ac:chgData name="Zied Belhocine" userId="200cc0e2b299676e" providerId="LiveId" clId="{36CCCAD6-9B8B-4ECC-B7BF-7E36B9ADD69A}" dt="2026-01-30T16:41:06.656" v="1384"/>
           <ac:spMkLst>
             <pc:docMk/>
             <pc:sldMk cId="0" sldId="259"/>
             <ac:spMk id="145" creationId="{00000000-0000-0000-0000-000000000000}"/>
           </ac:spMkLst>
         </pc:spChg>
-        <pc:spChg chg="mod">
-          <ac:chgData name="Zied Belhocine" userId="200cc0e2b299676e" providerId="LiveId" clId="{36CCCAD6-9B8B-4ECC-B7BF-7E36B9ADD69A}" dt="2026-01-28T14:29:59.048" v="1088" actId="2711"/>
+        <pc:spChg chg="del mod">
+          <ac:chgData name="Zied Belhocine" userId="200cc0e2b299676e" providerId="LiveId" clId="{36CCCAD6-9B8B-4ECC-B7BF-7E36B9ADD69A}" dt="2026-01-30T16:38:34.306" v="1355" actId="478"/>
           <ac:spMkLst>
             <pc:docMk/>
             <pc:sldMk cId="0" sldId="259"/>
             <ac:spMk id="146" creationId="{00000000-0000-0000-0000-000000000000}"/>
           </ac:spMkLst>
         </pc:spChg>
-        <pc:spChg chg="mod">
-          <ac:chgData name="Zied Belhocine" userId="200cc0e2b299676e" providerId="LiveId" clId="{36CCCAD6-9B8B-4ECC-B7BF-7E36B9ADD69A}" dt="2026-01-28T14:29:59.048" v="1088" actId="2711"/>
+        <pc:spChg chg="del mod">
+          <ac:chgData name="Zied Belhocine" userId="200cc0e2b299676e" providerId="LiveId" clId="{36CCCAD6-9B8B-4ECC-B7BF-7E36B9ADD69A}" dt="2026-01-30T15:11:01.354" v="1112" actId="478"/>
           <ac:spMkLst>
             <pc:docMk/>
             <pc:sldMk cId="0" sldId="259"/>
             <ac:spMk id="147" creationId="{00000000-0000-0000-0000-000000000000}"/>
           </ac:spMkLst>
         </pc:spChg>
+        <pc:picChg chg="add mod">
+          <ac:chgData name="Zied Belhocine" userId="200cc0e2b299676e" providerId="LiveId" clId="{36CCCAD6-9B8B-4ECC-B7BF-7E36B9ADD69A}" dt="2026-02-05T08:53:00.758" v="2545" actId="1076"/>
+          <ac:picMkLst>
+            <pc:docMk/>
+            <pc:sldMk cId="0" sldId="259"/>
+            <ac:picMk id="5" creationId="{AFF187F8-70D2-A5B1-ED33-1CFD638C7EEC}"/>
+          </ac:picMkLst>
+        </pc:picChg>
+        <pc:picChg chg="add del mod ord">
+          <ac:chgData name="Zied Belhocine" userId="200cc0e2b299676e" providerId="LiveId" clId="{36CCCAD6-9B8B-4ECC-B7BF-7E36B9ADD69A}" dt="2026-01-30T16:38:58.449" v="1357" actId="478"/>
+          <ac:picMkLst>
+            <pc:docMk/>
+            <pc:sldMk cId="0" sldId="259"/>
+            <ac:picMk id="7" creationId="{59B39551-E772-2CAF-CA7C-57770DFC7FBB}"/>
+          </ac:picMkLst>
+        </pc:picChg>
+        <pc:picChg chg="add del mod">
+          <ac:chgData name="Zied Belhocine" userId="200cc0e2b299676e" providerId="LiveId" clId="{36CCCAD6-9B8B-4ECC-B7BF-7E36B9ADD69A}" dt="2026-01-30T16:38:24.703" v="1352" actId="478"/>
+          <ac:picMkLst>
+            <pc:docMk/>
+            <pc:sldMk cId="0" sldId="259"/>
+            <ac:picMk id="10" creationId="{A9BA7499-DDDA-BFAA-34C2-4673C81E0671}"/>
+          </ac:picMkLst>
+        </pc:picChg>
+        <pc:picChg chg="add del mod ord">
+          <ac:chgData name="Zied Belhocine" userId="200cc0e2b299676e" providerId="LiveId" clId="{36CCCAD6-9B8B-4ECC-B7BF-7E36B9ADD69A}" dt="2026-02-05T08:50:55.834" v="2523" actId="478"/>
+          <ac:picMkLst>
+            <pc:docMk/>
+            <pc:sldMk cId="0" sldId="259"/>
+            <ac:picMk id="13" creationId="{D32B202C-3D8F-C06C-C81E-506CA6C77B7D}"/>
+          </ac:picMkLst>
+        </pc:picChg>
+        <pc:picChg chg="add mod">
+          <ac:chgData name="Zied Belhocine" userId="200cc0e2b299676e" providerId="LiveId" clId="{36CCCAD6-9B8B-4ECC-B7BF-7E36B9ADD69A}" dt="2026-01-30T16:40:30.793" v="1371" actId="1076"/>
+          <ac:picMkLst>
+            <pc:docMk/>
+            <pc:sldMk cId="0" sldId="259"/>
+            <ac:picMk id="19" creationId="{A3E9BD6F-847C-4219-5302-F3CEC09EB4BC}"/>
+          </ac:picMkLst>
+        </pc:picChg>
       </pc:sldChg>
-      <pc:sldChg chg="modSp mod">
-        <pc:chgData name="Zied Belhocine" userId="200cc0e2b299676e" providerId="LiveId" clId="{36CCCAD6-9B8B-4ECC-B7BF-7E36B9ADD69A}" dt="2026-01-28T14:30:03.517" v="1089" actId="2711"/>
+      <pc:sldChg chg="addSp delSp modSp mod">
+        <pc:chgData name="Zied Belhocine" userId="200cc0e2b299676e" providerId="LiveId" clId="{36CCCAD6-9B8B-4ECC-B7BF-7E36B9ADD69A}" dt="2026-02-03T11:08:41.080" v="2504" actId="20577"/>
         <pc:sldMkLst>
           <pc:docMk/>
           <pc:sldMk cId="0" sldId="260"/>
         </pc:sldMkLst>
+        <pc:spChg chg="add mod">
+          <ac:chgData name="Zied Belhocine" userId="200cc0e2b299676e" providerId="LiveId" clId="{36CCCAD6-9B8B-4ECC-B7BF-7E36B9ADD69A}" dt="2026-02-03T11:08:41.080" v="2504" actId="20577"/>
+          <ac:spMkLst>
+            <pc:docMk/>
+            <pc:sldMk cId="0" sldId="260"/>
+            <ac:spMk id="2" creationId="{B4C59EA3-5F2F-CFF2-D4AD-4AC8D054B5DA}"/>
+          </ac:spMkLst>
+        </pc:spChg>
+        <pc:spChg chg="add">
+          <ac:chgData name="Zied Belhocine" userId="200cc0e2b299676e" providerId="LiveId" clId="{36CCCAD6-9B8B-4ECC-B7BF-7E36B9ADD69A}" dt="2026-02-02T13:37:06.568" v="1419"/>
+          <ac:spMkLst>
+            <pc:docMk/>
+            <pc:sldMk cId="0" sldId="260"/>
+            <ac:spMk id="3" creationId="{067FEDF7-DC9E-C02F-2DF6-9367BB6EDCB1}"/>
+          </ac:spMkLst>
+        </pc:spChg>
+        <pc:spChg chg="add">
+          <ac:chgData name="Zied Belhocine" userId="200cc0e2b299676e" providerId="LiveId" clId="{36CCCAD6-9B8B-4ECC-B7BF-7E36B9ADD69A}" dt="2026-02-02T13:37:20.498" v="1420"/>
+          <ac:spMkLst>
+            <pc:docMk/>
+            <pc:sldMk cId="0" sldId="260"/>
+            <ac:spMk id="4" creationId="{3E3006DD-1B46-D53C-D44D-D7A28217E337}"/>
+          </ac:spMkLst>
+        </pc:spChg>
+        <pc:spChg chg="add del mod">
+          <ac:chgData name="Zied Belhocine" userId="200cc0e2b299676e" providerId="LiveId" clId="{36CCCAD6-9B8B-4ECC-B7BF-7E36B9ADD69A}" dt="2026-02-02T13:47:59.622" v="1735" actId="478"/>
+          <ac:spMkLst>
+            <pc:docMk/>
+            <pc:sldMk cId="0" sldId="260"/>
+            <ac:spMk id="7" creationId="{CE31435F-DDB0-AEF9-CC47-AEA80E6EA5B8}"/>
+          </ac:spMkLst>
+        </pc:spChg>
+        <pc:spChg chg="add mod">
+          <ac:chgData name="Zied Belhocine" userId="200cc0e2b299676e" providerId="LiveId" clId="{36CCCAD6-9B8B-4ECC-B7BF-7E36B9ADD69A}" dt="2026-02-02T13:53:00.276" v="1905" actId="20577"/>
+          <ac:spMkLst>
+            <pc:docMk/>
+            <pc:sldMk cId="0" sldId="260"/>
+            <ac:spMk id="8" creationId="{39ED7FC7-A5A5-D08A-AEB6-A498CF960A28}"/>
+          </ac:spMkLst>
+        </pc:spChg>
+        <pc:spChg chg="add del mod">
+          <ac:chgData name="Zied Belhocine" userId="200cc0e2b299676e" providerId="LiveId" clId="{36CCCAD6-9B8B-4ECC-B7BF-7E36B9ADD69A}" dt="2026-02-02T13:40:12.625" v="1463" actId="478"/>
+          <ac:spMkLst>
+            <pc:docMk/>
+            <pc:sldMk cId="0" sldId="260"/>
+            <ac:spMk id="9" creationId="{AECC73AF-460C-751B-48BA-5A3661CD84CE}"/>
+          </ac:spMkLst>
+        </pc:spChg>
+        <pc:spChg chg="add del mod">
+          <ac:chgData name="Zied Belhocine" userId="200cc0e2b299676e" providerId="LiveId" clId="{36CCCAD6-9B8B-4ECC-B7BF-7E36B9ADD69A}" dt="2026-02-02T13:40:14.093" v="1464" actId="478"/>
+          <ac:spMkLst>
+            <pc:docMk/>
+            <pc:sldMk cId="0" sldId="260"/>
+            <ac:spMk id="10" creationId="{A6A880FB-13BD-7367-FB2A-5CC2400B1EF2}"/>
+          </ac:spMkLst>
+        </pc:spChg>
+        <pc:spChg chg="add mod">
+          <ac:chgData name="Zied Belhocine" userId="200cc0e2b299676e" providerId="LiveId" clId="{36CCCAD6-9B8B-4ECC-B7BF-7E36B9ADD69A}" dt="2026-02-02T13:49:44.162" v="1781" actId="20577"/>
+          <ac:spMkLst>
+            <pc:docMk/>
+            <pc:sldMk cId="0" sldId="260"/>
+            <ac:spMk id="11" creationId="{EA18FBBD-EC4F-3A05-C02B-49434AEF7717}"/>
+          </ac:spMkLst>
+        </pc:spChg>
+        <pc:spChg chg="add mod">
+          <ac:chgData name="Zied Belhocine" userId="200cc0e2b299676e" providerId="LiveId" clId="{36CCCAD6-9B8B-4ECC-B7BF-7E36B9ADD69A}" dt="2026-02-02T13:48:48.289" v="1758" actId="1076"/>
+          <ac:spMkLst>
+            <pc:docMk/>
+            <pc:sldMk cId="0" sldId="260"/>
+            <ac:spMk id="16" creationId="{A74500E9-C47A-EB79-13AE-435EE8D6B2D7}"/>
+          </ac:spMkLst>
+        </pc:spChg>
+        <pc:spChg chg="add mod">
+          <ac:chgData name="Zied Belhocine" userId="200cc0e2b299676e" providerId="LiveId" clId="{36CCCAD6-9B8B-4ECC-B7BF-7E36B9ADD69A}" dt="2026-02-02T13:48:35.760" v="1741" actId="1076"/>
+          <ac:spMkLst>
+            <pc:docMk/>
+            <pc:sldMk cId="0" sldId="260"/>
+            <ac:spMk id="17" creationId="{E3F83F8E-FBD5-D3A6-36C1-32991F9C40E3}"/>
+          </ac:spMkLst>
+        </pc:spChg>
+        <pc:spChg chg="add mod">
+          <ac:chgData name="Zied Belhocine" userId="200cc0e2b299676e" providerId="LiveId" clId="{36CCCAD6-9B8B-4ECC-B7BF-7E36B9ADD69A}" dt="2026-02-02T13:53:15.305" v="1914" actId="20577"/>
+          <ac:spMkLst>
+            <pc:docMk/>
+            <pc:sldMk cId="0" sldId="260"/>
+            <ac:spMk id="18" creationId="{D7CC7DC0-BC77-AE9C-1812-7FBCCB438C89}"/>
+          </ac:spMkLst>
+        </pc:spChg>
+        <pc:spChg chg="add mod">
+          <ac:chgData name="Zied Belhocine" userId="200cc0e2b299676e" providerId="LiveId" clId="{36CCCAD6-9B8B-4ECC-B7BF-7E36B9ADD69A}" dt="2026-02-02T13:48:59.098" v="1773" actId="1037"/>
+          <ac:spMkLst>
+            <pc:docMk/>
+            <pc:sldMk cId="0" sldId="260"/>
+            <ac:spMk id="19" creationId="{EDF6C174-050D-7B87-A04E-0D9D2FF055A5}"/>
+          </ac:spMkLst>
+        </pc:spChg>
+        <pc:spChg chg="add mod">
+          <ac:chgData name="Zied Belhocine" userId="200cc0e2b299676e" providerId="LiveId" clId="{36CCCAD6-9B8B-4ECC-B7BF-7E36B9ADD69A}" dt="2026-02-02T13:48:29.157" v="1740" actId="207"/>
+          <ac:spMkLst>
+            <pc:docMk/>
+            <pc:sldMk cId="0" sldId="260"/>
+            <ac:spMk id="20" creationId="{D269DE3B-3BEA-B178-D27D-14C13DA838A9}"/>
+          </ac:spMkLst>
+        </pc:spChg>
+        <pc:spChg chg="add del mod">
+          <ac:chgData name="Zied Belhocine" userId="200cc0e2b299676e" providerId="LiveId" clId="{36CCCAD6-9B8B-4ECC-B7BF-7E36B9ADD69A}" dt="2026-02-02T13:50:59.831" v="1789"/>
+          <ac:spMkLst>
+            <pc:docMk/>
+            <pc:sldMk cId="0" sldId="260"/>
+            <ac:spMk id="22" creationId="{017A17B2-1B88-4667-8F51-FA4790813AF3}"/>
+          </ac:spMkLst>
+        </pc:spChg>
+        <pc:spChg chg="add mod">
+          <ac:chgData name="Zied Belhocine" userId="200cc0e2b299676e" providerId="LiveId" clId="{36CCCAD6-9B8B-4ECC-B7BF-7E36B9ADD69A}" dt="2026-02-03T11:08:29.269" v="2484" actId="20577"/>
+          <ac:spMkLst>
+            <pc:docMk/>
+            <pc:sldMk cId="0" sldId="260"/>
+            <ac:spMk id="24" creationId="{F1E7BF95-A00F-B687-0DEA-05EB431F0415}"/>
+          </ac:spMkLst>
+        </pc:spChg>
         <pc:spChg chg="mod">
           <ac:chgData name="Zied Belhocine" userId="200cc0e2b299676e" providerId="LiveId" clId="{36CCCAD6-9B8B-4ECC-B7BF-7E36B9ADD69A}" dt="2026-01-28T14:30:03.517" v="1089" actId="2711"/>
           <ac:spMkLst>
@@ -696,7 +992,7 @@
           </ac:spMkLst>
         </pc:spChg>
         <pc:spChg chg="mod">
-          <ac:chgData name="Zied Belhocine" userId="200cc0e2b299676e" providerId="LiveId" clId="{36CCCAD6-9B8B-4ECC-B7BF-7E36B9ADD69A}" dt="2026-01-28T14:30:03.517" v="1089" actId="2711"/>
+          <ac:chgData name="Zied Belhocine" userId="200cc0e2b299676e" providerId="LiveId" clId="{36CCCAD6-9B8B-4ECC-B7BF-7E36B9ADD69A}" dt="2026-02-02T13:39:18.605" v="1448" actId="1076"/>
           <ac:spMkLst>
             <pc:docMk/>
             <pc:sldMk cId="0" sldId="260"/>
@@ -704,20 +1000,132 @@
           </ac:spMkLst>
         </pc:spChg>
         <pc:spChg chg="mod">
-          <ac:chgData name="Zied Belhocine" userId="200cc0e2b299676e" providerId="LiveId" clId="{36CCCAD6-9B8B-4ECC-B7BF-7E36B9ADD69A}" dt="2026-01-28T14:30:03.517" v="1089" actId="2711"/>
+          <ac:chgData name="Zied Belhocine" userId="200cc0e2b299676e" providerId="LiveId" clId="{36CCCAD6-9B8B-4ECC-B7BF-7E36B9ADD69A}" dt="2026-02-03T11:05:58.105" v="2477" actId="1076"/>
           <ac:spMkLst>
             <pc:docMk/>
             <pc:sldMk cId="0" sldId="260"/>
             <ac:spMk id="154" creationId="{00000000-0000-0000-0000-000000000000}"/>
           </ac:spMkLst>
         </pc:spChg>
+        <pc:graphicFrameChg chg="add del mod modGraphic">
+          <ac:chgData name="Zied Belhocine" userId="200cc0e2b299676e" providerId="LiveId" clId="{36CCCAD6-9B8B-4ECC-B7BF-7E36B9ADD69A}" dt="2026-02-02T13:36:44.997" v="1418" actId="478"/>
+          <ac:graphicFrameMkLst>
+            <pc:docMk/>
+            <pc:sldMk cId="0" sldId="260"/>
+            <ac:graphicFrameMk id="2" creationId="{C9BBA2D7-3A66-0EE6-F082-68645F91156F}"/>
+          </ac:graphicFrameMkLst>
+        </pc:graphicFrameChg>
+        <pc:picChg chg="add del mod">
+          <ac:chgData name="Zied Belhocine" userId="200cc0e2b299676e" providerId="LiveId" clId="{36CCCAD6-9B8B-4ECC-B7BF-7E36B9ADD69A}" dt="2026-02-02T13:43:23.728" v="1625" actId="478"/>
+          <ac:picMkLst>
+            <pc:docMk/>
+            <pc:sldMk cId="0" sldId="260"/>
+            <ac:picMk id="6" creationId="{A0B29AA0-F167-AB5D-7E5F-D05B566642E8}"/>
+          </ac:picMkLst>
+        </pc:picChg>
+        <pc:picChg chg="add del mod">
+          <ac:chgData name="Zied Belhocine" userId="200cc0e2b299676e" providerId="LiveId" clId="{36CCCAD6-9B8B-4ECC-B7BF-7E36B9ADD69A}" dt="2026-02-02T13:43:55.043" v="1630" actId="478"/>
+          <ac:picMkLst>
+            <pc:docMk/>
+            <pc:sldMk cId="0" sldId="260"/>
+            <ac:picMk id="13" creationId="{E0AFDB26-6F91-0176-7719-BC2474F9BF6C}"/>
+          </ac:picMkLst>
+        </pc:picChg>
+        <pc:picChg chg="add del mod">
+          <ac:chgData name="Zied Belhocine" userId="200cc0e2b299676e" providerId="LiveId" clId="{36CCCAD6-9B8B-4ECC-B7BF-7E36B9ADD69A}" dt="2026-02-03T11:05:04.684" v="2428" actId="478"/>
+          <ac:picMkLst>
+            <pc:docMk/>
+            <pc:sldMk cId="0" sldId="260"/>
+            <ac:picMk id="15" creationId="{9F3B4AD3-9B1B-6735-3B8F-9CE94EF36596}"/>
+          </ac:picMkLst>
+        </pc:picChg>
+        <pc:picChg chg="add del mod">
+          <ac:chgData name="Zied Belhocine" userId="200cc0e2b299676e" providerId="LiveId" clId="{36CCCAD6-9B8B-4ECC-B7BF-7E36B9ADD69A}" dt="2026-02-02T13:50:41.209" v="1784" actId="478"/>
+          <ac:picMkLst>
+            <pc:docMk/>
+            <pc:sldMk cId="0" sldId="260"/>
+            <ac:picMk id="21" creationId="{AB18CDEC-81BE-E01E-2491-9AE303B53917}"/>
+          </ac:picMkLst>
+        </pc:picChg>
       </pc:sldChg>
-      <pc:sldChg chg="modSp mod">
-        <pc:chgData name="Zied Belhocine" userId="200cc0e2b299676e" providerId="LiveId" clId="{36CCCAD6-9B8B-4ECC-B7BF-7E36B9ADD69A}" dt="2026-01-28T14:30:15.889" v="1091" actId="2711"/>
+      <pc:sldChg chg="addSp delSp modSp mod">
+        <pc:chgData name="Zied Belhocine" userId="200cc0e2b299676e" providerId="LiveId" clId="{36CCCAD6-9B8B-4ECC-B7BF-7E36B9ADD69A}" dt="2026-02-03T11:09:16.280" v="2513" actId="20577"/>
         <pc:sldMkLst>
           <pc:docMk/>
           <pc:sldMk cId="0" sldId="261"/>
         </pc:sldMkLst>
+        <pc:spChg chg="add mod">
+          <ac:chgData name="Zied Belhocine" userId="200cc0e2b299676e" providerId="LiveId" clId="{36CCCAD6-9B8B-4ECC-B7BF-7E36B9ADD69A}" dt="2026-02-03T10:28:34.922" v="2004" actId="20577"/>
+          <ac:spMkLst>
+            <pc:docMk/>
+            <pc:sldMk cId="0" sldId="261"/>
+            <ac:spMk id="2" creationId="{69C9B610-9784-E7BC-09E1-304855359E98}"/>
+          </ac:spMkLst>
+        </pc:spChg>
+        <pc:spChg chg="add mod">
+          <ac:chgData name="Zied Belhocine" userId="200cc0e2b299676e" providerId="LiveId" clId="{36CCCAD6-9B8B-4ECC-B7BF-7E36B9ADD69A}" dt="2026-02-03T10:28:42.797" v="2013" actId="20577"/>
+          <ac:spMkLst>
+            <pc:docMk/>
+            <pc:sldMk cId="0" sldId="261"/>
+            <ac:spMk id="3" creationId="{BC1F652D-F5DE-C634-E07F-274418B0C7AC}"/>
+          </ac:spMkLst>
+        </pc:spChg>
+        <pc:spChg chg="add mod">
+          <ac:chgData name="Zied Belhocine" userId="200cc0e2b299676e" providerId="LiveId" clId="{36CCCAD6-9B8B-4ECC-B7BF-7E36B9ADD69A}" dt="2026-02-02T13:54:13.257" v="1916"/>
+          <ac:spMkLst>
+            <pc:docMk/>
+            <pc:sldMk cId="0" sldId="261"/>
+            <ac:spMk id="5" creationId="{0495A920-A68F-CF17-7122-417C23D81BA3}"/>
+          </ac:spMkLst>
+        </pc:spChg>
+        <pc:spChg chg="add mod">
+          <ac:chgData name="Zied Belhocine" userId="200cc0e2b299676e" providerId="LiveId" clId="{36CCCAD6-9B8B-4ECC-B7BF-7E36B9ADD69A}" dt="2026-02-02T13:54:13.257" v="1916"/>
+          <ac:spMkLst>
+            <pc:docMk/>
+            <pc:sldMk cId="0" sldId="261"/>
+            <ac:spMk id="6" creationId="{7D0D3F6A-C0E1-EA14-09D0-26AB77740A69}"/>
+          </ac:spMkLst>
+        </pc:spChg>
+        <pc:spChg chg="add mod">
+          <ac:chgData name="Zied Belhocine" userId="200cc0e2b299676e" providerId="LiveId" clId="{36CCCAD6-9B8B-4ECC-B7BF-7E36B9ADD69A}" dt="2026-02-02T13:54:13.257" v="1916"/>
+          <ac:spMkLst>
+            <pc:docMk/>
+            <pc:sldMk cId="0" sldId="261"/>
+            <ac:spMk id="7" creationId="{31BF7932-C337-6BA2-ED62-C7C0D006D2FF}"/>
+          </ac:spMkLst>
+        </pc:spChg>
+        <pc:spChg chg="add mod">
+          <ac:chgData name="Zied Belhocine" userId="200cc0e2b299676e" providerId="LiveId" clId="{36CCCAD6-9B8B-4ECC-B7BF-7E36B9ADD69A}" dt="2026-02-02T13:54:13.257" v="1916"/>
+          <ac:spMkLst>
+            <pc:docMk/>
+            <pc:sldMk cId="0" sldId="261"/>
+            <ac:spMk id="8" creationId="{F3D8CC57-8C8D-3871-46F5-C4529D4112A7}"/>
+          </ac:spMkLst>
+        </pc:spChg>
+        <pc:spChg chg="add mod">
+          <ac:chgData name="Zied Belhocine" userId="200cc0e2b299676e" providerId="LiveId" clId="{36CCCAD6-9B8B-4ECC-B7BF-7E36B9ADD69A}" dt="2026-02-02T13:54:13.257" v="1916"/>
+          <ac:spMkLst>
+            <pc:docMk/>
+            <pc:sldMk cId="0" sldId="261"/>
+            <ac:spMk id="9" creationId="{5FDC7050-6E40-EA14-5130-48D10D56DFA5}"/>
+          </ac:spMkLst>
+        </pc:spChg>
+        <pc:spChg chg="add mod">
+          <ac:chgData name="Zied Belhocine" userId="200cc0e2b299676e" providerId="LiveId" clId="{36CCCAD6-9B8B-4ECC-B7BF-7E36B9ADD69A}" dt="2026-02-03T11:09:16.280" v="2513" actId="20577"/>
+          <ac:spMkLst>
+            <pc:docMk/>
+            <pc:sldMk cId="0" sldId="261"/>
+            <ac:spMk id="10" creationId="{3D3D1CBC-E1D7-4D4A-9AA0-011B7A1380C5}"/>
+          </ac:spMkLst>
+        </pc:spChg>
+        <pc:spChg chg="add mod">
+          <ac:chgData name="Zied Belhocine" userId="200cc0e2b299676e" providerId="LiveId" clId="{36CCCAD6-9B8B-4ECC-B7BF-7E36B9ADD69A}" dt="2026-02-03T11:09:02.004" v="2506"/>
+          <ac:spMkLst>
+            <pc:docMk/>
+            <pc:sldMk cId="0" sldId="261"/>
+            <ac:spMk id="11" creationId="{ED059039-EA47-C6E8-855C-7184EBEED48B}"/>
+          </ac:spMkLst>
+        </pc:spChg>
         <pc:spChg chg="mod">
           <ac:chgData name="Zied Belhocine" userId="200cc0e2b299676e" providerId="LiveId" clId="{36CCCAD6-9B8B-4ECC-B7BF-7E36B9ADD69A}" dt="2026-01-28T14:30:15.889" v="1091" actId="2711"/>
           <ac:spMkLst>
@@ -726,8 +1134,8 @@
             <ac:spMk id="159" creationId="{00000000-0000-0000-0000-000000000000}"/>
           </ac:spMkLst>
         </pc:spChg>
-        <pc:spChg chg="mod">
-          <ac:chgData name="Zied Belhocine" userId="200cc0e2b299676e" providerId="LiveId" clId="{36CCCAD6-9B8B-4ECC-B7BF-7E36B9ADD69A}" dt="2026-01-28T14:30:15.889" v="1091" actId="2711"/>
+        <pc:spChg chg="del mod">
+          <ac:chgData name="Zied Belhocine" userId="200cc0e2b299676e" providerId="LiveId" clId="{36CCCAD6-9B8B-4ECC-B7BF-7E36B9ADD69A}" dt="2026-02-02T13:54:16.995" v="1917" actId="478"/>
           <ac:spMkLst>
             <pc:docMk/>
             <pc:sldMk cId="0" sldId="261"/>
@@ -735,16 +1143,24 @@
           </ac:spMkLst>
         </pc:spChg>
         <pc:spChg chg="mod">
-          <ac:chgData name="Zied Belhocine" userId="200cc0e2b299676e" providerId="LiveId" clId="{36CCCAD6-9B8B-4ECC-B7BF-7E36B9ADD69A}" dt="2026-01-28T14:30:15.889" v="1091" actId="2711"/>
+          <ac:chgData name="Zied Belhocine" userId="200cc0e2b299676e" providerId="LiveId" clId="{36CCCAD6-9B8B-4ECC-B7BF-7E36B9ADD69A}" dt="2026-02-03T10:28:55.749" v="2015" actId="1076"/>
           <ac:spMkLst>
             <pc:docMk/>
             <pc:sldMk cId="0" sldId="261"/>
             <ac:spMk id="161" creationId="{00000000-0000-0000-0000-000000000000}"/>
           </ac:spMkLst>
         </pc:spChg>
+        <pc:picChg chg="add del mod">
+          <ac:chgData name="Zied Belhocine" userId="200cc0e2b299676e" providerId="LiveId" clId="{36CCCAD6-9B8B-4ECC-B7BF-7E36B9ADD69A}" dt="2026-02-03T11:08:58.761" v="2505" actId="478"/>
+          <ac:picMkLst>
+            <pc:docMk/>
+            <pc:sldMk cId="0" sldId="261"/>
+            <ac:picMk id="4" creationId="{B295E544-59BF-89F8-A5B6-64360E81DD5E}"/>
+          </ac:picMkLst>
+        </pc:picChg>
       </pc:sldChg>
-      <pc:sldChg chg="modSp mod setBg">
-        <pc:chgData name="Zied Belhocine" userId="200cc0e2b299676e" providerId="LiveId" clId="{36CCCAD6-9B8B-4ECC-B7BF-7E36B9ADD69A}" dt="2026-01-28T14:30:27.238" v="1093"/>
+      <pc:sldChg chg="addSp delSp modSp mod setBg">
+        <pc:chgData name="Zied Belhocine" userId="200cc0e2b299676e" providerId="LiveId" clId="{36CCCAD6-9B8B-4ECC-B7BF-7E36B9ADD69A}" dt="2026-02-05T10:14:26.092" v="2557" actId="14100"/>
         <pc:sldMkLst>
           <pc:docMk/>
           <pc:sldMk cId="0" sldId="262"/>
@@ -766,7 +1182,7 @@
           </ac:spMkLst>
         </pc:spChg>
         <pc:spChg chg="mod">
-          <ac:chgData name="Zied Belhocine" userId="200cc0e2b299676e" providerId="LiveId" clId="{36CCCAD6-9B8B-4ECC-B7BF-7E36B9ADD69A}" dt="2026-01-28T14:30:24.145" v="1092" actId="2711"/>
+          <ac:chgData name="Zied Belhocine" userId="200cc0e2b299676e" providerId="LiveId" clId="{36CCCAD6-9B8B-4ECC-B7BF-7E36B9ADD69A}" dt="2026-02-05T09:01:57.235" v="2549" actId="1076"/>
           <ac:spMkLst>
             <pc:docMk/>
             <pc:sldMk cId="0" sldId="262"/>
@@ -774,16 +1190,40 @@
           </ac:spMkLst>
         </pc:spChg>
         <pc:spChg chg="mod">
-          <ac:chgData name="Zied Belhocine" userId="200cc0e2b299676e" providerId="LiveId" clId="{36CCCAD6-9B8B-4ECC-B7BF-7E36B9ADD69A}" dt="2026-01-28T14:30:24.145" v="1092" actId="2711"/>
+          <ac:chgData name="Zied Belhocine" userId="200cc0e2b299676e" providerId="LiveId" clId="{36CCCAD6-9B8B-4ECC-B7BF-7E36B9ADD69A}" dt="2026-02-05T09:01:55.965" v="2548" actId="1076"/>
           <ac:spMkLst>
             <pc:docMk/>
             <pc:sldMk cId="0" sldId="262"/>
             <ac:spMk id="169" creationId="{00000000-0000-0000-0000-000000000000}"/>
           </ac:spMkLst>
         </pc:spChg>
+        <pc:picChg chg="add mod">
+          <ac:chgData name="Zied Belhocine" userId="200cc0e2b299676e" providerId="LiveId" clId="{36CCCAD6-9B8B-4ECC-B7BF-7E36B9ADD69A}" dt="2026-02-02T16:11:15.426" v="1950" actId="1076"/>
+          <ac:picMkLst>
+            <pc:docMk/>
+            <pc:sldMk cId="0" sldId="262"/>
+            <ac:picMk id="3" creationId="{B3760D85-B619-BBC4-7DD5-ACE85EF40AC1}"/>
+          </ac:picMkLst>
+        </pc:picChg>
+        <pc:picChg chg="add del mod">
+          <ac:chgData name="Zied Belhocine" userId="200cc0e2b299676e" providerId="LiveId" clId="{36CCCAD6-9B8B-4ECC-B7BF-7E36B9ADD69A}" dt="2026-02-05T10:14:15.975" v="2553" actId="478"/>
+          <ac:picMkLst>
+            <pc:docMk/>
+            <pc:sldMk cId="0" sldId="262"/>
+            <ac:picMk id="4" creationId="{AB88618B-EE6D-3F3C-6331-87E8DB4D97C9}"/>
+          </ac:picMkLst>
+        </pc:picChg>
+        <pc:picChg chg="add mod">
+          <ac:chgData name="Zied Belhocine" userId="200cc0e2b299676e" providerId="LiveId" clId="{36CCCAD6-9B8B-4ECC-B7BF-7E36B9ADD69A}" dt="2026-02-05T10:14:26.092" v="2557" actId="14100"/>
+          <ac:picMkLst>
+            <pc:docMk/>
+            <pc:sldMk cId="0" sldId="262"/>
+            <ac:picMk id="6" creationId="{D1F90F54-3FDF-D519-5E00-5C25FAD5E2F8}"/>
+          </ac:picMkLst>
+        </pc:picChg>
       </pc:sldChg>
-      <pc:sldChg chg="modSp mod setBg">
-        <pc:chgData name="Zied Belhocine" userId="200cc0e2b299676e" providerId="LiveId" clId="{36CCCAD6-9B8B-4ECC-B7BF-7E36B9ADD69A}" dt="2026-01-28T14:30:33.694" v="1095" actId="2711"/>
+      <pc:sldChg chg="addSp modSp mod setBg">
+        <pc:chgData name="Zied Belhocine" userId="200cc0e2b299676e" providerId="LiveId" clId="{36CCCAD6-9B8B-4ECC-B7BF-7E36B9ADD69A}" dt="2026-02-02T19:26:48.368" v="1954" actId="1076"/>
         <pc:sldMkLst>
           <pc:docMk/>
           <pc:sldMk cId="0" sldId="263"/>
@@ -812,9 +1252,17 @@
             <ac:spMk id="176" creationId="{00000000-0000-0000-0000-000000000000}"/>
           </ac:spMkLst>
         </pc:spChg>
+        <pc:picChg chg="add mod">
+          <ac:chgData name="Zied Belhocine" userId="200cc0e2b299676e" providerId="LiveId" clId="{36CCCAD6-9B8B-4ECC-B7BF-7E36B9ADD69A}" dt="2026-02-02T19:26:48.368" v="1954" actId="1076"/>
+          <ac:picMkLst>
+            <pc:docMk/>
+            <pc:sldMk cId="0" sldId="263"/>
+            <ac:picMk id="3" creationId="{3E9ECCD4-01EA-969D-859F-5F7106BE3752}"/>
+          </ac:picMkLst>
+        </pc:picChg>
       </pc:sldChg>
-      <pc:sldChg chg="modSp mod">
-        <pc:chgData name="Zied Belhocine" userId="200cc0e2b299676e" providerId="LiveId" clId="{36CCCAD6-9B8B-4ECC-B7BF-7E36B9ADD69A}" dt="2026-01-28T14:30:43.739" v="1096" actId="2711"/>
+      <pc:sldChg chg="addSp delSp modSp mod">
+        <pc:chgData name="Zied Belhocine" userId="200cc0e2b299676e" providerId="LiveId" clId="{36CCCAD6-9B8B-4ECC-B7BF-7E36B9ADD69A}" dt="2026-02-05T10:22:28.146" v="2564" actId="14100"/>
         <pc:sldMkLst>
           <pc:docMk/>
           <pc:sldMk cId="0" sldId="264"/>
@@ -827,8 +1275,8 @@
             <ac:spMk id="181" creationId="{00000000-0000-0000-0000-000000000000}"/>
           </ac:spMkLst>
         </pc:spChg>
-        <pc:spChg chg="mod">
-          <ac:chgData name="Zied Belhocine" userId="200cc0e2b299676e" providerId="LiveId" clId="{36CCCAD6-9B8B-4ECC-B7BF-7E36B9ADD69A}" dt="2026-01-28T14:30:43.739" v="1096" actId="2711"/>
+        <pc:spChg chg="del mod">
+          <ac:chgData name="Zied Belhocine" userId="200cc0e2b299676e" providerId="LiveId" clId="{36CCCAD6-9B8B-4ECC-B7BF-7E36B9ADD69A}" dt="2026-02-02T19:41:20.434" v="1962" actId="478"/>
           <ac:spMkLst>
             <pc:docMk/>
             <pc:sldMk cId="0" sldId="264"/>
@@ -843,9 +1291,25 @@
             <ac:spMk id="183" creationId="{00000000-0000-0000-0000-000000000000}"/>
           </ac:spMkLst>
         </pc:spChg>
+        <pc:picChg chg="add del mod">
+          <ac:chgData name="Zied Belhocine" userId="200cc0e2b299676e" providerId="LiveId" clId="{36CCCAD6-9B8B-4ECC-B7BF-7E36B9ADD69A}" dt="2026-02-05T10:22:17.766" v="2558" actId="478"/>
+          <ac:picMkLst>
+            <pc:docMk/>
+            <pc:sldMk cId="0" sldId="264"/>
+            <ac:picMk id="3" creationId="{DE0BFE79-B453-BC64-5349-643A0A078F3A}"/>
+          </ac:picMkLst>
+        </pc:picChg>
+        <pc:picChg chg="add mod">
+          <ac:chgData name="Zied Belhocine" userId="200cc0e2b299676e" providerId="LiveId" clId="{36CCCAD6-9B8B-4ECC-B7BF-7E36B9ADD69A}" dt="2026-02-05T10:22:28.146" v="2564" actId="14100"/>
+          <ac:picMkLst>
+            <pc:docMk/>
+            <pc:sldMk cId="0" sldId="264"/>
+            <ac:picMk id="4" creationId="{23A5F8A5-4B3E-7CB1-C38F-0DAB1A291480}"/>
+          </ac:picMkLst>
+        </pc:picChg>
       </pc:sldChg>
-      <pc:sldChg chg="modSp mod">
-        <pc:chgData name="Zied Belhocine" userId="200cc0e2b299676e" providerId="LiveId" clId="{36CCCAD6-9B8B-4ECC-B7BF-7E36B9ADD69A}" dt="2026-01-28T14:31:00.316" v="1101" actId="2711"/>
+      <pc:sldChg chg="addSp delSp modSp mod">
+        <pc:chgData name="Zied Belhocine" userId="200cc0e2b299676e" providerId="LiveId" clId="{36CCCAD6-9B8B-4ECC-B7BF-7E36B9ADD69A}" dt="2026-02-05T10:23:19.346" v="2567" actId="478"/>
         <pc:sldMkLst>
           <pc:docMk/>
           <pc:sldMk cId="0" sldId="265"/>
@@ -858,8 +1322,8 @@
             <ac:spMk id="188" creationId="{00000000-0000-0000-0000-000000000000}"/>
           </ac:spMkLst>
         </pc:spChg>
-        <pc:spChg chg="mod">
-          <ac:chgData name="Zied Belhocine" userId="200cc0e2b299676e" providerId="LiveId" clId="{36CCCAD6-9B8B-4ECC-B7BF-7E36B9ADD69A}" dt="2026-01-28T14:31:00.316" v="1101" actId="2711"/>
+        <pc:spChg chg="del mod">
+          <ac:chgData name="Zied Belhocine" userId="200cc0e2b299676e" providerId="LiveId" clId="{36CCCAD6-9B8B-4ECC-B7BF-7E36B9ADD69A}" dt="2026-02-02T19:41:48.402" v="1967" actId="478"/>
           <ac:spMkLst>
             <pc:docMk/>
             <pc:sldMk cId="0" sldId="265"/>
@@ -874,9 +1338,25 @@
             <ac:spMk id="190" creationId="{00000000-0000-0000-0000-000000000000}"/>
           </ac:spMkLst>
         </pc:spChg>
+        <pc:picChg chg="add del mod">
+          <ac:chgData name="Zied Belhocine" userId="200cc0e2b299676e" providerId="LiveId" clId="{36CCCAD6-9B8B-4ECC-B7BF-7E36B9ADD69A}" dt="2026-02-05T10:23:19.346" v="2567" actId="478"/>
+          <ac:picMkLst>
+            <pc:docMk/>
+            <pc:sldMk cId="0" sldId="265"/>
+            <ac:picMk id="3" creationId="{2E44E867-57FD-6800-B510-81134C522B50}"/>
+          </ac:picMkLst>
+        </pc:picChg>
+        <pc:picChg chg="add mod">
+          <ac:chgData name="Zied Belhocine" userId="200cc0e2b299676e" providerId="LiveId" clId="{36CCCAD6-9B8B-4ECC-B7BF-7E36B9ADD69A}" dt="2026-02-05T10:23:17.438" v="2566" actId="14100"/>
+          <ac:picMkLst>
+            <pc:docMk/>
+            <pc:sldMk cId="0" sldId="265"/>
+            <ac:picMk id="4" creationId="{207DCDAB-31D7-C2A5-DA44-B2B7F919E54C}"/>
+          </ac:picMkLst>
+        </pc:picChg>
       </pc:sldChg>
-      <pc:sldChg chg="modSp mod">
-        <pc:chgData name="Zied Belhocine" userId="200cc0e2b299676e" providerId="LiveId" clId="{36CCCAD6-9B8B-4ECC-B7BF-7E36B9ADD69A}" dt="2026-01-28T14:31:12.402" v="1104" actId="2711"/>
+      <pc:sldChg chg="addSp delSp modSp mod">
+        <pc:chgData name="Zied Belhocine" userId="200cc0e2b299676e" providerId="LiveId" clId="{36CCCAD6-9B8B-4ECC-B7BF-7E36B9ADD69A}" dt="2026-02-05T10:25:07.903" v="2573" actId="478"/>
         <pc:sldMkLst>
           <pc:docMk/>
           <pc:sldMk cId="0" sldId="266"/>
@@ -889,8 +1369,8 @@
             <ac:spMk id="195" creationId="{00000000-0000-0000-0000-000000000000}"/>
           </ac:spMkLst>
         </pc:spChg>
-        <pc:spChg chg="mod">
-          <ac:chgData name="Zied Belhocine" userId="200cc0e2b299676e" providerId="LiveId" clId="{36CCCAD6-9B8B-4ECC-B7BF-7E36B9ADD69A}" dt="2026-01-28T14:31:12.402" v="1104" actId="2711"/>
+        <pc:spChg chg="del mod">
+          <ac:chgData name="Zied Belhocine" userId="200cc0e2b299676e" providerId="LiveId" clId="{36CCCAD6-9B8B-4ECC-B7BF-7E36B9ADD69A}" dt="2026-02-05T10:25:07.903" v="2573" actId="478"/>
           <ac:spMkLst>
             <pc:docMk/>
             <pc:sldMk cId="0" sldId="266"/>
@@ -905,9 +1385,33 @@
             <ac:spMk id="197" creationId="{00000000-0000-0000-0000-000000000000}"/>
           </ac:spMkLst>
         </pc:spChg>
+        <pc:picChg chg="add del mod">
+          <ac:chgData name="Zied Belhocine" userId="200cc0e2b299676e" providerId="LiveId" clId="{36CCCAD6-9B8B-4ECC-B7BF-7E36B9ADD69A}" dt="2026-02-05T10:25:01.233" v="2571" actId="478"/>
+          <ac:picMkLst>
+            <pc:docMk/>
+            <pc:sldMk cId="0" sldId="266"/>
+            <ac:picMk id="3" creationId="{D7B53139-3E28-965A-42AE-ADA607776D00}"/>
+          </ac:picMkLst>
+        </pc:picChg>
+        <pc:picChg chg="add del">
+          <ac:chgData name="Zied Belhocine" userId="200cc0e2b299676e" providerId="LiveId" clId="{36CCCAD6-9B8B-4ECC-B7BF-7E36B9ADD69A}" dt="2026-02-05T10:24:57.144" v="2569" actId="478"/>
+          <ac:picMkLst>
+            <pc:docMk/>
+            <pc:sldMk cId="0" sldId="266"/>
+            <ac:picMk id="4" creationId="{027C19FC-6FE2-2143-3F74-CCD02A8D7E8D}"/>
+          </ac:picMkLst>
+        </pc:picChg>
+        <pc:picChg chg="add mod">
+          <ac:chgData name="Zied Belhocine" userId="200cc0e2b299676e" providerId="LiveId" clId="{36CCCAD6-9B8B-4ECC-B7BF-7E36B9ADD69A}" dt="2026-02-05T10:25:05.889" v="2572" actId="1076"/>
+          <ac:picMkLst>
+            <pc:docMk/>
+            <pc:sldMk cId="0" sldId="266"/>
+            <ac:picMk id="6" creationId="{ACAA7E2C-A938-C52D-9A74-A8814BAB7C35}"/>
+          </ac:picMkLst>
+        </pc:picChg>
       </pc:sldChg>
-      <pc:sldChg chg="modSp mod">
-        <pc:chgData name="Zied Belhocine" userId="200cc0e2b299676e" providerId="LiveId" clId="{36CCCAD6-9B8B-4ECC-B7BF-7E36B9ADD69A}" dt="2026-01-28T14:31:25.076" v="1105" actId="2711"/>
+      <pc:sldChg chg="addSp delSp modSp mod">
+        <pc:chgData name="Zied Belhocine" userId="200cc0e2b299676e" providerId="LiveId" clId="{36CCCAD6-9B8B-4ECC-B7BF-7E36B9ADD69A}" dt="2026-02-05T10:35:29.583" v="2583" actId="478"/>
         <pc:sldMkLst>
           <pc:docMk/>
           <pc:sldMk cId="0" sldId="267"/>
@@ -920,8 +1424,8 @@
             <ac:spMk id="202" creationId="{00000000-0000-0000-0000-000000000000}"/>
           </ac:spMkLst>
         </pc:spChg>
-        <pc:spChg chg="mod">
-          <ac:chgData name="Zied Belhocine" userId="200cc0e2b299676e" providerId="LiveId" clId="{36CCCAD6-9B8B-4ECC-B7BF-7E36B9ADD69A}" dt="2026-01-28T14:31:25.076" v="1105" actId="2711"/>
+        <pc:spChg chg="del mod">
+          <ac:chgData name="Zied Belhocine" userId="200cc0e2b299676e" providerId="LiveId" clId="{36CCCAD6-9B8B-4ECC-B7BF-7E36B9ADD69A}" dt="2026-02-05T10:35:29.583" v="2583" actId="478"/>
           <ac:spMkLst>
             <pc:docMk/>
             <pc:sldMk cId="0" sldId="267"/>
@@ -936,9 +1440,25 @@
             <ac:spMk id="204" creationId="{00000000-0000-0000-0000-000000000000}"/>
           </ac:spMkLst>
         </pc:spChg>
+        <pc:picChg chg="add del mod">
+          <ac:chgData name="Zied Belhocine" userId="200cc0e2b299676e" providerId="LiveId" clId="{36CCCAD6-9B8B-4ECC-B7BF-7E36B9ADD69A}" dt="2026-02-05T10:35:24.711" v="2581" actId="478"/>
+          <ac:picMkLst>
+            <pc:docMk/>
+            <pc:sldMk cId="0" sldId="267"/>
+            <ac:picMk id="3" creationId="{AC3E736C-91B0-A1B9-78F2-90C36A8441C0}"/>
+          </ac:picMkLst>
+        </pc:picChg>
+        <pc:picChg chg="add mod">
+          <ac:chgData name="Zied Belhocine" userId="200cc0e2b299676e" providerId="LiveId" clId="{36CCCAD6-9B8B-4ECC-B7BF-7E36B9ADD69A}" dt="2026-02-05T10:35:27.187" v="2582" actId="1076"/>
+          <ac:picMkLst>
+            <pc:docMk/>
+            <pc:sldMk cId="0" sldId="267"/>
+            <ac:picMk id="4" creationId="{E4BD25E6-8A9C-B497-D9D8-FBB6322235FF}"/>
+          </ac:picMkLst>
+        </pc:picChg>
       </pc:sldChg>
-      <pc:sldChg chg="modSp mod">
-        <pc:chgData name="Zied Belhocine" userId="200cc0e2b299676e" providerId="LiveId" clId="{36CCCAD6-9B8B-4ECC-B7BF-7E36B9ADD69A}" dt="2026-01-28T14:31:29.988" v="1106" actId="2711"/>
+      <pc:sldChg chg="addSp delSp modSp mod">
+        <pc:chgData name="Zied Belhocine" userId="200cc0e2b299676e" providerId="LiveId" clId="{36CCCAD6-9B8B-4ECC-B7BF-7E36B9ADD69A}" dt="2026-02-05T10:35:03.426" v="2579" actId="1076"/>
         <pc:sldMkLst>
           <pc:docMk/>
           <pc:sldMk cId="0" sldId="268"/>
@@ -967,15 +1487,55 @@
             <ac:spMk id="211" creationId="{00000000-0000-0000-0000-000000000000}"/>
           </ac:spMkLst>
         </pc:spChg>
+        <pc:picChg chg="add del mod">
+          <ac:chgData name="Zied Belhocine" userId="200cc0e2b299676e" providerId="LiveId" clId="{36CCCAD6-9B8B-4ECC-B7BF-7E36B9ADD69A}" dt="2026-02-05T10:35:01.953" v="2578" actId="478"/>
+          <ac:picMkLst>
+            <pc:docMk/>
+            <pc:sldMk cId="0" sldId="268"/>
+            <ac:picMk id="3" creationId="{840195CE-C596-80CD-EF12-E37CDF7650DC}"/>
+          </ac:picMkLst>
+        </pc:picChg>
+        <pc:picChg chg="add mod">
+          <ac:chgData name="Zied Belhocine" userId="200cc0e2b299676e" providerId="LiveId" clId="{36CCCAD6-9B8B-4ECC-B7BF-7E36B9ADD69A}" dt="2026-02-05T10:35:03.426" v="2579" actId="1076"/>
+          <ac:picMkLst>
+            <pc:docMk/>
+            <pc:sldMk cId="0" sldId="268"/>
+            <ac:picMk id="4" creationId="{BCDD7AA4-44F0-295D-5EEA-DA216A7876FA}"/>
+          </ac:picMkLst>
+        </pc:picChg>
       </pc:sldChg>
-      <pc:sldChg chg="modSp mod">
-        <pc:chgData name="Zied Belhocine" userId="200cc0e2b299676e" providerId="LiveId" clId="{36CCCAD6-9B8B-4ECC-B7BF-7E36B9ADD69A}" dt="2026-01-28T14:31:37.731" v="1109" actId="2711"/>
+      <pc:sldChg chg="addSp modSp mod">
+        <pc:chgData name="Zied Belhocine" userId="200cc0e2b299676e" providerId="LiveId" clId="{36CCCAD6-9B8B-4ECC-B7BF-7E36B9ADD69A}" dt="2026-02-03T10:46:34.163" v="2425" actId="20577"/>
         <pc:sldMkLst>
           <pc:docMk/>
           <pc:sldMk cId="0" sldId="269"/>
         </pc:sldMkLst>
+        <pc:spChg chg="add mod">
+          <ac:chgData name="Zied Belhocine" userId="200cc0e2b299676e" providerId="LiveId" clId="{36CCCAD6-9B8B-4ECC-B7BF-7E36B9ADD69A}" dt="2026-02-03T10:45:57.205" v="2418" actId="404"/>
+          <ac:spMkLst>
+            <pc:docMk/>
+            <pc:sldMk cId="0" sldId="269"/>
+            <ac:spMk id="4" creationId="{A88531B9-B831-DC2D-C0E1-E9CB4313E0DC}"/>
+          </ac:spMkLst>
+        </pc:spChg>
+        <pc:spChg chg="add mod">
+          <ac:chgData name="Zied Belhocine" userId="200cc0e2b299676e" providerId="LiveId" clId="{36CCCAD6-9B8B-4ECC-B7BF-7E36B9ADD69A}" dt="2026-02-03T10:46:13.891" v="2420" actId="1076"/>
+          <ac:spMkLst>
+            <pc:docMk/>
+            <pc:sldMk cId="0" sldId="269"/>
+            <ac:spMk id="7" creationId="{EFA7C28F-73BB-1C83-A5CE-C957145CC904}"/>
+          </ac:spMkLst>
+        </pc:spChg>
+        <pc:spChg chg="add mod">
+          <ac:chgData name="Zied Belhocine" userId="200cc0e2b299676e" providerId="LiveId" clId="{36CCCAD6-9B8B-4ECC-B7BF-7E36B9ADD69A}" dt="2026-02-03T10:46:34.163" v="2425" actId="20577"/>
+          <ac:spMkLst>
+            <pc:docMk/>
+            <pc:sldMk cId="0" sldId="269"/>
+            <ac:spMk id="10" creationId="{49E975FD-507F-C91E-750D-B7DCD6A11A4C}"/>
+          </ac:spMkLst>
+        </pc:spChg>
         <pc:spChg chg="mod">
-          <ac:chgData name="Zied Belhocine" userId="200cc0e2b299676e" providerId="LiveId" clId="{36CCCAD6-9B8B-4ECC-B7BF-7E36B9ADD69A}" dt="2026-01-28T14:31:37.731" v="1109" actId="2711"/>
+          <ac:chgData name="Zied Belhocine" userId="200cc0e2b299676e" providerId="LiveId" clId="{36CCCAD6-9B8B-4ECC-B7BF-7E36B9ADD69A}" dt="2026-02-03T10:32:53.209" v="2022" actId="108"/>
           <ac:spMkLst>
             <pc:docMk/>
             <pc:sldMk cId="0" sldId="269"/>
@@ -983,7 +1543,7 @@
           </ac:spMkLst>
         </pc:spChg>
         <pc:spChg chg="mod">
-          <ac:chgData name="Zied Belhocine" userId="200cc0e2b299676e" providerId="LiveId" clId="{36CCCAD6-9B8B-4ECC-B7BF-7E36B9ADD69A}" dt="2026-01-28T14:31:37.731" v="1109" actId="2711"/>
+          <ac:chgData name="Zied Belhocine" userId="200cc0e2b299676e" providerId="LiveId" clId="{36CCCAD6-9B8B-4ECC-B7BF-7E36B9ADD69A}" dt="2026-02-03T10:32:05.042" v="2019" actId="1076"/>
           <ac:spMkLst>
             <pc:docMk/>
             <pc:sldMk cId="0" sldId="269"/>
@@ -991,13 +1551,37 @@
           </ac:spMkLst>
         </pc:spChg>
         <pc:spChg chg="mod">
-          <ac:chgData name="Zied Belhocine" userId="200cc0e2b299676e" providerId="LiveId" clId="{36CCCAD6-9B8B-4ECC-B7BF-7E36B9ADD69A}" dt="2026-01-28T14:31:37.731" v="1109" actId="2711"/>
+          <ac:chgData name="Zied Belhocine" userId="200cc0e2b299676e" providerId="LiveId" clId="{36CCCAD6-9B8B-4ECC-B7BF-7E36B9ADD69A}" dt="2026-02-03T10:41:03.633" v="2258" actId="1076"/>
           <ac:spMkLst>
             <pc:docMk/>
             <pc:sldMk cId="0" sldId="269"/>
             <ac:spMk id="218" creationId="{00000000-0000-0000-0000-000000000000}"/>
           </ac:spMkLst>
         </pc:spChg>
+        <pc:picChg chg="add mod">
+          <ac:chgData name="Zied Belhocine" userId="200cc0e2b299676e" providerId="LiveId" clId="{36CCCAD6-9B8B-4ECC-B7BF-7E36B9ADD69A}" dt="2026-02-03T10:31:57.320" v="2017" actId="1076"/>
+          <ac:picMkLst>
+            <pc:docMk/>
+            <pc:sldMk cId="0" sldId="269"/>
+            <ac:picMk id="2" creationId="{4698441E-9425-EE13-89F4-DDCBABB1B25A}"/>
+          </ac:picMkLst>
+        </pc:picChg>
+        <pc:picChg chg="add mod">
+          <ac:chgData name="Zied Belhocine" userId="200cc0e2b299676e" providerId="LiveId" clId="{36CCCAD6-9B8B-4ECC-B7BF-7E36B9ADD69A}" dt="2026-02-03T10:37:30.663" v="2088" actId="14100"/>
+          <ac:picMkLst>
+            <pc:docMk/>
+            <pc:sldMk cId="0" sldId="269"/>
+            <ac:picMk id="6" creationId="{211723DC-2D6C-D54B-286C-AD73A72C4275}"/>
+          </ac:picMkLst>
+        </pc:picChg>
+        <pc:picChg chg="add mod">
+          <ac:chgData name="Zied Belhocine" userId="200cc0e2b299676e" providerId="LiveId" clId="{36CCCAD6-9B8B-4ECC-B7BF-7E36B9ADD69A}" dt="2026-02-03T10:40:11.535" v="2137" actId="14100"/>
+          <ac:picMkLst>
+            <pc:docMk/>
+            <pc:sldMk cId="0" sldId="269"/>
+            <ac:picMk id="9" creationId="{46EEB327-04F4-6F07-F03A-1E9C92048FBD}"/>
+          </ac:picMkLst>
+        </pc:picChg>
       </pc:sldChg>
       <pc:sldChg chg="modSp mod">
         <pc:chgData name="Zied Belhocine" userId="200cc0e2b299676e" providerId="LiveId" clId="{36CCCAD6-9B8B-4ECC-B7BF-7E36B9ADD69A}" dt="2026-01-28T14:31:43.852" v="1110" actId="2711"/>
@@ -22635,61 +23219,6 @@
       </p:sp>
       <p:sp>
         <p:nvSpPr>
-          <p:cNvPr id="189" name="Google Shape;189;p10"/>
-          <p:cNvSpPr txBox="1">
-            <a:spLocks noGrp="1"/>
-          </p:cNvSpPr>
-          <p:nvPr>
-            <p:ph type="body" idx="1"/>
-          </p:nvPr>
-        </p:nvSpPr>
-        <p:spPr>
-          <a:xfrm>
-            <a:off x="818712" y="2222287"/>
-            <a:ext cx="10554574" cy="3636511"/>
-          </a:xfrm>
-          <a:prstGeom prst="rect">
-            <a:avLst/>
-          </a:prstGeom>
-          <a:noFill/>
-          <a:ln>
-            <a:noFill/>
-          </a:ln>
-          <a:effectLst>
-            <a:outerShdw blurRad="50800">
-              <a:srgbClr val="000000">
-                <a:alpha val="40000"/>
-              </a:srgbClr>
-            </a:outerShdw>
-          </a:effectLst>
-        </p:spPr>
-        <p:txBody>
-          <a:bodyPr spcFirstLastPara="1" wrap="square" lIns="91425" tIns="45700" rIns="91425" bIns="45700" anchor="ctr" anchorCtr="0">
-            <a:normAutofit/>
-          </a:bodyPr>
-          <a:lstStyle/>
-          <a:p>
-            <a:pPr marL="0" lvl="0" indent="0" algn="l" rtl="0">
-              <a:lnSpc>
-                <a:spcPct val="100000"/>
-              </a:lnSpc>
-              <a:spcBef>
-                <a:spcPts val="0"/>
-              </a:spcBef>
-              <a:spcAft>
-                <a:spcPts val="0"/>
-              </a:spcAft>
-              <a:buSzPts val="1800"/>
-              <a:buNone/>
-            </a:pPr>
-            <a:endParaRPr dirty="0">
-              <a:latin typeface="Century Gothic" panose="020B0502020202020204" pitchFamily="34" charset="0"/>
-            </a:endParaRPr>
-          </a:p>
-        </p:txBody>
-      </p:sp>
-      <p:sp>
-        <p:nvSpPr>
           <p:cNvPr id="190" name="Google Shape;190;p10"/>
           <p:cNvSpPr/>
           <p:nvPr/>
@@ -22944,6 +23473,36 @@
           </a:p>
         </p:txBody>
       </p:sp>
+      <p:pic>
+        <p:nvPicPr>
+          <p:cNvPr id="4" name="Image 3">
+            <a:extLst>
+              <a:ext uri="{FF2B5EF4-FFF2-40B4-BE49-F238E27FC236}">
+                <a16:creationId xmlns:a16="http://schemas.microsoft.com/office/drawing/2014/main" id="{207DCDAB-31D7-C2A5-DA44-B2B7F919E54C}"/>
+              </a:ext>
+            </a:extLst>
+          </p:cNvPr>
+          <p:cNvPicPr>
+            <a:picLocks noChangeAspect="1"/>
+          </p:cNvPicPr>
+          <p:nvPr/>
+        </p:nvPicPr>
+        <p:blipFill>
+          <a:blip r:embed="rId3"/>
+          <a:stretch>
+            <a:fillRect/>
+          </a:stretch>
+        </p:blipFill>
+        <p:spPr>
+          <a:xfrm>
+            <a:off x="3105150" y="1903241"/>
+            <a:ext cx="4572000" cy="4411834"/>
+          </a:xfrm>
+          <a:prstGeom prst="rect">
+            <a:avLst/>
+          </a:prstGeom>
+        </p:spPr>
+      </p:pic>
     </p:spTree>
   </p:cSld>
   <p:clrMapOvr>
@@ -23036,61 +23595,6 @@
       </p:sp>
       <p:sp>
         <p:nvSpPr>
-          <p:cNvPr id="196" name="Google Shape;196;g2233f607d43_0_0"/>
-          <p:cNvSpPr txBox="1">
-            <a:spLocks noGrp="1"/>
-          </p:cNvSpPr>
-          <p:nvPr>
-            <p:ph type="body" idx="1"/>
-          </p:nvPr>
-        </p:nvSpPr>
-        <p:spPr>
-          <a:xfrm>
-            <a:off x="818712" y="2222287"/>
-            <a:ext cx="10554600" cy="3636600"/>
-          </a:xfrm>
-          <a:prstGeom prst="rect">
-            <a:avLst/>
-          </a:prstGeom>
-          <a:noFill/>
-          <a:ln>
-            <a:noFill/>
-          </a:ln>
-          <a:effectLst>
-            <a:outerShdw blurRad="50800">
-              <a:srgbClr val="000000">
-                <a:alpha val="40000"/>
-              </a:srgbClr>
-            </a:outerShdw>
-          </a:effectLst>
-        </p:spPr>
-        <p:txBody>
-          <a:bodyPr spcFirstLastPara="1" wrap="square" lIns="91425" tIns="45700" rIns="91425" bIns="45700" anchor="ctr" anchorCtr="0">
-            <a:normAutofit/>
-          </a:bodyPr>
-          <a:lstStyle/>
-          <a:p>
-            <a:pPr marL="0" lvl="0" indent="0" algn="l" rtl="0">
-              <a:lnSpc>
-                <a:spcPct val="100000"/>
-              </a:lnSpc>
-              <a:spcBef>
-                <a:spcPts val="0"/>
-              </a:spcBef>
-              <a:spcAft>
-                <a:spcPts val="0"/>
-              </a:spcAft>
-              <a:buSzPts val="1800"/>
-              <a:buNone/>
-            </a:pPr>
-            <a:endParaRPr dirty="0">
-              <a:latin typeface="Century Gothic" panose="020B0502020202020204" pitchFamily="34" charset="0"/>
-            </a:endParaRPr>
-          </a:p>
-        </p:txBody>
-      </p:sp>
-      <p:sp>
-        <p:nvSpPr>
           <p:cNvPr id="197" name="Google Shape;197;g2233f607d43_0_0"/>
           <p:cNvSpPr/>
           <p:nvPr/>
@@ -23331,6 +23835,36 @@
           </a:p>
         </p:txBody>
       </p:sp>
+      <p:pic>
+        <p:nvPicPr>
+          <p:cNvPr id="6" name="Image 5">
+            <a:extLst>
+              <a:ext uri="{FF2B5EF4-FFF2-40B4-BE49-F238E27FC236}">
+                <a16:creationId xmlns:a16="http://schemas.microsoft.com/office/drawing/2014/main" id="{ACAA7E2C-A938-C52D-9A74-A8814BAB7C35}"/>
+              </a:ext>
+            </a:extLst>
+          </p:cNvPr>
+          <p:cNvPicPr>
+            <a:picLocks noChangeAspect="1"/>
+          </p:cNvPicPr>
+          <p:nvPr/>
+        </p:nvPicPr>
+        <p:blipFill>
+          <a:blip r:embed="rId3"/>
+          <a:stretch>
+            <a:fillRect/>
+          </a:stretch>
+        </p:blipFill>
+        <p:spPr>
+          <a:xfrm>
+            <a:off x="2400300" y="1924537"/>
+            <a:ext cx="7562850" cy="4486275"/>
+          </a:xfrm>
+          <a:prstGeom prst="rect">
+            <a:avLst/>
+          </a:prstGeom>
+        </p:spPr>
+      </p:pic>
     </p:spTree>
   </p:cSld>
   <p:clrMapOvr>
@@ -23423,61 +23957,6 @@
       </p:sp>
       <p:sp>
         <p:nvSpPr>
-          <p:cNvPr id="203" name="Google Shape;203;p11"/>
-          <p:cNvSpPr txBox="1">
-            <a:spLocks noGrp="1"/>
-          </p:cNvSpPr>
-          <p:nvPr>
-            <p:ph type="body" idx="1"/>
-          </p:nvPr>
-        </p:nvSpPr>
-        <p:spPr>
-          <a:xfrm>
-            <a:off x="818712" y="2222287"/>
-            <a:ext cx="10554574" cy="3636511"/>
-          </a:xfrm>
-          <a:prstGeom prst="rect">
-            <a:avLst/>
-          </a:prstGeom>
-          <a:noFill/>
-          <a:ln>
-            <a:noFill/>
-          </a:ln>
-          <a:effectLst>
-            <a:outerShdw blurRad="50800">
-              <a:srgbClr val="000000">
-                <a:alpha val="40000"/>
-              </a:srgbClr>
-            </a:outerShdw>
-          </a:effectLst>
-        </p:spPr>
-        <p:txBody>
-          <a:bodyPr spcFirstLastPara="1" wrap="square" lIns="91425" tIns="45700" rIns="91425" bIns="45700" anchor="ctr" anchorCtr="0">
-            <a:normAutofit/>
-          </a:bodyPr>
-          <a:lstStyle/>
-          <a:p>
-            <a:pPr marL="0" lvl="0" indent="0" algn="l" rtl="0">
-              <a:lnSpc>
-                <a:spcPct val="100000"/>
-              </a:lnSpc>
-              <a:spcBef>
-                <a:spcPts val="0"/>
-              </a:spcBef>
-              <a:spcAft>
-                <a:spcPts val="0"/>
-              </a:spcAft>
-              <a:buSzPts val="1800"/>
-              <a:buNone/>
-            </a:pPr>
-            <a:endParaRPr>
-              <a:latin typeface="Century Gothic" panose="020B0502020202020204" pitchFamily="34" charset="0"/>
-            </a:endParaRPr>
-          </a:p>
-        </p:txBody>
-      </p:sp>
-      <p:sp>
-        <p:nvSpPr>
           <p:cNvPr id="204" name="Google Shape;204;p11"/>
           <p:cNvSpPr/>
           <p:nvPr/>
@@ -23756,6 +24235,36 @@
           </a:p>
         </p:txBody>
       </p:sp>
+      <p:pic>
+        <p:nvPicPr>
+          <p:cNvPr id="4" name="Image 3">
+            <a:extLst>
+              <a:ext uri="{FF2B5EF4-FFF2-40B4-BE49-F238E27FC236}">
+                <a16:creationId xmlns:a16="http://schemas.microsoft.com/office/drawing/2014/main" id="{E4BD25E6-8A9C-B497-D9D8-FBB6322235FF}"/>
+              </a:ext>
+            </a:extLst>
+          </p:cNvPr>
+          <p:cNvPicPr>
+            <a:picLocks noChangeAspect="1"/>
+          </p:cNvPicPr>
+          <p:nvPr/>
+        </p:nvPicPr>
+        <p:blipFill>
+          <a:blip r:embed="rId3"/>
+          <a:stretch>
+            <a:fillRect/>
+          </a:stretch>
+        </p:blipFill>
+        <p:spPr>
+          <a:xfrm>
+            <a:off x="2738437" y="1417638"/>
+            <a:ext cx="5591175" cy="5219700"/>
+          </a:xfrm>
+          <a:prstGeom prst="rect">
+            <a:avLst/>
+          </a:prstGeom>
+        </p:spPr>
+      </p:pic>
     </p:spTree>
   </p:cSld>
   <p:clrMapOvr>
@@ -23895,7 +24404,7 @@
               <a:buSzPts val="1800"/>
               <a:buNone/>
             </a:pPr>
-            <a:endParaRPr>
+            <a:endParaRPr dirty="0">
               <a:latin typeface="Century Gothic" panose="020B0502020202020204" pitchFamily="34" charset="0"/>
             </a:endParaRPr>
           </a:p>
@@ -24181,6 +24690,36 @@
           </a:p>
         </p:txBody>
       </p:sp>
+      <p:pic>
+        <p:nvPicPr>
+          <p:cNvPr id="4" name="Image 3">
+            <a:extLst>
+              <a:ext uri="{FF2B5EF4-FFF2-40B4-BE49-F238E27FC236}">
+                <a16:creationId xmlns:a16="http://schemas.microsoft.com/office/drawing/2014/main" id="{BCDD7AA4-44F0-295D-5EEA-DA216A7876FA}"/>
+              </a:ext>
+            </a:extLst>
+          </p:cNvPr>
+          <p:cNvPicPr>
+            <a:picLocks noChangeAspect="1"/>
+          </p:cNvPicPr>
+          <p:nvPr/>
+        </p:nvPicPr>
+        <p:blipFill>
+          <a:blip r:embed="rId3"/>
+          <a:stretch>
+            <a:fillRect/>
+          </a:stretch>
+        </p:blipFill>
+        <p:spPr>
+          <a:xfrm>
+            <a:off x="3198709" y="1754296"/>
+            <a:ext cx="4637192" cy="4754775"/>
+          </a:xfrm>
+          <a:prstGeom prst="rect">
+            <a:avLst/>
+          </a:prstGeom>
+        </p:spPr>
+      </p:pic>
     </p:spTree>
   </p:cSld>
   <p:clrMapOvr>
@@ -24260,12 +24799,12 @@
               <a:buNone/>
             </a:pPr>
             <a:r>
-              <a:rPr lang="fr-FR" sz="3200">
+              <a:rPr lang="fr-FR" sz="3200" dirty="0">
                 <a:latin typeface="Century Gothic" panose="020B0502020202020204" pitchFamily="34" charset="0"/>
               </a:rPr>
               <a:t>10) Étude sur le manioc en Thaïlande</a:t>
             </a:r>
-            <a:endParaRPr>
+            <a:endParaRPr dirty="0">
               <a:latin typeface="Century Gothic" panose="020B0502020202020204" pitchFamily="34" charset="0"/>
             </a:endParaRPr>
           </a:p>
@@ -24283,8 +24822,8 @@
         </p:nvSpPr>
         <p:spPr>
           <a:xfrm>
-            <a:off x="818712" y="2222287"/>
-            <a:ext cx="10554574" cy="3636511"/>
+            <a:off x="827426" y="5641001"/>
+            <a:ext cx="10554574" cy="1149638"/>
           </a:xfrm>
           <a:prstGeom prst="rect">
             <a:avLst/>
@@ -24320,6 +24859,10 @@
               <a:buSzPts val="1800"/>
               <a:buNone/>
             </a:pPr>
+            <a:r>
+              <a:rPr lang="fr-FR" dirty="0"/>
+              <a:t>La sous-nutrition n'est pas toujours due à un manque de production nationale, mais souvent à une logique économique (exporter des produits pour gagner des devises plutôt que de nourrir la population locale).</a:t>
+            </a:r>
             <a:endParaRPr dirty="0">
               <a:latin typeface="Century Gothic" panose="020B0502020202020204" pitchFamily="34" charset="0"/>
             </a:endParaRPr>
@@ -24334,7 +24877,7 @@
         </p:nvSpPr>
         <p:spPr>
           <a:xfrm>
-            <a:off x="7941262" y="1898637"/>
+            <a:off x="1075719" y="8267044"/>
             <a:ext cx="3432024" cy="3742364"/>
           </a:xfrm>
           <a:prstGeom prst="rect">
@@ -24575,6 +25118,257 @@
               <a:latin typeface="Century Gothic" panose="020B0502020202020204" pitchFamily="34" charset="0"/>
               <a:sym typeface="Arial"/>
             </a:endParaRPr>
+          </a:p>
+        </p:txBody>
+      </p:sp>
+      <p:pic>
+        <p:nvPicPr>
+          <p:cNvPr id="2" name="Image 1">
+            <a:extLst>
+              <a:ext uri="{FF2B5EF4-FFF2-40B4-BE49-F238E27FC236}">
+                <a16:creationId xmlns:a16="http://schemas.microsoft.com/office/drawing/2014/main" id="{4698441E-9425-EE13-89F4-DDCBABB1B25A}"/>
+              </a:ext>
+            </a:extLst>
+          </p:cNvPr>
+          <p:cNvPicPr>
+            <a:picLocks noChangeAspect="1"/>
+          </p:cNvPicPr>
+          <p:nvPr/>
+        </p:nvPicPr>
+        <p:blipFill>
+          <a:blip r:embed="rId3"/>
+          <a:stretch>
+            <a:fillRect/>
+          </a:stretch>
+        </p:blipFill>
+        <p:spPr>
+          <a:xfrm>
+            <a:off x="600814" y="2048768"/>
+            <a:ext cx="2419596" cy="1581894"/>
+          </a:xfrm>
+          <a:prstGeom prst="rect">
+            <a:avLst/>
+          </a:prstGeom>
+        </p:spPr>
+      </p:pic>
+      <p:sp>
+        <p:nvSpPr>
+          <p:cNvPr id="4" name="ZoneTexte 3">
+            <a:extLst>
+              <a:ext uri="{FF2B5EF4-FFF2-40B4-BE49-F238E27FC236}">
+                <a16:creationId xmlns:a16="http://schemas.microsoft.com/office/drawing/2014/main" id="{A88531B9-B831-DC2D-C0E1-E9CB4313E0DC}"/>
+              </a:ext>
+            </a:extLst>
+          </p:cNvPr>
+          <p:cNvSpPr txBox="1"/>
+          <p:nvPr/>
+        </p:nvSpPr>
+        <p:spPr>
+          <a:xfrm>
+            <a:off x="600814" y="3757968"/>
+            <a:ext cx="2419596" cy="1477328"/>
+          </a:xfrm>
+          <a:prstGeom prst="rect">
+            <a:avLst/>
+          </a:prstGeom>
+          <a:noFill/>
+        </p:spPr>
+        <p:txBody>
+          <a:bodyPr wrap="square">
+            <a:spAutoFit/>
+          </a:bodyPr>
+          <a:lstStyle/>
+          <a:p>
+            <a:pPr>
+              <a:buClr>
+                <a:srgbClr val="FEFEFE"/>
+              </a:buClr>
+              <a:buSzPts val="3200"/>
+            </a:pPr>
+            <a:r>
+              <a:rPr lang="fr-FR" sz="1800" b="1" dirty="0">
+                <a:solidFill>
+                  <a:srgbClr val="FEFEFE"/>
+                </a:solidFill>
+                <a:latin typeface="Century Gothic" panose="020B0502020202020204" pitchFamily="34" charset="0"/>
+                <a:sym typeface="Century Gothic"/>
+              </a:rPr>
+              <a:t>La Thaïlande a environ 70 millions d’habitants et ~9% de la population est en sous nutrition.</a:t>
+            </a:r>
+          </a:p>
+        </p:txBody>
+      </p:sp>
+      <p:pic>
+        <p:nvPicPr>
+          <p:cNvPr id="6" name="Image 5">
+            <a:extLst>
+              <a:ext uri="{FF2B5EF4-FFF2-40B4-BE49-F238E27FC236}">
+                <a16:creationId xmlns:a16="http://schemas.microsoft.com/office/drawing/2014/main" id="{211723DC-2D6C-D54B-286C-AD73A72C4275}"/>
+              </a:ext>
+            </a:extLst>
+          </p:cNvPr>
+          <p:cNvPicPr>
+            <a:picLocks noChangeAspect="1"/>
+          </p:cNvPicPr>
+          <p:nvPr/>
+        </p:nvPicPr>
+        <p:blipFill>
+          <a:blip r:embed="rId4"/>
+          <a:stretch>
+            <a:fillRect/>
+          </a:stretch>
+        </p:blipFill>
+        <p:spPr>
+          <a:xfrm>
+            <a:off x="4329329" y="2048769"/>
+            <a:ext cx="2885287" cy="1581894"/>
+          </a:xfrm>
+          <a:prstGeom prst="rect">
+            <a:avLst/>
+          </a:prstGeom>
+        </p:spPr>
+      </p:pic>
+      <p:sp>
+        <p:nvSpPr>
+          <p:cNvPr id="7" name="ZoneTexte 6">
+            <a:extLst>
+              <a:ext uri="{FF2B5EF4-FFF2-40B4-BE49-F238E27FC236}">
+                <a16:creationId xmlns:a16="http://schemas.microsoft.com/office/drawing/2014/main" id="{EFA7C28F-73BB-1C83-A5CE-C957145CC904}"/>
+              </a:ext>
+            </a:extLst>
+          </p:cNvPr>
+          <p:cNvSpPr txBox="1"/>
+          <p:nvPr/>
+        </p:nvSpPr>
+        <p:spPr>
+          <a:xfrm>
+            <a:off x="4329328" y="3768701"/>
+            <a:ext cx="2885287" cy="1200329"/>
+          </a:xfrm>
+          <a:prstGeom prst="rect">
+            <a:avLst/>
+          </a:prstGeom>
+          <a:noFill/>
+        </p:spPr>
+        <p:txBody>
+          <a:bodyPr wrap="square">
+            <a:spAutoFit/>
+          </a:bodyPr>
+          <a:lstStyle/>
+          <a:p>
+            <a:pPr>
+              <a:buClr>
+                <a:srgbClr val="FEFEFE"/>
+              </a:buClr>
+              <a:buSzPts val="3200"/>
+            </a:pPr>
+            <a:r>
+              <a:rPr lang="fr-FR" sz="1800" b="1" dirty="0">
+                <a:solidFill>
+                  <a:srgbClr val="FEFEFE"/>
+                </a:solidFill>
+                <a:latin typeface="Century Gothic" panose="020B0502020202020204" pitchFamily="34" charset="0"/>
+                <a:sym typeface="Century Gothic"/>
+              </a:rPr>
+              <a:t>Sur les 30 milliards de </a:t>
+            </a:r>
+            <a:r>
+              <a:rPr lang="fr-FR" sz="1800" b="1" dirty="0" err="1">
+                <a:solidFill>
+                  <a:srgbClr val="FEFEFE"/>
+                </a:solidFill>
+                <a:latin typeface="Century Gothic" panose="020B0502020202020204" pitchFamily="34" charset="0"/>
+                <a:sym typeface="Century Gothic"/>
+              </a:rPr>
+              <a:t>kgs</a:t>
+            </a:r>
+            <a:r>
+              <a:rPr lang="fr-FR" sz="1800" b="1" dirty="0">
+                <a:solidFill>
+                  <a:srgbClr val="FEFEFE"/>
+                </a:solidFill>
+                <a:latin typeface="Century Gothic" panose="020B0502020202020204" pitchFamily="34" charset="0"/>
+                <a:sym typeface="Century Gothic"/>
+              </a:rPr>
+              <a:t> manioc produits par an, plus de 80% sont exportés.</a:t>
+            </a:r>
+          </a:p>
+        </p:txBody>
+      </p:sp>
+      <p:pic>
+        <p:nvPicPr>
+          <p:cNvPr id="9" name="Image 8">
+            <a:extLst>
+              <a:ext uri="{FF2B5EF4-FFF2-40B4-BE49-F238E27FC236}">
+                <a16:creationId xmlns:a16="http://schemas.microsoft.com/office/drawing/2014/main" id="{46EEB327-04F4-6F07-F03A-1E9C92048FBD}"/>
+              </a:ext>
+            </a:extLst>
+          </p:cNvPr>
+          <p:cNvPicPr>
+            <a:picLocks noChangeAspect="1"/>
+          </p:cNvPicPr>
+          <p:nvPr/>
+        </p:nvPicPr>
+        <p:blipFill>
+          <a:blip r:embed="rId5"/>
+          <a:stretch>
+            <a:fillRect/>
+          </a:stretch>
+        </p:blipFill>
+        <p:spPr>
+          <a:xfrm>
+            <a:off x="8523535" y="2048768"/>
+            <a:ext cx="3067651" cy="1581894"/>
+          </a:xfrm>
+          <a:prstGeom prst="rect">
+            <a:avLst/>
+          </a:prstGeom>
+        </p:spPr>
+      </p:pic>
+      <p:sp>
+        <p:nvSpPr>
+          <p:cNvPr id="10" name="ZoneTexte 9">
+            <a:extLst>
+              <a:ext uri="{FF2B5EF4-FFF2-40B4-BE49-F238E27FC236}">
+                <a16:creationId xmlns:a16="http://schemas.microsoft.com/office/drawing/2014/main" id="{49E975FD-507F-C91E-750D-B7DCD6A11A4C}"/>
+              </a:ext>
+            </a:extLst>
+          </p:cNvPr>
+          <p:cNvSpPr txBox="1"/>
+          <p:nvPr/>
+        </p:nvSpPr>
+        <p:spPr>
+          <a:xfrm>
+            <a:off x="8523535" y="3753912"/>
+            <a:ext cx="3067651" cy="1477328"/>
+          </a:xfrm>
+          <a:prstGeom prst="rect">
+            <a:avLst/>
+          </a:prstGeom>
+          <a:noFill/>
+        </p:spPr>
+        <p:txBody>
+          <a:bodyPr wrap="square">
+            <a:spAutoFit/>
+          </a:bodyPr>
+          <a:lstStyle/>
+          <a:p>
+            <a:pPr>
+              <a:buClr>
+                <a:srgbClr val="FEFEFE"/>
+              </a:buClr>
+              <a:buSzPts val="3200"/>
+            </a:pPr>
+            <a:r>
+              <a:rPr lang="fr-FR" sz="1800" b="1" dirty="0">
+                <a:solidFill>
+                  <a:srgbClr val="FEFEFE"/>
+                </a:solidFill>
+                <a:latin typeface="Century Gothic" panose="020B0502020202020204" pitchFamily="34" charset="0"/>
+                <a:sym typeface="Century Gothic"/>
+              </a:rPr>
+              <a:t>Cela laisse 13kg par personne / an soit 40kcal par jour (pour rappel une personne a besoin de 2500 kcal / jour).</a:t>
+            </a:r>
           </a:p>
         </p:txBody>
       </p:sp>
@@ -25413,6 +26207,185 @@
           </a:p>
         </p:txBody>
       </p:sp>
+      <p:sp>
+        <p:nvSpPr>
+          <p:cNvPr id="2" name="Google Shape;132;p2">
+            <a:extLst>
+              <a:ext uri="{FF2B5EF4-FFF2-40B4-BE49-F238E27FC236}">
+                <a16:creationId xmlns:a16="http://schemas.microsoft.com/office/drawing/2014/main" id="{502E3F99-3B74-F244-9CD3-C337EAE5FFF7}"/>
+              </a:ext>
+            </a:extLst>
+          </p:cNvPr>
+          <p:cNvSpPr/>
+          <p:nvPr/>
+        </p:nvSpPr>
+        <p:spPr>
+          <a:xfrm>
+            <a:off x="8727371" y="0"/>
+            <a:ext cx="3432024" cy="2582431"/>
+          </a:xfrm>
+          <a:prstGeom prst="rect">
+            <a:avLst/>
+          </a:prstGeom>
+          <a:solidFill>
+            <a:srgbClr val="FFFF00"/>
+          </a:solidFill>
+          <a:ln w="15875" cap="rnd" cmpd="sng">
+            <a:solidFill>
+              <a:srgbClr val="AE813B"/>
+            </a:solidFill>
+            <a:prstDash val="solid"/>
+            <a:round/>
+            <a:headEnd type="none" w="sm" len="sm"/>
+            <a:tailEnd type="none" w="sm" len="sm"/>
+          </a:ln>
+        </p:spPr>
+        <p:txBody>
+          <a:bodyPr spcFirstLastPara="1" wrap="square" lIns="91425" tIns="45700" rIns="91425" bIns="45700" anchor="ctr" anchorCtr="0">
+            <a:noAutofit/>
+          </a:bodyPr>
+          <a:lstStyle/>
+          <a:p>
+            <a:pPr marL="0" marR="0" lvl="0" indent="0" algn="ctr" rtl="0">
+              <a:lnSpc>
+                <a:spcPct val="100000"/>
+              </a:lnSpc>
+              <a:spcBef>
+                <a:spcPts val="0"/>
+              </a:spcBef>
+              <a:spcAft>
+                <a:spcPts val="0"/>
+              </a:spcAft>
+              <a:buClr>
+                <a:srgbClr val="000000"/>
+              </a:buClr>
+              <a:buSzPts val="1800"/>
+              <a:buFont typeface="Arial"/>
+              <a:buNone/>
+            </a:pPr>
+            <a:r>
+              <a:rPr lang="fr-FR" sz="1800" b="0" i="0" u="none" strike="noStrike" cap="none">
+                <a:solidFill>
+                  <a:srgbClr val="000000"/>
+                </a:solidFill>
+                <a:latin typeface="Century Gothic"/>
+                <a:ea typeface="Century Gothic"/>
+                <a:cs typeface="Century Gothic"/>
+                <a:sym typeface="Century Gothic"/>
+              </a:rPr>
+              <a:t>MEMO : </a:t>
+            </a:r>
+            <a:endParaRPr sz="1400" b="0" i="0" u="none" strike="noStrike" cap="none">
+              <a:solidFill>
+                <a:srgbClr val="000000"/>
+              </a:solidFill>
+              <a:latin typeface="Arial"/>
+              <a:ea typeface="Arial"/>
+              <a:cs typeface="Arial"/>
+              <a:sym typeface="Arial"/>
+            </a:endParaRPr>
+          </a:p>
+          <a:p>
+            <a:pPr marL="0" marR="0" lvl="0" indent="0" algn="ctr" rtl="0">
+              <a:lnSpc>
+                <a:spcPct val="100000"/>
+              </a:lnSpc>
+              <a:spcBef>
+                <a:spcPts val="0"/>
+              </a:spcBef>
+              <a:spcAft>
+                <a:spcPts val="0"/>
+              </a:spcAft>
+              <a:buClr>
+                <a:srgbClr val="000000"/>
+              </a:buClr>
+              <a:buSzPts val="1800"/>
+              <a:buFont typeface="Arial"/>
+              <a:buNone/>
+            </a:pPr>
+            <a:r>
+              <a:rPr lang="fr-FR" sz="1800" b="0" i="0" u="none" strike="noStrike" cap="none">
+                <a:solidFill>
+                  <a:srgbClr val="000000"/>
+                </a:solidFill>
+                <a:latin typeface="Century Gothic"/>
+                <a:ea typeface="Century Gothic"/>
+                <a:cs typeface="Century Gothic"/>
+                <a:sym typeface="Century Gothic"/>
+              </a:rPr>
+              <a:t>Rappel de ce que nous devons faire</a:t>
+            </a:r>
+            <a:endParaRPr sz="1800" b="0" i="0" u="none" strike="noStrike" cap="none">
+              <a:solidFill>
+                <a:srgbClr val="000000"/>
+              </a:solidFill>
+              <a:latin typeface="Century Gothic"/>
+              <a:ea typeface="Century Gothic"/>
+              <a:cs typeface="Century Gothic"/>
+              <a:sym typeface="Century Gothic"/>
+            </a:endParaRPr>
+          </a:p>
+          <a:p>
+            <a:pPr marL="0" marR="0" lvl="0" indent="0" algn="ctr" rtl="0">
+              <a:lnSpc>
+                <a:spcPct val="100000"/>
+              </a:lnSpc>
+              <a:spcBef>
+                <a:spcPts val="0"/>
+              </a:spcBef>
+              <a:spcAft>
+                <a:spcPts val="0"/>
+              </a:spcAft>
+              <a:buClr>
+                <a:srgbClr val="000000"/>
+              </a:buClr>
+              <a:buSzPts val="1800"/>
+              <a:buFont typeface="Arial"/>
+              <a:buNone/>
+            </a:pPr>
+            <a:endParaRPr sz="1800">
+              <a:latin typeface="Century Gothic"/>
+              <a:ea typeface="Century Gothic"/>
+              <a:cs typeface="Century Gothic"/>
+              <a:sym typeface="Century Gothic"/>
+            </a:endParaRPr>
+          </a:p>
+          <a:p>
+            <a:pPr marL="0" marR="0" lvl="0" indent="0" algn="ctr" rtl="0">
+              <a:lnSpc>
+                <a:spcPct val="100000"/>
+              </a:lnSpc>
+              <a:spcBef>
+                <a:spcPts val="0"/>
+              </a:spcBef>
+              <a:spcAft>
+                <a:spcPts val="0"/>
+              </a:spcAft>
+              <a:buClr>
+                <a:srgbClr val="000000"/>
+              </a:buClr>
+              <a:buSzPts val="1800"/>
+              <a:buFont typeface="Arial"/>
+              <a:buNone/>
+            </a:pPr>
+            <a:r>
+              <a:rPr lang="fr-FR" sz="1800">
+                <a:latin typeface="Century Gothic"/>
+                <a:ea typeface="Century Gothic"/>
+                <a:cs typeface="Century Gothic"/>
+                <a:sym typeface="Century Gothic"/>
+              </a:rPr>
+              <a:t>Présentation des types de données à analyser</a:t>
+            </a:r>
+            <a:endParaRPr sz="1800">
+              <a:latin typeface="Century Gothic"/>
+              <a:ea typeface="Century Gothic"/>
+              <a:cs typeface="Century Gothic"/>
+              <a:sym typeface="Century Gothic"/>
+            </a:endParaRPr>
+          </a:p>
+        </p:txBody>
+      </p:sp>
     </p:spTree>
   </p:cSld>
   <p:clrMapOvr>
@@ -25782,6 +26755,410 @@
           </a:p>
         </p:txBody>
       </p:sp>
+      <p:sp>
+        <p:nvSpPr>
+          <p:cNvPr id="3" name="Google Shape;139;p3">
+            <a:extLst>
+              <a:ext uri="{FF2B5EF4-FFF2-40B4-BE49-F238E27FC236}">
+                <a16:creationId xmlns:a16="http://schemas.microsoft.com/office/drawing/2014/main" id="{EECD0240-8179-BCDF-47CF-EC5CF7CB5FB6}"/>
+              </a:ext>
+            </a:extLst>
+          </p:cNvPr>
+          <p:cNvSpPr/>
+          <p:nvPr/>
+        </p:nvSpPr>
+        <p:spPr>
+          <a:xfrm>
+            <a:off x="11325123" y="0"/>
+            <a:ext cx="3691200" cy="3783000"/>
+          </a:xfrm>
+          <a:prstGeom prst="rect">
+            <a:avLst/>
+          </a:prstGeom>
+          <a:solidFill>
+            <a:srgbClr val="FFFF00"/>
+          </a:solidFill>
+          <a:ln w="15875" cap="rnd" cmpd="sng">
+            <a:solidFill>
+              <a:srgbClr val="AE813B"/>
+            </a:solidFill>
+            <a:prstDash val="solid"/>
+            <a:round/>
+            <a:headEnd type="none" w="sm" len="sm"/>
+            <a:tailEnd type="none" w="sm" len="sm"/>
+          </a:ln>
+        </p:spPr>
+        <p:txBody>
+          <a:bodyPr spcFirstLastPara="1" wrap="square" lIns="91425" tIns="45700" rIns="91425" bIns="45700" anchor="ctr" anchorCtr="0">
+            <a:noAutofit/>
+          </a:bodyPr>
+          <a:lstStyle/>
+          <a:p>
+            <a:pPr marL="0" marR="0" lvl="0" indent="0" algn="ctr" rtl="0">
+              <a:lnSpc>
+                <a:spcPct val="100000"/>
+              </a:lnSpc>
+              <a:spcBef>
+                <a:spcPts val="0"/>
+              </a:spcBef>
+              <a:spcAft>
+                <a:spcPts val="0"/>
+              </a:spcAft>
+              <a:buClr>
+                <a:srgbClr val="000000"/>
+              </a:buClr>
+              <a:buSzPts val="1800"/>
+              <a:buFont typeface="Arial"/>
+              <a:buNone/>
+            </a:pPr>
+            <a:r>
+              <a:rPr lang="fr-FR" sz="1800" b="0" i="0" u="none" strike="noStrike" cap="none" dirty="0">
+                <a:solidFill>
+                  <a:srgbClr val="000000"/>
+                </a:solidFill>
+                <a:latin typeface="Century Gothic"/>
+                <a:ea typeface="Century Gothic"/>
+                <a:cs typeface="Century Gothic"/>
+                <a:sym typeface="Century Gothic"/>
+              </a:rPr>
+              <a:t>MEMO : </a:t>
+            </a:r>
+            <a:endParaRPr sz="1400" b="0" i="0" u="none" strike="noStrike" cap="none" dirty="0">
+              <a:solidFill>
+                <a:srgbClr val="000000"/>
+              </a:solidFill>
+              <a:latin typeface="Arial"/>
+              <a:ea typeface="Arial"/>
+              <a:cs typeface="Arial"/>
+              <a:sym typeface="Arial"/>
+            </a:endParaRPr>
+          </a:p>
+          <a:p>
+            <a:pPr marL="0" marR="0" lvl="0" indent="0" algn="ctr" rtl="0">
+              <a:lnSpc>
+                <a:spcPct val="100000"/>
+              </a:lnSpc>
+              <a:spcBef>
+                <a:spcPts val="0"/>
+              </a:spcBef>
+              <a:spcAft>
+                <a:spcPts val="0"/>
+              </a:spcAft>
+              <a:buClr>
+                <a:srgbClr val="000000"/>
+              </a:buClr>
+              <a:buSzPts val="1800"/>
+              <a:buFont typeface="Arial"/>
+              <a:buNone/>
+            </a:pPr>
+            <a:r>
+              <a:rPr lang="fr-FR" sz="1800" b="0" i="0" u="none" strike="noStrike" cap="none" dirty="0">
+                <a:solidFill>
+                  <a:srgbClr val="000000"/>
+                </a:solidFill>
+                <a:latin typeface="Century Gothic"/>
+                <a:ea typeface="Century Gothic"/>
+                <a:cs typeface="Century Gothic"/>
+                <a:sym typeface="Century Gothic"/>
+              </a:rPr>
+              <a:t>Comment j’ai fait mon analyse ? </a:t>
+            </a:r>
+            <a:endParaRPr sz="1400" b="0" i="0" u="none" strike="noStrike" cap="none" dirty="0">
+              <a:solidFill>
+                <a:srgbClr val="000000"/>
+              </a:solidFill>
+              <a:latin typeface="Arial"/>
+              <a:ea typeface="Arial"/>
+              <a:cs typeface="Arial"/>
+              <a:sym typeface="Arial"/>
+            </a:endParaRPr>
+          </a:p>
+          <a:p>
+            <a:pPr marL="0" marR="0" lvl="0" indent="0" algn="ctr" rtl="0">
+              <a:lnSpc>
+                <a:spcPct val="100000"/>
+              </a:lnSpc>
+              <a:spcBef>
+                <a:spcPts val="0"/>
+              </a:spcBef>
+              <a:spcAft>
+                <a:spcPts val="0"/>
+              </a:spcAft>
+              <a:buClr>
+                <a:srgbClr val="000000"/>
+              </a:buClr>
+              <a:buSzPts val="1800"/>
+              <a:buFont typeface="Arial"/>
+              <a:buNone/>
+            </a:pPr>
+            <a:endParaRPr sz="1800" b="0" i="0" u="none" strike="noStrike" cap="none" dirty="0">
+              <a:solidFill>
+                <a:srgbClr val="000000"/>
+              </a:solidFill>
+              <a:latin typeface="Century Gothic"/>
+              <a:ea typeface="Century Gothic"/>
+              <a:cs typeface="Century Gothic"/>
+              <a:sym typeface="Century Gothic"/>
+            </a:endParaRPr>
+          </a:p>
+          <a:p>
+            <a:pPr marL="0" marR="0" lvl="0" indent="0" algn="ctr" rtl="0">
+              <a:lnSpc>
+                <a:spcPct val="100000"/>
+              </a:lnSpc>
+              <a:spcBef>
+                <a:spcPts val="0"/>
+              </a:spcBef>
+              <a:spcAft>
+                <a:spcPts val="0"/>
+              </a:spcAft>
+              <a:buClr>
+                <a:srgbClr val="000000"/>
+              </a:buClr>
+              <a:buSzPts val="1800"/>
+              <a:buFont typeface="Arial"/>
+              <a:buNone/>
+            </a:pPr>
+            <a:r>
+              <a:rPr lang="fr-FR" sz="1800" b="0" i="0" u="none" strike="noStrike" cap="none" dirty="0">
+                <a:solidFill>
+                  <a:srgbClr val="000000"/>
+                </a:solidFill>
+                <a:latin typeface="Century Gothic"/>
+                <a:ea typeface="Century Gothic"/>
+                <a:cs typeface="Century Gothic"/>
+                <a:sym typeface="Century Gothic"/>
+              </a:rPr>
+              <a:t>Attention, il faut s’adapter à l’interlocuteur (pas trop de technique)</a:t>
+            </a:r>
+            <a:endParaRPr sz="1400" b="0" i="0" u="none" strike="noStrike" cap="none" dirty="0">
+              <a:solidFill>
+                <a:srgbClr val="000000"/>
+              </a:solidFill>
+              <a:latin typeface="Arial"/>
+              <a:ea typeface="Arial"/>
+              <a:cs typeface="Arial"/>
+              <a:sym typeface="Arial"/>
+            </a:endParaRPr>
+          </a:p>
+          <a:p>
+            <a:pPr marL="0" marR="0" lvl="0" indent="0" algn="ctr" rtl="0">
+              <a:lnSpc>
+                <a:spcPct val="100000"/>
+              </a:lnSpc>
+              <a:spcBef>
+                <a:spcPts val="0"/>
+              </a:spcBef>
+              <a:spcAft>
+                <a:spcPts val="0"/>
+              </a:spcAft>
+              <a:buClr>
+                <a:srgbClr val="000000"/>
+              </a:buClr>
+              <a:buSzPts val="1800"/>
+              <a:buFont typeface="Arial"/>
+              <a:buNone/>
+            </a:pPr>
+            <a:r>
+              <a:rPr lang="fr-FR" sz="1800" b="0" i="0" u="none" strike="noStrike" cap="none" dirty="0">
+                <a:solidFill>
+                  <a:srgbClr val="000000"/>
+                </a:solidFill>
+                <a:latin typeface="Century Gothic"/>
+                <a:ea typeface="Century Gothic"/>
+                <a:cs typeface="Century Gothic"/>
+                <a:sym typeface="Century Gothic"/>
+              </a:rPr>
+              <a:t>Vérifier que l’interlocuteur comprend  bien les choses</a:t>
+            </a:r>
+            <a:endParaRPr sz="1800" b="0" i="0" u="none" strike="noStrike" cap="none" dirty="0">
+              <a:solidFill>
+                <a:srgbClr val="000000"/>
+              </a:solidFill>
+              <a:latin typeface="Century Gothic"/>
+              <a:ea typeface="Century Gothic"/>
+              <a:cs typeface="Century Gothic"/>
+              <a:sym typeface="Century Gothic"/>
+            </a:endParaRPr>
+          </a:p>
+          <a:p>
+            <a:pPr marL="0" marR="0" lvl="0" indent="0" algn="ctr" rtl="0">
+              <a:lnSpc>
+                <a:spcPct val="100000"/>
+              </a:lnSpc>
+              <a:spcBef>
+                <a:spcPts val="0"/>
+              </a:spcBef>
+              <a:spcAft>
+                <a:spcPts val="0"/>
+              </a:spcAft>
+              <a:buClr>
+                <a:srgbClr val="000000"/>
+              </a:buClr>
+              <a:buSzPts val="1800"/>
+              <a:buFont typeface="Arial"/>
+              <a:buNone/>
+            </a:pPr>
+            <a:endParaRPr sz="1800" b="0" i="0" u="none" strike="noStrike" cap="none" dirty="0">
+              <a:solidFill>
+                <a:srgbClr val="000000"/>
+              </a:solidFill>
+              <a:latin typeface="Century Gothic"/>
+              <a:ea typeface="Century Gothic"/>
+              <a:cs typeface="Century Gothic"/>
+              <a:sym typeface="Century Gothic"/>
+            </a:endParaRPr>
+          </a:p>
+          <a:p>
+            <a:pPr marL="0" marR="0" lvl="0" indent="0" algn="ctr" rtl="0">
+              <a:lnSpc>
+                <a:spcPct val="100000"/>
+              </a:lnSpc>
+              <a:spcBef>
+                <a:spcPts val="0"/>
+              </a:spcBef>
+              <a:spcAft>
+                <a:spcPts val="0"/>
+              </a:spcAft>
+              <a:buClr>
+                <a:srgbClr val="000000"/>
+              </a:buClr>
+              <a:buSzPts val="1800"/>
+              <a:buFont typeface="Arial"/>
+              <a:buNone/>
+            </a:pPr>
+            <a:r>
+              <a:rPr lang="fr-FR" sz="1800" b="0" i="0" u="none" strike="noStrike" cap="none" dirty="0">
+                <a:solidFill>
+                  <a:srgbClr val="000000"/>
+                </a:solidFill>
+                <a:latin typeface="Century Gothic"/>
+                <a:ea typeface="Century Gothic"/>
+                <a:cs typeface="Century Gothic"/>
+                <a:sym typeface="Century Gothic"/>
+              </a:rPr>
+              <a:t>Penser à commenter les slides pendant la présentation mais à ne pas les lire</a:t>
+            </a:r>
+            <a:endParaRPr sz="1800" b="0" i="0" u="none" strike="noStrike" cap="none" dirty="0">
+              <a:solidFill>
+                <a:srgbClr val="000000"/>
+              </a:solidFill>
+              <a:latin typeface="Century Gothic"/>
+              <a:ea typeface="Century Gothic"/>
+              <a:cs typeface="Century Gothic"/>
+              <a:sym typeface="Century Gothic"/>
+            </a:endParaRPr>
+          </a:p>
+          <a:p>
+            <a:pPr marL="0" marR="0" lvl="0" indent="0" algn="ctr" rtl="0">
+              <a:lnSpc>
+                <a:spcPct val="100000"/>
+              </a:lnSpc>
+              <a:spcBef>
+                <a:spcPts val="0"/>
+              </a:spcBef>
+              <a:spcAft>
+                <a:spcPts val="0"/>
+              </a:spcAft>
+              <a:buClr>
+                <a:srgbClr val="000000"/>
+              </a:buClr>
+              <a:buSzPts val="1800"/>
+              <a:buFont typeface="Arial"/>
+              <a:buNone/>
+            </a:pPr>
+            <a:endParaRPr sz="1800" b="0" i="0" u="none" strike="noStrike" cap="none" dirty="0">
+              <a:solidFill>
+                <a:srgbClr val="000000"/>
+              </a:solidFill>
+              <a:latin typeface="Century Gothic"/>
+              <a:ea typeface="Century Gothic"/>
+              <a:cs typeface="Century Gothic"/>
+              <a:sym typeface="Century Gothic"/>
+            </a:endParaRPr>
+          </a:p>
+        </p:txBody>
+      </p:sp>
+      <p:sp>
+        <p:nvSpPr>
+          <p:cNvPr id="4" name="Google Shape;140;p3">
+            <a:extLst>
+              <a:ext uri="{FF2B5EF4-FFF2-40B4-BE49-F238E27FC236}">
+                <a16:creationId xmlns:a16="http://schemas.microsoft.com/office/drawing/2014/main" id="{45559D09-3D65-7B25-A451-9C10E26A6A25}"/>
+              </a:ext>
+            </a:extLst>
+          </p:cNvPr>
+          <p:cNvSpPr/>
+          <p:nvPr/>
+        </p:nvSpPr>
+        <p:spPr>
+          <a:xfrm>
+            <a:off x="11436950" y="4072225"/>
+            <a:ext cx="2653800" cy="2716200"/>
+          </a:xfrm>
+          <a:prstGeom prst="rect">
+            <a:avLst/>
+          </a:prstGeom>
+          <a:solidFill>
+            <a:srgbClr val="FFFF00"/>
+          </a:solidFill>
+          <a:ln w="15875" cap="rnd" cmpd="sng">
+            <a:solidFill>
+              <a:srgbClr val="AE813B"/>
+            </a:solidFill>
+            <a:prstDash val="solid"/>
+            <a:round/>
+            <a:headEnd type="none" w="sm" len="sm"/>
+            <a:tailEnd type="none" w="sm" len="sm"/>
+          </a:ln>
+        </p:spPr>
+        <p:txBody>
+          <a:bodyPr spcFirstLastPara="1" wrap="square" lIns="91425" tIns="45700" rIns="91425" bIns="45700" anchor="ctr" anchorCtr="0">
+            <a:noAutofit/>
+          </a:bodyPr>
+          <a:lstStyle/>
+          <a:p>
+            <a:pPr marL="0" marR="0" lvl="0" indent="0" algn="l" rtl="0">
+              <a:lnSpc>
+                <a:spcPct val="100000"/>
+              </a:lnSpc>
+              <a:spcBef>
+                <a:spcPts val="0"/>
+              </a:spcBef>
+              <a:spcAft>
+                <a:spcPts val="0"/>
+              </a:spcAft>
+              <a:buClr>
+                <a:srgbClr val="000000"/>
+              </a:buClr>
+              <a:buSzPts val="1800"/>
+              <a:buFont typeface="Arial"/>
+              <a:buNone/>
+            </a:pPr>
+            <a:r>
+              <a:rPr lang="fr-FR" sz="1800" b="0" i="0" u="none" strike="noStrike" cap="none">
+                <a:solidFill>
+                  <a:srgbClr val="000000"/>
+                </a:solidFill>
+                <a:latin typeface="Century Gothic"/>
+                <a:ea typeface="Century Gothic"/>
+                <a:cs typeface="Century Gothic"/>
+                <a:sym typeface="Century Gothic"/>
+              </a:rPr>
+              <a:t>Est-ce que le RGPD s’applique dans notre projet ?</a:t>
+            </a:r>
+            <a:endParaRPr sz="1800" b="0" i="0" u="none" strike="noStrike" cap="none">
+              <a:solidFill>
+                <a:srgbClr val="000000"/>
+              </a:solidFill>
+              <a:latin typeface="Century Gothic"/>
+              <a:ea typeface="Century Gothic"/>
+              <a:cs typeface="Century Gothic"/>
+              <a:sym typeface="Century Gothic"/>
+            </a:endParaRPr>
+          </a:p>
+        </p:txBody>
+      </p:sp>
     </p:spTree>
   </p:cSld>
   <p:clrMapOvr>
@@ -25861,12 +27238,12 @@
               <a:buNone/>
             </a:pPr>
             <a:r>
-              <a:rPr lang="fr-FR" sz="3200">
+              <a:rPr lang="fr-FR" sz="3200" dirty="0">
                 <a:latin typeface="Century Gothic" panose="020B0502020202020204" pitchFamily="34" charset="0"/>
               </a:rPr>
               <a:t>1) Proportion de personnes en état de sous-nutrition en 2017</a:t>
             </a:r>
-            <a:endParaRPr sz="3200">
+            <a:endParaRPr sz="3200" dirty="0">
               <a:latin typeface="Century Gothic" panose="020B0502020202020204" pitchFamily="34" charset="0"/>
             </a:endParaRPr>
           </a:p>
@@ -25874,18 +27251,211 @@
       </p:sp>
       <p:sp>
         <p:nvSpPr>
-          <p:cNvPr id="146" name="Google Shape;146;p4"/>
+          <p:cNvPr id="4" name="Rectangle 1">
+            <a:extLst>
+              <a:ext uri="{FF2B5EF4-FFF2-40B4-BE49-F238E27FC236}">
+                <a16:creationId xmlns:a16="http://schemas.microsoft.com/office/drawing/2014/main" id="{4854AF66-421A-0037-E3B6-BC967ECB2910}"/>
+              </a:ext>
+            </a:extLst>
+          </p:cNvPr>
+          <p:cNvSpPr>
+            <a:spLocks noChangeArrowheads="1"/>
+          </p:cNvSpPr>
+          <p:nvPr/>
+        </p:nvSpPr>
+        <p:spPr bwMode="auto">
+          <a:xfrm>
+            <a:off x="0" y="0"/>
+            <a:ext cx="12192000" cy="0"/>
+          </a:xfrm>
+          <a:prstGeom prst="rect">
+            <a:avLst/>
+          </a:prstGeom>
+          <a:noFill/>
+          <a:ln>
+            <a:noFill/>
+          </a:ln>
+          <a:effectLst/>
+          <a:extLst>
+            <a:ext uri="{909E8E84-426E-40DD-AFC4-6F175D3DCCD1}">
+              <a14:hiddenFill xmlns:a14="http://schemas.microsoft.com/office/drawing/2010/main">
+                <a:solidFill>
+                  <a:schemeClr val="accent1"/>
+                </a:solidFill>
+              </a14:hiddenFill>
+            </a:ext>
+            <a:ext uri="{91240B29-F687-4F45-9708-019B960494DF}">
+              <a14:hiddenLine xmlns:a14="http://schemas.microsoft.com/office/drawing/2010/main" w="9525">
+                <a:solidFill>
+                  <a:schemeClr val="tx1"/>
+                </a:solidFill>
+                <a:miter lim="800000"/>
+                <a:headEnd/>
+                <a:tailEnd/>
+              </a14:hiddenLine>
+            </a:ext>
+            <a:ext uri="{AF507438-7753-43E0-B8FC-AC1667EBCBE1}">
+              <a14:hiddenEffects xmlns:a14="http://schemas.microsoft.com/office/drawing/2010/main">
+                <a:effectLst>
+                  <a:outerShdw dist="35921" dir="2700000" algn="ctr" rotWithShape="0">
+                    <a:schemeClr val="bg2"/>
+                  </a:outerShdw>
+                </a:effectLst>
+              </a14:hiddenEffects>
+            </a:ext>
+          </a:extLst>
+        </p:spPr>
+        <p:txBody>
+          <a:bodyPr vert="horz" wrap="none" lIns="91440" tIns="45720" rIns="91440" bIns="45720" numCol="1" anchor="ctr" anchorCtr="0" compatLnSpc="1">
+            <a:prstTxWarp prst="textNoShape">
+              <a:avLst/>
+            </a:prstTxWarp>
+            <a:spAutoFit/>
+          </a:bodyPr>
+          <a:lstStyle/>
+          <a:p>
+            <a:endParaRPr lang="fr-FR"/>
+          </a:p>
+        </p:txBody>
+      </p:sp>
+      <p:sp>
+        <p:nvSpPr>
+          <p:cNvPr id="14" name="AutoShape 5">
+            <a:extLst>
+              <a:ext uri="{FF2B5EF4-FFF2-40B4-BE49-F238E27FC236}">
+                <a16:creationId xmlns:a16="http://schemas.microsoft.com/office/drawing/2014/main" id="{E8C93C5F-BC8D-6571-C5C6-87440A2E91DD}"/>
+              </a:ext>
+            </a:extLst>
+          </p:cNvPr>
+          <p:cNvSpPr>
+            <a:spLocks noChangeAspect="1" noChangeArrowheads="1"/>
+          </p:cNvSpPr>
+          <p:nvPr/>
+        </p:nvSpPr>
+        <p:spPr bwMode="auto">
+          <a:xfrm>
+            <a:off x="152400" y="152400"/>
+            <a:ext cx="304800" cy="304800"/>
+          </a:xfrm>
+          <a:prstGeom prst="rect">
+            <a:avLst/>
+          </a:prstGeom>
+          <a:noFill/>
+          <a:extLst>
+            <a:ext uri="{909E8E84-426E-40DD-AFC4-6F175D3DCCD1}">
+              <a14:hiddenFill xmlns:a14="http://schemas.microsoft.com/office/drawing/2010/main">
+                <a:solidFill>
+                  <a:srgbClr val="FFFFFF"/>
+                </a:solidFill>
+              </a14:hiddenFill>
+            </a:ext>
+          </a:extLst>
+        </p:spPr>
+        <p:txBody>
+          <a:bodyPr vert="horz" wrap="square" lIns="91440" tIns="45720" rIns="91440" bIns="45720" numCol="1" anchor="t" anchorCtr="0" compatLnSpc="1">
+            <a:prstTxWarp prst="textNoShape">
+              <a:avLst/>
+            </a:prstTxWarp>
+          </a:bodyPr>
+          <a:lstStyle/>
+          <a:p>
+            <a:endParaRPr lang="fr-FR"/>
+          </a:p>
+        </p:txBody>
+      </p:sp>
+      <p:sp>
+        <p:nvSpPr>
+          <p:cNvPr id="15" name="AutoShape 6">
+            <a:extLst>
+              <a:ext uri="{FF2B5EF4-FFF2-40B4-BE49-F238E27FC236}">
+                <a16:creationId xmlns:a16="http://schemas.microsoft.com/office/drawing/2014/main" id="{B5C06CD8-CF23-37C0-FA53-8EC695412C81}"/>
+              </a:ext>
+            </a:extLst>
+          </p:cNvPr>
+          <p:cNvSpPr>
+            <a:spLocks noChangeAspect="1" noChangeArrowheads="1"/>
+          </p:cNvSpPr>
+          <p:nvPr/>
+        </p:nvSpPr>
+        <p:spPr bwMode="auto">
+          <a:xfrm>
+            <a:off x="152400" y="152400"/>
+            <a:ext cx="304800" cy="304800"/>
+          </a:xfrm>
+          <a:prstGeom prst="rect">
+            <a:avLst/>
+          </a:prstGeom>
+          <a:noFill/>
+          <a:extLst>
+            <a:ext uri="{909E8E84-426E-40DD-AFC4-6F175D3DCCD1}">
+              <a14:hiddenFill xmlns:a14="http://schemas.microsoft.com/office/drawing/2010/main">
+                <a:solidFill>
+                  <a:srgbClr val="FFFFFF"/>
+                </a:solidFill>
+              </a14:hiddenFill>
+            </a:ext>
+          </a:extLst>
+        </p:spPr>
+        <p:txBody>
+          <a:bodyPr vert="horz" wrap="square" lIns="91440" tIns="45720" rIns="91440" bIns="45720" numCol="1" anchor="t" anchorCtr="0" compatLnSpc="1">
+            <a:prstTxWarp prst="textNoShape">
+              <a:avLst/>
+            </a:prstTxWarp>
+          </a:bodyPr>
+          <a:lstStyle/>
+          <a:p>
+            <a:endParaRPr lang="fr-FR"/>
+          </a:p>
+        </p:txBody>
+      </p:sp>
+      <p:pic>
+        <p:nvPicPr>
+          <p:cNvPr id="19" name="Image 18" descr="Une image contenant habits, dessin humoristique, femme, personne&#10;&#10;Le contenu généré par l’IA peut être incorrect.">
+            <a:extLst>
+              <a:ext uri="{FF2B5EF4-FFF2-40B4-BE49-F238E27FC236}">
+                <a16:creationId xmlns:a16="http://schemas.microsoft.com/office/drawing/2014/main" id="{A3E9BD6F-847C-4219-5302-F3CEC09EB4BC}"/>
+              </a:ext>
+            </a:extLst>
+          </p:cNvPr>
+          <p:cNvPicPr>
+            <a:picLocks noChangeAspect="1"/>
+          </p:cNvPicPr>
+          <p:nvPr/>
+        </p:nvPicPr>
+        <p:blipFill>
+          <a:blip r:embed="rId3"/>
+          <a:stretch>
+            <a:fillRect/>
+          </a:stretch>
+        </p:blipFill>
+        <p:spPr>
+          <a:xfrm>
+            <a:off x="6502400" y="2657022"/>
+            <a:ext cx="5093547" cy="1721724"/>
+          </a:xfrm>
+          <a:prstGeom prst="rect">
+            <a:avLst/>
+          </a:prstGeom>
+        </p:spPr>
+      </p:pic>
+      <p:sp>
+        <p:nvSpPr>
+          <p:cNvPr id="21" name="Google Shape;145;p4">
+            <a:extLst>
+              <a:ext uri="{FF2B5EF4-FFF2-40B4-BE49-F238E27FC236}">
+                <a16:creationId xmlns:a16="http://schemas.microsoft.com/office/drawing/2014/main" id="{972F5F94-D4F7-FB0F-86DE-1DBA70A4C8A7}"/>
+              </a:ext>
+            </a:extLst>
+          </p:cNvPr>
           <p:cNvSpPr txBox="1">
-            <a:spLocks noGrp="1"/>
+            <a:spLocks/>
           </p:cNvSpPr>
-          <p:nvPr>
-            <p:ph type="body" idx="1"/>
-          </p:nvPr>
+          <p:nvPr/>
         </p:nvSpPr>
         <p:spPr>
           <a:xfrm>
-            <a:off x="818712" y="2222287"/>
-            <a:ext cx="10554574" cy="3636511"/>
+            <a:off x="6502400" y="4218803"/>
+            <a:ext cx="7233333" cy="970500"/>
           </a:xfrm>
           <a:prstGeom prst="rect">
             <a:avLst/>
@@ -25897,51 +27467,290 @@
           <a:effectLst>
             <a:outerShdw blurRad="50800">
               <a:srgbClr val="000000">
-                <a:alpha val="40000"/>
+                <a:alpha val="60000"/>
               </a:srgbClr>
             </a:outerShdw>
           </a:effectLst>
         </p:spPr>
         <p:txBody>
-          <a:bodyPr spcFirstLastPara="1" wrap="square" lIns="91425" tIns="45700" rIns="91425" bIns="45700" anchor="ctr" anchorCtr="0">
-            <a:normAutofit/>
+          <a:bodyPr spcFirstLastPara="1" wrap="square" lIns="91425" tIns="45700" rIns="91425" bIns="45700" anchor="b" anchorCtr="0">
+            <a:noAutofit/>
           </a:bodyPr>
-          <a:lstStyle/>
+          <a:lstStyle>
+            <a:defPPr marR="0" lvl="0" algn="l" rtl="0">
+              <a:lnSpc>
+                <a:spcPct val="100000"/>
+              </a:lnSpc>
+              <a:spcBef>
+                <a:spcPts val="0"/>
+              </a:spcBef>
+              <a:spcAft>
+                <a:spcPts val="0"/>
+              </a:spcAft>
+            </a:defPPr>
+            <a:lvl1pPr marR="0" lvl="0" algn="l" rtl="0">
+              <a:lnSpc>
+                <a:spcPct val="100000"/>
+              </a:lnSpc>
+              <a:spcBef>
+                <a:spcPts val="0"/>
+              </a:spcBef>
+              <a:spcAft>
+                <a:spcPts val="0"/>
+              </a:spcAft>
+              <a:buClr>
+                <a:srgbClr val="FEFEFE"/>
+              </a:buClr>
+              <a:buSzPts val="1800"/>
+              <a:buFont typeface="Century Gothic"/>
+              <a:buNone/>
+              <a:defRPr sz="4000" b="1" i="0" u="none" strike="noStrike" cap="none">
+                <a:solidFill>
+                  <a:srgbClr val="FEFEFE"/>
+                </a:solidFill>
+                <a:latin typeface="Century Gothic"/>
+                <a:ea typeface="Century Gothic"/>
+                <a:cs typeface="Century Gothic"/>
+                <a:sym typeface="Century Gothic"/>
+              </a:defRPr>
+            </a:lvl1pPr>
+            <a:lvl2pPr marR="0" lvl="1" algn="l" rtl="0">
+              <a:lnSpc>
+                <a:spcPct val="100000"/>
+              </a:lnSpc>
+              <a:spcBef>
+                <a:spcPts val="0"/>
+              </a:spcBef>
+              <a:spcAft>
+                <a:spcPts val="0"/>
+              </a:spcAft>
+              <a:buClr>
+                <a:srgbClr val="000000"/>
+              </a:buClr>
+              <a:buSzPts val="1400"/>
+              <a:buFont typeface="Arial"/>
+              <a:buNone/>
+              <a:defRPr sz="1800" b="0" i="0" u="none" strike="noStrike" cap="none">
+                <a:solidFill>
+                  <a:schemeClr val="lt2"/>
+                </a:solidFill>
+                <a:latin typeface="Arial"/>
+                <a:ea typeface="Arial"/>
+                <a:cs typeface="Arial"/>
+                <a:sym typeface="Arial"/>
+              </a:defRPr>
+            </a:lvl2pPr>
+            <a:lvl3pPr marR="0" lvl="2" algn="l" rtl="0">
+              <a:lnSpc>
+                <a:spcPct val="100000"/>
+              </a:lnSpc>
+              <a:spcBef>
+                <a:spcPts val="0"/>
+              </a:spcBef>
+              <a:spcAft>
+                <a:spcPts val="0"/>
+              </a:spcAft>
+              <a:buClr>
+                <a:srgbClr val="000000"/>
+              </a:buClr>
+              <a:buSzPts val="1400"/>
+              <a:buFont typeface="Arial"/>
+              <a:buNone/>
+              <a:defRPr sz="1800" b="0" i="0" u="none" strike="noStrike" cap="none">
+                <a:solidFill>
+                  <a:schemeClr val="lt2"/>
+                </a:solidFill>
+                <a:latin typeface="Arial"/>
+                <a:ea typeface="Arial"/>
+                <a:cs typeface="Arial"/>
+                <a:sym typeface="Arial"/>
+              </a:defRPr>
+            </a:lvl3pPr>
+            <a:lvl4pPr marR="0" lvl="3" algn="l" rtl="0">
+              <a:lnSpc>
+                <a:spcPct val="100000"/>
+              </a:lnSpc>
+              <a:spcBef>
+                <a:spcPts val="0"/>
+              </a:spcBef>
+              <a:spcAft>
+                <a:spcPts val="0"/>
+              </a:spcAft>
+              <a:buClr>
+                <a:srgbClr val="000000"/>
+              </a:buClr>
+              <a:buSzPts val="1400"/>
+              <a:buFont typeface="Arial"/>
+              <a:buNone/>
+              <a:defRPr sz="1800" b="0" i="0" u="none" strike="noStrike" cap="none">
+                <a:solidFill>
+                  <a:schemeClr val="lt2"/>
+                </a:solidFill>
+                <a:latin typeface="Arial"/>
+                <a:ea typeface="Arial"/>
+                <a:cs typeface="Arial"/>
+                <a:sym typeface="Arial"/>
+              </a:defRPr>
+            </a:lvl4pPr>
+            <a:lvl5pPr marR="0" lvl="4" algn="l" rtl="0">
+              <a:lnSpc>
+                <a:spcPct val="100000"/>
+              </a:lnSpc>
+              <a:spcBef>
+                <a:spcPts val="0"/>
+              </a:spcBef>
+              <a:spcAft>
+                <a:spcPts val="0"/>
+              </a:spcAft>
+              <a:buClr>
+                <a:srgbClr val="000000"/>
+              </a:buClr>
+              <a:buSzPts val="1400"/>
+              <a:buFont typeface="Arial"/>
+              <a:buNone/>
+              <a:defRPr sz="1800" b="0" i="0" u="none" strike="noStrike" cap="none">
+                <a:solidFill>
+                  <a:schemeClr val="lt2"/>
+                </a:solidFill>
+                <a:latin typeface="Arial"/>
+                <a:ea typeface="Arial"/>
+                <a:cs typeface="Arial"/>
+                <a:sym typeface="Arial"/>
+              </a:defRPr>
+            </a:lvl5pPr>
+            <a:lvl6pPr marR="0" lvl="5" algn="l" rtl="0">
+              <a:lnSpc>
+                <a:spcPct val="100000"/>
+              </a:lnSpc>
+              <a:spcBef>
+                <a:spcPts val="0"/>
+              </a:spcBef>
+              <a:spcAft>
+                <a:spcPts val="0"/>
+              </a:spcAft>
+              <a:buClr>
+                <a:srgbClr val="000000"/>
+              </a:buClr>
+              <a:buSzPts val="1400"/>
+              <a:buFont typeface="Arial"/>
+              <a:buNone/>
+              <a:defRPr sz="1800" b="0" i="0" u="none" strike="noStrike" cap="none">
+                <a:solidFill>
+                  <a:schemeClr val="lt2"/>
+                </a:solidFill>
+                <a:latin typeface="Arial"/>
+                <a:ea typeface="Arial"/>
+                <a:cs typeface="Arial"/>
+                <a:sym typeface="Arial"/>
+              </a:defRPr>
+            </a:lvl6pPr>
+            <a:lvl7pPr marR="0" lvl="6" algn="l" rtl="0">
+              <a:lnSpc>
+                <a:spcPct val="100000"/>
+              </a:lnSpc>
+              <a:spcBef>
+                <a:spcPts val="0"/>
+              </a:spcBef>
+              <a:spcAft>
+                <a:spcPts val="0"/>
+              </a:spcAft>
+              <a:buClr>
+                <a:srgbClr val="000000"/>
+              </a:buClr>
+              <a:buSzPts val="1400"/>
+              <a:buFont typeface="Arial"/>
+              <a:buNone/>
+              <a:defRPr sz="1800" b="0" i="0" u="none" strike="noStrike" cap="none">
+                <a:solidFill>
+                  <a:schemeClr val="lt2"/>
+                </a:solidFill>
+                <a:latin typeface="Arial"/>
+                <a:ea typeface="Arial"/>
+                <a:cs typeface="Arial"/>
+                <a:sym typeface="Arial"/>
+              </a:defRPr>
+            </a:lvl7pPr>
+            <a:lvl8pPr marR="0" lvl="7" algn="l" rtl="0">
+              <a:lnSpc>
+                <a:spcPct val="100000"/>
+              </a:lnSpc>
+              <a:spcBef>
+                <a:spcPts val="0"/>
+              </a:spcBef>
+              <a:spcAft>
+                <a:spcPts val="0"/>
+              </a:spcAft>
+              <a:buClr>
+                <a:srgbClr val="000000"/>
+              </a:buClr>
+              <a:buSzPts val="1400"/>
+              <a:buFont typeface="Arial"/>
+              <a:buNone/>
+              <a:defRPr sz="1800" b="0" i="0" u="none" strike="noStrike" cap="none">
+                <a:solidFill>
+                  <a:schemeClr val="lt2"/>
+                </a:solidFill>
+                <a:latin typeface="Arial"/>
+                <a:ea typeface="Arial"/>
+                <a:cs typeface="Arial"/>
+                <a:sym typeface="Arial"/>
+              </a:defRPr>
+            </a:lvl8pPr>
+            <a:lvl9pPr marR="0" lvl="8" algn="l" rtl="0">
+              <a:lnSpc>
+                <a:spcPct val="100000"/>
+              </a:lnSpc>
+              <a:spcBef>
+                <a:spcPts val="0"/>
+              </a:spcBef>
+              <a:spcAft>
+                <a:spcPts val="0"/>
+              </a:spcAft>
+              <a:buClr>
+                <a:srgbClr val="000000"/>
+              </a:buClr>
+              <a:buSzPts val="1400"/>
+              <a:buFont typeface="Arial"/>
+              <a:buNone/>
+              <a:defRPr sz="1800" b="0" i="0" u="none" strike="noStrike" cap="none">
+                <a:solidFill>
+                  <a:schemeClr val="lt2"/>
+                </a:solidFill>
+                <a:latin typeface="Arial"/>
+                <a:ea typeface="Arial"/>
+                <a:cs typeface="Arial"/>
+                <a:sym typeface="Arial"/>
+              </a:defRPr>
+            </a:lvl9pPr>
+          </a:lstStyle>
           <a:p>
-            <a:pPr marL="0" lvl="0" indent="0" algn="l" rtl="0">
-              <a:lnSpc>
-                <a:spcPct val="100000"/>
-              </a:lnSpc>
-              <a:spcBef>
-                <a:spcPts val="0"/>
-              </a:spcBef>
-              <a:spcAft>
-                <a:spcPts val="0"/>
-              </a:spcAft>
-              <a:buSzPts val="1800"/>
-              <a:buNone/>
+            <a:pPr>
+              <a:buSzPts val="3200"/>
             </a:pPr>
             <a:r>
-              <a:rPr lang="fr-FR" dirty="0">
+              <a:rPr lang="fr-FR" sz="3200" dirty="0">
                 <a:latin typeface="Century Gothic" panose="020B0502020202020204" pitchFamily="34" charset="0"/>
               </a:rPr>
-              <a:t>Mettre une infographie et un camembert.</a:t>
+              <a:t>554 millions de personnes</a:t>
             </a:r>
-            <a:endParaRPr dirty="0">
-              <a:latin typeface="Century Gothic" panose="020B0502020202020204" pitchFamily="34" charset="0"/>
-            </a:endParaRPr>
           </a:p>
         </p:txBody>
       </p:sp>
       <p:sp>
         <p:nvSpPr>
-          <p:cNvPr id="147" name="Google Shape;147;p4"/>
+          <p:cNvPr id="2" name="Google Shape;147;p4">
+            <a:extLst>
+              <a:ext uri="{FF2B5EF4-FFF2-40B4-BE49-F238E27FC236}">
+                <a16:creationId xmlns:a16="http://schemas.microsoft.com/office/drawing/2014/main" id="{877C2B17-23E2-4B8A-E055-0F562898E27C}"/>
+              </a:ext>
+            </a:extLst>
+          </p:cNvPr>
           <p:cNvSpPr/>
           <p:nvPr/>
         </p:nvSpPr>
         <p:spPr>
           <a:xfrm>
-            <a:off x="7899401" y="2501803"/>
+            <a:off x="9019869" y="270566"/>
             <a:ext cx="3432024" cy="2582431"/>
           </a:xfrm>
           <a:prstGeom prst="rect">
@@ -25988,7 +27797,7 @@
                 <a:solidFill>
                   <a:srgbClr val="000000"/>
                 </a:solidFill>
-                <a:latin typeface="Century Gothic" panose="020B0502020202020204" pitchFamily="34" charset="0"/>
+                <a:latin typeface="Century Gothic"/>
                 <a:ea typeface="Century Gothic"/>
                 <a:cs typeface="Century Gothic"/>
                 <a:sym typeface="Century Gothic"/>
@@ -25999,7 +27808,9 @@
               <a:solidFill>
                 <a:srgbClr val="000000"/>
               </a:solidFill>
-              <a:latin typeface="Century Gothic" panose="020B0502020202020204" pitchFamily="34" charset="0"/>
+              <a:latin typeface="Arial"/>
+              <a:ea typeface="Arial"/>
+              <a:cs typeface="Arial"/>
               <a:sym typeface="Arial"/>
             </a:endParaRPr>
           </a:p>
@@ -26026,7 +27837,7 @@
                 <a:solidFill>
                   <a:srgbClr val="000000"/>
                 </a:solidFill>
-                <a:latin typeface="Century Gothic" panose="020B0502020202020204" pitchFamily="34" charset="0"/>
+                <a:latin typeface="Century Gothic"/>
                 <a:ea typeface="Century Gothic"/>
                 <a:cs typeface="Century Gothic"/>
                 <a:sym typeface="Century Gothic"/>
@@ -26037,7 +27848,9 @@
               <a:solidFill>
                 <a:srgbClr val="000000"/>
               </a:solidFill>
-              <a:latin typeface="Century Gothic" panose="020B0502020202020204" pitchFamily="34" charset="0"/>
+              <a:latin typeface="Arial"/>
+              <a:ea typeface="Arial"/>
+              <a:cs typeface="Arial"/>
               <a:sym typeface="Arial"/>
             </a:endParaRPr>
           </a:p>
@@ -26063,7 +27876,7 @@
               <a:solidFill>
                 <a:srgbClr val="000000"/>
               </a:solidFill>
-              <a:latin typeface="Century Gothic" panose="020B0502020202020204" pitchFamily="34" charset="0"/>
+              <a:latin typeface="Century Gothic"/>
               <a:ea typeface="Century Gothic"/>
               <a:cs typeface="Century Gothic"/>
               <a:sym typeface="Century Gothic"/>
@@ -26092,7 +27905,7 @@
                 <a:solidFill>
                   <a:srgbClr val="000000"/>
                 </a:solidFill>
-                <a:latin typeface="Century Gothic" panose="020B0502020202020204" pitchFamily="34" charset="0"/>
+                <a:latin typeface="Century Gothic"/>
                 <a:ea typeface="Century Gothic"/>
                 <a:cs typeface="Century Gothic"/>
                 <a:sym typeface="Century Gothic"/>
@@ -26103,9 +27916,90 @@
               <a:solidFill>
                 <a:srgbClr val="000000"/>
               </a:solidFill>
-              <a:latin typeface="Century Gothic" panose="020B0502020202020204" pitchFamily="34" charset="0"/>
+              <a:latin typeface="Arial"/>
+              <a:ea typeface="Arial"/>
+              <a:cs typeface="Arial"/>
               <a:sym typeface="Arial"/>
             </a:endParaRPr>
+          </a:p>
+        </p:txBody>
+      </p:sp>
+      <p:pic>
+        <p:nvPicPr>
+          <p:cNvPr id="5" name="Image 4">
+            <a:extLst>
+              <a:ext uri="{FF2B5EF4-FFF2-40B4-BE49-F238E27FC236}">
+                <a16:creationId xmlns:a16="http://schemas.microsoft.com/office/drawing/2014/main" id="{AFF187F8-70D2-A5B1-ED33-1CFD638C7EEC}"/>
+              </a:ext>
+            </a:extLst>
+          </p:cNvPr>
+          <p:cNvPicPr>
+            <a:picLocks noChangeAspect="1"/>
+          </p:cNvPicPr>
+          <p:nvPr/>
+        </p:nvPicPr>
+        <p:blipFill>
+          <a:blip r:embed="rId4"/>
+          <a:stretch>
+            <a:fillRect/>
+          </a:stretch>
+        </p:blipFill>
+        <p:spPr>
+          <a:xfrm>
+            <a:off x="596053" y="2270940"/>
+            <a:ext cx="5457825" cy="3895725"/>
+          </a:xfrm>
+          <a:prstGeom prst="rect">
+            <a:avLst/>
+          </a:prstGeom>
+        </p:spPr>
+      </p:pic>
+      <p:sp>
+        <p:nvSpPr>
+          <p:cNvPr id="7" name="Flèche : droite 6">
+            <a:extLst>
+              <a:ext uri="{FF2B5EF4-FFF2-40B4-BE49-F238E27FC236}">
+                <a16:creationId xmlns:a16="http://schemas.microsoft.com/office/drawing/2014/main" id="{DE350F41-FEEB-F480-B4A8-DF32C04F4EB7}"/>
+              </a:ext>
+            </a:extLst>
+          </p:cNvPr>
+          <p:cNvSpPr/>
+          <p:nvPr/>
+        </p:nvSpPr>
+        <p:spPr>
+          <a:xfrm rot="19806387">
+            <a:off x="4735708" y="3888816"/>
+            <a:ext cx="1907786" cy="234434"/>
+          </a:xfrm>
+          <a:prstGeom prst="rightArrow">
+            <a:avLst/>
+          </a:prstGeom>
+          <a:solidFill>
+            <a:srgbClr val="D95F02"/>
+          </a:solidFill>
+        </p:spPr>
+        <p:style>
+          <a:lnRef idx="2">
+            <a:schemeClr val="accent4">
+              <a:shade val="15000"/>
+            </a:schemeClr>
+          </a:lnRef>
+          <a:fillRef idx="1">
+            <a:schemeClr val="accent4"/>
+          </a:fillRef>
+          <a:effectRef idx="0">
+            <a:schemeClr val="accent4"/>
+          </a:effectRef>
+          <a:fontRef idx="minor">
+            <a:schemeClr val="lt1"/>
+          </a:fontRef>
+        </p:style>
+        <p:txBody>
+          <a:bodyPr rtlCol="0" anchor="ctr"/>
+          <a:lstStyle/>
+          <a:p>
+            <a:pPr algn="ctr"/>
+            <a:endParaRPr lang="fr-FR"/>
           </a:p>
         </p:txBody>
       </p:sp>
@@ -26188,12 +28082,12 @@
               <a:buNone/>
             </a:pPr>
             <a:r>
-              <a:rPr lang="fr-FR" sz="3200">
+              <a:rPr lang="fr-FR" sz="3200" dirty="0">
                 <a:latin typeface="Century Gothic" panose="020B0502020202020204" pitchFamily="34" charset="0"/>
               </a:rPr>
               <a:t>2) Nombre théorique de personnes qui pourraient être nourries en 2017</a:t>
             </a:r>
-            <a:endParaRPr sz="3200">
+            <a:endParaRPr sz="3200" dirty="0">
               <a:latin typeface="Century Gothic" panose="020B0502020202020204" pitchFamily="34" charset="0"/>
             </a:endParaRPr>
           </a:p>
@@ -26211,8 +28105,8 @@
         </p:nvSpPr>
         <p:spPr>
           <a:xfrm>
-            <a:off x="818712" y="2222287"/>
-            <a:ext cx="10554574" cy="3636511"/>
+            <a:off x="5366328" y="1535192"/>
+            <a:ext cx="6825672" cy="518702"/>
           </a:xfrm>
           <a:prstGeom prst="rect">
             <a:avLst/>
@@ -26249,12 +28143,12 @@
               <a:buNone/>
             </a:pPr>
             <a:r>
-              <a:rPr lang="fr-FR" dirty="0">
+              <a:rPr lang="fr-FR" sz="1050" dirty="0">
                 <a:latin typeface="Century Gothic" panose="020B0502020202020204" pitchFamily="34" charset="0"/>
               </a:rPr>
-              <a:t>Mettre le lien vers l’info + graph</a:t>
+              <a:t>Source : https://www.fao.org/4/y3557f/y3557f15.htm</a:t>
             </a:r>
-            <a:endParaRPr dirty="0">
+            <a:endParaRPr sz="1050" dirty="0">
               <a:latin typeface="Century Gothic" panose="020B0502020202020204" pitchFamily="34" charset="0"/>
             </a:endParaRPr>
           </a:p>
@@ -26268,7 +28162,7 @@
         </p:nvSpPr>
         <p:spPr>
           <a:xfrm>
-            <a:off x="7835901" y="2840469"/>
+            <a:off x="11006867" y="1417638"/>
             <a:ext cx="3432024" cy="2582431"/>
           </a:xfrm>
           <a:prstGeom prst="rect">
@@ -26471,6 +28365,462 @@
               <a:latin typeface="Century Gothic" panose="020B0502020202020204" pitchFamily="34" charset="0"/>
               <a:sym typeface="Arial"/>
             </a:endParaRPr>
+          </a:p>
+        </p:txBody>
+      </p:sp>
+      <p:sp>
+        <p:nvSpPr>
+          <p:cNvPr id="8" name="Rectangle : coins arrondis 7">
+            <a:extLst>
+              <a:ext uri="{FF2B5EF4-FFF2-40B4-BE49-F238E27FC236}">
+                <a16:creationId xmlns:a16="http://schemas.microsoft.com/office/drawing/2014/main" id="{39ED7FC7-A5A5-D08A-AEB6-A498CF960A28}"/>
+              </a:ext>
+            </a:extLst>
+          </p:cNvPr>
+          <p:cNvSpPr/>
+          <p:nvPr/>
+        </p:nvSpPr>
+        <p:spPr>
+          <a:xfrm>
+            <a:off x="245097" y="2298048"/>
+            <a:ext cx="1875934" cy="1356799"/>
+          </a:xfrm>
+          <a:prstGeom prst="roundRect">
+            <a:avLst/>
+          </a:prstGeom>
+        </p:spPr>
+        <p:style>
+          <a:lnRef idx="2">
+            <a:schemeClr val="accent1">
+              <a:shade val="15000"/>
+            </a:schemeClr>
+          </a:lnRef>
+          <a:fillRef idx="1">
+            <a:schemeClr val="accent1"/>
+          </a:fillRef>
+          <a:effectRef idx="0">
+            <a:schemeClr val="accent1"/>
+          </a:effectRef>
+          <a:fontRef idx="minor">
+            <a:schemeClr val="lt1"/>
+          </a:fontRef>
+        </p:style>
+        <p:txBody>
+          <a:bodyPr rtlCol="0" anchor="ctr"/>
+          <a:lstStyle/>
+          <a:p>
+            <a:pPr algn="ctr"/>
+            <a:r>
+              <a:rPr lang="fr-FR" sz="1400" dirty="0">
+                <a:latin typeface="Century Gothic" panose="020B0502020202020204" pitchFamily="34" charset="0"/>
+              </a:rPr>
+              <a:t>Pour chaque aliment dans chaque pays la dispo en </a:t>
+            </a:r>
+            <a:r>
+              <a:rPr lang="fr-FR" sz="1400" b="1" dirty="0">
+                <a:latin typeface="Century Gothic" panose="020B0502020202020204" pitchFamily="34" charset="0"/>
+              </a:rPr>
+              <a:t>kcal / personne / jour</a:t>
+            </a:r>
+            <a:endParaRPr lang="fr-FR" b="1" dirty="0"/>
+          </a:p>
+        </p:txBody>
+      </p:sp>
+      <p:sp>
+        <p:nvSpPr>
+          <p:cNvPr id="11" name="Rectangle : coins arrondis 10">
+            <a:extLst>
+              <a:ext uri="{FF2B5EF4-FFF2-40B4-BE49-F238E27FC236}">
+                <a16:creationId xmlns:a16="http://schemas.microsoft.com/office/drawing/2014/main" id="{EA18FBBD-EC4F-3A05-C02B-49434AEF7717}"/>
+              </a:ext>
+            </a:extLst>
+          </p:cNvPr>
+          <p:cNvSpPr/>
+          <p:nvPr/>
+        </p:nvSpPr>
+        <p:spPr>
+          <a:xfrm>
+            <a:off x="2962744" y="2300803"/>
+            <a:ext cx="1768603" cy="1356799"/>
+          </a:xfrm>
+          <a:prstGeom prst="roundRect">
+            <a:avLst/>
+          </a:prstGeom>
+        </p:spPr>
+        <p:style>
+          <a:lnRef idx="2">
+            <a:schemeClr val="accent1">
+              <a:shade val="15000"/>
+            </a:schemeClr>
+          </a:lnRef>
+          <a:fillRef idx="1">
+            <a:schemeClr val="accent1"/>
+          </a:fillRef>
+          <a:effectRef idx="0">
+            <a:schemeClr val="accent1"/>
+          </a:effectRef>
+          <a:fontRef idx="minor">
+            <a:schemeClr val="lt1"/>
+          </a:fontRef>
+        </p:style>
+        <p:txBody>
+          <a:bodyPr rtlCol="0" anchor="ctr"/>
+          <a:lstStyle/>
+          <a:p>
+            <a:pPr algn="ctr"/>
+            <a:r>
+              <a:rPr lang="fr-FR" dirty="0"/>
+              <a:t>La population du pays en 2017.</a:t>
+            </a:r>
+          </a:p>
+        </p:txBody>
+      </p:sp>
+      <p:sp>
+        <p:nvSpPr>
+          <p:cNvPr id="16" name="Signe de multiplication 15">
+            <a:extLst>
+              <a:ext uri="{FF2B5EF4-FFF2-40B4-BE49-F238E27FC236}">
+                <a16:creationId xmlns:a16="http://schemas.microsoft.com/office/drawing/2014/main" id="{A74500E9-C47A-EB79-13AE-435EE8D6B2D7}"/>
+              </a:ext>
+            </a:extLst>
+          </p:cNvPr>
+          <p:cNvSpPr/>
+          <p:nvPr/>
+        </p:nvSpPr>
+        <p:spPr>
+          <a:xfrm>
+            <a:off x="2173175" y="2628576"/>
+            <a:ext cx="761836" cy="779422"/>
+          </a:xfrm>
+          <a:prstGeom prst="mathMultiply">
+            <a:avLst/>
+          </a:prstGeom>
+          <a:solidFill>
+            <a:schemeClr val="bg1"/>
+          </a:solidFill>
+        </p:spPr>
+        <p:style>
+          <a:lnRef idx="2">
+            <a:schemeClr val="accent1">
+              <a:shade val="15000"/>
+            </a:schemeClr>
+          </a:lnRef>
+          <a:fillRef idx="1">
+            <a:schemeClr val="accent1"/>
+          </a:fillRef>
+          <a:effectRef idx="0">
+            <a:schemeClr val="accent1"/>
+          </a:effectRef>
+          <a:fontRef idx="minor">
+            <a:schemeClr val="lt1"/>
+          </a:fontRef>
+        </p:style>
+        <p:txBody>
+          <a:bodyPr rtlCol="0" anchor="ctr"/>
+          <a:lstStyle/>
+          <a:p>
+            <a:pPr algn="ctr"/>
+            <a:endParaRPr lang="fr-FR" dirty="0"/>
+          </a:p>
+        </p:txBody>
+      </p:sp>
+      <p:sp>
+        <p:nvSpPr>
+          <p:cNvPr id="17" name="Est égal à 16">
+            <a:extLst>
+              <a:ext uri="{FF2B5EF4-FFF2-40B4-BE49-F238E27FC236}">
+                <a16:creationId xmlns:a16="http://schemas.microsoft.com/office/drawing/2014/main" id="{E3F83F8E-FBD5-D3A6-36C1-32991F9C40E3}"/>
+              </a:ext>
+            </a:extLst>
+          </p:cNvPr>
+          <p:cNvSpPr/>
+          <p:nvPr/>
+        </p:nvSpPr>
+        <p:spPr>
+          <a:xfrm>
+            <a:off x="4858648" y="2623863"/>
+            <a:ext cx="774309" cy="788849"/>
+          </a:xfrm>
+          <a:prstGeom prst="mathEqual">
+            <a:avLst/>
+          </a:prstGeom>
+          <a:solidFill>
+            <a:schemeClr val="bg1"/>
+          </a:solidFill>
+        </p:spPr>
+        <p:style>
+          <a:lnRef idx="2">
+            <a:schemeClr val="accent1">
+              <a:shade val="15000"/>
+            </a:schemeClr>
+          </a:lnRef>
+          <a:fillRef idx="1">
+            <a:schemeClr val="accent1"/>
+          </a:fillRef>
+          <a:effectRef idx="0">
+            <a:schemeClr val="accent1"/>
+          </a:effectRef>
+          <a:fontRef idx="minor">
+            <a:schemeClr val="lt1"/>
+          </a:fontRef>
+        </p:style>
+        <p:txBody>
+          <a:bodyPr rtlCol="0" anchor="ctr"/>
+          <a:lstStyle/>
+          <a:p>
+            <a:pPr algn="ctr"/>
+            <a:endParaRPr lang="fr-FR">
+              <a:solidFill>
+                <a:schemeClr val="tx1"/>
+              </a:solidFill>
+            </a:endParaRPr>
+          </a:p>
+        </p:txBody>
+      </p:sp>
+      <p:sp>
+        <p:nvSpPr>
+          <p:cNvPr id="18" name="Rectangle : coins arrondis 17">
+            <a:extLst>
+              <a:ext uri="{FF2B5EF4-FFF2-40B4-BE49-F238E27FC236}">
+                <a16:creationId xmlns:a16="http://schemas.microsoft.com/office/drawing/2014/main" id="{D7CC7DC0-BC77-AE9C-1812-7FBCCB438C89}"/>
+              </a:ext>
+            </a:extLst>
+          </p:cNvPr>
+          <p:cNvSpPr/>
+          <p:nvPr/>
+        </p:nvSpPr>
+        <p:spPr>
+          <a:xfrm>
+            <a:off x="5841472" y="2298048"/>
+            <a:ext cx="1875934" cy="1359554"/>
+          </a:xfrm>
+          <a:prstGeom prst="roundRect">
+            <a:avLst/>
+          </a:prstGeom>
+        </p:spPr>
+        <p:style>
+          <a:lnRef idx="2">
+            <a:schemeClr val="accent1">
+              <a:shade val="15000"/>
+            </a:schemeClr>
+          </a:lnRef>
+          <a:fillRef idx="1">
+            <a:schemeClr val="accent1"/>
+          </a:fillRef>
+          <a:effectRef idx="0">
+            <a:schemeClr val="accent1"/>
+          </a:effectRef>
+          <a:fontRef idx="minor">
+            <a:schemeClr val="lt1"/>
+          </a:fontRef>
+        </p:style>
+        <p:txBody>
+          <a:bodyPr rtlCol="0" anchor="ctr"/>
+          <a:lstStyle/>
+          <a:p>
+            <a:pPr algn="ctr"/>
+            <a:r>
+              <a:rPr lang="fr-FR" b="1" dirty="0">
+                <a:latin typeface="Century Gothic" panose="020B0502020202020204" pitchFamily="34" charset="0"/>
+              </a:rPr>
+              <a:t>Dispo mondiale totale en kcal / jour</a:t>
+            </a:r>
+            <a:endParaRPr lang="fr-FR" b="1" dirty="0"/>
+          </a:p>
+        </p:txBody>
+      </p:sp>
+      <p:sp>
+        <p:nvSpPr>
+          <p:cNvPr id="19" name="Signe de division 18">
+            <a:extLst>
+              <a:ext uri="{FF2B5EF4-FFF2-40B4-BE49-F238E27FC236}">
+                <a16:creationId xmlns:a16="http://schemas.microsoft.com/office/drawing/2014/main" id="{EDF6C174-050D-7B87-A04E-0D9D2FF055A5}"/>
+              </a:ext>
+            </a:extLst>
+          </p:cNvPr>
+          <p:cNvSpPr/>
+          <p:nvPr/>
+        </p:nvSpPr>
+        <p:spPr>
+          <a:xfrm>
+            <a:off x="7830235" y="2600876"/>
+            <a:ext cx="694774" cy="769995"/>
+          </a:xfrm>
+          <a:prstGeom prst="mathDivide">
+            <a:avLst/>
+          </a:prstGeom>
+          <a:solidFill>
+            <a:srgbClr val="FFFF00"/>
+          </a:solidFill>
+        </p:spPr>
+        <p:style>
+          <a:lnRef idx="2">
+            <a:schemeClr val="accent1">
+              <a:shade val="15000"/>
+            </a:schemeClr>
+          </a:lnRef>
+          <a:fillRef idx="1">
+            <a:schemeClr val="accent1"/>
+          </a:fillRef>
+          <a:effectRef idx="0">
+            <a:schemeClr val="accent1"/>
+          </a:effectRef>
+          <a:fontRef idx="minor">
+            <a:schemeClr val="lt1"/>
+          </a:fontRef>
+        </p:style>
+        <p:txBody>
+          <a:bodyPr rtlCol="0" anchor="ctr"/>
+          <a:lstStyle/>
+          <a:p>
+            <a:pPr algn="ctr"/>
+            <a:endParaRPr lang="fr-FR"/>
+          </a:p>
+        </p:txBody>
+      </p:sp>
+      <p:sp>
+        <p:nvSpPr>
+          <p:cNvPr id="20" name="Est égal à 19">
+            <a:extLst>
+              <a:ext uri="{FF2B5EF4-FFF2-40B4-BE49-F238E27FC236}">
+                <a16:creationId xmlns:a16="http://schemas.microsoft.com/office/drawing/2014/main" id="{D269DE3B-3BEA-B178-D27D-14C13DA838A9}"/>
+              </a:ext>
+            </a:extLst>
+          </p:cNvPr>
+          <p:cNvSpPr/>
+          <p:nvPr/>
+        </p:nvSpPr>
+        <p:spPr>
+          <a:xfrm>
+            <a:off x="1051996" y="4340745"/>
+            <a:ext cx="1649691" cy="1687398"/>
+          </a:xfrm>
+          <a:prstGeom prst="mathEqual">
+            <a:avLst/>
+          </a:prstGeom>
+          <a:solidFill>
+            <a:srgbClr val="FFFF00"/>
+          </a:solidFill>
+        </p:spPr>
+        <p:style>
+          <a:lnRef idx="2">
+            <a:schemeClr val="accent1">
+              <a:shade val="15000"/>
+            </a:schemeClr>
+          </a:lnRef>
+          <a:fillRef idx="1">
+            <a:schemeClr val="accent1"/>
+          </a:fillRef>
+          <a:effectRef idx="0">
+            <a:schemeClr val="accent1"/>
+          </a:effectRef>
+          <a:fontRef idx="minor">
+            <a:schemeClr val="lt1"/>
+          </a:fontRef>
+        </p:style>
+        <p:txBody>
+          <a:bodyPr rtlCol="0" anchor="ctr"/>
+          <a:lstStyle/>
+          <a:p>
+            <a:pPr algn="ctr"/>
+            <a:endParaRPr lang="fr-FR">
+              <a:solidFill>
+                <a:schemeClr val="tx1"/>
+              </a:solidFill>
+            </a:endParaRPr>
+          </a:p>
+        </p:txBody>
+      </p:sp>
+      <p:sp>
+        <p:nvSpPr>
+          <p:cNvPr id="24" name="ZoneTexte 23">
+            <a:extLst>
+              <a:ext uri="{FF2B5EF4-FFF2-40B4-BE49-F238E27FC236}">
+                <a16:creationId xmlns:a16="http://schemas.microsoft.com/office/drawing/2014/main" id="{F1E7BF95-A00F-B687-0DEA-05EB431F0415}"/>
+              </a:ext>
+            </a:extLst>
+          </p:cNvPr>
+          <p:cNvSpPr txBox="1"/>
+          <p:nvPr/>
+        </p:nvSpPr>
+        <p:spPr>
+          <a:xfrm>
+            <a:off x="2701687" y="4231534"/>
+            <a:ext cx="9207504" cy="2308324"/>
+          </a:xfrm>
+          <a:prstGeom prst="rect">
+            <a:avLst/>
+          </a:prstGeom>
+          <a:noFill/>
+        </p:spPr>
+        <p:txBody>
+          <a:bodyPr wrap="square">
+            <a:spAutoFit/>
+          </a:bodyPr>
+          <a:lstStyle/>
+          <a:p>
+            <a:r>
+              <a:rPr lang="fr-FR" sz="4800" b="1" dirty="0">
+                <a:solidFill>
+                  <a:srgbClr val="FEFEFE"/>
+                </a:solidFill>
+                <a:latin typeface="Century Gothic" panose="020B0502020202020204" pitchFamily="34" charset="0"/>
+                <a:sym typeface="Century Gothic"/>
+              </a:rPr>
+              <a:t>8,83 Milliards de personnes, soit 120 % de la population mondiale.</a:t>
+            </a:r>
+          </a:p>
+        </p:txBody>
+      </p:sp>
+      <p:sp>
+        <p:nvSpPr>
+          <p:cNvPr id="2" name="Rectangle : coins arrondis 1">
+            <a:extLst>
+              <a:ext uri="{FF2B5EF4-FFF2-40B4-BE49-F238E27FC236}">
+                <a16:creationId xmlns:a16="http://schemas.microsoft.com/office/drawing/2014/main" id="{B4C59EA3-5F2F-CFF2-D4AD-4AC8D054B5DA}"/>
+              </a:ext>
+            </a:extLst>
+          </p:cNvPr>
+          <p:cNvSpPr/>
+          <p:nvPr/>
+        </p:nvSpPr>
+        <p:spPr>
+          <a:xfrm>
+            <a:off x="8779164" y="2306096"/>
+            <a:ext cx="1875934" cy="1359554"/>
+          </a:xfrm>
+          <a:prstGeom prst="roundRect">
+            <a:avLst/>
+          </a:prstGeom>
+        </p:spPr>
+        <p:style>
+          <a:lnRef idx="2">
+            <a:schemeClr val="accent1">
+              <a:shade val="15000"/>
+            </a:schemeClr>
+          </a:lnRef>
+          <a:fillRef idx="1">
+            <a:schemeClr val="accent1"/>
+          </a:fillRef>
+          <a:effectRef idx="0">
+            <a:schemeClr val="accent1"/>
+          </a:effectRef>
+          <a:fontRef idx="minor">
+            <a:schemeClr val="lt1"/>
+          </a:fontRef>
+        </p:style>
+        <p:txBody>
+          <a:bodyPr rtlCol="0" anchor="ctr"/>
+          <a:lstStyle/>
+          <a:p>
+            <a:pPr algn="ctr"/>
+            <a:r>
+              <a:rPr lang="fr-FR" b="1" dirty="0">
+                <a:latin typeface="Century Gothic" panose="020B0502020202020204" pitchFamily="34" charset="0"/>
+              </a:rPr>
+              <a:t>Besoins quotidiens d’un être humain (2400 kcal)</a:t>
+            </a:r>
+            <a:endParaRPr lang="fr-FR" b="1" dirty="0"/>
           </a:p>
         </p:txBody>
       </p:sp>
@@ -26566,68 +28916,13 @@
       </p:sp>
       <p:sp>
         <p:nvSpPr>
-          <p:cNvPr id="160" name="Google Shape;160;p6"/>
-          <p:cNvSpPr txBox="1">
-            <a:spLocks noGrp="1"/>
-          </p:cNvSpPr>
-          <p:nvPr>
-            <p:ph type="body" idx="1"/>
-          </p:nvPr>
-        </p:nvSpPr>
-        <p:spPr>
-          <a:xfrm>
-            <a:off x="818712" y="2222287"/>
-            <a:ext cx="10554574" cy="3636511"/>
-          </a:xfrm>
-          <a:prstGeom prst="rect">
-            <a:avLst/>
-          </a:prstGeom>
-          <a:noFill/>
-          <a:ln>
-            <a:noFill/>
-          </a:ln>
-          <a:effectLst>
-            <a:outerShdw blurRad="50800">
-              <a:srgbClr val="000000">
-                <a:alpha val="40000"/>
-              </a:srgbClr>
-            </a:outerShdw>
-          </a:effectLst>
-        </p:spPr>
-        <p:txBody>
-          <a:bodyPr spcFirstLastPara="1" wrap="square" lIns="91425" tIns="45700" rIns="91425" bIns="45700" anchor="ctr" anchorCtr="0">
-            <a:normAutofit/>
-          </a:bodyPr>
-          <a:lstStyle/>
-          <a:p>
-            <a:pPr marL="0" lvl="0" indent="0" algn="l" rtl="0">
-              <a:lnSpc>
-                <a:spcPct val="100000"/>
-              </a:lnSpc>
-              <a:spcBef>
-                <a:spcPts val="0"/>
-              </a:spcBef>
-              <a:spcAft>
-                <a:spcPts val="0"/>
-              </a:spcAft>
-              <a:buSzPts val="1800"/>
-              <a:buNone/>
-            </a:pPr>
-            <a:endParaRPr dirty="0">
-              <a:latin typeface="Century Gothic" panose="020B0502020202020204" pitchFamily="34" charset="0"/>
-            </a:endParaRPr>
-          </a:p>
-        </p:txBody>
-      </p:sp>
-      <p:sp>
-        <p:nvSpPr>
           <p:cNvPr id="161" name="Google Shape;161;p6"/>
           <p:cNvSpPr/>
           <p:nvPr/>
         </p:nvSpPr>
         <p:spPr>
           <a:xfrm>
-            <a:off x="7835901" y="2840469"/>
+            <a:off x="11140004" y="3828381"/>
             <a:ext cx="3432024" cy="2582431"/>
           </a:xfrm>
           <a:prstGeom prst="rect">
@@ -26670,7 +28965,7 @@
               <a:buNone/>
             </a:pPr>
             <a:r>
-              <a:rPr lang="fr-FR" sz="1800" b="0" i="0" u="none" strike="noStrike" cap="none">
+              <a:rPr lang="fr-FR" sz="1800" b="0" i="0" u="none" strike="noStrike" cap="none" dirty="0">
                 <a:solidFill>
                   <a:srgbClr val="000000"/>
                 </a:solidFill>
@@ -26684,7 +28979,7 @@
               </a:rPr>
               <a:t>MEMO : </a:t>
             </a:r>
-            <a:endParaRPr sz="1400" b="0" i="0" u="none" strike="noStrike" cap="none">
+            <a:endParaRPr sz="1400" b="0" i="0" u="none" strike="noStrike" cap="none" dirty="0">
               <a:solidFill>
                 <a:srgbClr val="000000"/>
               </a:solidFill>
@@ -26711,7 +29006,7 @@
               <a:buNone/>
             </a:pPr>
             <a:r>
-              <a:rPr lang="fr-FR" sz="1800" b="0" i="0" u="none" strike="noStrike" cap="none">
+              <a:rPr lang="fr-FR" sz="1800" b="0" i="0" u="none" strike="noStrike" cap="none" dirty="0">
                 <a:solidFill>
                   <a:srgbClr val="000000"/>
                 </a:solidFill>
@@ -26725,13 +29020,469 @@
               </a:rPr>
               <a:t>Même calcul que précédemment mais avec uniquement les végétaux</a:t>
             </a:r>
-            <a:endParaRPr sz="1400" b="0" i="0" u="none" strike="noStrike" cap="none">
+            <a:endParaRPr sz="1400" b="0" i="0" u="none" strike="noStrike" cap="none" dirty="0">
               <a:solidFill>
                 <a:srgbClr val="000000"/>
               </a:solidFill>
               <a:latin typeface="Century Gothic" panose="020B0502020202020204" pitchFamily="34" charset="0"/>
               <a:sym typeface="Arial"/>
             </a:endParaRPr>
+          </a:p>
+        </p:txBody>
+      </p:sp>
+      <p:sp>
+        <p:nvSpPr>
+          <p:cNvPr id="2" name="Rectangle : coins arrondis 1">
+            <a:extLst>
+              <a:ext uri="{FF2B5EF4-FFF2-40B4-BE49-F238E27FC236}">
+                <a16:creationId xmlns:a16="http://schemas.microsoft.com/office/drawing/2014/main" id="{69C9B610-9784-E7BC-09E1-304855359E98}"/>
+              </a:ext>
+            </a:extLst>
+          </p:cNvPr>
+          <p:cNvSpPr/>
+          <p:nvPr/>
+        </p:nvSpPr>
+        <p:spPr>
+          <a:xfrm>
+            <a:off x="245097" y="2298048"/>
+            <a:ext cx="1875934" cy="1356799"/>
+          </a:xfrm>
+          <a:prstGeom prst="roundRect">
+            <a:avLst/>
+          </a:prstGeom>
+        </p:spPr>
+        <p:style>
+          <a:lnRef idx="2">
+            <a:schemeClr val="accent1">
+              <a:shade val="15000"/>
+            </a:schemeClr>
+          </a:lnRef>
+          <a:fillRef idx="1">
+            <a:schemeClr val="accent1"/>
+          </a:fillRef>
+          <a:effectRef idx="0">
+            <a:schemeClr val="accent1"/>
+          </a:effectRef>
+          <a:fontRef idx="minor">
+            <a:schemeClr val="lt1"/>
+          </a:fontRef>
+        </p:style>
+        <p:txBody>
+          <a:bodyPr rtlCol="0" anchor="ctr"/>
+          <a:lstStyle/>
+          <a:p>
+            <a:pPr algn="ctr"/>
+            <a:r>
+              <a:rPr lang="fr-FR" sz="1400" dirty="0">
+                <a:latin typeface="Century Gothic" panose="020B0502020202020204" pitchFamily="34" charset="0"/>
+              </a:rPr>
+              <a:t>Pour chaque aliment végétal dans chaque pays : la dispo en </a:t>
+            </a:r>
+            <a:r>
+              <a:rPr lang="fr-FR" sz="1400" b="1" dirty="0">
+                <a:latin typeface="Century Gothic" panose="020B0502020202020204" pitchFamily="34" charset="0"/>
+              </a:rPr>
+              <a:t>kcal / personne / jour</a:t>
+            </a:r>
+            <a:endParaRPr lang="fr-FR" b="1" dirty="0"/>
+          </a:p>
+        </p:txBody>
+      </p:sp>
+      <p:sp>
+        <p:nvSpPr>
+          <p:cNvPr id="3" name="Rectangle : coins arrondis 2">
+            <a:extLst>
+              <a:ext uri="{FF2B5EF4-FFF2-40B4-BE49-F238E27FC236}">
+                <a16:creationId xmlns:a16="http://schemas.microsoft.com/office/drawing/2014/main" id="{BC1F652D-F5DE-C634-E07F-274418B0C7AC}"/>
+              </a:ext>
+            </a:extLst>
+          </p:cNvPr>
+          <p:cNvSpPr/>
+          <p:nvPr/>
+        </p:nvSpPr>
+        <p:spPr>
+          <a:xfrm>
+            <a:off x="2962744" y="2300803"/>
+            <a:ext cx="1768603" cy="1356799"/>
+          </a:xfrm>
+          <a:prstGeom prst="roundRect">
+            <a:avLst/>
+          </a:prstGeom>
+        </p:spPr>
+        <p:style>
+          <a:lnRef idx="2">
+            <a:schemeClr val="accent1">
+              <a:shade val="15000"/>
+            </a:schemeClr>
+          </a:lnRef>
+          <a:fillRef idx="1">
+            <a:schemeClr val="accent1"/>
+          </a:fillRef>
+          <a:effectRef idx="0">
+            <a:schemeClr val="accent1"/>
+          </a:effectRef>
+          <a:fontRef idx="minor">
+            <a:schemeClr val="lt1"/>
+          </a:fontRef>
+        </p:style>
+        <p:txBody>
+          <a:bodyPr rtlCol="0" anchor="ctr"/>
+          <a:lstStyle/>
+          <a:p>
+            <a:pPr algn="ctr"/>
+            <a:r>
+              <a:rPr lang="fr-FR" dirty="0"/>
+              <a:t>La population du pays concerné en 2017.</a:t>
+            </a:r>
+          </a:p>
+        </p:txBody>
+      </p:sp>
+      <p:sp>
+        <p:nvSpPr>
+          <p:cNvPr id="5" name="Signe de multiplication 4">
+            <a:extLst>
+              <a:ext uri="{FF2B5EF4-FFF2-40B4-BE49-F238E27FC236}">
+                <a16:creationId xmlns:a16="http://schemas.microsoft.com/office/drawing/2014/main" id="{0495A920-A68F-CF17-7122-417C23D81BA3}"/>
+              </a:ext>
+            </a:extLst>
+          </p:cNvPr>
+          <p:cNvSpPr/>
+          <p:nvPr/>
+        </p:nvSpPr>
+        <p:spPr>
+          <a:xfrm>
+            <a:off x="2173175" y="2628576"/>
+            <a:ext cx="761836" cy="779422"/>
+          </a:xfrm>
+          <a:prstGeom prst="mathMultiply">
+            <a:avLst/>
+          </a:prstGeom>
+          <a:solidFill>
+            <a:schemeClr val="bg1"/>
+          </a:solidFill>
+        </p:spPr>
+        <p:style>
+          <a:lnRef idx="2">
+            <a:schemeClr val="accent1">
+              <a:shade val="15000"/>
+            </a:schemeClr>
+          </a:lnRef>
+          <a:fillRef idx="1">
+            <a:schemeClr val="accent1"/>
+          </a:fillRef>
+          <a:effectRef idx="0">
+            <a:schemeClr val="accent1"/>
+          </a:effectRef>
+          <a:fontRef idx="minor">
+            <a:schemeClr val="lt1"/>
+          </a:fontRef>
+        </p:style>
+        <p:txBody>
+          <a:bodyPr rtlCol="0" anchor="ctr"/>
+          <a:lstStyle/>
+          <a:p>
+            <a:pPr algn="ctr"/>
+            <a:endParaRPr lang="fr-FR" dirty="0"/>
+          </a:p>
+        </p:txBody>
+      </p:sp>
+      <p:sp>
+        <p:nvSpPr>
+          <p:cNvPr id="6" name="Est égal à 5">
+            <a:extLst>
+              <a:ext uri="{FF2B5EF4-FFF2-40B4-BE49-F238E27FC236}">
+                <a16:creationId xmlns:a16="http://schemas.microsoft.com/office/drawing/2014/main" id="{7D0D3F6A-C0E1-EA14-09D0-26AB77740A69}"/>
+              </a:ext>
+            </a:extLst>
+          </p:cNvPr>
+          <p:cNvSpPr/>
+          <p:nvPr/>
+        </p:nvSpPr>
+        <p:spPr>
+          <a:xfrm>
+            <a:off x="4858648" y="2623863"/>
+            <a:ext cx="774309" cy="788849"/>
+          </a:xfrm>
+          <a:prstGeom prst="mathEqual">
+            <a:avLst/>
+          </a:prstGeom>
+          <a:solidFill>
+            <a:schemeClr val="bg1"/>
+          </a:solidFill>
+        </p:spPr>
+        <p:style>
+          <a:lnRef idx="2">
+            <a:schemeClr val="accent1">
+              <a:shade val="15000"/>
+            </a:schemeClr>
+          </a:lnRef>
+          <a:fillRef idx="1">
+            <a:schemeClr val="accent1"/>
+          </a:fillRef>
+          <a:effectRef idx="0">
+            <a:schemeClr val="accent1"/>
+          </a:effectRef>
+          <a:fontRef idx="minor">
+            <a:schemeClr val="lt1"/>
+          </a:fontRef>
+        </p:style>
+        <p:txBody>
+          <a:bodyPr rtlCol="0" anchor="ctr"/>
+          <a:lstStyle/>
+          <a:p>
+            <a:pPr algn="ctr"/>
+            <a:endParaRPr lang="fr-FR">
+              <a:solidFill>
+                <a:schemeClr val="tx1"/>
+              </a:solidFill>
+            </a:endParaRPr>
+          </a:p>
+        </p:txBody>
+      </p:sp>
+      <p:sp>
+        <p:nvSpPr>
+          <p:cNvPr id="7" name="Rectangle : coins arrondis 6">
+            <a:extLst>
+              <a:ext uri="{FF2B5EF4-FFF2-40B4-BE49-F238E27FC236}">
+                <a16:creationId xmlns:a16="http://schemas.microsoft.com/office/drawing/2014/main" id="{31BF7932-C337-6BA2-ED62-C7C0D006D2FF}"/>
+              </a:ext>
+            </a:extLst>
+          </p:cNvPr>
+          <p:cNvSpPr/>
+          <p:nvPr/>
+        </p:nvSpPr>
+        <p:spPr>
+          <a:xfrm>
+            <a:off x="5841472" y="2298048"/>
+            <a:ext cx="1875934" cy="1359554"/>
+          </a:xfrm>
+          <a:prstGeom prst="roundRect">
+            <a:avLst/>
+          </a:prstGeom>
+        </p:spPr>
+        <p:style>
+          <a:lnRef idx="2">
+            <a:schemeClr val="accent1">
+              <a:shade val="15000"/>
+            </a:schemeClr>
+          </a:lnRef>
+          <a:fillRef idx="1">
+            <a:schemeClr val="accent1"/>
+          </a:fillRef>
+          <a:effectRef idx="0">
+            <a:schemeClr val="accent1"/>
+          </a:effectRef>
+          <a:fontRef idx="minor">
+            <a:schemeClr val="lt1"/>
+          </a:fontRef>
+        </p:style>
+        <p:txBody>
+          <a:bodyPr rtlCol="0" anchor="ctr"/>
+          <a:lstStyle/>
+          <a:p>
+            <a:pPr algn="ctr"/>
+            <a:r>
+              <a:rPr lang="fr-FR" b="1" dirty="0">
+                <a:latin typeface="Century Gothic" panose="020B0502020202020204" pitchFamily="34" charset="0"/>
+              </a:rPr>
+              <a:t>Dispo mondiale totale en kcal / jour</a:t>
+            </a:r>
+            <a:endParaRPr lang="fr-FR" b="1" dirty="0"/>
+          </a:p>
+        </p:txBody>
+      </p:sp>
+      <p:sp>
+        <p:nvSpPr>
+          <p:cNvPr id="8" name="Signe de division 7">
+            <a:extLst>
+              <a:ext uri="{FF2B5EF4-FFF2-40B4-BE49-F238E27FC236}">
+                <a16:creationId xmlns:a16="http://schemas.microsoft.com/office/drawing/2014/main" id="{F3D8CC57-8C8D-3871-46F5-C4529D4112A7}"/>
+              </a:ext>
+            </a:extLst>
+          </p:cNvPr>
+          <p:cNvSpPr/>
+          <p:nvPr/>
+        </p:nvSpPr>
+        <p:spPr>
+          <a:xfrm>
+            <a:off x="7830235" y="2600876"/>
+            <a:ext cx="694774" cy="769995"/>
+          </a:xfrm>
+          <a:prstGeom prst="mathDivide">
+            <a:avLst/>
+          </a:prstGeom>
+          <a:solidFill>
+            <a:srgbClr val="FFFF00"/>
+          </a:solidFill>
+        </p:spPr>
+        <p:style>
+          <a:lnRef idx="2">
+            <a:schemeClr val="accent1">
+              <a:shade val="15000"/>
+            </a:schemeClr>
+          </a:lnRef>
+          <a:fillRef idx="1">
+            <a:schemeClr val="accent1"/>
+          </a:fillRef>
+          <a:effectRef idx="0">
+            <a:schemeClr val="accent1"/>
+          </a:effectRef>
+          <a:fontRef idx="minor">
+            <a:schemeClr val="lt1"/>
+          </a:fontRef>
+        </p:style>
+        <p:txBody>
+          <a:bodyPr rtlCol="0" anchor="ctr"/>
+          <a:lstStyle/>
+          <a:p>
+            <a:pPr algn="ctr"/>
+            <a:endParaRPr lang="fr-FR"/>
+          </a:p>
+        </p:txBody>
+      </p:sp>
+      <p:sp>
+        <p:nvSpPr>
+          <p:cNvPr id="9" name="Est égal à 8">
+            <a:extLst>
+              <a:ext uri="{FF2B5EF4-FFF2-40B4-BE49-F238E27FC236}">
+                <a16:creationId xmlns:a16="http://schemas.microsoft.com/office/drawing/2014/main" id="{5FDC7050-6E40-EA14-5130-48D10D56DFA5}"/>
+              </a:ext>
+            </a:extLst>
+          </p:cNvPr>
+          <p:cNvSpPr/>
+          <p:nvPr/>
+        </p:nvSpPr>
+        <p:spPr>
+          <a:xfrm>
+            <a:off x="1051996" y="4340745"/>
+            <a:ext cx="1649691" cy="1687398"/>
+          </a:xfrm>
+          <a:prstGeom prst="mathEqual">
+            <a:avLst/>
+          </a:prstGeom>
+          <a:solidFill>
+            <a:srgbClr val="FFFF00"/>
+          </a:solidFill>
+        </p:spPr>
+        <p:style>
+          <a:lnRef idx="2">
+            <a:schemeClr val="accent1">
+              <a:shade val="15000"/>
+            </a:schemeClr>
+          </a:lnRef>
+          <a:fillRef idx="1">
+            <a:schemeClr val="accent1"/>
+          </a:fillRef>
+          <a:effectRef idx="0">
+            <a:schemeClr val="accent1"/>
+          </a:effectRef>
+          <a:fontRef idx="minor">
+            <a:schemeClr val="lt1"/>
+          </a:fontRef>
+        </p:style>
+        <p:txBody>
+          <a:bodyPr rtlCol="0" anchor="ctr"/>
+          <a:lstStyle/>
+          <a:p>
+            <a:pPr algn="ctr"/>
+            <a:endParaRPr lang="fr-FR">
+              <a:solidFill>
+                <a:schemeClr val="tx1"/>
+              </a:solidFill>
+            </a:endParaRPr>
+          </a:p>
+        </p:txBody>
+      </p:sp>
+      <p:sp>
+        <p:nvSpPr>
+          <p:cNvPr id="10" name="ZoneTexte 9">
+            <a:extLst>
+              <a:ext uri="{FF2B5EF4-FFF2-40B4-BE49-F238E27FC236}">
+                <a16:creationId xmlns:a16="http://schemas.microsoft.com/office/drawing/2014/main" id="{3D3D1CBC-E1D7-4D4A-9AA0-011B7A1380C5}"/>
+              </a:ext>
+            </a:extLst>
+          </p:cNvPr>
+          <p:cNvSpPr txBox="1"/>
+          <p:nvPr/>
+        </p:nvSpPr>
+        <p:spPr>
+          <a:xfrm>
+            <a:off x="2701687" y="3893228"/>
+            <a:ext cx="8949430" cy="2308324"/>
+          </a:xfrm>
+          <a:prstGeom prst="rect">
+            <a:avLst/>
+          </a:prstGeom>
+          <a:noFill/>
+        </p:spPr>
+        <p:txBody>
+          <a:bodyPr wrap="square">
+            <a:spAutoFit/>
+          </a:bodyPr>
+          <a:lstStyle/>
+          <a:p>
+            <a:r>
+              <a:rPr lang="fr-FR" sz="4800" b="1" dirty="0">
+                <a:solidFill>
+                  <a:srgbClr val="FEFEFE"/>
+                </a:solidFill>
+                <a:latin typeface="Century Gothic" panose="020B0502020202020204" pitchFamily="34" charset="0"/>
+                <a:sym typeface="Century Gothic"/>
+              </a:rPr>
+              <a:t>7,27 Milliards de personnes, soit 99 % de la population mondiale.</a:t>
+            </a:r>
+          </a:p>
+        </p:txBody>
+      </p:sp>
+      <p:sp>
+        <p:nvSpPr>
+          <p:cNvPr id="11" name="Rectangle : coins arrondis 10">
+            <a:extLst>
+              <a:ext uri="{FF2B5EF4-FFF2-40B4-BE49-F238E27FC236}">
+                <a16:creationId xmlns:a16="http://schemas.microsoft.com/office/drawing/2014/main" id="{ED059039-EA47-C6E8-855C-7184EBEED48B}"/>
+              </a:ext>
+            </a:extLst>
+          </p:cNvPr>
+          <p:cNvSpPr/>
+          <p:nvPr/>
+        </p:nvSpPr>
+        <p:spPr>
+          <a:xfrm>
+            <a:off x="8779164" y="2306096"/>
+            <a:ext cx="1875934" cy="1359554"/>
+          </a:xfrm>
+          <a:prstGeom prst="roundRect">
+            <a:avLst/>
+          </a:prstGeom>
+        </p:spPr>
+        <p:style>
+          <a:lnRef idx="2">
+            <a:schemeClr val="accent1">
+              <a:shade val="15000"/>
+            </a:schemeClr>
+          </a:lnRef>
+          <a:fillRef idx="1">
+            <a:schemeClr val="accent1"/>
+          </a:fillRef>
+          <a:effectRef idx="0">
+            <a:schemeClr val="accent1"/>
+          </a:effectRef>
+          <a:fontRef idx="minor">
+            <a:schemeClr val="lt1"/>
+          </a:fontRef>
+        </p:style>
+        <p:txBody>
+          <a:bodyPr rtlCol="0" anchor="ctr"/>
+          <a:lstStyle/>
+          <a:p>
+            <a:pPr algn="ctr"/>
+            <a:r>
+              <a:rPr lang="fr-FR" b="1" dirty="0">
+                <a:latin typeface="Century Gothic" panose="020B0502020202020204" pitchFamily="34" charset="0"/>
+              </a:rPr>
+              <a:t>Besoins quotidiens d’un être humain (2400 kcal)</a:t>
+            </a:r>
+            <a:endParaRPr lang="fr-FR" b="1" dirty="0"/>
           </a:p>
         </p:txBody>
       </p:sp>
@@ -26878,7 +29629,7 @@
               <a:buFont typeface="Arial"/>
               <a:buNone/>
             </a:pPr>
-            <a:endParaRPr>
+            <a:endParaRPr dirty="0">
               <a:latin typeface="Century Gothic" panose="020B0502020202020204" pitchFamily="34" charset="0"/>
             </a:endParaRPr>
           </a:p>
@@ -26892,7 +29643,7 @@
         </p:nvSpPr>
         <p:spPr>
           <a:xfrm>
-            <a:off x="7682715" y="2600341"/>
+            <a:off x="4892962" y="-171086"/>
             <a:ext cx="3432000" cy="2582400"/>
           </a:xfrm>
           <a:prstGeom prst="rect">
@@ -26935,7 +29686,7 @@
               <a:buNone/>
             </a:pPr>
             <a:r>
-              <a:rPr lang="fr-FR" sz="1800" b="0" i="0" u="none" strike="noStrike" cap="none">
+              <a:rPr lang="fr-FR" sz="1800" b="0" i="0" u="none" strike="noStrike" cap="none" dirty="0">
                 <a:solidFill>
                   <a:srgbClr val="000000"/>
                 </a:solidFill>
@@ -26946,7 +29697,7 @@
               </a:rPr>
               <a:t>MEMO : </a:t>
             </a:r>
-            <a:endParaRPr sz="1400" b="0" i="0" u="none" strike="noStrike" cap="none">
+            <a:endParaRPr sz="1400" b="0" i="0" u="none" strike="noStrike" cap="none" dirty="0">
               <a:solidFill>
                 <a:srgbClr val="000000"/>
               </a:solidFill>
@@ -26973,7 +29724,7 @@
               <a:buNone/>
             </a:pPr>
             <a:r>
-              <a:rPr lang="fr-FR" sz="1800" b="0" i="0" u="none" strike="noStrike" cap="none">
+              <a:rPr lang="fr-FR" sz="1800" b="0" i="0" u="none" strike="noStrike" cap="none" dirty="0">
                 <a:solidFill>
                   <a:srgbClr val="000000"/>
                 </a:solidFill>
@@ -26984,7 +29735,7 @@
               </a:rPr>
               <a:t>Donner la part de l’alimentation humaine, animale et perdue (est-ce qu’on peut aussi calculer les autres ?) </a:t>
             </a:r>
-            <a:endParaRPr sz="1400" b="0" i="0" u="none" strike="noStrike" cap="none">
+            <a:endParaRPr sz="1400" b="0" i="0" u="none" strike="noStrike" cap="none" dirty="0">
               <a:solidFill>
                 <a:srgbClr val="000000"/>
               </a:solidFill>
@@ -27011,7 +29762,7 @@
               <a:buNone/>
             </a:pPr>
             <a:r>
-              <a:rPr lang="fr-FR" sz="1800" b="0" i="0" u="none" strike="noStrike" cap="none">
+              <a:rPr lang="fr-FR" sz="1800" b="0" i="0" u="none" strike="noStrike" cap="none" dirty="0">
                 <a:solidFill>
                   <a:srgbClr val="000000"/>
                 </a:solidFill>
@@ -27022,7 +29773,7 @@
               </a:rPr>
               <a:t>=&gt; Graphique ?</a:t>
             </a:r>
-            <a:endParaRPr sz="1400" b="0" i="0" u="none" strike="noStrike" cap="none">
+            <a:endParaRPr sz="1400" b="0" i="0" u="none" strike="noStrike" cap="none" dirty="0">
               <a:solidFill>
                 <a:srgbClr val="000000"/>
               </a:solidFill>
@@ -27040,7 +29791,7 @@
         </p:nvSpPr>
         <p:spPr>
           <a:xfrm>
-            <a:off x="4250715" y="2600341"/>
+            <a:off x="9234495" y="-171086"/>
             <a:ext cx="3432000" cy="2582400"/>
           </a:xfrm>
           <a:prstGeom prst="rect">
@@ -27306,6 +30057,66 @@
           </a:p>
         </p:txBody>
       </p:sp>
+      <p:pic>
+        <p:nvPicPr>
+          <p:cNvPr id="3" name="Image 2">
+            <a:extLst>
+              <a:ext uri="{FF2B5EF4-FFF2-40B4-BE49-F238E27FC236}">
+                <a16:creationId xmlns:a16="http://schemas.microsoft.com/office/drawing/2014/main" id="{B3760D85-B619-BBC4-7DD5-ACE85EF40AC1}"/>
+              </a:ext>
+            </a:extLst>
+          </p:cNvPr>
+          <p:cNvPicPr>
+            <a:picLocks noChangeAspect="1"/>
+          </p:cNvPicPr>
+          <p:nvPr/>
+        </p:nvPicPr>
+        <p:blipFill>
+          <a:blip r:embed="rId4"/>
+          <a:stretch>
+            <a:fillRect/>
+          </a:stretch>
+        </p:blipFill>
+        <p:spPr>
+          <a:xfrm>
+            <a:off x="743922" y="2123275"/>
+            <a:ext cx="5222791" cy="4192513"/>
+          </a:xfrm>
+          <a:prstGeom prst="rect">
+            <a:avLst/>
+          </a:prstGeom>
+        </p:spPr>
+      </p:pic>
+      <p:pic>
+        <p:nvPicPr>
+          <p:cNvPr id="6" name="Image 5">
+            <a:extLst>
+              <a:ext uri="{FF2B5EF4-FFF2-40B4-BE49-F238E27FC236}">
+                <a16:creationId xmlns:a16="http://schemas.microsoft.com/office/drawing/2014/main" id="{D1F90F54-3FDF-D519-5E00-5C25FAD5E2F8}"/>
+              </a:ext>
+            </a:extLst>
+          </p:cNvPr>
+          <p:cNvPicPr>
+            <a:picLocks noChangeAspect="1"/>
+          </p:cNvPicPr>
+          <p:nvPr/>
+        </p:nvPicPr>
+        <p:blipFill>
+          <a:blip r:embed="rId5"/>
+          <a:stretch>
+            <a:fillRect/>
+          </a:stretch>
+        </p:blipFill>
+        <p:spPr>
+          <a:xfrm>
+            <a:off x="6093679" y="2123275"/>
+            <a:ext cx="5372100" cy="4192514"/>
+          </a:xfrm>
+          <a:prstGeom prst="rect">
+            <a:avLst/>
+          </a:prstGeom>
+        </p:spPr>
+      </p:pic>
     </p:spTree>
   </p:cSld>
   <p:clrMapOvr>
@@ -27502,7 +30313,7 @@
               <a:buNone/>
             </a:pPr>
             <a:r>
-              <a:rPr lang="fr-FR" sz="1800" b="0" i="0" u="none" strike="noStrike" cap="none">
+              <a:rPr lang="fr-FR" sz="1800" b="0" i="0" u="none" strike="noStrike" cap="none" dirty="0">
                 <a:solidFill>
                   <a:srgbClr val="000000"/>
                 </a:solidFill>
@@ -27513,7 +30324,7 @@
               </a:rPr>
               <a:t>MEMO : </a:t>
             </a:r>
-            <a:endParaRPr sz="1400" b="0" i="0" u="none" strike="noStrike" cap="none">
+            <a:endParaRPr sz="1400" b="0" i="0" u="none" strike="noStrike" cap="none" dirty="0">
               <a:solidFill>
                 <a:srgbClr val="000000"/>
               </a:solidFill>
@@ -27540,7 +30351,7 @@
               <a:buNone/>
             </a:pPr>
             <a:r>
-              <a:rPr lang="fr-FR" sz="1800" b="0" i="0" u="none" strike="noStrike" cap="none">
+              <a:rPr lang="fr-FR" sz="1800" b="0" i="0" u="none" strike="noStrike" cap="none" dirty="0">
                 <a:solidFill>
                   <a:srgbClr val="000000"/>
                 </a:solidFill>
@@ -27551,7 +30362,7 @@
               </a:rPr>
               <a:t>Noms des céréales que j’ai récupérés sur le site de la FAO :</a:t>
             </a:r>
-            <a:endParaRPr sz="1400" b="0" i="0" u="none" strike="noStrike" cap="none">
+            <a:endParaRPr sz="1400" b="0" i="0" u="none" strike="noStrike" cap="none" dirty="0">
               <a:solidFill>
                 <a:srgbClr val="000000"/>
               </a:solidFill>
@@ -27578,7 +30389,7 @@
               <a:buNone/>
             </a:pPr>
             <a:r>
-              <a:rPr lang="fr-FR" sz="1800" b="0" i="0" u="none" strike="noStrike" cap="none">
+              <a:rPr lang="fr-FR" sz="1800" b="0" i="0" u="none" strike="noStrike" cap="none" dirty="0">
                 <a:solidFill>
                   <a:srgbClr val="000000"/>
                 </a:solidFill>
@@ -27589,7 +30400,7 @@
               </a:rPr>
               <a:t>Blé</a:t>
             </a:r>
-            <a:endParaRPr sz="1400" b="0" i="0" u="none" strike="noStrike" cap="none">
+            <a:endParaRPr sz="1400" b="0" i="0" u="none" strike="noStrike" cap="none" dirty="0">
               <a:solidFill>
                 <a:srgbClr val="000000"/>
               </a:solidFill>
@@ -27616,7 +30427,7 @@
               <a:buNone/>
             </a:pPr>
             <a:r>
-              <a:rPr lang="fr-FR" sz="1800" b="0" i="0" u="none" strike="noStrike" cap="none">
+              <a:rPr lang="fr-FR" sz="1800" b="0" i="0" u="none" strike="noStrike" cap="none" dirty="0">
                 <a:solidFill>
                   <a:srgbClr val="000000"/>
                 </a:solidFill>
@@ -27627,7 +30438,7 @@
               </a:rPr>
               <a:t>Riz (Eq Blanchi)</a:t>
             </a:r>
-            <a:endParaRPr sz="1400" b="0" i="0" u="none" strike="noStrike" cap="none">
+            <a:endParaRPr sz="1400" b="0" i="0" u="none" strike="noStrike" cap="none" dirty="0">
               <a:solidFill>
                 <a:srgbClr val="000000"/>
               </a:solidFill>
@@ -27654,7 +30465,7 @@
               <a:buNone/>
             </a:pPr>
             <a:r>
-              <a:rPr lang="fr-FR" sz="1800" b="0" i="0" u="none" strike="noStrike" cap="none">
+              <a:rPr lang="fr-FR" sz="1800" b="0" i="0" u="none" strike="noStrike" cap="none" dirty="0">
                 <a:solidFill>
                   <a:srgbClr val="000000"/>
                 </a:solidFill>
@@ -27665,7 +30476,7 @@
               </a:rPr>
               <a:t>Orge</a:t>
             </a:r>
-            <a:endParaRPr sz="1400" b="0" i="0" u="none" strike="noStrike" cap="none">
+            <a:endParaRPr sz="1400" b="0" i="0" u="none" strike="noStrike" cap="none" dirty="0">
               <a:solidFill>
                 <a:srgbClr val="000000"/>
               </a:solidFill>
@@ -27692,7 +30503,7 @@
               <a:buNone/>
             </a:pPr>
             <a:r>
-              <a:rPr lang="fr-FR" sz="1800" b="0" i="0" u="none" strike="noStrike" cap="none">
+              <a:rPr lang="fr-FR" sz="1800" b="0" i="0" u="none" strike="noStrike" cap="none" dirty="0">
                 <a:solidFill>
                   <a:srgbClr val="000000"/>
                 </a:solidFill>
@@ -27703,7 +30514,7 @@
               </a:rPr>
               <a:t>Maïs</a:t>
             </a:r>
-            <a:endParaRPr sz="1400" b="0" i="0" u="none" strike="noStrike" cap="none">
+            <a:endParaRPr sz="1400" b="0" i="0" u="none" strike="noStrike" cap="none" dirty="0">
               <a:solidFill>
                 <a:srgbClr val="000000"/>
               </a:solidFill>
@@ -27730,7 +30541,7 @@
               <a:buNone/>
             </a:pPr>
             <a:r>
-              <a:rPr lang="fr-FR" sz="1800" b="0" i="0" u="none" strike="noStrike" cap="none">
+              <a:rPr lang="fr-FR" sz="1800" b="0" i="0" u="none" strike="noStrike" cap="none" dirty="0">
                 <a:solidFill>
                   <a:srgbClr val="000000"/>
                 </a:solidFill>
@@ -27741,7 +30552,7 @@
               </a:rPr>
               <a:t>Seigle</a:t>
             </a:r>
-            <a:endParaRPr sz="1400" b="0" i="0" u="none" strike="noStrike" cap="none">
+            <a:endParaRPr sz="1400" b="0" i="0" u="none" strike="noStrike" cap="none" dirty="0">
               <a:solidFill>
                 <a:srgbClr val="000000"/>
               </a:solidFill>
@@ -27768,7 +30579,7 @@
               <a:buNone/>
             </a:pPr>
             <a:r>
-              <a:rPr lang="fr-FR" sz="1800" b="0" i="0" u="none" strike="noStrike" cap="none">
+              <a:rPr lang="fr-FR" sz="1800" b="0" i="0" u="none" strike="noStrike" cap="none" dirty="0">
                 <a:solidFill>
                   <a:srgbClr val="000000"/>
                 </a:solidFill>
@@ -27779,7 +30590,7 @@
               </a:rPr>
               <a:t>Avoine</a:t>
             </a:r>
-            <a:endParaRPr sz="1400" b="0" i="0" u="none" strike="noStrike" cap="none">
+            <a:endParaRPr sz="1400" b="0" i="0" u="none" strike="noStrike" cap="none" dirty="0">
               <a:solidFill>
                 <a:srgbClr val="000000"/>
               </a:solidFill>
@@ -27806,7 +30617,7 @@
               <a:buNone/>
             </a:pPr>
             <a:r>
-              <a:rPr lang="fr-FR" sz="1800" b="0" i="0" u="none" strike="noStrike" cap="none">
+              <a:rPr lang="fr-FR" sz="1800" b="0" i="0" u="none" strike="noStrike" cap="none" dirty="0">
                 <a:solidFill>
                   <a:srgbClr val="000000"/>
                 </a:solidFill>
@@ -27817,7 +30628,7 @@
               </a:rPr>
               <a:t>Millet</a:t>
             </a:r>
-            <a:endParaRPr sz="1400" b="0" i="0" u="none" strike="noStrike" cap="none">
+            <a:endParaRPr sz="1400" b="0" i="0" u="none" strike="noStrike" cap="none" dirty="0">
               <a:solidFill>
                 <a:srgbClr val="000000"/>
               </a:solidFill>
@@ -27844,7 +30655,7 @@
               <a:buNone/>
             </a:pPr>
             <a:r>
-              <a:rPr lang="fr-FR" sz="1800" b="0" i="0" u="none" strike="noStrike" cap="none">
+              <a:rPr lang="fr-FR" sz="1800" b="0" i="0" u="none" strike="noStrike" cap="none" dirty="0">
                 <a:solidFill>
                   <a:srgbClr val="000000"/>
                 </a:solidFill>
@@ -27855,7 +30666,7 @@
               </a:rPr>
               <a:t>Sorgho</a:t>
             </a:r>
-            <a:endParaRPr sz="1400" b="0" i="0" u="none" strike="noStrike" cap="none">
+            <a:endParaRPr sz="1400" b="0" i="0" u="none" strike="noStrike" cap="none" dirty="0">
               <a:solidFill>
                 <a:srgbClr val="000000"/>
               </a:solidFill>
@@ -27882,7 +30693,7 @@
               <a:buNone/>
             </a:pPr>
             <a:r>
-              <a:rPr lang="fr-FR" sz="1800" b="0" i="0" u="none" strike="noStrike" cap="none">
+              <a:rPr lang="fr-FR" sz="1800" b="0" i="0" u="none" strike="noStrike" cap="none" dirty="0">
                 <a:solidFill>
                   <a:srgbClr val="000000"/>
                 </a:solidFill>
@@ -27893,7 +30704,7 @@
               </a:rPr>
               <a:t>Céréales, </a:t>
             </a:r>
-            <a:endParaRPr sz="1800" b="0" i="0" u="none" strike="noStrike" cap="none">
+            <a:endParaRPr sz="1800" b="0" i="0" u="none" strike="noStrike" cap="none" dirty="0">
               <a:solidFill>
                 <a:srgbClr val="000000"/>
               </a:solidFill>
@@ -27922,7 +30733,7 @@
               <a:buNone/>
             </a:pPr>
             <a:r>
-              <a:rPr lang="fr-FR" sz="1800" b="0" i="0" u="none" strike="noStrike" cap="none">
+              <a:rPr lang="fr-FR" sz="1800" b="0" i="0" u="none" strike="noStrike" cap="none" dirty="0">
                 <a:solidFill>
                   <a:srgbClr val="000000"/>
                 </a:solidFill>
@@ -27933,7 +30744,7 @@
               </a:rPr>
               <a:t>Autres</a:t>
             </a:r>
-            <a:endParaRPr sz="1400" b="0" i="0" u="none" strike="noStrike" cap="none">
+            <a:endParaRPr sz="1400" b="0" i="0" u="none" strike="noStrike" cap="none" dirty="0">
               <a:solidFill>
                 <a:srgbClr val="000000"/>
               </a:solidFill>
@@ -27960,7 +30771,7 @@
               <a:buNone/>
             </a:pPr>
             <a:r>
-              <a:rPr lang="fr-FR" sz="1800" b="0" i="0" u="none" strike="noStrike" cap="none">
+              <a:rPr lang="fr-FR" sz="1800" b="0" i="0" u="none" strike="noStrike" cap="none" dirty="0">
                 <a:solidFill>
                   <a:srgbClr val="000000"/>
                 </a:solidFill>
@@ -27971,7 +30782,7 @@
               </a:rPr>
               <a:t>Est-ce qu’il ne faut donner que le total ou le détail par céréales et pour les humains et les animaux ? </a:t>
             </a:r>
-            <a:endParaRPr sz="1400" b="0" i="0" u="none" strike="noStrike" cap="none">
+            <a:endParaRPr sz="1400" b="0" i="0" u="none" strike="noStrike" cap="none" dirty="0">
               <a:solidFill>
                 <a:srgbClr val="000000"/>
               </a:solidFill>
@@ -27998,7 +30809,7 @@
               <a:buNone/>
             </a:pPr>
             <a:r>
-              <a:rPr lang="fr-FR" sz="1800" b="0" i="0" u="none" strike="noStrike" cap="none">
+              <a:rPr lang="fr-FR" sz="1800" b="0" i="0" u="none" strike="noStrike" cap="none" dirty="0">
                 <a:solidFill>
                   <a:srgbClr val="000000"/>
                 </a:solidFill>
@@ -28009,7 +30820,7 @@
               </a:rPr>
               <a:t>Je ne sais pas encore, à voir. </a:t>
             </a:r>
-            <a:endParaRPr sz="1400" b="0" i="0" u="none" strike="noStrike" cap="none">
+            <a:endParaRPr sz="1400" b="0" i="0" u="none" strike="noStrike" cap="none" dirty="0">
               <a:solidFill>
                 <a:srgbClr val="000000"/>
               </a:solidFill>
@@ -28019,6 +30830,36 @@
           </a:p>
         </p:txBody>
       </p:sp>
+      <p:pic>
+        <p:nvPicPr>
+          <p:cNvPr id="3" name="Image 2">
+            <a:extLst>
+              <a:ext uri="{FF2B5EF4-FFF2-40B4-BE49-F238E27FC236}">
+                <a16:creationId xmlns:a16="http://schemas.microsoft.com/office/drawing/2014/main" id="{3E9ECCD4-01EA-969D-859F-5F7106BE3752}"/>
+              </a:ext>
+            </a:extLst>
+          </p:cNvPr>
+          <p:cNvPicPr>
+            <a:picLocks noChangeAspect="1"/>
+          </p:cNvPicPr>
+          <p:nvPr/>
+        </p:nvPicPr>
+        <p:blipFill>
+          <a:blip r:embed="rId4"/>
+          <a:stretch>
+            <a:fillRect/>
+          </a:stretch>
+        </p:blipFill>
+        <p:spPr>
+          <a:xfrm>
+            <a:off x="1337901" y="1514279"/>
+            <a:ext cx="7906853" cy="4896533"/>
+          </a:xfrm>
+          <a:prstGeom prst="rect">
+            <a:avLst/>
+          </a:prstGeom>
+        </p:spPr>
+      </p:pic>
     </p:spTree>
   </p:cSld>
   <p:clrMapOvr>
@@ -28120,61 +30961,6 @@
       </p:sp>
       <p:sp>
         <p:nvSpPr>
-          <p:cNvPr id="182" name="Google Shape;182;p9"/>
-          <p:cNvSpPr txBox="1">
-            <a:spLocks noGrp="1"/>
-          </p:cNvSpPr>
-          <p:nvPr>
-            <p:ph type="body" idx="1"/>
-          </p:nvPr>
-        </p:nvSpPr>
-        <p:spPr>
-          <a:xfrm>
-            <a:off x="818712" y="2222287"/>
-            <a:ext cx="10554574" cy="3636511"/>
-          </a:xfrm>
-          <a:prstGeom prst="rect">
-            <a:avLst/>
-          </a:prstGeom>
-          <a:noFill/>
-          <a:ln>
-            <a:noFill/>
-          </a:ln>
-          <a:effectLst>
-            <a:outerShdw blurRad="50800">
-              <a:srgbClr val="000000">
-                <a:alpha val="40000"/>
-              </a:srgbClr>
-            </a:outerShdw>
-          </a:effectLst>
-        </p:spPr>
-        <p:txBody>
-          <a:bodyPr spcFirstLastPara="1" wrap="square" lIns="91425" tIns="45700" rIns="91425" bIns="45700" anchor="ctr" anchorCtr="0">
-            <a:normAutofit/>
-          </a:bodyPr>
-          <a:lstStyle/>
-          <a:p>
-            <a:pPr marL="0" lvl="0" indent="0" algn="l" rtl="0">
-              <a:lnSpc>
-                <a:spcPct val="100000"/>
-              </a:lnSpc>
-              <a:spcBef>
-                <a:spcPts val="0"/>
-              </a:spcBef>
-              <a:spcAft>
-                <a:spcPts val="0"/>
-              </a:spcAft>
-              <a:buSzPts val="1800"/>
-              <a:buNone/>
-            </a:pPr>
-            <a:endParaRPr dirty="0">
-              <a:latin typeface="Century Gothic" panose="020B0502020202020204" pitchFamily="34" charset="0"/>
-            </a:endParaRPr>
-          </a:p>
-        </p:txBody>
-      </p:sp>
-      <p:sp>
-        <p:nvSpPr>
           <p:cNvPr id="183" name="Google Shape;183;p9"/>
           <p:cNvSpPr/>
           <p:nvPr/>
@@ -28415,6 +31201,36 @@
           </a:p>
         </p:txBody>
       </p:sp>
+      <p:pic>
+        <p:nvPicPr>
+          <p:cNvPr id="4" name="Image 3">
+            <a:extLst>
+              <a:ext uri="{FF2B5EF4-FFF2-40B4-BE49-F238E27FC236}">
+                <a16:creationId xmlns:a16="http://schemas.microsoft.com/office/drawing/2014/main" id="{23A5F8A5-4B3E-7CB1-C38F-0DAB1A291480}"/>
+              </a:ext>
+            </a:extLst>
+          </p:cNvPr>
+          <p:cNvPicPr>
+            <a:picLocks noChangeAspect="1"/>
+          </p:cNvPicPr>
+          <p:nvPr/>
+        </p:nvPicPr>
+        <p:blipFill>
+          <a:blip r:embed="rId3"/>
+          <a:stretch>
+            <a:fillRect/>
+          </a:stretch>
+        </p:blipFill>
+        <p:spPr>
+          <a:xfrm>
+            <a:off x="1819275" y="1838326"/>
+            <a:ext cx="5705475" cy="4919662"/>
+          </a:xfrm>
+          <a:prstGeom prst="rect">
+            <a:avLst/>
+          </a:prstGeom>
+        </p:spPr>
+      </p:pic>
     </p:spTree>
   </p:cSld>
   <p:clrMapOvr>

</xml_diff>